<commit_message>
Add demo and thank-you slides
</commit_message>
<xml_diff>
--- a/docs/presentation/NetraJyoti_AI_Capstone_Demo_Deck.pptx
+++ b/docs/presentation/NetraJyoti_AI_Capstone_Demo_Deck.pptx
@@ -2,23 +2,25 @@
 <file path=ppt/presentation.xml><?xml version="1.0" encoding="utf-8"?>
 <p:presentation xmlns:p="http://schemas.openxmlformats.org/presentationml/2006/main">
   <p:sldMasterIdLst>
-    <p:sldMasterId xmlns:r="http://schemas.openxmlformats.org/officeDocument/2006/relationships" id="2147483648" r:id="Rb9d2bb8176674198"/>
+    <p:sldMasterId xmlns:r="http://schemas.openxmlformats.org/officeDocument/2006/relationships" id="2147483648" r:id="Rf75708d4ee7c40b0"/>
   </p:sldMasterIdLst>
   <p:notesMasterIdLst>
-    <p:notesMasterId xmlns:r="http://schemas.openxmlformats.org/officeDocument/2006/relationships" r:id="R5121620b9b3c4e22"/>
+    <p:notesMasterId xmlns:r="http://schemas.openxmlformats.org/officeDocument/2006/relationships" r:id="R2aaa831b0ee548f1"/>
   </p:notesMasterIdLst>
   <p:sldIdLst>
-    <p:sldId xmlns:r="http://schemas.openxmlformats.org/officeDocument/2006/relationships" id="256" r:id="R6b68776f6d9a43c2"/>
-    <p:sldId xmlns:r="http://schemas.openxmlformats.org/officeDocument/2006/relationships" id="257" r:id="R39728e42a8d14dae"/>
-    <p:sldId xmlns:r="http://schemas.openxmlformats.org/officeDocument/2006/relationships" id="258" r:id="R26bfcb9bdbd046b7"/>
-    <p:sldId xmlns:r="http://schemas.openxmlformats.org/officeDocument/2006/relationships" id="259" r:id="Ra51ccd59ce414b50"/>
-    <p:sldId xmlns:r="http://schemas.openxmlformats.org/officeDocument/2006/relationships" id="260" r:id="Rfa7bffa9910945b6"/>
-    <p:sldId xmlns:r="http://schemas.openxmlformats.org/officeDocument/2006/relationships" id="261" r:id="Red10757078f9493f"/>
-    <p:sldId xmlns:r="http://schemas.openxmlformats.org/officeDocument/2006/relationships" id="262" r:id="R164cfa7b256f4daf"/>
-    <p:sldId xmlns:r="http://schemas.openxmlformats.org/officeDocument/2006/relationships" id="263" r:id="R512787f3857f4d3f"/>
-    <p:sldId xmlns:r="http://schemas.openxmlformats.org/officeDocument/2006/relationships" id="264" r:id="R40d3183feefc443a"/>
-    <p:sldId xmlns:r="http://schemas.openxmlformats.org/officeDocument/2006/relationships" id="265" r:id="Rf06a6e805a5547f7"/>
-    <p:sldId xmlns:r="http://schemas.openxmlformats.org/officeDocument/2006/relationships" id="266" r:id="Rf2b281d688a945f2"/>
+    <p:sldId xmlns:r="http://schemas.openxmlformats.org/officeDocument/2006/relationships" id="256" r:id="R1d85e9daa84f4402"/>
+    <p:sldId xmlns:r="http://schemas.openxmlformats.org/officeDocument/2006/relationships" id="257" r:id="Rfa1277a1dff34b05"/>
+    <p:sldId xmlns:r="http://schemas.openxmlformats.org/officeDocument/2006/relationships" id="258" r:id="R381cd9b12f6d45f2"/>
+    <p:sldId xmlns:r="http://schemas.openxmlformats.org/officeDocument/2006/relationships" id="259" r:id="Rb109f643c1d04018"/>
+    <p:sldId xmlns:r="http://schemas.openxmlformats.org/officeDocument/2006/relationships" id="260" r:id="R0ed5b814fd6248c1"/>
+    <p:sldId xmlns:r="http://schemas.openxmlformats.org/officeDocument/2006/relationships" id="261" r:id="R0a73cb2175884d47"/>
+    <p:sldId xmlns:r="http://schemas.openxmlformats.org/officeDocument/2006/relationships" id="262" r:id="Rb58e79eec0df43b0"/>
+    <p:sldId xmlns:r="http://schemas.openxmlformats.org/officeDocument/2006/relationships" id="263" r:id="R42c8ca5eeb2341a1"/>
+    <p:sldId xmlns:r="http://schemas.openxmlformats.org/officeDocument/2006/relationships" id="264" r:id="R2f6c2a407c6e4abb"/>
+    <p:sldId xmlns:r="http://schemas.openxmlformats.org/officeDocument/2006/relationships" id="265" r:id="Rbf5e19ddc8174c33"/>
+    <p:sldId xmlns:r="http://schemas.openxmlformats.org/officeDocument/2006/relationships" id="266" r:id="R32051bcea67b468a"/>
+    <p:sldId xmlns:r="http://schemas.openxmlformats.org/officeDocument/2006/relationships" id="267" r:id="R8b8fe513eb504769"/>
+    <p:sldId xmlns:r="http://schemas.openxmlformats.org/officeDocument/2006/relationships" id="268" r:id="R619865c3b3e748da"/>
   </p:sldIdLst>
   <p:sldSz cx="12192000" cy="6858000"/>
   <p:notesSz cx="6858000" cy="9144000"/>
@@ -614,6 +616,138 @@
 </p:notes>
 </file>
 
+<file path=ppt/notesSlides/notesSlide12.xml><?xml version="1.0" encoding="utf-8"?>
+<p:notes xmlns:p="http://schemas.openxmlformats.org/presentationml/2006/main">
+  <p:cSld>
+    <p:spTree>
+      <p:nvGrpSpPr>
+        <p:cNvPr id="1" name=""/>
+        <p:cNvGrpSpPr/>
+        <p:nvPr/>
+      </p:nvGrpSpPr>
+      <p:grpSpPr>
+        <a:xfrm xmlns:a="http://schemas.openxmlformats.org/drawingml/2006/main"/>
+      </p:grpSpPr>
+      <p:sp>
+        <p:nvSpPr>
+          <p:cNvPr id="2" name="Slide Image Placeholder 1"/>
+          <p:cNvSpPr>
+            <a:spLocks xmlns:a="http://schemas.openxmlformats.org/drawingml/2006/main" noGrp="1"/>
+          </p:cNvSpPr>
+          <p:nvPr>
+            <p:ph type="sldImg" idx="0"/>
+          </p:nvPr>
+        </p:nvSpPr>
+        <p:spPr/>
+      </p:sp>
+      <p:sp>
+        <p:nvSpPr>
+          <p:cNvPr id="3" name="Notes Placeholder 2"/>
+          <p:cNvSpPr>
+            <a:spLocks xmlns:a="http://schemas.openxmlformats.org/drawingml/2006/main" noGrp="1"/>
+          </p:cNvSpPr>
+          <p:nvPr>
+            <p:ph type="body" idx="1"/>
+          </p:nvPr>
+        </p:nvSpPr>
+        <p:spPr/>
+        <p:txBody>
+          <a:bodyPr xmlns:a="http://schemas.openxmlformats.org/drawingml/2006/main"/>
+          <a:lstStyle xmlns:a="http://schemas.openxmlformats.org/drawingml/2006/main"/>
+          <a:p xmlns:a="http://schemas.openxmlformats.org/drawingml/2006/main"/>
+        </p:txBody>
+      </p:sp>
+      <p:sp>
+        <p:nvSpPr>
+          <p:cNvPr id="4" name="Slide Number Placeholder 3"/>
+          <p:cNvSpPr>
+            <a:spLocks xmlns:a="http://schemas.openxmlformats.org/drawingml/2006/main" noGrp="1"/>
+          </p:cNvSpPr>
+          <p:nvPr>
+            <p:ph type="sldNum" idx="5"/>
+          </p:nvPr>
+        </p:nvSpPr>
+        <p:spPr/>
+        <p:txBody>
+          <a:bodyPr xmlns:a="http://schemas.openxmlformats.org/drawingml/2006/main"/>
+          <a:lstStyle xmlns:a="http://schemas.openxmlformats.org/drawingml/2006/main"/>
+          <a:p xmlns:a="http://schemas.openxmlformats.org/drawingml/2006/main"/>
+        </p:txBody>
+      </p:sp>
+    </p:spTree>
+  </p:cSld>
+  <p:clrMapOvr>
+    <a:masterClrMapping xmlns:a="http://schemas.openxmlformats.org/drawingml/2006/main"/>
+  </p:clrMapOvr>
+</p:notes>
+</file>
+
+<file path=ppt/notesSlides/notesSlide13.xml><?xml version="1.0" encoding="utf-8"?>
+<p:notes xmlns:p="http://schemas.openxmlformats.org/presentationml/2006/main">
+  <p:cSld>
+    <p:spTree>
+      <p:nvGrpSpPr>
+        <p:cNvPr id="1" name=""/>
+        <p:cNvGrpSpPr/>
+        <p:nvPr/>
+      </p:nvGrpSpPr>
+      <p:grpSpPr>
+        <a:xfrm xmlns:a="http://schemas.openxmlformats.org/drawingml/2006/main"/>
+      </p:grpSpPr>
+      <p:sp>
+        <p:nvSpPr>
+          <p:cNvPr id="2" name="Slide Image Placeholder 1"/>
+          <p:cNvSpPr>
+            <a:spLocks xmlns:a="http://schemas.openxmlformats.org/drawingml/2006/main" noGrp="1"/>
+          </p:cNvSpPr>
+          <p:nvPr>
+            <p:ph type="sldImg" idx="0"/>
+          </p:nvPr>
+        </p:nvSpPr>
+        <p:spPr/>
+      </p:sp>
+      <p:sp>
+        <p:nvSpPr>
+          <p:cNvPr id="3" name="Notes Placeholder 2"/>
+          <p:cNvSpPr>
+            <a:spLocks xmlns:a="http://schemas.openxmlformats.org/drawingml/2006/main" noGrp="1"/>
+          </p:cNvSpPr>
+          <p:nvPr>
+            <p:ph type="body" idx="1"/>
+          </p:nvPr>
+        </p:nvSpPr>
+        <p:spPr/>
+        <p:txBody>
+          <a:bodyPr xmlns:a="http://schemas.openxmlformats.org/drawingml/2006/main"/>
+          <a:lstStyle xmlns:a="http://schemas.openxmlformats.org/drawingml/2006/main"/>
+          <a:p xmlns:a="http://schemas.openxmlformats.org/drawingml/2006/main"/>
+        </p:txBody>
+      </p:sp>
+      <p:sp>
+        <p:nvSpPr>
+          <p:cNvPr id="4" name="Slide Number Placeholder 3"/>
+          <p:cNvSpPr>
+            <a:spLocks xmlns:a="http://schemas.openxmlformats.org/drawingml/2006/main" noGrp="1"/>
+          </p:cNvSpPr>
+          <p:nvPr>
+            <p:ph type="sldNum" idx="5"/>
+          </p:nvPr>
+        </p:nvSpPr>
+        <p:spPr/>
+        <p:txBody>
+          <a:bodyPr xmlns:a="http://schemas.openxmlformats.org/drawingml/2006/main"/>
+          <a:lstStyle xmlns:a="http://schemas.openxmlformats.org/drawingml/2006/main"/>
+          <a:p xmlns:a="http://schemas.openxmlformats.org/drawingml/2006/main"/>
+        </p:txBody>
+      </p:sp>
+    </p:spTree>
+  </p:cSld>
+  <p:clrMapOvr>
+    <a:masterClrMapping xmlns:a="http://schemas.openxmlformats.org/drawingml/2006/main"/>
+  </p:clrMapOvr>
+</p:notes>
+</file>
+
 <file path=ppt/notesSlides/notesSlide2.xml><?xml version="1.0" encoding="utf-8"?>
 <p:notes xmlns:p="http://schemas.openxmlformats.org/presentationml/2006/main">
   <p:cSld>
@@ -1200,7 +1334,7 @@
   </p:cSld>
   <p:clrMap bg1="lt1" tx1="dk1" bg2="lt2" tx2="dk2" accent1="accent1" accent2="accent2" accent3="accent3" accent4="accent4" accent5="accent5" accent6="accent6" hlink="hlink" folHlink="folHlink"/>
   <p:sldLayoutIdLst>
-    <p:sldLayoutId xmlns:r="http://schemas.openxmlformats.org/officeDocument/2006/relationships" id="2147483649" r:id="R357a1ec4b9c044af"/>
+    <p:sldLayoutId xmlns:r="http://schemas.openxmlformats.org/officeDocument/2006/relationships" id="2147483649" r:id="R0c1f2f9357024e49"/>
   </p:sldLayoutIdLst>
   <p:txStyles>
     <p:titleStyle>
@@ -2303,7 +2437,7 @@
           <p:cNvPr id="12" name="">
             <a:extLst xmlns:a="http://schemas.openxmlformats.org/drawingml/2006/main">
               <a:ext uri="{FF2B5EF4-FFF2-40B4-BE49-F238E27FC236}">
-                <a16:creationId xmlns:a16="http://schemas.microsoft.com/office/drawing/2014/main" id="{DF28933A-A4D4-45B4-A47A-D78134DFCD49}"/>
+                <a16:creationId xmlns:a16="http://schemas.microsoft.com/office/drawing/2014/main" id="{3EC45FE9-929E-4369-BC72-E13F633B42F7}"/>
               </a:ext>
             </a:extLst>
           </p:cNvPr>
@@ -2333,7 +2467,7 @@
           <p:cNvPr id="13" name="">
             <a:extLst xmlns:a="http://schemas.openxmlformats.org/drawingml/2006/main">
               <a:ext uri="{FF2B5EF4-FFF2-40B4-BE49-F238E27FC236}">
-                <a16:creationId xmlns:a16="http://schemas.microsoft.com/office/drawing/2014/main" id="{57809CAC-37C8-4F36-A54B-3A20E0FAB02E}"/>
+                <a16:creationId xmlns:a16="http://schemas.microsoft.com/office/drawing/2014/main" id="{B733FBF3-6E07-4412-B202-6E884FD0EC64}"/>
               </a:ext>
             </a:extLst>
           </p:cNvPr>
@@ -2363,7 +2497,7 @@
           <p:cNvPr id="14" name="">
             <a:extLst xmlns:a="http://schemas.openxmlformats.org/drawingml/2006/main">
               <a:ext uri="{FF2B5EF4-FFF2-40B4-BE49-F238E27FC236}">
-                <a16:creationId xmlns:a16="http://schemas.microsoft.com/office/drawing/2014/main" id="{7DEB110C-0B13-4FB0-A8B9-D6E9070C93FA}"/>
+                <a16:creationId xmlns:a16="http://schemas.microsoft.com/office/drawing/2014/main" id="{B2DD5855-FE6D-4166-8F8A-0A5B7E4CC85E}"/>
               </a:ext>
             </a:extLst>
           </p:cNvPr>
@@ -2393,7 +2527,7 @@
           <p:cNvPr id="15" name="">
             <a:extLst xmlns:a="http://schemas.openxmlformats.org/drawingml/2006/main">
               <a:ext uri="{FF2B5EF4-FFF2-40B4-BE49-F238E27FC236}">
-                <a16:creationId xmlns:a16="http://schemas.microsoft.com/office/drawing/2014/main" id="{BCD0DF2D-5338-4144-A179-876F113374E5}"/>
+                <a16:creationId xmlns:a16="http://schemas.microsoft.com/office/drawing/2014/main" id="{8E45BAFA-1F15-45B2-A800-3A948E5B5722}"/>
               </a:ext>
             </a:extLst>
           </p:cNvPr>
@@ -2450,7 +2584,7 @@
           <p:cNvPr id="16" name="">
             <a:extLst xmlns:a="http://schemas.openxmlformats.org/drawingml/2006/main">
               <a:ext uri="{FF2B5EF4-FFF2-40B4-BE49-F238E27FC236}">
-                <a16:creationId xmlns:a16="http://schemas.microsoft.com/office/drawing/2014/main" id="{5A70FE30-273F-4939-8DCC-58C826849BD0}"/>
+                <a16:creationId xmlns:a16="http://schemas.microsoft.com/office/drawing/2014/main" id="{43C2B640-615D-4B55-88EA-E64A9E0B736C}"/>
               </a:ext>
             </a:extLst>
           </p:cNvPr>
@@ -2530,7 +2664,7 @@
           <p:cNvPr id="17" name="">
             <a:extLst xmlns:a="http://schemas.openxmlformats.org/drawingml/2006/main">
               <a:ext uri="{FF2B5EF4-FFF2-40B4-BE49-F238E27FC236}">
-                <a16:creationId xmlns:a16="http://schemas.microsoft.com/office/drawing/2014/main" id="{D5FB369E-E20C-4FE5-8A4B-588CB8DE7DC1}"/>
+                <a16:creationId xmlns:a16="http://schemas.microsoft.com/office/drawing/2014/main" id="{82A9AB05-00EB-4167-A9DD-0D01E974FA04}"/>
               </a:ext>
             </a:extLst>
           </p:cNvPr>
@@ -2560,7 +2694,7 @@
           <p:cNvPr id="18" name="">
             <a:extLst xmlns:a="http://schemas.openxmlformats.org/drawingml/2006/main">
               <a:ext uri="{FF2B5EF4-FFF2-40B4-BE49-F238E27FC236}">
-                <a16:creationId xmlns:a16="http://schemas.microsoft.com/office/drawing/2014/main" id="{23C623C6-9B87-4D8E-8804-59834B47E2C3}"/>
+                <a16:creationId xmlns:a16="http://schemas.microsoft.com/office/drawing/2014/main" id="{E47D6B2A-0413-48E1-AFFB-C08918341641}"/>
               </a:ext>
             </a:extLst>
           </p:cNvPr>
@@ -2640,7 +2774,7 @@
           <p:cNvPr id="19" name="">
             <a:extLst xmlns:a="http://schemas.openxmlformats.org/drawingml/2006/main">
               <a:ext uri="{FF2B5EF4-FFF2-40B4-BE49-F238E27FC236}">
-                <a16:creationId xmlns:a16="http://schemas.microsoft.com/office/drawing/2014/main" id="{5000B94F-A5BB-40A3-8E38-32CEE370182C}"/>
+                <a16:creationId xmlns:a16="http://schemas.microsoft.com/office/drawing/2014/main" id="{53764A19-B9E1-4404-9E62-22AF753EE05F}"/>
               </a:ext>
             </a:extLst>
           </p:cNvPr>
@@ -2720,7 +2854,7 @@
           <p:cNvPr id="20" name="">
             <a:extLst xmlns:a="http://schemas.openxmlformats.org/drawingml/2006/main">
               <a:ext uri="{FF2B5EF4-FFF2-40B4-BE49-F238E27FC236}">
-                <a16:creationId xmlns:a16="http://schemas.microsoft.com/office/drawing/2014/main" id="{F10CB5A1-0630-44BD-AF74-F801F4A8F398}"/>
+                <a16:creationId xmlns:a16="http://schemas.microsoft.com/office/drawing/2014/main" id="{39FB8633-CFF7-41C0-AC7A-C7698BBA9F95}"/>
               </a:ext>
             </a:extLst>
           </p:cNvPr>
@@ -2777,7 +2911,7 @@
           <p:cNvPr id="21" name="">
             <a:extLst xmlns:a="http://schemas.openxmlformats.org/drawingml/2006/main">
               <a:ext uri="{FF2B5EF4-FFF2-40B4-BE49-F238E27FC236}">
-                <a16:creationId xmlns:a16="http://schemas.microsoft.com/office/drawing/2014/main" id="{4F2F6D2F-C184-4BCC-A253-8F7F980D19F9}"/>
+                <a16:creationId xmlns:a16="http://schemas.microsoft.com/office/drawing/2014/main" id="{07A4D393-200C-486E-8BEF-6D329C3AD57D}"/>
               </a:ext>
             </a:extLst>
           </p:cNvPr>
@@ -2834,7 +2968,7 @@
           <p:cNvPr id="22" name="">
             <a:extLst xmlns:a="http://schemas.openxmlformats.org/drawingml/2006/main">
               <a:ext uri="{FF2B5EF4-FFF2-40B4-BE49-F238E27FC236}">
-                <a16:creationId xmlns:a16="http://schemas.microsoft.com/office/drawing/2014/main" id="{4D4D0619-6004-4E74-8D06-DD96A6F11EFF}"/>
+                <a16:creationId xmlns:a16="http://schemas.microsoft.com/office/drawing/2014/main" id="{589D2D31-11F1-4568-A40B-C1AF6963E729}"/>
               </a:ext>
             </a:extLst>
           </p:cNvPr>
@@ -2891,7 +3025,7 @@
           <p:cNvPr id="23" name="">
             <a:extLst xmlns:a="http://schemas.openxmlformats.org/drawingml/2006/main">
               <a:ext uri="{FF2B5EF4-FFF2-40B4-BE49-F238E27FC236}">
-                <a16:creationId xmlns:a16="http://schemas.microsoft.com/office/drawing/2014/main" id="{AFCE4D4F-D700-42DA-AEA3-628093403A4A}"/>
+                <a16:creationId xmlns:a16="http://schemas.microsoft.com/office/drawing/2014/main" id="{CBEE1D33-BF5D-4CAA-A035-0AAEAA7C3EFA}"/>
               </a:ext>
             </a:extLst>
           </p:cNvPr>
@@ -2921,7 +3055,7 @@
           <p:cNvPr id="24" name="">
             <a:extLst xmlns:a="http://schemas.openxmlformats.org/drawingml/2006/main">
               <a:ext uri="{FF2B5EF4-FFF2-40B4-BE49-F238E27FC236}">
-                <a16:creationId xmlns:a16="http://schemas.microsoft.com/office/drawing/2014/main" id="{6E985843-4258-41A9-8942-C9F2B243A504}"/>
+                <a16:creationId xmlns:a16="http://schemas.microsoft.com/office/drawing/2014/main" id="{AF4D1115-108B-4A13-A4A2-644416BA2173}"/>
               </a:ext>
             </a:extLst>
           </p:cNvPr>
@@ -2978,7 +3112,7 @@
           <p:cNvPr id="25" name="">
             <a:extLst xmlns:a="http://schemas.openxmlformats.org/drawingml/2006/main">
               <a:ext uri="{FF2B5EF4-FFF2-40B4-BE49-F238E27FC236}">
-                <a16:creationId xmlns:a16="http://schemas.microsoft.com/office/drawing/2014/main" id="{601B3A92-902D-44F5-BF13-31AC4EB23203}"/>
+                <a16:creationId xmlns:a16="http://schemas.microsoft.com/office/drawing/2014/main" id="{684A5E74-13C4-483E-B1A8-09E2C98BAF22}"/>
               </a:ext>
             </a:extLst>
           </p:cNvPr>
@@ -3008,7 +3142,7 @@
           <p:cNvPr id="26" name="">
             <a:extLst xmlns:a="http://schemas.openxmlformats.org/drawingml/2006/main">
               <a:ext uri="{FF2B5EF4-FFF2-40B4-BE49-F238E27FC236}">
-                <a16:creationId xmlns:a16="http://schemas.microsoft.com/office/drawing/2014/main" id="{C6C90D46-DAF6-4091-B8B4-2DD3DCDB6ECA}"/>
+                <a16:creationId xmlns:a16="http://schemas.microsoft.com/office/drawing/2014/main" id="{0C778DD6-3F2C-4CDE-BB63-7B117307920A}"/>
               </a:ext>
             </a:extLst>
           </p:cNvPr>
@@ -3087,7 +3221,7 @@
           <p:cNvPr id="29" name="">
             <a:extLst xmlns:a="http://schemas.openxmlformats.org/drawingml/2006/main">
               <a:ext uri="{FF2B5EF4-FFF2-40B4-BE49-F238E27FC236}">
-                <a16:creationId xmlns:a16="http://schemas.microsoft.com/office/drawing/2014/main" id="{B9BA1084-8C5A-43A8-9131-A0B012E50D9F}"/>
+                <a16:creationId xmlns:a16="http://schemas.microsoft.com/office/drawing/2014/main" id="{F5F5C9FF-8B10-4C16-B0EC-E6805985CC91}"/>
               </a:ext>
             </a:extLst>
           </p:cNvPr>
@@ -3117,7 +3251,7 @@
           <p:cNvPr id="2" name="">
             <a:extLst xmlns:a="http://schemas.openxmlformats.org/drawingml/2006/main">
               <a:ext uri="{FF2B5EF4-FFF2-40B4-BE49-F238E27FC236}">
-                <a16:creationId xmlns:a16="http://schemas.microsoft.com/office/drawing/2014/main" id="{95EA1C69-BEEC-4BAB-9920-DFF9287B3CAE}"/>
+                <a16:creationId xmlns:a16="http://schemas.microsoft.com/office/drawing/2014/main" id="{C35AF737-13EC-4FB1-BD52-B3DB7D474482}"/>
               </a:ext>
             </a:extLst>
           </p:cNvPr>
@@ -3174,7 +3308,7 @@
           <p:cNvPr id="3" name="">
             <a:extLst xmlns:a="http://schemas.openxmlformats.org/drawingml/2006/main">
               <a:ext uri="{FF2B5EF4-FFF2-40B4-BE49-F238E27FC236}">
-                <a16:creationId xmlns:a16="http://schemas.microsoft.com/office/drawing/2014/main" id="{F16C0A9C-0631-43DD-B3EA-D7D536314C71}"/>
+                <a16:creationId xmlns:a16="http://schemas.microsoft.com/office/drawing/2014/main" id="{08ADA32A-B9D9-4CA3-B56C-207524321E03}"/>
               </a:ext>
             </a:extLst>
           </p:cNvPr>
@@ -3231,7 +3365,7 @@
           <p:cNvPr id="4" name="">
             <a:extLst xmlns:a="http://schemas.openxmlformats.org/drawingml/2006/main">
               <a:ext uri="{FF2B5EF4-FFF2-40B4-BE49-F238E27FC236}">
-                <a16:creationId xmlns:a16="http://schemas.microsoft.com/office/drawing/2014/main" id="{FE491DE4-D601-4BE7-B729-AA04055A3C76}"/>
+                <a16:creationId xmlns:a16="http://schemas.microsoft.com/office/drawing/2014/main" id="{A19C072D-FFB0-4024-8714-F3F5A1F08D28}"/>
               </a:ext>
             </a:extLst>
           </p:cNvPr>
@@ -3288,7 +3422,7 @@
           <p:cNvPr id="5" name="">
             <a:extLst xmlns:a="http://schemas.openxmlformats.org/drawingml/2006/main">
               <a:ext uri="{FF2B5EF4-FFF2-40B4-BE49-F238E27FC236}">
-                <a16:creationId xmlns:a16="http://schemas.microsoft.com/office/drawing/2014/main" id="{4207355F-1AD7-44F0-B6CC-164E72EE7F29}"/>
+                <a16:creationId xmlns:a16="http://schemas.microsoft.com/office/drawing/2014/main" id="{E9ED07BD-9BC1-4C8B-B704-BF5D9F3DDFA5}"/>
               </a:ext>
             </a:extLst>
           </p:cNvPr>
@@ -3345,7 +3479,7 @@
           <p:cNvPr id="6" name="">
             <a:extLst xmlns:a="http://schemas.openxmlformats.org/drawingml/2006/main">
               <a:ext uri="{FF2B5EF4-FFF2-40B4-BE49-F238E27FC236}">
-                <a16:creationId xmlns:a16="http://schemas.microsoft.com/office/drawing/2014/main" id="{225747B6-77A6-426C-A621-33DEC4E148D2}"/>
+                <a16:creationId xmlns:a16="http://schemas.microsoft.com/office/drawing/2014/main" id="{72247874-A5A8-4E98-B9E3-4725AAF9787F}"/>
               </a:ext>
             </a:extLst>
           </p:cNvPr>
@@ -3375,7 +3509,7 @@
           <p:cNvPr id="7" name="">
             <a:extLst xmlns:a="http://schemas.openxmlformats.org/drawingml/2006/main">
               <a:ext uri="{FF2B5EF4-FFF2-40B4-BE49-F238E27FC236}">
-                <a16:creationId xmlns:a16="http://schemas.microsoft.com/office/drawing/2014/main" id="{D9B1C3A3-A6CC-45E2-BD36-330C98614985}"/>
+                <a16:creationId xmlns:a16="http://schemas.microsoft.com/office/drawing/2014/main" id="{2E22E02B-D2D9-496E-916F-7887477AB85D}"/>
               </a:ext>
             </a:extLst>
           </p:cNvPr>
@@ -3409,7 +3543,7 @@
           <p:cNvPr id="8" name="">
             <a:extLst xmlns:a="http://schemas.openxmlformats.org/drawingml/2006/main">
               <a:ext uri="{FF2B5EF4-FFF2-40B4-BE49-F238E27FC236}">
-                <a16:creationId xmlns:a16="http://schemas.microsoft.com/office/drawing/2014/main" id="{5E28D383-48F6-4B66-A745-87AAB4956D10}"/>
+                <a16:creationId xmlns:a16="http://schemas.microsoft.com/office/drawing/2014/main" id="{58B39B4D-27D5-43DB-AB17-A838C603960D}"/>
               </a:ext>
             </a:extLst>
           </p:cNvPr>
@@ -3441,7 +3575,7 @@
           <p:cNvPr id="9" name="">
             <a:extLst xmlns:a="http://schemas.openxmlformats.org/drawingml/2006/main">
               <a:ext uri="{FF2B5EF4-FFF2-40B4-BE49-F238E27FC236}">
-                <a16:creationId xmlns:a16="http://schemas.microsoft.com/office/drawing/2014/main" id="{E65F2459-0594-40BC-9C75-322FFFE1C187}"/>
+                <a16:creationId xmlns:a16="http://schemas.microsoft.com/office/drawing/2014/main" id="{1A7127CF-3163-4A20-BEB7-BC6DDEBA7827}"/>
               </a:ext>
             </a:extLst>
           </p:cNvPr>
@@ -3498,7 +3632,7 @@
           <p:cNvPr id="10" name="">
             <a:extLst xmlns:a="http://schemas.openxmlformats.org/drawingml/2006/main">
               <a:ext uri="{FF2B5EF4-FFF2-40B4-BE49-F238E27FC236}">
-                <a16:creationId xmlns:a16="http://schemas.microsoft.com/office/drawing/2014/main" id="{8B993937-06B6-4527-B208-D75A6E381E55}"/>
+                <a16:creationId xmlns:a16="http://schemas.microsoft.com/office/drawing/2014/main" id="{63E5101E-96E8-416F-A6AD-85CB0324BAF0}"/>
               </a:ext>
             </a:extLst>
           </p:cNvPr>
@@ -3555,7 +3689,7 @@
           <p:cNvPr id="11" name="">
             <a:extLst xmlns:a="http://schemas.openxmlformats.org/drawingml/2006/main">
               <a:ext uri="{FF2B5EF4-FFF2-40B4-BE49-F238E27FC236}">
-                <a16:creationId xmlns:a16="http://schemas.microsoft.com/office/drawing/2014/main" id="{F4D654A1-AC03-441E-B0DA-3D273EE92658}"/>
+                <a16:creationId xmlns:a16="http://schemas.microsoft.com/office/drawing/2014/main" id="{3EFBF571-659C-47E7-AF8C-95C4A2B653F5}"/>
               </a:ext>
             </a:extLst>
           </p:cNvPr>
@@ -3612,7 +3746,7 @@
           <p:cNvPr id="12" name="">
             <a:extLst xmlns:a="http://schemas.openxmlformats.org/drawingml/2006/main">
               <a:ext uri="{FF2B5EF4-FFF2-40B4-BE49-F238E27FC236}">
-                <a16:creationId xmlns:a16="http://schemas.microsoft.com/office/drawing/2014/main" id="{E7C1C2FB-2E7B-4B09-9DE6-DAACF8C14C2C}"/>
+                <a16:creationId xmlns:a16="http://schemas.microsoft.com/office/drawing/2014/main" id="{B56A4123-4C31-4D45-BA77-4F56A86C2436}"/>
               </a:ext>
             </a:extLst>
           </p:cNvPr>
@@ -3669,7 +3803,7 @@
           <p:cNvPr id="13" name="">
             <a:extLst xmlns:a="http://schemas.openxmlformats.org/drawingml/2006/main">
               <a:ext uri="{FF2B5EF4-FFF2-40B4-BE49-F238E27FC236}">
-                <a16:creationId xmlns:a16="http://schemas.microsoft.com/office/drawing/2014/main" id="{F15A28CB-E05A-4311-BBE6-365BB537C85E}"/>
+                <a16:creationId xmlns:a16="http://schemas.microsoft.com/office/drawing/2014/main" id="{76BA06DD-57C7-4EF4-8362-2CA709632DEC}"/>
               </a:ext>
             </a:extLst>
           </p:cNvPr>
@@ -3703,7 +3837,7 @@
           <p:cNvPr id="14" name="">
             <a:extLst xmlns:a="http://schemas.openxmlformats.org/drawingml/2006/main">
               <a:ext uri="{FF2B5EF4-FFF2-40B4-BE49-F238E27FC236}">
-                <a16:creationId xmlns:a16="http://schemas.microsoft.com/office/drawing/2014/main" id="{742CDC0F-44A3-43F1-9130-26BA2955E5AC}"/>
+                <a16:creationId xmlns:a16="http://schemas.microsoft.com/office/drawing/2014/main" id="{7BF4832C-3EC7-4C63-A78A-9F96917AD0FC}"/>
               </a:ext>
             </a:extLst>
           </p:cNvPr>
@@ -3735,7 +3869,7 @@
           <p:cNvPr id="15" name="">
             <a:extLst xmlns:a="http://schemas.openxmlformats.org/drawingml/2006/main">
               <a:ext uri="{FF2B5EF4-FFF2-40B4-BE49-F238E27FC236}">
-                <a16:creationId xmlns:a16="http://schemas.microsoft.com/office/drawing/2014/main" id="{AF5276E6-BF2D-4C44-AC5C-FA7566E5018B}"/>
+                <a16:creationId xmlns:a16="http://schemas.microsoft.com/office/drawing/2014/main" id="{ACC62658-BBC3-40F9-8F66-F23BFFD32E1C}"/>
               </a:ext>
             </a:extLst>
           </p:cNvPr>
@@ -3792,7 +3926,7 @@
           <p:cNvPr id="16" name="">
             <a:extLst xmlns:a="http://schemas.openxmlformats.org/drawingml/2006/main">
               <a:ext uri="{FF2B5EF4-FFF2-40B4-BE49-F238E27FC236}">
-                <a16:creationId xmlns:a16="http://schemas.microsoft.com/office/drawing/2014/main" id="{7C910F13-781E-4C6F-A41A-7521323F95A9}"/>
+                <a16:creationId xmlns:a16="http://schemas.microsoft.com/office/drawing/2014/main" id="{FA48AC3A-7C4C-4DCA-9467-7758430F08D3}"/>
               </a:ext>
             </a:extLst>
           </p:cNvPr>
@@ -3849,7 +3983,7 @@
           <p:cNvPr id="17" name="">
             <a:extLst xmlns:a="http://schemas.openxmlformats.org/drawingml/2006/main">
               <a:ext uri="{FF2B5EF4-FFF2-40B4-BE49-F238E27FC236}">
-                <a16:creationId xmlns:a16="http://schemas.microsoft.com/office/drawing/2014/main" id="{F4C0130E-AA48-440A-AA90-E1025C1DDE71}"/>
+                <a16:creationId xmlns:a16="http://schemas.microsoft.com/office/drawing/2014/main" id="{8BBCF0BF-A7E2-48BF-86FA-270137CA492D}"/>
               </a:ext>
             </a:extLst>
           </p:cNvPr>
@@ -3906,7 +4040,7 @@
           <p:cNvPr id="18" name="">
             <a:extLst xmlns:a="http://schemas.openxmlformats.org/drawingml/2006/main">
               <a:ext uri="{FF2B5EF4-FFF2-40B4-BE49-F238E27FC236}">
-                <a16:creationId xmlns:a16="http://schemas.microsoft.com/office/drawing/2014/main" id="{9F95E0F4-6EF8-4B50-AB25-8992BE896937}"/>
+                <a16:creationId xmlns:a16="http://schemas.microsoft.com/office/drawing/2014/main" id="{4F4130B3-2ABC-41C3-A0E5-B2DFA7C7F477}"/>
               </a:ext>
             </a:extLst>
           </p:cNvPr>
@@ -3963,7 +4097,7 @@
           <p:cNvPr id="19" name="">
             <a:extLst xmlns:a="http://schemas.openxmlformats.org/drawingml/2006/main">
               <a:ext uri="{FF2B5EF4-FFF2-40B4-BE49-F238E27FC236}">
-                <a16:creationId xmlns:a16="http://schemas.microsoft.com/office/drawing/2014/main" id="{D7CF30D9-C6FC-4B64-B9EF-976A0E3DF138}"/>
+                <a16:creationId xmlns:a16="http://schemas.microsoft.com/office/drawing/2014/main" id="{E7B42ACA-219C-4917-9B25-6A20F83D2BC6}"/>
               </a:ext>
             </a:extLst>
           </p:cNvPr>
@@ -3997,7 +4131,7 @@
           <p:cNvPr id="20" name="">
             <a:extLst xmlns:a="http://schemas.openxmlformats.org/drawingml/2006/main">
               <a:ext uri="{FF2B5EF4-FFF2-40B4-BE49-F238E27FC236}">
-                <a16:creationId xmlns:a16="http://schemas.microsoft.com/office/drawing/2014/main" id="{88D6F87E-E913-48D9-A36C-1E10E8A21E1F}"/>
+                <a16:creationId xmlns:a16="http://schemas.microsoft.com/office/drawing/2014/main" id="{346FC3ED-7C18-44B3-8C70-CF49328BE00B}"/>
               </a:ext>
             </a:extLst>
           </p:cNvPr>
@@ -4029,7 +4163,7 @@
           <p:cNvPr id="21" name="">
             <a:extLst xmlns:a="http://schemas.openxmlformats.org/drawingml/2006/main">
               <a:ext uri="{FF2B5EF4-FFF2-40B4-BE49-F238E27FC236}">
-                <a16:creationId xmlns:a16="http://schemas.microsoft.com/office/drawing/2014/main" id="{992CADCE-8489-4320-A50B-430D2CF3F033}"/>
+                <a16:creationId xmlns:a16="http://schemas.microsoft.com/office/drawing/2014/main" id="{65D27B71-DE06-4A3E-906C-0050DB0E5869}"/>
               </a:ext>
             </a:extLst>
           </p:cNvPr>
@@ -4086,7 +4220,7 @@
           <p:cNvPr id="22" name="">
             <a:extLst xmlns:a="http://schemas.openxmlformats.org/drawingml/2006/main">
               <a:ext uri="{FF2B5EF4-FFF2-40B4-BE49-F238E27FC236}">
-                <a16:creationId xmlns:a16="http://schemas.microsoft.com/office/drawing/2014/main" id="{978B525C-4F85-4A22-891D-9A4FBA55CB2A}"/>
+                <a16:creationId xmlns:a16="http://schemas.microsoft.com/office/drawing/2014/main" id="{AD2571AD-BEEA-4DA3-A41C-484CE0ED601D}"/>
               </a:ext>
             </a:extLst>
           </p:cNvPr>
@@ -4143,7 +4277,7 @@
           <p:cNvPr id="23" name="">
             <a:extLst xmlns:a="http://schemas.openxmlformats.org/drawingml/2006/main">
               <a:ext uri="{FF2B5EF4-FFF2-40B4-BE49-F238E27FC236}">
-                <a16:creationId xmlns:a16="http://schemas.microsoft.com/office/drawing/2014/main" id="{CE2316F7-A700-4AAB-9D6F-77078FEB310E}"/>
+                <a16:creationId xmlns:a16="http://schemas.microsoft.com/office/drawing/2014/main" id="{8E35905E-1765-4EB3-8027-C8780788702B}"/>
               </a:ext>
             </a:extLst>
           </p:cNvPr>
@@ -4200,7 +4334,7 @@
           <p:cNvPr id="24" name="">
             <a:extLst xmlns:a="http://schemas.openxmlformats.org/drawingml/2006/main">
               <a:ext uri="{FF2B5EF4-FFF2-40B4-BE49-F238E27FC236}">
-                <a16:creationId xmlns:a16="http://schemas.microsoft.com/office/drawing/2014/main" id="{E3D4EB02-623F-49B7-84C0-D8E13CFA05F1}"/>
+                <a16:creationId xmlns:a16="http://schemas.microsoft.com/office/drawing/2014/main" id="{5ED6821C-1675-45AD-88EC-7257C39459C7}"/>
               </a:ext>
             </a:extLst>
           </p:cNvPr>
@@ -4257,7 +4391,7 @@
           <p:cNvPr id="25" name="">
             <a:extLst xmlns:a="http://schemas.openxmlformats.org/drawingml/2006/main">
               <a:ext uri="{FF2B5EF4-FFF2-40B4-BE49-F238E27FC236}">
-                <a16:creationId xmlns:a16="http://schemas.microsoft.com/office/drawing/2014/main" id="{B6222794-76BE-434F-90F6-40FF1A40385C}"/>
+                <a16:creationId xmlns:a16="http://schemas.microsoft.com/office/drawing/2014/main" id="{32700AB2-7DD9-4C95-9F08-7E50AE09F23F}"/>
               </a:ext>
             </a:extLst>
           </p:cNvPr>
@@ -4289,7 +4423,7 @@
           <p:cNvPr id="26" name="">
             <a:extLst xmlns:a="http://schemas.openxmlformats.org/drawingml/2006/main">
               <a:ext uri="{FF2B5EF4-FFF2-40B4-BE49-F238E27FC236}">
-                <a16:creationId xmlns:a16="http://schemas.microsoft.com/office/drawing/2014/main" id="{D7C0C576-87AC-4603-A4B1-819A0FD7E77F}"/>
+                <a16:creationId xmlns:a16="http://schemas.microsoft.com/office/drawing/2014/main" id="{082C6631-162B-406F-BF50-2519975816C1}"/>
               </a:ext>
             </a:extLst>
           </p:cNvPr>
@@ -4346,7 +4480,7 @@
           <p:cNvPr id="27" name="">
             <a:extLst xmlns:a="http://schemas.openxmlformats.org/drawingml/2006/main">
               <a:ext uri="{FF2B5EF4-FFF2-40B4-BE49-F238E27FC236}">
-                <a16:creationId xmlns:a16="http://schemas.microsoft.com/office/drawing/2014/main" id="{6FB9129D-05C2-4EA4-9C1B-8D56F01EEBBF}"/>
+                <a16:creationId xmlns:a16="http://schemas.microsoft.com/office/drawing/2014/main" id="{494C142E-FB2D-4127-B5B6-5F0BF17AE02C}"/>
               </a:ext>
             </a:extLst>
           </p:cNvPr>
@@ -4403,7 +4537,7 @@
           <p:cNvPr id="28" name="">
             <a:extLst xmlns:a="http://schemas.openxmlformats.org/drawingml/2006/main">
               <a:ext uri="{FF2B5EF4-FFF2-40B4-BE49-F238E27FC236}">
-                <a16:creationId xmlns:a16="http://schemas.microsoft.com/office/drawing/2014/main" id="{D0677020-D5EF-4F6C-ACB7-D86A1FDA2DC3}"/>
+                <a16:creationId xmlns:a16="http://schemas.microsoft.com/office/drawing/2014/main" id="{68FEBAF1-D49E-4C67-874A-5F8977FF4397}"/>
               </a:ext>
             </a:extLst>
           </p:cNvPr>
@@ -4458,7 +4592,7 @@
     </p:spTree>
     <p:extLst>
       <p:ext uri="{BB962C8B-B14F-4D97-AF65-F5344CB8AC3E}">
-        <p14:creationId xmlns:p14="http://schemas.microsoft.com/office/powerpoint/2010/main" val="834058474"/>
+        <p14:creationId xmlns:p14="http://schemas.microsoft.com/office/powerpoint/2010/main" val="10996520"/>
       </p:ext>
     </p:extLst>
   </p:cSld>
@@ -4482,7 +4616,7 @@
           <p:cNvPr id="23" name="">
             <a:extLst xmlns:a="http://schemas.openxmlformats.org/drawingml/2006/main">
               <a:ext uri="{FF2B5EF4-FFF2-40B4-BE49-F238E27FC236}">
-                <a16:creationId xmlns:a16="http://schemas.microsoft.com/office/drawing/2014/main" id="{149F3221-EFF5-4E72-8181-BBF925E2E234}"/>
+                <a16:creationId xmlns:a16="http://schemas.microsoft.com/office/drawing/2014/main" id="{CE3210AA-2902-447B-8CDE-E1FD6E0EC0A5}"/>
               </a:ext>
             </a:extLst>
           </p:cNvPr>
@@ -4512,7 +4646,7 @@
           <p:cNvPr id="2" name="">
             <a:extLst xmlns:a="http://schemas.openxmlformats.org/drawingml/2006/main">
               <a:ext uri="{FF2B5EF4-FFF2-40B4-BE49-F238E27FC236}">
-                <a16:creationId xmlns:a16="http://schemas.microsoft.com/office/drawing/2014/main" id="{70EED1D1-8FC0-495B-AC2A-898062C99A7E}"/>
+                <a16:creationId xmlns:a16="http://schemas.microsoft.com/office/drawing/2014/main" id="{10915634-A6CB-4417-B2BB-44721772C712}"/>
               </a:ext>
             </a:extLst>
           </p:cNvPr>
@@ -4569,7 +4703,7 @@
           <p:cNvPr id="3" name="">
             <a:extLst xmlns:a="http://schemas.openxmlformats.org/drawingml/2006/main">
               <a:ext uri="{FF2B5EF4-FFF2-40B4-BE49-F238E27FC236}">
-                <a16:creationId xmlns:a16="http://schemas.microsoft.com/office/drawing/2014/main" id="{A4E6E5DF-FF4A-48AB-A8A4-C19C17E56EAD}"/>
+                <a16:creationId xmlns:a16="http://schemas.microsoft.com/office/drawing/2014/main" id="{B9DFA4FE-8155-48DE-B31C-E288815B4F0E}"/>
               </a:ext>
             </a:extLst>
           </p:cNvPr>
@@ -4626,7 +4760,7 @@
           <p:cNvPr id="4" name="">
             <a:extLst xmlns:a="http://schemas.openxmlformats.org/drawingml/2006/main">
               <a:ext uri="{FF2B5EF4-FFF2-40B4-BE49-F238E27FC236}">
-                <a16:creationId xmlns:a16="http://schemas.microsoft.com/office/drawing/2014/main" id="{F9A43B23-F7EE-4BBF-A44D-26DA3F949700}"/>
+                <a16:creationId xmlns:a16="http://schemas.microsoft.com/office/drawing/2014/main" id="{7B499BFA-43E6-41E4-B410-E3F36769011A}"/>
               </a:ext>
             </a:extLst>
           </p:cNvPr>
@@ -4683,7 +4817,7 @@
           <p:cNvPr id="5" name="">
             <a:extLst xmlns:a="http://schemas.openxmlformats.org/drawingml/2006/main">
               <a:ext uri="{FF2B5EF4-FFF2-40B4-BE49-F238E27FC236}">
-                <a16:creationId xmlns:a16="http://schemas.microsoft.com/office/drawing/2014/main" id="{B82F519D-474E-4740-ABC6-9E054717E812}"/>
+                <a16:creationId xmlns:a16="http://schemas.microsoft.com/office/drawing/2014/main" id="{ADD949DB-61DF-4576-A37E-35370D2F3927}"/>
               </a:ext>
             </a:extLst>
           </p:cNvPr>
@@ -4740,7 +4874,7 @@
           <p:cNvPr id="6" name="">
             <a:extLst xmlns:a="http://schemas.openxmlformats.org/drawingml/2006/main">
               <a:ext uri="{FF2B5EF4-FFF2-40B4-BE49-F238E27FC236}">
-                <a16:creationId xmlns:a16="http://schemas.microsoft.com/office/drawing/2014/main" id="{C0181C35-F3B8-4A85-915B-2E4AD5B365E1}"/>
+                <a16:creationId xmlns:a16="http://schemas.microsoft.com/office/drawing/2014/main" id="{FA102D37-BF07-4993-A3A2-66DC019CC64E}"/>
               </a:ext>
             </a:extLst>
           </p:cNvPr>
@@ -4770,7 +4904,7 @@
           <p:cNvPr id="7" name="">
             <a:extLst xmlns:a="http://schemas.openxmlformats.org/drawingml/2006/main">
               <a:ext uri="{FF2B5EF4-FFF2-40B4-BE49-F238E27FC236}">
-                <a16:creationId xmlns:a16="http://schemas.microsoft.com/office/drawing/2014/main" id="{B19B7DA6-08E1-43CE-A4C8-767A5203A7AB}"/>
+                <a16:creationId xmlns:a16="http://schemas.microsoft.com/office/drawing/2014/main" id="{CA7A335F-EDE4-472F-9AED-DF0CB8660DEB}"/>
               </a:ext>
             </a:extLst>
           </p:cNvPr>
@@ -4800,7 +4934,7 @@
           <p:cNvPr id="8" name="">
             <a:extLst xmlns:a="http://schemas.openxmlformats.org/drawingml/2006/main">
               <a:ext uri="{FF2B5EF4-FFF2-40B4-BE49-F238E27FC236}">
-                <a16:creationId xmlns:a16="http://schemas.microsoft.com/office/drawing/2014/main" id="{36A66222-066E-4CF7-BEFB-A6B700AB9897}"/>
+                <a16:creationId xmlns:a16="http://schemas.microsoft.com/office/drawing/2014/main" id="{DD778004-5755-4676-966C-F61D3719A4E9}"/>
               </a:ext>
             </a:extLst>
           </p:cNvPr>
@@ -4834,7 +4968,7 @@
           <p:cNvPr id="9" name="">
             <a:extLst xmlns:a="http://schemas.openxmlformats.org/drawingml/2006/main">
               <a:ext uri="{FF2B5EF4-FFF2-40B4-BE49-F238E27FC236}">
-                <a16:creationId xmlns:a16="http://schemas.microsoft.com/office/drawing/2014/main" id="{84922D67-AB2B-46C0-A061-035729A1E344}"/>
+                <a16:creationId xmlns:a16="http://schemas.microsoft.com/office/drawing/2014/main" id="{5E0C9C77-C8E5-4501-9867-778BC6AEE359}"/>
               </a:ext>
             </a:extLst>
           </p:cNvPr>
@@ -4866,7 +5000,7 @@
           <p:cNvPr id="10" name="">
             <a:extLst xmlns:a="http://schemas.openxmlformats.org/drawingml/2006/main">
               <a:ext uri="{FF2B5EF4-FFF2-40B4-BE49-F238E27FC236}">
-                <a16:creationId xmlns:a16="http://schemas.microsoft.com/office/drawing/2014/main" id="{B93A35D3-DC51-402E-A7B4-82B2334959EE}"/>
+                <a16:creationId xmlns:a16="http://schemas.microsoft.com/office/drawing/2014/main" id="{F109EE29-2449-4050-BC3C-C0147FAB6843}"/>
               </a:ext>
             </a:extLst>
           </p:cNvPr>
@@ -4923,7 +5057,7 @@
           <p:cNvPr id="11" name="">
             <a:extLst xmlns:a="http://schemas.openxmlformats.org/drawingml/2006/main">
               <a:ext uri="{FF2B5EF4-FFF2-40B4-BE49-F238E27FC236}">
-                <a16:creationId xmlns:a16="http://schemas.microsoft.com/office/drawing/2014/main" id="{29A4AF9B-935A-491D-96B6-A93AE494AA84}"/>
+                <a16:creationId xmlns:a16="http://schemas.microsoft.com/office/drawing/2014/main" id="{4FA68A43-1FA8-4586-8F3C-484E3F812EC1}"/>
               </a:ext>
             </a:extLst>
           </p:cNvPr>
@@ -5003,7 +5137,7 @@
           <p:cNvPr id="12" name="">
             <a:extLst xmlns:a="http://schemas.openxmlformats.org/drawingml/2006/main">
               <a:ext uri="{FF2B5EF4-FFF2-40B4-BE49-F238E27FC236}">
-                <a16:creationId xmlns:a16="http://schemas.microsoft.com/office/drawing/2014/main" id="{E20F883C-60F4-4EAE-AED9-52799DEEA06A}"/>
+                <a16:creationId xmlns:a16="http://schemas.microsoft.com/office/drawing/2014/main" id="{FC969F34-1C30-48DA-9D58-2B17569B5FA8}"/>
               </a:ext>
             </a:extLst>
           </p:cNvPr>
@@ -5037,7 +5171,7 @@
           <p:cNvPr id="13" name="">
             <a:extLst xmlns:a="http://schemas.openxmlformats.org/drawingml/2006/main">
               <a:ext uri="{FF2B5EF4-FFF2-40B4-BE49-F238E27FC236}">
-                <a16:creationId xmlns:a16="http://schemas.microsoft.com/office/drawing/2014/main" id="{A4D8EAE9-F7FA-442C-9FF8-067E166753BF}"/>
+                <a16:creationId xmlns:a16="http://schemas.microsoft.com/office/drawing/2014/main" id="{A26F0EAA-0C8A-47EB-8206-4E0346952D9F}"/>
               </a:ext>
             </a:extLst>
           </p:cNvPr>
@@ -5069,7 +5203,7 @@
           <p:cNvPr id="14" name="">
             <a:extLst xmlns:a="http://schemas.openxmlformats.org/drawingml/2006/main">
               <a:ext uri="{FF2B5EF4-FFF2-40B4-BE49-F238E27FC236}">
-                <a16:creationId xmlns:a16="http://schemas.microsoft.com/office/drawing/2014/main" id="{A969DC18-F3E5-4005-A829-9DA57830E70A}"/>
+                <a16:creationId xmlns:a16="http://schemas.microsoft.com/office/drawing/2014/main" id="{381D84C4-F1CE-4D1E-B341-5B10E700DDC9}"/>
               </a:ext>
             </a:extLst>
           </p:cNvPr>
@@ -5126,7 +5260,7 @@
           <p:cNvPr id="15" name="">
             <a:extLst xmlns:a="http://schemas.openxmlformats.org/drawingml/2006/main">
               <a:ext uri="{FF2B5EF4-FFF2-40B4-BE49-F238E27FC236}">
-                <a16:creationId xmlns:a16="http://schemas.microsoft.com/office/drawing/2014/main" id="{76E8FFF2-F883-4538-9315-90F24907C541}"/>
+                <a16:creationId xmlns:a16="http://schemas.microsoft.com/office/drawing/2014/main" id="{67DDE95F-9DAC-4577-A600-728A12ACA75E}"/>
               </a:ext>
             </a:extLst>
           </p:cNvPr>
@@ -5206,7 +5340,7 @@
           <p:cNvPr id="16" name="">
             <a:extLst xmlns:a="http://schemas.openxmlformats.org/drawingml/2006/main">
               <a:ext uri="{FF2B5EF4-FFF2-40B4-BE49-F238E27FC236}">
-                <a16:creationId xmlns:a16="http://schemas.microsoft.com/office/drawing/2014/main" id="{7586CCD1-6EE7-4CEB-AEF0-414A7E87CB62}"/>
+                <a16:creationId xmlns:a16="http://schemas.microsoft.com/office/drawing/2014/main" id="{07EE7B8A-857E-4160-AC3B-583856FC85CB}"/>
               </a:ext>
             </a:extLst>
           </p:cNvPr>
@@ -5240,7 +5374,7 @@
           <p:cNvPr id="17" name="">
             <a:extLst xmlns:a="http://schemas.openxmlformats.org/drawingml/2006/main">
               <a:ext uri="{FF2B5EF4-FFF2-40B4-BE49-F238E27FC236}">
-                <a16:creationId xmlns:a16="http://schemas.microsoft.com/office/drawing/2014/main" id="{CDD3FDDE-CD20-4DE8-BD5D-C98332A054B9}"/>
+                <a16:creationId xmlns:a16="http://schemas.microsoft.com/office/drawing/2014/main" id="{96844FA9-9F61-47C8-97FF-5A0CEF64B7B9}"/>
               </a:ext>
             </a:extLst>
           </p:cNvPr>
@@ -5272,7 +5406,7 @@
           <p:cNvPr id="18" name="">
             <a:extLst xmlns:a="http://schemas.openxmlformats.org/drawingml/2006/main">
               <a:ext uri="{FF2B5EF4-FFF2-40B4-BE49-F238E27FC236}">
-                <a16:creationId xmlns:a16="http://schemas.microsoft.com/office/drawing/2014/main" id="{10C75CD6-53D8-4EAF-912B-35EC511CCEB9}"/>
+                <a16:creationId xmlns:a16="http://schemas.microsoft.com/office/drawing/2014/main" id="{18EC2F2F-5345-4024-92F6-D26693A28630}"/>
               </a:ext>
             </a:extLst>
           </p:cNvPr>
@@ -5329,7 +5463,7 @@
           <p:cNvPr id="19" name="">
             <a:extLst xmlns:a="http://schemas.openxmlformats.org/drawingml/2006/main">
               <a:ext uri="{FF2B5EF4-FFF2-40B4-BE49-F238E27FC236}">
-                <a16:creationId xmlns:a16="http://schemas.microsoft.com/office/drawing/2014/main" id="{3AB5CE7A-7A06-46B3-9602-AF75B2AA2AC3}"/>
+                <a16:creationId xmlns:a16="http://schemas.microsoft.com/office/drawing/2014/main" id="{583C2BBD-8BEF-40A7-8071-5EB3AD88FEFC}"/>
               </a:ext>
             </a:extLst>
           </p:cNvPr>
@@ -5409,7 +5543,7 @@
           <p:cNvPr id="20" name="">
             <a:extLst xmlns:a="http://schemas.openxmlformats.org/drawingml/2006/main">
               <a:ext uri="{FF2B5EF4-FFF2-40B4-BE49-F238E27FC236}">
-                <a16:creationId xmlns:a16="http://schemas.microsoft.com/office/drawing/2014/main" id="{875771E9-FACB-4695-9D9B-FED46D16A22C}"/>
+                <a16:creationId xmlns:a16="http://schemas.microsoft.com/office/drawing/2014/main" id="{54C6E585-30E4-41D0-91A1-C5806B49AD06}"/>
               </a:ext>
             </a:extLst>
           </p:cNvPr>
@@ -5466,7 +5600,7 @@
           <p:cNvPr id="21" name="">
             <a:extLst xmlns:a="http://schemas.openxmlformats.org/drawingml/2006/main">
               <a:ext uri="{FF2B5EF4-FFF2-40B4-BE49-F238E27FC236}">
-                <a16:creationId xmlns:a16="http://schemas.microsoft.com/office/drawing/2014/main" id="{93CEF16E-17EB-4274-8A9E-3E3EC57B480D}"/>
+                <a16:creationId xmlns:a16="http://schemas.microsoft.com/office/drawing/2014/main" id="{3A6E89C9-F6BE-46D8-810C-2E768043555A}"/>
               </a:ext>
             </a:extLst>
           </p:cNvPr>
@@ -5523,7 +5657,7 @@
           <p:cNvPr id="22" name="">
             <a:extLst xmlns:a="http://schemas.openxmlformats.org/drawingml/2006/main">
               <a:ext uri="{FF2B5EF4-FFF2-40B4-BE49-F238E27FC236}">
-                <a16:creationId xmlns:a16="http://schemas.microsoft.com/office/drawing/2014/main" id="{591BED53-FC78-4E32-B9F3-8356D001F3FC}"/>
+                <a16:creationId xmlns:a16="http://schemas.microsoft.com/office/drawing/2014/main" id="{BA612B66-CDAD-438C-A7E1-4FB9A1D268A5}"/>
               </a:ext>
             </a:extLst>
           </p:cNvPr>
@@ -5578,7 +5712,1736 @@
     </p:spTree>
     <p:extLst>
       <p:ext uri="{BB962C8B-B14F-4D97-AF65-F5344CB8AC3E}">
-        <p14:creationId xmlns:p14="http://schemas.microsoft.com/office/powerpoint/2010/main" val="1883962070"/>
+        <p14:creationId xmlns:p14="http://schemas.microsoft.com/office/powerpoint/2010/main" val="1805129058"/>
+      </p:ext>
+    </p:extLst>
+  </p:cSld>
+</p:sld>
+</file>
+
+<file path=ppt/slides/slide12.xml><?xml version="1.0" encoding="utf-8"?>
+<p:sld xmlns:p="http://schemas.openxmlformats.org/presentationml/2006/main">
+  <p:cSld>
+    <p:spTree>
+      <p:nvGrpSpPr>
+        <p:cNvPr id="1" name=""/>
+        <p:cNvGrpSpPr/>
+        <p:nvPr/>
+      </p:nvGrpSpPr>
+      <p:grpSpPr>
+        <a:xfrm xmlns:a="http://schemas.openxmlformats.org/drawingml/2006/main"/>
+      </p:grpSpPr>
+      <p:sp>
+        <p:nvSpPr>
+          <p:cNvPr id="26" name="">
+            <a:extLst xmlns:a="http://schemas.openxmlformats.org/drawingml/2006/main">
+              <a:ext uri="{FF2B5EF4-FFF2-40B4-BE49-F238E27FC236}">
+                <a16:creationId xmlns:a16="http://schemas.microsoft.com/office/drawing/2014/main" id="{4F0E697E-754C-47C4-A0E2-E627211B6A80}"/>
+              </a:ext>
+            </a:extLst>
+          </p:cNvPr>
+          <p:cNvSpPr>
+            <a:spLocks xmlns:a="http://schemas.openxmlformats.org/drawingml/2006/main" noGrp="1"/>
+          </p:cNvSpPr>
+          <p:nvPr/>
+        </p:nvSpPr>
+        <p:spPr>
+          <a:xfrm xmlns:a="http://schemas.openxmlformats.org/drawingml/2006/main">
+            <a:off x="0" y="0"/>
+            <a:ext cx="12192000" cy="6858000"/>
+          </a:xfrm>
+          <a:prstGeom xmlns:a="http://schemas.openxmlformats.org/drawingml/2006/main" prst="rect">
+            <a:avLst/>
+          </a:prstGeom>
+          <a:solidFill xmlns:a="http://schemas.openxmlformats.org/drawingml/2006/main">
+            <a:srgbClr val="DDE8F6"/>
+          </a:solidFill>
+          <a:ln xmlns:a="http://schemas.openxmlformats.org/drawingml/2006/main" w="0">
+            <a:noFill/>
+          </a:ln>
+        </p:spPr>
+      </p:sp>
+      <p:sp>
+        <p:nvSpPr>
+          <p:cNvPr id="2" name="">
+            <a:extLst xmlns:a="http://schemas.openxmlformats.org/drawingml/2006/main">
+              <a:ext uri="{FF2B5EF4-FFF2-40B4-BE49-F238E27FC236}">
+                <a16:creationId xmlns:a16="http://schemas.microsoft.com/office/drawing/2014/main" id="{720EA545-27DA-4A6E-B2A2-4F3EB1AE6F9C}"/>
+              </a:ext>
+            </a:extLst>
+          </p:cNvPr>
+          <p:cNvSpPr>
+            <a:spLocks xmlns:a="http://schemas.openxmlformats.org/drawingml/2006/main" noGrp="1"/>
+          </p:cNvSpPr>
+          <p:nvPr/>
+        </p:nvSpPr>
+        <p:spPr>
+          <a:xfrm xmlns:a="http://schemas.openxmlformats.org/drawingml/2006/main">
+            <a:off x="685800" y="419100"/>
+            <a:ext cx="666750" cy="209550"/>
+          </a:xfrm>
+          <a:prstGeom xmlns:a="http://schemas.openxmlformats.org/drawingml/2006/main" prst="rect">
+            <a:avLst/>
+          </a:prstGeom>
+          <a:noFill xmlns:a="http://schemas.openxmlformats.org/drawingml/2006/main"/>
+          <a:ln xmlns:a="http://schemas.openxmlformats.org/drawingml/2006/main" w="0">
+            <a:noFill/>
+          </a:ln>
+        </p:spPr>
+        <p:txBody>
+          <a:bodyPr xmlns:a="http://schemas.openxmlformats.org/drawingml/2006/main">
+            <a:noAutofit/>
+          </a:bodyPr>
+          <a:lstStyle xmlns:a="http://schemas.openxmlformats.org/drawingml/2006/main"/>
+          <a:p xmlns:a="http://schemas.openxmlformats.org/drawingml/2006/main">
+            <a:pPr>
+              <a:defRPr sz="1200" b="1">
+                <a:solidFill>
+                  <a:srgbClr val="E7A048"/>
+                </a:solidFill>
+                <a:latin typeface="Arial"/>
+                <a:ea typeface="Arial"/>
+                <a:cs typeface="Arial"/>
+              </a:defRPr>
+            </a:pPr>
+            <a:r>
+              <a:rPr sz="1200" b="1">
+                <a:solidFill>
+                  <a:srgbClr val="E7A048"/>
+                </a:solidFill>
+                <a:latin typeface="Arial"/>
+                <a:ea typeface="Arial"/>
+                <a:cs typeface="Arial"/>
+              </a:rPr>
+              <a:t>12</a:t>
+            </a:r>
+          </a:p>
+        </p:txBody>
+      </p:sp>
+      <p:sp>
+        <p:nvSpPr>
+          <p:cNvPr id="3" name="">
+            <a:extLst xmlns:a="http://schemas.openxmlformats.org/drawingml/2006/main">
+              <a:ext uri="{FF2B5EF4-FFF2-40B4-BE49-F238E27FC236}">
+                <a16:creationId xmlns:a16="http://schemas.microsoft.com/office/drawing/2014/main" id="{BC752B34-FF07-4259-8E84-21B22739D155}"/>
+              </a:ext>
+            </a:extLst>
+          </p:cNvPr>
+          <p:cNvSpPr>
+            <a:spLocks xmlns:a="http://schemas.openxmlformats.org/drawingml/2006/main" noGrp="1"/>
+          </p:cNvSpPr>
+          <p:nvPr/>
+        </p:nvSpPr>
+        <p:spPr>
+          <a:xfrm xmlns:a="http://schemas.openxmlformats.org/drawingml/2006/main">
+            <a:off x="9810750" y="428625"/>
+            <a:ext cx="1695450" cy="190500"/>
+          </a:xfrm>
+          <a:prstGeom xmlns:a="http://schemas.openxmlformats.org/drawingml/2006/main" prst="rect">
+            <a:avLst/>
+          </a:prstGeom>
+          <a:noFill xmlns:a="http://schemas.openxmlformats.org/drawingml/2006/main"/>
+          <a:ln xmlns:a="http://schemas.openxmlformats.org/drawingml/2006/main" w="0">
+            <a:noFill/>
+          </a:ln>
+        </p:spPr>
+        <p:txBody>
+          <a:bodyPr xmlns:a="http://schemas.openxmlformats.org/drawingml/2006/main">
+            <a:noAutofit/>
+          </a:bodyPr>
+          <a:lstStyle xmlns:a="http://schemas.openxmlformats.org/drawingml/2006/main"/>
+          <a:p xmlns:a="http://schemas.openxmlformats.org/drawingml/2006/main">
+            <a:pPr algn="r">
+              <a:defRPr sz="975" b="1">
+                <a:solidFill>
+                  <a:srgbClr val="4656A8"/>
+                </a:solidFill>
+                <a:latin typeface="Arial"/>
+                <a:ea typeface="Arial"/>
+                <a:cs typeface="Arial"/>
+              </a:defRPr>
+            </a:pPr>
+            <a:r>
+              <a:rPr sz="975" b="1">
+                <a:solidFill>
+                  <a:srgbClr val="4656A8"/>
+                </a:solidFill>
+                <a:latin typeface="Arial"/>
+                <a:ea typeface="Arial"/>
+                <a:cs typeface="Arial"/>
+              </a:rPr>
+              <a:t>NETRAJYOTI AI</a:t>
+            </a:r>
+          </a:p>
+        </p:txBody>
+      </p:sp>
+      <p:sp>
+        <p:nvSpPr>
+          <p:cNvPr id="4" name="">
+            <a:extLst xmlns:a="http://schemas.openxmlformats.org/drawingml/2006/main">
+              <a:ext uri="{FF2B5EF4-FFF2-40B4-BE49-F238E27FC236}">
+                <a16:creationId xmlns:a16="http://schemas.microsoft.com/office/drawing/2014/main" id="{9BEC4659-FBBA-4175-819D-AEA48668BCA1}"/>
+              </a:ext>
+            </a:extLst>
+          </p:cNvPr>
+          <p:cNvSpPr>
+            <a:spLocks xmlns:a="http://schemas.openxmlformats.org/drawingml/2006/main" noGrp="1"/>
+          </p:cNvSpPr>
+          <p:nvPr/>
+        </p:nvSpPr>
+        <p:spPr>
+          <a:xfrm xmlns:a="http://schemas.openxmlformats.org/drawingml/2006/main">
+            <a:off x="685800" y="762000"/>
+            <a:ext cx="10287000" cy="457200"/>
+          </a:xfrm>
+          <a:prstGeom xmlns:a="http://schemas.openxmlformats.org/drawingml/2006/main" prst="rect">
+            <a:avLst/>
+          </a:prstGeom>
+          <a:noFill xmlns:a="http://schemas.openxmlformats.org/drawingml/2006/main"/>
+          <a:ln xmlns:a="http://schemas.openxmlformats.org/drawingml/2006/main" w="0">
+            <a:noFill/>
+          </a:ln>
+        </p:spPr>
+        <p:txBody>
+          <a:bodyPr xmlns:a="http://schemas.openxmlformats.org/drawingml/2006/main">
+            <a:noAutofit/>
+          </a:bodyPr>
+          <a:lstStyle xmlns:a="http://schemas.openxmlformats.org/drawingml/2006/main"/>
+          <a:p xmlns:a="http://schemas.openxmlformats.org/drawingml/2006/main">
+            <a:pPr>
+              <a:defRPr sz="2550" b="1">
+                <a:solidFill>
+                  <a:srgbClr val="202A44"/>
+                </a:solidFill>
+                <a:latin typeface="Arial"/>
+                <a:ea typeface="Arial"/>
+                <a:cs typeface="Arial"/>
+              </a:defRPr>
+            </a:pPr>
+            <a:r>
+              <a:rPr sz="2550" b="1">
+                <a:solidFill>
+                  <a:srgbClr val="202A44"/>
+                </a:solidFill>
+                <a:latin typeface="Arial"/>
+                <a:ea typeface="Arial"/>
+                <a:cs typeface="Arial"/>
+              </a:rPr>
+              <a:t>Live demonstration</a:t>
+            </a:r>
+          </a:p>
+        </p:txBody>
+      </p:sp>
+      <p:sp>
+        <p:nvSpPr>
+          <p:cNvPr id="5" name="">
+            <a:extLst xmlns:a="http://schemas.openxmlformats.org/drawingml/2006/main">
+              <a:ext uri="{FF2B5EF4-FFF2-40B4-BE49-F238E27FC236}">
+                <a16:creationId xmlns:a16="http://schemas.microsoft.com/office/drawing/2014/main" id="{3A841A6A-EC76-40FC-B5AE-F09837975FB8}"/>
+              </a:ext>
+            </a:extLst>
+          </p:cNvPr>
+          <p:cNvSpPr>
+            <a:spLocks xmlns:a="http://schemas.openxmlformats.org/drawingml/2006/main" noGrp="1"/>
+          </p:cNvSpPr>
+          <p:nvPr/>
+        </p:nvSpPr>
+        <p:spPr>
+          <a:xfrm xmlns:a="http://schemas.openxmlformats.org/drawingml/2006/main">
+            <a:off x="704850" y="1343025"/>
+            <a:ext cx="10287000" cy="266700"/>
+          </a:xfrm>
+          <a:prstGeom xmlns:a="http://schemas.openxmlformats.org/drawingml/2006/main" prst="rect">
+            <a:avLst/>
+          </a:prstGeom>
+          <a:noFill xmlns:a="http://schemas.openxmlformats.org/drawingml/2006/main"/>
+          <a:ln xmlns:a="http://schemas.openxmlformats.org/drawingml/2006/main" w="0">
+            <a:noFill/>
+          </a:ln>
+        </p:spPr>
+        <p:txBody>
+          <a:bodyPr xmlns:a="http://schemas.openxmlformats.org/drawingml/2006/main">
+            <a:noAutofit/>
+          </a:bodyPr>
+          <a:lstStyle xmlns:a="http://schemas.openxmlformats.org/drawingml/2006/main"/>
+          <a:p xmlns:a="http://schemas.openxmlformats.org/drawingml/2006/main">
+            <a:pPr>
+              <a:defRPr sz="1275">
+                <a:solidFill>
+                  <a:srgbClr val="56647A"/>
+                </a:solidFill>
+                <a:latin typeface="Arial"/>
+                <a:ea typeface="Arial"/>
+                <a:cs typeface="Arial"/>
+              </a:defRPr>
+            </a:pPr>
+            <a:r>
+              <a:rPr sz="1275">
+                <a:solidFill>
+                  <a:srgbClr val="56647A"/>
+                </a:solidFill>
+                <a:latin typeface="Arial"/>
+                <a:ea typeface="Arial"/>
+                <a:cs typeface="Arial"/>
+              </a:rPr>
+              <a:t>A short walkthrough of the user journey and the locked safety-route decision</a:t>
+            </a:r>
+          </a:p>
+        </p:txBody>
+      </p:sp>
+      <p:sp>
+        <p:nvSpPr>
+          <p:cNvPr id="6" name="">
+            <a:extLst xmlns:a="http://schemas.openxmlformats.org/drawingml/2006/main">
+              <a:ext uri="{FF2B5EF4-FFF2-40B4-BE49-F238E27FC236}">
+                <a16:creationId xmlns:a16="http://schemas.microsoft.com/office/drawing/2014/main" id="{E33EAA7A-4905-4827-B158-36F7AE6A86FD}"/>
+              </a:ext>
+            </a:extLst>
+          </p:cNvPr>
+          <p:cNvSpPr>
+            <a:spLocks xmlns:a="http://schemas.openxmlformats.org/drawingml/2006/main" noGrp="1"/>
+          </p:cNvSpPr>
+          <p:nvPr/>
+        </p:nvSpPr>
+        <p:spPr>
+          <a:xfrm xmlns:a="http://schemas.openxmlformats.org/drawingml/2006/main">
+            <a:off x="685800" y="1752600"/>
+            <a:ext cx="10820400" cy="19050"/>
+          </a:xfrm>
+          <a:prstGeom xmlns:a="http://schemas.openxmlformats.org/drawingml/2006/main" prst="rect">
+            <a:avLst/>
+          </a:prstGeom>
+          <a:solidFill xmlns:a="http://schemas.openxmlformats.org/drawingml/2006/main">
+            <a:srgbClr val="D7D0C7"/>
+          </a:solidFill>
+          <a:ln xmlns:a="http://schemas.openxmlformats.org/drawingml/2006/main" w="0">
+            <a:noFill/>
+          </a:ln>
+        </p:spPr>
+      </p:sp>
+      <p:sp>
+        <p:nvSpPr>
+          <p:cNvPr id="7" name="">
+            <a:extLst xmlns:a="http://schemas.openxmlformats.org/drawingml/2006/main">
+              <a:ext uri="{FF2B5EF4-FFF2-40B4-BE49-F238E27FC236}">
+                <a16:creationId xmlns:a16="http://schemas.microsoft.com/office/drawing/2014/main" id="{211EE4B8-4581-448A-A05A-F7D17713EB39}"/>
+              </a:ext>
+            </a:extLst>
+          </p:cNvPr>
+          <p:cNvSpPr>
+            <a:spLocks xmlns:a="http://schemas.openxmlformats.org/drawingml/2006/main" noGrp="1"/>
+          </p:cNvSpPr>
+          <p:nvPr/>
+        </p:nvSpPr>
+        <p:spPr>
+          <a:xfrm xmlns:a="http://schemas.openxmlformats.org/drawingml/2006/main">
+            <a:off x="952500" y="2667000"/>
+            <a:ext cx="1524000" cy="171450"/>
+          </a:xfrm>
+          <a:prstGeom xmlns:a="http://schemas.openxmlformats.org/drawingml/2006/main" prst="rect">
+            <a:avLst/>
+          </a:prstGeom>
+          <a:noFill xmlns:a="http://schemas.openxmlformats.org/drawingml/2006/main"/>
+          <a:ln xmlns:a="http://schemas.openxmlformats.org/drawingml/2006/main" w="0">
+            <a:noFill/>
+          </a:ln>
+        </p:spPr>
+        <p:txBody>
+          <a:bodyPr xmlns:a="http://schemas.openxmlformats.org/drawingml/2006/main">
+            <a:noAutofit/>
+          </a:bodyPr>
+          <a:lstStyle xmlns:a="http://schemas.openxmlformats.org/drawingml/2006/main"/>
+          <a:p xmlns:a="http://schemas.openxmlformats.org/drawingml/2006/main">
+            <a:pPr>
+              <a:defRPr sz="1050" b="1">
+                <a:solidFill>
+                  <a:srgbClr val="4656A8"/>
+                </a:solidFill>
+                <a:latin typeface="Arial"/>
+                <a:ea typeface="Arial"/>
+                <a:cs typeface="Arial"/>
+              </a:defRPr>
+            </a:pPr>
+            <a:r>
+              <a:rPr sz="1050" b="1">
+                <a:solidFill>
+                  <a:srgbClr val="4656A8"/>
+                </a:solidFill>
+                <a:latin typeface="Arial"/>
+                <a:ea typeface="Arial"/>
+                <a:cs typeface="Arial"/>
+              </a:rPr>
+              <a:t>DEMO FLOW</a:t>
+            </a:r>
+          </a:p>
+        </p:txBody>
+      </p:sp>
+      <p:sp>
+        <p:nvSpPr>
+          <p:cNvPr id="8" name="">
+            <a:extLst xmlns:a="http://schemas.openxmlformats.org/drawingml/2006/main">
+              <a:ext uri="{FF2B5EF4-FFF2-40B4-BE49-F238E27FC236}">
+                <a16:creationId xmlns:a16="http://schemas.microsoft.com/office/drawing/2014/main" id="{00FC1634-FBA3-4C15-9B2E-3EDF9E22FFB6}"/>
+              </a:ext>
+            </a:extLst>
+          </p:cNvPr>
+          <p:cNvSpPr>
+            <a:spLocks xmlns:a="http://schemas.openxmlformats.org/drawingml/2006/main" noGrp="1"/>
+          </p:cNvSpPr>
+          <p:nvPr/>
+        </p:nvSpPr>
+        <p:spPr>
+          <a:xfrm xmlns:a="http://schemas.openxmlformats.org/drawingml/2006/main">
+            <a:off x="952500" y="3143250"/>
+            <a:ext cx="2857500" cy="1809750"/>
+          </a:xfrm>
+          <a:prstGeom xmlns:a="http://schemas.openxmlformats.org/drawingml/2006/main" prst="roundRect">
+            <a:avLst>
+              <a:gd name="adj" fmla="val 4211"/>
+            </a:avLst>
+          </a:prstGeom>
+          <a:solidFill xmlns:a="http://schemas.openxmlformats.org/drawingml/2006/main">
+            <a:srgbClr val="FFFFFF"/>
+          </a:solidFill>
+          <a:ln xmlns:a="http://schemas.openxmlformats.org/drawingml/2006/main" w="9525">
+            <a:solidFill>
+              <a:srgbClr val="D7D0C7"/>
+            </a:solidFill>
+          </a:ln>
+        </p:spPr>
+      </p:sp>
+      <p:sp>
+        <p:nvSpPr>
+          <p:cNvPr id="9" name="">
+            <a:extLst xmlns:a="http://schemas.openxmlformats.org/drawingml/2006/main">
+              <a:ext uri="{FF2B5EF4-FFF2-40B4-BE49-F238E27FC236}">
+                <a16:creationId xmlns:a16="http://schemas.microsoft.com/office/drawing/2014/main" id="{DC6D74A0-FF8D-4EEC-8146-3E5EF6D6DE64}"/>
+              </a:ext>
+            </a:extLst>
+          </p:cNvPr>
+          <p:cNvSpPr>
+            <a:spLocks xmlns:a="http://schemas.openxmlformats.org/drawingml/2006/main" noGrp="1"/>
+          </p:cNvSpPr>
+          <p:nvPr/>
+        </p:nvSpPr>
+        <p:spPr>
+          <a:xfrm xmlns:a="http://schemas.openxmlformats.org/drawingml/2006/main">
+            <a:off x="1219200" y="3429000"/>
+            <a:ext cx="457200" cy="457200"/>
+          </a:xfrm>
+          <a:prstGeom xmlns:a="http://schemas.openxmlformats.org/drawingml/2006/main" prst="ellipse">
+            <a:avLst/>
+          </a:prstGeom>
+          <a:solidFill xmlns:a="http://schemas.openxmlformats.org/drawingml/2006/main">
+            <a:srgbClr val="237A7A"/>
+          </a:solidFill>
+          <a:ln xmlns:a="http://schemas.openxmlformats.org/drawingml/2006/main" w="0">
+            <a:noFill/>
+          </a:ln>
+        </p:spPr>
+      </p:sp>
+      <p:sp>
+        <p:nvSpPr>
+          <p:cNvPr id="10" name="">
+            <a:extLst xmlns:a="http://schemas.openxmlformats.org/drawingml/2006/main">
+              <a:ext uri="{FF2B5EF4-FFF2-40B4-BE49-F238E27FC236}">
+                <a16:creationId xmlns:a16="http://schemas.microsoft.com/office/drawing/2014/main" id="{7B3A0C1A-0ED5-4721-A0D9-A912C4380BDD}"/>
+              </a:ext>
+            </a:extLst>
+          </p:cNvPr>
+          <p:cNvSpPr>
+            <a:spLocks xmlns:a="http://schemas.openxmlformats.org/drawingml/2006/main" noGrp="1"/>
+          </p:cNvSpPr>
+          <p:nvPr/>
+        </p:nvSpPr>
+        <p:spPr>
+          <a:xfrm xmlns:a="http://schemas.openxmlformats.org/drawingml/2006/main">
+            <a:off x="1219200" y="3524250"/>
+            <a:ext cx="457200" cy="209550"/>
+          </a:xfrm>
+          <a:prstGeom xmlns:a="http://schemas.openxmlformats.org/drawingml/2006/main" prst="rect">
+            <a:avLst/>
+          </a:prstGeom>
+          <a:noFill xmlns:a="http://schemas.openxmlformats.org/drawingml/2006/main"/>
+          <a:ln xmlns:a="http://schemas.openxmlformats.org/drawingml/2006/main" w="0">
+            <a:noFill/>
+          </a:ln>
+        </p:spPr>
+        <p:txBody>
+          <a:bodyPr xmlns:a="http://schemas.openxmlformats.org/drawingml/2006/main">
+            <a:noAutofit/>
+          </a:bodyPr>
+          <a:lstStyle xmlns:a="http://schemas.openxmlformats.org/drawingml/2006/main"/>
+          <a:p xmlns:a="http://schemas.openxmlformats.org/drawingml/2006/main">
+            <a:pPr algn="ctr">
+              <a:defRPr sz="1425" b="1">
+                <a:solidFill>
+                  <a:srgbClr val="FFFFFF"/>
+                </a:solidFill>
+                <a:latin typeface="Arial"/>
+                <a:ea typeface="Arial"/>
+                <a:cs typeface="Arial"/>
+              </a:defRPr>
+            </a:pPr>
+            <a:r>
+              <a:rPr sz="1425" b="1">
+                <a:solidFill>
+                  <a:srgbClr val="FFFFFF"/>
+                </a:solidFill>
+                <a:latin typeface="Arial"/>
+                <a:ea typeface="Arial"/>
+                <a:cs typeface="Arial"/>
+              </a:rPr>
+              <a:t>1</a:t>
+            </a:r>
+          </a:p>
+        </p:txBody>
+      </p:sp>
+      <p:sp>
+        <p:nvSpPr>
+          <p:cNvPr id="11" name="">
+            <a:extLst xmlns:a="http://schemas.openxmlformats.org/drawingml/2006/main">
+              <a:ext uri="{FF2B5EF4-FFF2-40B4-BE49-F238E27FC236}">
+                <a16:creationId xmlns:a16="http://schemas.microsoft.com/office/drawing/2014/main" id="{201139BA-8712-4F70-8909-021870918B29}"/>
+              </a:ext>
+            </a:extLst>
+          </p:cNvPr>
+          <p:cNvSpPr>
+            <a:spLocks xmlns:a="http://schemas.openxmlformats.org/drawingml/2006/main" noGrp="1"/>
+          </p:cNvSpPr>
+          <p:nvPr/>
+        </p:nvSpPr>
+        <p:spPr>
+          <a:xfrm xmlns:a="http://schemas.openxmlformats.org/drawingml/2006/main">
+            <a:off x="1219200" y="4095750"/>
+            <a:ext cx="2324100" cy="266700"/>
+          </a:xfrm>
+          <a:prstGeom xmlns:a="http://schemas.openxmlformats.org/drawingml/2006/main" prst="rect">
+            <a:avLst/>
+          </a:prstGeom>
+          <a:noFill xmlns:a="http://schemas.openxmlformats.org/drawingml/2006/main"/>
+          <a:ln xmlns:a="http://schemas.openxmlformats.org/drawingml/2006/main" w="0">
+            <a:noFill/>
+          </a:ln>
+        </p:spPr>
+        <p:txBody>
+          <a:bodyPr xmlns:a="http://schemas.openxmlformats.org/drawingml/2006/main">
+            <a:noAutofit/>
+          </a:bodyPr>
+          <a:lstStyle xmlns:a="http://schemas.openxmlformats.org/drawingml/2006/main"/>
+          <a:p xmlns:a="http://schemas.openxmlformats.org/drawingml/2006/main">
+            <a:pPr>
+              <a:defRPr sz="1350" b="1">
+                <a:solidFill>
+                  <a:srgbClr val="202A44"/>
+                </a:solidFill>
+                <a:latin typeface="Arial"/>
+                <a:ea typeface="Arial"/>
+                <a:cs typeface="Arial"/>
+              </a:defRPr>
+            </a:pPr>
+            <a:r>
+              <a:rPr sz="1350" b="1">
+                <a:solidFill>
+                  <a:srgbClr val="202A44"/>
+                </a:solidFill>
+                <a:latin typeface="Arial"/>
+                <a:ea typeface="Arial"/>
+                <a:cs typeface="Arial"/>
+              </a:rPr>
+              <a:t>Start the Bengali journey</a:t>
+            </a:r>
+          </a:p>
+        </p:txBody>
+      </p:sp>
+      <p:sp>
+        <p:nvSpPr>
+          <p:cNvPr id="12" name="">
+            <a:extLst xmlns:a="http://schemas.openxmlformats.org/drawingml/2006/main">
+              <a:ext uri="{FF2B5EF4-FFF2-40B4-BE49-F238E27FC236}">
+                <a16:creationId xmlns:a16="http://schemas.microsoft.com/office/drawing/2014/main" id="{00FD03B9-F1B5-41B6-AB95-8EBB68316011}"/>
+              </a:ext>
+            </a:extLst>
+          </p:cNvPr>
+          <p:cNvSpPr>
+            <a:spLocks xmlns:a="http://schemas.openxmlformats.org/drawingml/2006/main" noGrp="1"/>
+          </p:cNvSpPr>
+          <p:nvPr/>
+        </p:nvSpPr>
+        <p:spPr>
+          <a:xfrm xmlns:a="http://schemas.openxmlformats.org/drawingml/2006/main">
+            <a:off x="1219200" y="4476750"/>
+            <a:ext cx="2324100" cy="266700"/>
+          </a:xfrm>
+          <a:prstGeom xmlns:a="http://schemas.openxmlformats.org/drawingml/2006/main" prst="rect">
+            <a:avLst/>
+          </a:prstGeom>
+          <a:noFill xmlns:a="http://schemas.openxmlformats.org/drawingml/2006/main"/>
+          <a:ln xmlns:a="http://schemas.openxmlformats.org/drawingml/2006/main" w="0">
+            <a:noFill/>
+          </a:ln>
+        </p:spPr>
+        <p:txBody>
+          <a:bodyPr xmlns:a="http://schemas.openxmlformats.org/drawingml/2006/main">
+            <a:noAutofit/>
+          </a:bodyPr>
+          <a:lstStyle xmlns:a="http://schemas.openxmlformats.org/drawingml/2006/main"/>
+          <a:p xmlns:a="http://schemas.openxmlformats.org/drawingml/2006/main">
+            <a:pPr>
+              <a:defRPr sz="1050">
+                <a:solidFill>
+                  <a:srgbClr val="56647A"/>
+                </a:solidFill>
+                <a:latin typeface="Arial"/>
+                <a:ea typeface="Arial"/>
+                <a:cs typeface="Arial"/>
+              </a:defRPr>
+            </a:pPr>
+            <a:r>
+              <a:rPr sz="1050">
+                <a:solidFill>
+                  <a:srgbClr val="56647A"/>
+                </a:solidFill>
+                <a:latin typeface="Arial"/>
+                <a:ea typeface="Arial"/>
+                <a:cs typeface="Arial"/>
+              </a:rPr>
+              <a:t>Choose voice or text input</a:t>
+            </a:r>
+          </a:p>
+        </p:txBody>
+      </p:sp>
+      <p:sp>
+        <p:nvSpPr>
+          <p:cNvPr id="13" name="">
+            <a:extLst xmlns:a="http://schemas.openxmlformats.org/drawingml/2006/main">
+              <a:ext uri="{FF2B5EF4-FFF2-40B4-BE49-F238E27FC236}">
+                <a16:creationId xmlns:a16="http://schemas.microsoft.com/office/drawing/2014/main" id="{F1B68324-3409-4414-83D2-DB5FAFAB97DB}"/>
+              </a:ext>
+            </a:extLst>
+          </p:cNvPr>
+          <p:cNvSpPr>
+            <a:spLocks xmlns:a="http://schemas.openxmlformats.org/drawingml/2006/main" noGrp="1"/>
+          </p:cNvSpPr>
+          <p:nvPr/>
+        </p:nvSpPr>
+        <p:spPr>
+          <a:xfrm xmlns:a="http://schemas.openxmlformats.org/drawingml/2006/main">
+            <a:off x="4381500" y="3143250"/>
+            <a:ext cx="2857500" cy="1809750"/>
+          </a:xfrm>
+          <a:prstGeom xmlns:a="http://schemas.openxmlformats.org/drawingml/2006/main" prst="roundRect">
+            <a:avLst>
+              <a:gd name="adj" fmla="val 4211"/>
+            </a:avLst>
+          </a:prstGeom>
+          <a:solidFill xmlns:a="http://schemas.openxmlformats.org/drawingml/2006/main">
+            <a:srgbClr val="FFFFFF"/>
+          </a:solidFill>
+          <a:ln xmlns:a="http://schemas.openxmlformats.org/drawingml/2006/main" w="9525">
+            <a:solidFill>
+              <a:srgbClr val="D7D0C7"/>
+            </a:solidFill>
+          </a:ln>
+        </p:spPr>
+      </p:sp>
+      <p:sp>
+        <p:nvSpPr>
+          <p:cNvPr id="14" name="">
+            <a:extLst xmlns:a="http://schemas.openxmlformats.org/drawingml/2006/main">
+              <a:ext uri="{FF2B5EF4-FFF2-40B4-BE49-F238E27FC236}">
+                <a16:creationId xmlns:a16="http://schemas.microsoft.com/office/drawing/2014/main" id="{CCD1B659-2D31-4E4E-9233-A59069F53318}"/>
+              </a:ext>
+            </a:extLst>
+          </p:cNvPr>
+          <p:cNvSpPr>
+            <a:spLocks xmlns:a="http://schemas.openxmlformats.org/drawingml/2006/main" noGrp="1"/>
+          </p:cNvSpPr>
+          <p:nvPr/>
+        </p:nvSpPr>
+        <p:spPr>
+          <a:xfrm xmlns:a="http://schemas.openxmlformats.org/drawingml/2006/main">
+            <a:off x="4648200" y="3429000"/>
+            <a:ext cx="457200" cy="457200"/>
+          </a:xfrm>
+          <a:prstGeom xmlns:a="http://schemas.openxmlformats.org/drawingml/2006/main" prst="ellipse">
+            <a:avLst/>
+          </a:prstGeom>
+          <a:solidFill xmlns:a="http://schemas.openxmlformats.org/drawingml/2006/main">
+            <a:srgbClr val="4656A8"/>
+          </a:solidFill>
+          <a:ln xmlns:a="http://schemas.openxmlformats.org/drawingml/2006/main" w="0">
+            <a:noFill/>
+          </a:ln>
+        </p:spPr>
+      </p:sp>
+      <p:sp>
+        <p:nvSpPr>
+          <p:cNvPr id="15" name="">
+            <a:extLst xmlns:a="http://schemas.openxmlformats.org/drawingml/2006/main">
+              <a:ext uri="{FF2B5EF4-FFF2-40B4-BE49-F238E27FC236}">
+                <a16:creationId xmlns:a16="http://schemas.microsoft.com/office/drawing/2014/main" id="{4FA4FB7A-AC2F-498B-850A-E6A27E5A4602}"/>
+              </a:ext>
+            </a:extLst>
+          </p:cNvPr>
+          <p:cNvSpPr>
+            <a:spLocks xmlns:a="http://schemas.openxmlformats.org/drawingml/2006/main" noGrp="1"/>
+          </p:cNvSpPr>
+          <p:nvPr/>
+        </p:nvSpPr>
+        <p:spPr>
+          <a:xfrm xmlns:a="http://schemas.openxmlformats.org/drawingml/2006/main">
+            <a:off x="4648200" y="3524250"/>
+            <a:ext cx="457200" cy="209550"/>
+          </a:xfrm>
+          <a:prstGeom xmlns:a="http://schemas.openxmlformats.org/drawingml/2006/main" prst="rect">
+            <a:avLst/>
+          </a:prstGeom>
+          <a:noFill xmlns:a="http://schemas.openxmlformats.org/drawingml/2006/main"/>
+          <a:ln xmlns:a="http://schemas.openxmlformats.org/drawingml/2006/main" w="0">
+            <a:noFill/>
+          </a:ln>
+        </p:spPr>
+        <p:txBody>
+          <a:bodyPr xmlns:a="http://schemas.openxmlformats.org/drawingml/2006/main">
+            <a:noAutofit/>
+          </a:bodyPr>
+          <a:lstStyle xmlns:a="http://schemas.openxmlformats.org/drawingml/2006/main"/>
+          <a:p xmlns:a="http://schemas.openxmlformats.org/drawingml/2006/main">
+            <a:pPr algn="ctr">
+              <a:defRPr sz="1425" b="1">
+                <a:solidFill>
+                  <a:srgbClr val="FFFFFF"/>
+                </a:solidFill>
+                <a:latin typeface="Arial"/>
+                <a:ea typeface="Arial"/>
+                <a:cs typeface="Arial"/>
+              </a:defRPr>
+            </a:pPr>
+            <a:r>
+              <a:rPr sz="1425" b="1">
+                <a:solidFill>
+                  <a:srgbClr val="FFFFFF"/>
+                </a:solidFill>
+                <a:latin typeface="Arial"/>
+                <a:ea typeface="Arial"/>
+                <a:cs typeface="Arial"/>
+              </a:rPr>
+              <a:t>2</a:t>
+            </a:r>
+          </a:p>
+        </p:txBody>
+      </p:sp>
+      <p:sp>
+        <p:nvSpPr>
+          <p:cNvPr id="16" name="">
+            <a:extLst xmlns:a="http://schemas.openxmlformats.org/drawingml/2006/main">
+              <a:ext uri="{FF2B5EF4-FFF2-40B4-BE49-F238E27FC236}">
+                <a16:creationId xmlns:a16="http://schemas.microsoft.com/office/drawing/2014/main" id="{C5F77B76-FAB4-4340-BEB5-734999411E7F}"/>
+              </a:ext>
+            </a:extLst>
+          </p:cNvPr>
+          <p:cNvSpPr>
+            <a:spLocks xmlns:a="http://schemas.openxmlformats.org/drawingml/2006/main" noGrp="1"/>
+          </p:cNvSpPr>
+          <p:nvPr/>
+        </p:nvSpPr>
+        <p:spPr>
+          <a:xfrm xmlns:a="http://schemas.openxmlformats.org/drawingml/2006/main">
+            <a:off x="4648200" y="4095750"/>
+            <a:ext cx="2324100" cy="266700"/>
+          </a:xfrm>
+          <a:prstGeom xmlns:a="http://schemas.openxmlformats.org/drawingml/2006/main" prst="rect">
+            <a:avLst/>
+          </a:prstGeom>
+          <a:noFill xmlns:a="http://schemas.openxmlformats.org/drawingml/2006/main"/>
+          <a:ln xmlns:a="http://schemas.openxmlformats.org/drawingml/2006/main" w="0">
+            <a:noFill/>
+          </a:ln>
+        </p:spPr>
+        <p:txBody>
+          <a:bodyPr xmlns:a="http://schemas.openxmlformats.org/drawingml/2006/main">
+            <a:noAutofit/>
+          </a:bodyPr>
+          <a:lstStyle xmlns:a="http://schemas.openxmlformats.org/drawingml/2006/main"/>
+          <a:p xmlns:a="http://schemas.openxmlformats.org/drawingml/2006/main">
+            <a:pPr>
+              <a:defRPr sz="1350" b="1">
+                <a:solidFill>
+                  <a:srgbClr val="202A44"/>
+                </a:solidFill>
+                <a:latin typeface="Arial"/>
+                <a:ea typeface="Arial"/>
+                <a:cs typeface="Arial"/>
+              </a:defRPr>
+            </a:pPr>
+            <a:r>
+              <a:rPr sz="1350" b="1">
+                <a:solidFill>
+                  <a:srgbClr val="202A44"/>
+                </a:solidFill>
+                <a:latin typeface="Arial"/>
+                <a:ea typeface="Arial"/>
+                <a:cs typeface="Arial"/>
+              </a:rPr>
+              <a:t>Select eye symptoms</a:t>
+            </a:r>
+          </a:p>
+        </p:txBody>
+      </p:sp>
+      <p:sp>
+        <p:nvSpPr>
+          <p:cNvPr id="17" name="">
+            <a:extLst xmlns:a="http://schemas.openxmlformats.org/drawingml/2006/main">
+              <a:ext uri="{FF2B5EF4-FFF2-40B4-BE49-F238E27FC236}">
+                <a16:creationId xmlns:a16="http://schemas.microsoft.com/office/drawing/2014/main" id="{E21567ED-89FA-4823-ABD7-EE7C54C99846}"/>
+              </a:ext>
+            </a:extLst>
+          </p:cNvPr>
+          <p:cNvSpPr>
+            <a:spLocks xmlns:a="http://schemas.openxmlformats.org/drawingml/2006/main" noGrp="1"/>
+          </p:cNvSpPr>
+          <p:nvPr/>
+        </p:nvSpPr>
+        <p:spPr>
+          <a:xfrm xmlns:a="http://schemas.openxmlformats.org/drawingml/2006/main">
+            <a:off x="4648200" y="4476750"/>
+            <a:ext cx="2324100" cy="266700"/>
+          </a:xfrm>
+          <a:prstGeom xmlns:a="http://schemas.openxmlformats.org/drawingml/2006/main" prst="rect">
+            <a:avLst/>
+          </a:prstGeom>
+          <a:noFill xmlns:a="http://schemas.openxmlformats.org/drawingml/2006/main"/>
+          <a:ln xmlns:a="http://schemas.openxmlformats.org/drawingml/2006/main" w="0">
+            <a:noFill/>
+          </a:ln>
+        </p:spPr>
+        <p:txBody>
+          <a:bodyPr xmlns:a="http://schemas.openxmlformats.org/drawingml/2006/main">
+            <a:noAutofit/>
+          </a:bodyPr>
+          <a:lstStyle xmlns:a="http://schemas.openxmlformats.org/drawingml/2006/main"/>
+          <a:p xmlns:a="http://schemas.openxmlformats.org/drawingml/2006/main">
+            <a:pPr>
+              <a:defRPr sz="1050">
+                <a:solidFill>
+                  <a:srgbClr val="56647A"/>
+                </a:solidFill>
+                <a:latin typeface="Arial"/>
+                <a:ea typeface="Arial"/>
+                <a:cs typeface="Arial"/>
+              </a:defRPr>
+            </a:pPr>
+            <a:r>
+              <a:rPr sz="1050">
+                <a:solidFill>
+                  <a:srgbClr val="56647A"/>
+                </a:solidFill>
+                <a:latin typeface="Arial"/>
+                <a:ea typeface="Arial"/>
+                <a:cs typeface="Arial"/>
+              </a:rPr>
+              <a:t>Use fixed, Bengali-first options</a:t>
+            </a:r>
+          </a:p>
+        </p:txBody>
+      </p:sp>
+      <p:sp>
+        <p:nvSpPr>
+          <p:cNvPr id="18" name="">
+            <a:extLst xmlns:a="http://schemas.openxmlformats.org/drawingml/2006/main">
+              <a:ext uri="{FF2B5EF4-FFF2-40B4-BE49-F238E27FC236}">
+                <a16:creationId xmlns:a16="http://schemas.microsoft.com/office/drawing/2014/main" id="{5BD90F13-FDAD-456B-AA0E-7D7C528CCCF7}"/>
+              </a:ext>
+            </a:extLst>
+          </p:cNvPr>
+          <p:cNvSpPr>
+            <a:spLocks xmlns:a="http://schemas.openxmlformats.org/drawingml/2006/main" noGrp="1"/>
+          </p:cNvSpPr>
+          <p:nvPr/>
+        </p:nvSpPr>
+        <p:spPr>
+          <a:xfrm xmlns:a="http://schemas.openxmlformats.org/drawingml/2006/main">
+            <a:off x="7810500" y="3143250"/>
+            <a:ext cx="2857500" cy="1809750"/>
+          </a:xfrm>
+          <a:prstGeom xmlns:a="http://schemas.openxmlformats.org/drawingml/2006/main" prst="roundRect">
+            <a:avLst>
+              <a:gd name="adj" fmla="val 4211"/>
+            </a:avLst>
+          </a:prstGeom>
+          <a:solidFill xmlns:a="http://schemas.openxmlformats.org/drawingml/2006/main">
+            <a:srgbClr val="FFFFFF"/>
+          </a:solidFill>
+          <a:ln xmlns:a="http://schemas.openxmlformats.org/drawingml/2006/main" w="9525">
+            <a:solidFill>
+              <a:srgbClr val="D7D0C7"/>
+            </a:solidFill>
+          </a:ln>
+        </p:spPr>
+      </p:sp>
+      <p:sp>
+        <p:nvSpPr>
+          <p:cNvPr id="19" name="">
+            <a:extLst xmlns:a="http://schemas.openxmlformats.org/drawingml/2006/main">
+              <a:ext uri="{FF2B5EF4-FFF2-40B4-BE49-F238E27FC236}">
+                <a16:creationId xmlns:a16="http://schemas.microsoft.com/office/drawing/2014/main" id="{0AC7620D-65EE-4405-B6E2-2294C718078E}"/>
+              </a:ext>
+            </a:extLst>
+          </p:cNvPr>
+          <p:cNvSpPr>
+            <a:spLocks xmlns:a="http://schemas.openxmlformats.org/drawingml/2006/main" noGrp="1"/>
+          </p:cNvSpPr>
+          <p:nvPr/>
+        </p:nvSpPr>
+        <p:spPr>
+          <a:xfrm xmlns:a="http://schemas.openxmlformats.org/drawingml/2006/main">
+            <a:off x="8077200" y="3429000"/>
+            <a:ext cx="457200" cy="457200"/>
+          </a:xfrm>
+          <a:prstGeom xmlns:a="http://schemas.openxmlformats.org/drawingml/2006/main" prst="ellipse">
+            <a:avLst/>
+          </a:prstGeom>
+          <a:solidFill xmlns:a="http://schemas.openxmlformats.org/drawingml/2006/main">
+            <a:srgbClr val="DE664C"/>
+          </a:solidFill>
+          <a:ln xmlns:a="http://schemas.openxmlformats.org/drawingml/2006/main" w="0">
+            <a:noFill/>
+          </a:ln>
+        </p:spPr>
+      </p:sp>
+      <p:sp>
+        <p:nvSpPr>
+          <p:cNvPr id="20" name="">
+            <a:extLst xmlns:a="http://schemas.openxmlformats.org/drawingml/2006/main">
+              <a:ext uri="{FF2B5EF4-FFF2-40B4-BE49-F238E27FC236}">
+                <a16:creationId xmlns:a16="http://schemas.microsoft.com/office/drawing/2014/main" id="{0207001C-5BC3-4073-9964-2378F25A823A}"/>
+              </a:ext>
+            </a:extLst>
+          </p:cNvPr>
+          <p:cNvSpPr>
+            <a:spLocks xmlns:a="http://schemas.openxmlformats.org/drawingml/2006/main" noGrp="1"/>
+          </p:cNvSpPr>
+          <p:nvPr/>
+        </p:nvSpPr>
+        <p:spPr>
+          <a:xfrm xmlns:a="http://schemas.openxmlformats.org/drawingml/2006/main">
+            <a:off x="8077200" y="3524250"/>
+            <a:ext cx="457200" cy="209550"/>
+          </a:xfrm>
+          <a:prstGeom xmlns:a="http://schemas.openxmlformats.org/drawingml/2006/main" prst="rect">
+            <a:avLst/>
+          </a:prstGeom>
+          <a:noFill xmlns:a="http://schemas.openxmlformats.org/drawingml/2006/main"/>
+          <a:ln xmlns:a="http://schemas.openxmlformats.org/drawingml/2006/main" w="0">
+            <a:noFill/>
+          </a:ln>
+        </p:spPr>
+        <p:txBody>
+          <a:bodyPr xmlns:a="http://schemas.openxmlformats.org/drawingml/2006/main">
+            <a:noAutofit/>
+          </a:bodyPr>
+          <a:lstStyle xmlns:a="http://schemas.openxmlformats.org/drawingml/2006/main"/>
+          <a:p xmlns:a="http://schemas.openxmlformats.org/drawingml/2006/main">
+            <a:pPr algn="ctr">
+              <a:defRPr sz="1425" b="1">
+                <a:solidFill>
+                  <a:srgbClr val="FFFFFF"/>
+                </a:solidFill>
+                <a:latin typeface="Arial"/>
+                <a:ea typeface="Arial"/>
+                <a:cs typeface="Arial"/>
+              </a:defRPr>
+            </a:pPr>
+            <a:r>
+              <a:rPr sz="1425" b="1">
+                <a:solidFill>
+                  <a:srgbClr val="FFFFFF"/>
+                </a:solidFill>
+                <a:latin typeface="Arial"/>
+                <a:ea typeface="Arial"/>
+                <a:cs typeface="Arial"/>
+              </a:rPr>
+              <a:t>3</a:t>
+            </a:r>
+          </a:p>
+        </p:txBody>
+      </p:sp>
+      <p:sp>
+        <p:nvSpPr>
+          <p:cNvPr id="21" name="">
+            <a:extLst xmlns:a="http://schemas.openxmlformats.org/drawingml/2006/main">
+              <a:ext uri="{FF2B5EF4-FFF2-40B4-BE49-F238E27FC236}">
+                <a16:creationId xmlns:a16="http://schemas.microsoft.com/office/drawing/2014/main" id="{A2ADBB6B-C8AE-41C4-90CE-07104FD7FABE}"/>
+              </a:ext>
+            </a:extLst>
+          </p:cNvPr>
+          <p:cNvSpPr>
+            <a:spLocks xmlns:a="http://schemas.openxmlformats.org/drawingml/2006/main" noGrp="1"/>
+          </p:cNvSpPr>
+          <p:nvPr/>
+        </p:nvSpPr>
+        <p:spPr>
+          <a:xfrm xmlns:a="http://schemas.openxmlformats.org/drawingml/2006/main">
+            <a:off x="8077200" y="4095750"/>
+            <a:ext cx="2324100" cy="266700"/>
+          </a:xfrm>
+          <a:prstGeom xmlns:a="http://schemas.openxmlformats.org/drawingml/2006/main" prst="rect">
+            <a:avLst/>
+          </a:prstGeom>
+          <a:noFill xmlns:a="http://schemas.openxmlformats.org/drawingml/2006/main"/>
+          <a:ln xmlns:a="http://schemas.openxmlformats.org/drawingml/2006/main" w="0">
+            <a:noFill/>
+          </a:ln>
+        </p:spPr>
+        <p:txBody>
+          <a:bodyPr xmlns:a="http://schemas.openxmlformats.org/drawingml/2006/main">
+            <a:noAutofit/>
+          </a:bodyPr>
+          <a:lstStyle xmlns:a="http://schemas.openxmlformats.org/drawingml/2006/main"/>
+          <a:p xmlns:a="http://schemas.openxmlformats.org/drawingml/2006/main">
+            <a:pPr>
+              <a:defRPr sz="1350" b="1">
+                <a:solidFill>
+                  <a:srgbClr val="202A44"/>
+                </a:solidFill>
+                <a:latin typeface="Arial"/>
+                <a:ea typeface="Arial"/>
+                <a:cs typeface="Arial"/>
+              </a:defRPr>
+            </a:pPr>
+            <a:r>
+              <a:rPr sz="1350" b="1">
+                <a:solidFill>
+                  <a:srgbClr val="202A44"/>
+                </a:solidFill>
+                <a:latin typeface="Arial"/>
+                <a:ea typeface="Arial"/>
+                <a:cs typeface="Arial"/>
+              </a:rPr>
+              <a:t>View the safe result</a:t>
+            </a:r>
+          </a:p>
+        </p:txBody>
+      </p:sp>
+      <p:sp>
+        <p:nvSpPr>
+          <p:cNvPr id="22" name="">
+            <a:extLst xmlns:a="http://schemas.openxmlformats.org/drawingml/2006/main">
+              <a:ext uri="{FF2B5EF4-FFF2-40B4-BE49-F238E27FC236}">
+                <a16:creationId xmlns:a16="http://schemas.microsoft.com/office/drawing/2014/main" id="{E2D73620-BEDB-4B1C-8683-9B37D817A76C}"/>
+              </a:ext>
+            </a:extLst>
+          </p:cNvPr>
+          <p:cNvSpPr>
+            <a:spLocks xmlns:a="http://schemas.openxmlformats.org/drawingml/2006/main" noGrp="1"/>
+          </p:cNvSpPr>
+          <p:nvPr/>
+        </p:nvSpPr>
+        <p:spPr>
+          <a:xfrm xmlns:a="http://schemas.openxmlformats.org/drawingml/2006/main">
+            <a:off x="8077200" y="4476750"/>
+            <a:ext cx="2324100" cy="266700"/>
+          </a:xfrm>
+          <a:prstGeom xmlns:a="http://schemas.openxmlformats.org/drawingml/2006/main" prst="rect">
+            <a:avLst/>
+          </a:prstGeom>
+          <a:noFill xmlns:a="http://schemas.openxmlformats.org/drawingml/2006/main"/>
+          <a:ln xmlns:a="http://schemas.openxmlformats.org/drawingml/2006/main" w="0">
+            <a:noFill/>
+          </a:ln>
+        </p:spPr>
+        <p:txBody>
+          <a:bodyPr xmlns:a="http://schemas.openxmlformats.org/drawingml/2006/main">
+            <a:noAutofit/>
+          </a:bodyPr>
+          <a:lstStyle xmlns:a="http://schemas.openxmlformats.org/drawingml/2006/main"/>
+          <a:p xmlns:a="http://schemas.openxmlformats.org/drawingml/2006/main">
+            <a:pPr>
+              <a:defRPr sz="1050">
+                <a:solidFill>
+                  <a:srgbClr val="56647A"/>
+                </a:solidFill>
+                <a:latin typeface="Arial"/>
+                <a:ea typeface="Arial"/>
+                <a:cs typeface="Arial"/>
+              </a:defRPr>
+            </a:pPr>
+            <a:r>
+              <a:rPr sz="1050">
+                <a:solidFill>
+                  <a:srgbClr val="56647A"/>
+                </a:solidFill>
+                <a:latin typeface="Arial"/>
+                <a:ea typeface="Arial"/>
+                <a:cs typeface="Arial"/>
+              </a:rPr>
+              <a:t>Show route, guidance, and next action</a:t>
+            </a:r>
+          </a:p>
+        </p:txBody>
+      </p:sp>
+      <p:sp>
+        <p:nvSpPr>
+          <p:cNvPr id="23" name="">
+            <a:extLst xmlns:a="http://schemas.openxmlformats.org/drawingml/2006/main">
+              <a:ext uri="{FF2B5EF4-FFF2-40B4-BE49-F238E27FC236}">
+                <a16:creationId xmlns:a16="http://schemas.microsoft.com/office/drawing/2014/main" id="{C918394C-8C5B-41E9-90D1-86111E30DA6B}"/>
+              </a:ext>
+            </a:extLst>
+          </p:cNvPr>
+          <p:cNvSpPr>
+            <a:spLocks xmlns:a="http://schemas.openxmlformats.org/drawingml/2006/main" noGrp="1"/>
+          </p:cNvSpPr>
+          <p:nvPr/>
+        </p:nvSpPr>
+        <p:spPr>
+          <a:xfrm xmlns:a="http://schemas.openxmlformats.org/drawingml/2006/main">
+            <a:off x="1657350" y="5543550"/>
+            <a:ext cx="8877300" cy="552450"/>
+          </a:xfrm>
+          <a:prstGeom xmlns:a="http://schemas.openxmlformats.org/drawingml/2006/main" prst="roundRect">
+            <a:avLst>
+              <a:gd name="adj" fmla="val 13793"/>
+            </a:avLst>
+          </a:prstGeom>
+          <a:solidFill xmlns:a="http://schemas.openxmlformats.org/drawingml/2006/main">
+            <a:srgbClr val="E9E7F5"/>
+          </a:solidFill>
+          <a:ln xmlns:a="http://schemas.openxmlformats.org/drawingml/2006/main" w="0">
+            <a:noFill/>
+          </a:ln>
+        </p:spPr>
+      </p:sp>
+      <p:sp>
+        <p:nvSpPr>
+          <p:cNvPr id="24" name="">
+            <a:extLst xmlns:a="http://schemas.openxmlformats.org/drawingml/2006/main">
+              <a:ext uri="{FF2B5EF4-FFF2-40B4-BE49-F238E27FC236}">
+                <a16:creationId xmlns:a16="http://schemas.microsoft.com/office/drawing/2014/main" id="{1814A6B4-270F-4151-9248-6BF577B036CD}"/>
+              </a:ext>
+            </a:extLst>
+          </p:cNvPr>
+          <p:cNvSpPr>
+            <a:spLocks xmlns:a="http://schemas.openxmlformats.org/drawingml/2006/main" noGrp="1"/>
+          </p:cNvSpPr>
+          <p:nvPr/>
+        </p:nvSpPr>
+        <p:spPr>
+          <a:xfrm xmlns:a="http://schemas.openxmlformats.org/drawingml/2006/main">
+            <a:off x="1962150" y="5715000"/>
+            <a:ext cx="8267700" cy="190500"/>
+          </a:xfrm>
+          <a:prstGeom xmlns:a="http://schemas.openxmlformats.org/drawingml/2006/main" prst="rect">
+            <a:avLst/>
+          </a:prstGeom>
+          <a:noFill xmlns:a="http://schemas.openxmlformats.org/drawingml/2006/main"/>
+          <a:ln xmlns:a="http://schemas.openxmlformats.org/drawingml/2006/main" w="0">
+            <a:noFill/>
+          </a:ln>
+        </p:spPr>
+        <p:txBody>
+          <a:bodyPr xmlns:a="http://schemas.openxmlformats.org/drawingml/2006/main">
+            <a:noAutofit/>
+          </a:bodyPr>
+          <a:lstStyle xmlns:a="http://schemas.openxmlformats.org/drawingml/2006/main"/>
+          <a:p xmlns:a="http://schemas.openxmlformats.org/drawingml/2006/main">
+            <a:pPr algn="ctr">
+              <a:defRPr sz="1050" b="1">
+                <a:solidFill>
+                  <a:srgbClr val="202A44"/>
+                </a:solidFill>
+                <a:latin typeface="Arial"/>
+                <a:ea typeface="Arial"/>
+                <a:cs typeface="Arial"/>
+              </a:defRPr>
+            </a:pPr>
+            <a:r>
+              <a:rPr sz="1050" b="1">
+                <a:solidFill>
+                  <a:srgbClr val="202A44"/>
+                </a:solidFill>
+                <a:latin typeface="Arial"/>
+                <a:ea typeface="Arial"/>
+                <a:cs typeface="Arial"/>
+              </a:rPr>
+              <a:t>Demo check: the Java deterministic engine fixes the route before PostgreSQL RAG and Local Ollama provide the explanation.</a:t>
+            </a:r>
+          </a:p>
+        </p:txBody>
+      </p:sp>
+      <p:sp>
+        <p:nvSpPr>
+          <p:cNvPr id="25" name="">
+            <a:extLst xmlns:a="http://schemas.openxmlformats.org/drawingml/2006/main">
+              <a:ext uri="{FF2B5EF4-FFF2-40B4-BE49-F238E27FC236}">
+                <a16:creationId xmlns:a16="http://schemas.microsoft.com/office/drawing/2014/main" id="{07486BA9-0D2F-4EB5-935E-96FC0272881D}"/>
+              </a:ext>
+            </a:extLst>
+          </p:cNvPr>
+          <p:cNvSpPr>
+            <a:spLocks xmlns:a="http://schemas.openxmlformats.org/drawingml/2006/main" noGrp="1"/>
+          </p:cNvSpPr>
+          <p:nvPr/>
+        </p:nvSpPr>
+        <p:spPr>
+          <a:xfrm xmlns:a="http://schemas.openxmlformats.org/drawingml/2006/main">
+            <a:off x="11049000" y="6438900"/>
+            <a:ext cx="457200" cy="171450"/>
+          </a:xfrm>
+          <a:prstGeom xmlns:a="http://schemas.openxmlformats.org/drawingml/2006/main" prst="rect">
+            <a:avLst/>
+          </a:prstGeom>
+          <a:noFill xmlns:a="http://schemas.openxmlformats.org/drawingml/2006/main"/>
+          <a:ln xmlns:a="http://schemas.openxmlformats.org/drawingml/2006/main" w="0">
+            <a:noFill/>
+          </a:ln>
+        </p:spPr>
+        <p:txBody>
+          <a:bodyPr xmlns:a="http://schemas.openxmlformats.org/drawingml/2006/main">
+            <a:noAutofit/>
+          </a:bodyPr>
+          <a:lstStyle xmlns:a="http://schemas.openxmlformats.org/drawingml/2006/main"/>
+          <a:p xmlns:a="http://schemas.openxmlformats.org/drawingml/2006/main">
+            <a:pPr algn="r">
+              <a:defRPr sz="900">
+                <a:solidFill>
+                  <a:srgbClr val="56647A"/>
+                </a:solidFill>
+                <a:latin typeface="Arial"/>
+                <a:ea typeface="Arial"/>
+                <a:cs typeface="Arial"/>
+              </a:defRPr>
+            </a:pPr>
+            <a:r>
+              <a:rPr sz="900">
+                <a:solidFill>
+                  <a:srgbClr val="56647A"/>
+                </a:solidFill>
+                <a:latin typeface="Arial"/>
+                <a:ea typeface="Arial"/>
+                <a:cs typeface="Arial"/>
+              </a:rPr>
+              <a:t>12</a:t>
+            </a:r>
+          </a:p>
+        </p:txBody>
+      </p:sp>
+    </p:spTree>
+    <p:extLst>
+      <p:ext uri="{BB962C8B-B14F-4D97-AF65-F5344CB8AC3E}">
+        <p14:creationId xmlns:p14="http://schemas.microsoft.com/office/powerpoint/2010/main" val="863634096"/>
+      </p:ext>
+    </p:extLst>
+  </p:cSld>
+</p:sld>
+</file>
+
+<file path=ppt/slides/slide13.xml><?xml version="1.0" encoding="utf-8"?>
+<p:sld xmlns:p="http://schemas.openxmlformats.org/presentationml/2006/main">
+  <p:cSld>
+    <p:spTree>
+      <p:nvGrpSpPr>
+        <p:cNvPr id="1" name=""/>
+        <p:cNvGrpSpPr/>
+        <p:nvPr/>
+      </p:nvGrpSpPr>
+      <p:grpSpPr>
+        <a:xfrm xmlns:a="http://schemas.openxmlformats.org/drawingml/2006/main"/>
+      </p:grpSpPr>
+      <p:sp>
+        <p:nvSpPr>
+          <p:cNvPr id="11" name="">
+            <a:extLst xmlns:a="http://schemas.openxmlformats.org/drawingml/2006/main">
+              <a:ext uri="{FF2B5EF4-FFF2-40B4-BE49-F238E27FC236}">
+                <a16:creationId xmlns:a16="http://schemas.microsoft.com/office/drawing/2014/main" id="{33279760-B390-488A-B7E9-D50332061FAF}"/>
+              </a:ext>
+            </a:extLst>
+          </p:cNvPr>
+          <p:cNvSpPr>
+            <a:spLocks xmlns:a="http://schemas.openxmlformats.org/drawingml/2006/main" noGrp="1"/>
+          </p:cNvSpPr>
+          <p:nvPr/>
+        </p:nvSpPr>
+        <p:spPr>
+          <a:xfrm xmlns:a="http://schemas.openxmlformats.org/drawingml/2006/main">
+            <a:off x="0" y="0"/>
+            <a:ext cx="12192000" cy="6858000"/>
+          </a:xfrm>
+          <a:prstGeom xmlns:a="http://schemas.openxmlformats.org/drawingml/2006/main" prst="rect">
+            <a:avLst/>
+          </a:prstGeom>
+          <a:solidFill xmlns:a="http://schemas.openxmlformats.org/drawingml/2006/main">
+            <a:srgbClr val="202A44"/>
+          </a:solidFill>
+          <a:ln xmlns:a="http://schemas.openxmlformats.org/drawingml/2006/main" w="0">
+            <a:noFill/>
+          </a:ln>
+        </p:spPr>
+      </p:sp>
+      <p:sp>
+        <p:nvSpPr>
+          <p:cNvPr id="2" name="">
+            <a:extLst xmlns:a="http://schemas.openxmlformats.org/drawingml/2006/main">
+              <a:ext uri="{FF2B5EF4-FFF2-40B4-BE49-F238E27FC236}">
+                <a16:creationId xmlns:a16="http://schemas.microsoft.com/office/drawing/2014/main" id="{76445375-8A88-4350-A90F-2B2CA10F8030}"/>
+              </a:ext>
+            </a:extLst>
+          </p:cNvPr>
+          <p:cNvSpPr>
+            <a:spLocks xmlns:a="http://schemas.openxmlformats.org/drawingml/2006/main" noGrp="1"/>
+          </p:cNvSpPr>
+          <p:nvPr/>
+        </p:nvSpPr>
+        <p:spPr>
+          <a:xfrm xmlns:a="http://schemas.openxmlformats.org/drawingml/2006/main">
+            <a:off x="990600" y="819150"/>
+            <a:ext cx="2476500" cy="190500"/>
+          </a:xfrm>
+          <a:prstGeom xmlns:a="http://schemas.openxmlformats.org/drawingml/2006/main" prst="rect">
+            <a:avLst/>
+          </a:prstGeom>
+          <a:noFill xmlns:a="http://schemas.openxmlformats.org/drawingml/2006/main"/>
+          <a:ln xmlns:a="http://schemas.openxmlformats.org/drawingml/2006/main" w="0">
+            <a:noFill/>
+          </a:ln>
+        </p:spPr>
+        <p:txBody>
+          <a:bodyPr xmlns:a="http://schemas.openxmlformats.org/drawingml/2006/main">
+            <a:noAutofit/>
+          </a:bodyPr>
+          <a:lstStyle xmlns:a="http://schemas.openxmlformats.org/drawingml/2006/main"/>
+          <a:p xmlns:a="http://schemas.openxmlformats.org/drawingml/2006/main">
+            <a:pPr>
+              <a:defRPr sz="1200" b="1">
+                <a:solidFill>
+                  <a:srgbClr val="E7A048"/>
+                </a:solidFill>
+                <a:latin typeface="Arial"/>
+                <a:ea typeface="Arial"/>
+                <a:cs typeface="Arial"/>
+              </a:defRPr>
+            </a:pPr>
+            <a:r>
+              <a:rPr sz="1200" b="1">
+                <a:solidFill>
+                  <a:srgbClr val="E7A048"/>
+                </a:solidFill>
+                <a:latin typeface="Arial"/>
+                <a:ea typeface="Arial"/>
+                <a:cs typeface="Arial"/>
+              </a:rPr>
+              <a:t>NETRAJYOTI AI</a:t>
+            </a:r>
+          </a:p>
+        </p:txBody>
+      </p:sp>
+      <p:sp>
+        <p:nvSpPr>
+          <p:cNvPr id="3" name="">
+            <a:extLst xmlns:a="http://schemas.openxmlformats.org/drawingml/2006/main">
+              <a:ext uri="{FF2B5EF4-FFF2-40B4-BE49-F238E27FC236}">
+                <a16:creationId xmlns:a16="http://schemas.microsoft.com/office/drawing/2014/main" id="{A599CC87-C68D-41B1-9801-E4A44BFB29A3}"/>
+              </a:ext>
+            </a:extLst>
+          </p:cNvPr>
+          <p:cNvSpPr>
+            <a:spLocks xmlns:a="http://schemas.openxmlformats.org/drawingml/2006/main" noGrp="1"/>
+          </p:cNvSpPr>
+          <p:nvPr/>
+        </p:nvSpPr>
+        <p:spPr>
+          <a:xfrm xmlns:a="http://schemas.openxmlformats.org/drawingml/2006/main">
+            <a:off x="990600" y="1381125"/>
+            <a:ext cx="1809750" cy="47625"/>
+          </a:xfrm>
+          <a:prstGeom xmlns:a="http://schemas.openxmlformats.org/drawingml/2006/main" prst="rect">
+            <a:avLst/>
+          </a:prstGeom>
+          <a:solidFill xmlns:a="http://schemas.openxmlformats.org/drawingml/2006/main">
+            <a:srgbClr val="237A7A"/>
+          </a:solidFill>
+          <a:ln xmlns:a="http://schemas.openxmlformats.org/drawingml/2006/main" w="0">
+            <a:noFill/>
+          </a:ln>
+        </p:spPr>
+      </p:sp>
+      <p:sp>
+        <p:nvSpPr>
+          <p:cNvPr id="4" name="">
+            <a:extLst xmlns:a="http://schemas.openxmlformats.org/drawingml/2006/main">
+              <a:ext uri="{FF2B5EF4-FFF2-40B4-BE49-F238E27FC236}">
+                <a16:creationId xmlns:a16="http://schemas.microsoft.com/office/drawing/2014/main" id="{BCBCBE3A-B580-4276-A427-E7AE623208F2}"/>
+              </a:ext>
+            </a:extLst>
+          </p:cNvPr>
+          <p:cNvSpPr>
+            <a:spLocks xmlns:a="http://schemas.openxmlformats.org/drawingml/2006/main" noGrp="1"/>
+          </p:cNvSpPr>
+          <p:nvPr/>
+        </p:nvSpPr>
+        <p:spPr>
+          <a:xfrm xmlns:a="http://schemas.openxmlformats.org/drawingml/2006/main">
+            <a:off x="990600" y="2238375"/>
+            <a:ext cx="6477000" cy="609600"/>
+          </a:xfrm>
+          <a:prstGeom xmlns:a="http://schemas.openxmlformats.org/drawingml/2006/main" prst="rect">
+            <a:avLst/>
+          </a:prstGeom>
+          <a:noFill xmlns:a="http://schemas.openxmlformats.org/drawingml/2006/main"/>
+          <a:ln xmlns:a="http://schemas.openxmlformats.org/drawingml/2006/main" w="0">
+            <a:noFill/>
+          </a:ln>
+        </p:spPr>
+        <p:txBody>
+          <a:bodyPr xmlns:a="http://schemas.openxmlformats.org/drawingml/2006/main">
+            <a:noAutofit/>
+          </a:bodyPr>
+          <a:lstStyle xmlns:a="http://schemas.openxmlformats.org/drawingml/2006/main"/>
+          <a:p xmlns:a="http://schemas.openxmlformats.org/drawingml/2006/main">
+            <a:pPr>
+              <a:defRPr sz="3450" b="1">
+                <a:solidFill>
+                  <a:srgbClr val="FFFFFF"/>
+                </a:solidFill>
+                <a:latin typeface="Arial"/>
+                <a:ea typeface="Arial"/>
+                <a:cs typeface="Arial"/>
+              </a:defRPr>
+            </a:pPr>
+            <a:r>
+              <a:rPr sz="3450" b="1">
+                <a:solidFill>
+                  <a:srgbClr val="FFFFFF"/>
+                </a:solidFill>
+                <a:latin typeface="Arial"/>
+                <a:ea typeface="Arial"/>
+                <a:cs typeface="Arial"/>
+              </a:rPr>
+              <a:t>Thank you</a:t>
+            </a:r>
+          </a:p>
+        </p:txBody>
+      </p:sp>
+      <p:sp>
+        <p:nvSpPr>
+          <p:cNvPr id="5" name="">
+            <a:extLst xmlns:a="http://schemas.openxmlformats.org/drawingml/2006/main">
+              <a:ext uri="{FF2B5EF4-FFF2-40B4-BE49-F238E27FC236}">
+                <a16:creationId xmlns:a16="http://schemas.microsoft.com/office/drawing/2014/main" id="{7F04372B-E69E-451A-84F0-8F21C83D5B57}"/>
+              </a:ext>
+            </a:extLst>
+          </p:cNvPr>
+          <p:cNvSpPr>
+            <a:spLocks xmlns:a="http://schemas.openxmlformats.org/drawingml/2006/main" noGrp="1"/>
+          </p:cNvSpPr>
+          <p:nvPr/>
+        </p:nvSpPr>
+        <p:spPr>
+          <a:xfrm xmlns:a="http://schemas.openxmlformats.org/drawingml/2006/main">
+            <a:off x="990600" y="3067050"/>
+            <a:ext cx="5810250" cy="304800"/>
+          </a:xfrm>
+          <a:prstGeom xmlns:a="http://schemas.openxmlformats.org/drawingml/2006/main" prst="rect">
+            <a:avLst/>
+          </a:prstGeom>
+          <a:noFill xmlns:a="http://schemas.openxmlformats.org/drawingml/2006/main"/>
+          <a:ln xmlns:a="http://schemas.openxmlformats.org/drawingml/2006/main" w="0">
+            <a:noFill/>
+          </a:ln>
+        </p:spPr>
+        <p:txBody>
+          <a:bodyPr xmlns:a="http://schemas.openxmlformats.org/drawingml/2006/main">
+            <a:noAutofit/>
+          </a:bodyPr>
+          <a:lstStyle xmlns:a="http://schemas.openxmlformats.org/drawingml/2006/main"/>
+          <a:p xmlns:a="http://schemas.openxmlformats.org/drawingml/2006/main">
+            <a:pPr>
+              <a:defRPr sz="1650">
+                <a:solidFill>
+                  <a:srgbClr val="DDE8F6"/>
+                </a:solidFill>
+                <a:latin typeface="Arial"/>
+                <a:ea typeface="Arial"/>
+                <a:cs typeface="Arial"/>
+              </a:defRPr>
+            </a:pPr>
+            <a:r>
+              <a:rPr sz="1650">
+                <a:solidFill>
+                  <a:srgbClr val="DDE8F6"/>
+                </a:solidFill>
+                <a:latin typeface="Arial"/>
+                <a:ea typeface="Arial"/>
+                <a:cs typeface="Arial"/>
+              </a:rPr>
+              <a:t>Questions and discussion</a:t>
+            </a:r>
+          </a:p>
+        </p:txBody>
+      </p:sp>
+      <p:sp>
+        <p:nvSpPr>
+          <p:cNvPr id="6" name="">
+            <a:extLst xmlns:a="http://schemas.openxmlformats.org/drawingml/2006/main">
+              <a:ext uri="{FF2B5EF4-FFF2-40B4-BE49-F238E27FC236}">
+                <a16:creationId xmlns:a16="http://schemas.microsoft.com/office/drawing/2014/main" id="{7A7215BD-1577-4A16-A1E6-C497889D3C33}"/>
+              </a:ext>
+            </a:extLst>
+          </p:cNvPr>
+          <p:cNvSpPr>
+            <a:spLocks xmlns:a="http://schemas.openxmlformats.org/drawingml/2006/main" noGrp="1"/>
+          </p:cNvSpPr>
+          <p:nvPr/>
+        </p:nvSpPr>
+        <p:spPr>
+          <a:xfrm xmlns:a="http://schemas.openxmlformats.org/drawingml/2006/main">
+            <a:off x="990600" y="5105400"/>
+            <a:ext cx="6191250" cy="247650"/>
+          </a:xfrm>
+          <a:prstGeom xmlns:a="http://schemas.openxmlformats.org/drawingml/2006/main" prst="rect">
+            <a:avLst/>
+          </a:prstGeom>
+          <a:noFill xmlns:a="http://schemas.openxmlformats.org/drawingml/2006/main"/>
+          <a:ln xmlns:a="http://schemas.openxmlformats.org/drawingml/2006/main" w="0">
+            <a:noFill/>
+          </a:ln>
+        </p:spPr>
+        <p:txBody>
+          <a:bodyPr xmlns:a="http://schemas.openxmlformats.org/drawingml/2006/main">
+            <a:noAutofit/>
+          </a:bodyPr>
+          <a:lstStyle xmlns:a="http://schemas.openxmlformats.org/drawingml/2006/main"/>
+          <a:p xmlns:a="http://schemas.openxmlformats.org/drawingml/2006/main">
+            <a:pPr>
+              <a:defRPr sz="1350">
+                <a:solidFill>
+                  <a:srgbClr val="FFFFFF"/>
+                </a:solidFill>
+                <a:latin typeface="Arial"/>
+                <a:ea typeface="Arial"/>
+                <a:cs typeface="Arial"/>
+              </a:defRPr>
+            </a:pPr>
+            <a:r>
+              <a:rPr sz="1350">
+                <a:solidFill>
+                  <a:srgbClr val="FFFFFF"/>
+                </a:solidFill>
+                <a:latin typeface="Arial"/>
+                <a:ea typeface="Arial"/>
+                <a:cs typeface="Arial"/>
+              </a:rPr>
+              <a:t>Reliable Bengali eye-care guidance with a fixed safety route</a:t>
+            </a:r>
+          </a:p>
+        </p:txBody>
+      </p:sp>
+      <p:sp>
+        <p:nvSpPr>
+          <p:cNvPr id="7" name="">
+            <a:extLst xmlns:a="http://schemas.openxmlformats.org/drawingml/2006/main">
+              <a:ext uri="{FF2B5EF4-FFF2-40B4-BE49-F238E27FC236}">
+                <a16:creationId xmlns:a16="http://schemas.microsoft.com/office/drawing/2014/main" id="{BB619EFA-9B7F-43D0-A2C2-DE42286911D6}"/>
+              </a:ext>
+            </a:extLst>
+          </p:cNvPr>
+          <p:cNvSpPr>
+            <a:spLocks xmlns:a="http://schemas.openxmlformats.org/drawingml/2006/main" noGrp="1"/>
+          </p:cNvSpPr>
+          <p:nvPr/>
+        </p:nvSpPr>
+        <p:spPr>
+          <a:xfrm xmlns:a="http://schemas.openxmlformats.org/drawingml/2006/main">
+            <a:off x="990600" y="5524500"/>
+            <a:ext cx="7143750" cy="209550"/>
+          </a:xfrm>
+          <a:prstGeom xmlns:a="http://schemas.openxmlformats.org/drawingml/2006/main" prst="rect">
+            <a:avLst/>
+          </a:prstGeom>
+          <a:noFill xmlns:a="http://schemas.openxmlformats.org/drawingml/2006/main"/>
+          <a:ln xmlns:a="http://schemas.openxmlformats.org/drawingml/2006/main" w="0">
+            <a:noFill/>
+          </a:ln>
+        </p:spPr>
+        <p:txBody>
+          <a:bodyPr xmlns:a="http://schemas.openxmlformats.org/drawingml/2006/main">
+            <a:noAutofit/>
+          </a:bodyPr>
+          <a:lstStyle xmlns:a="http://schemas.openxmlformats.org/drawingml/2006/main"/>
+          <a:p xmlns:a="http://schemas.openxmlformats.org/drawingml/2006/main">
+            <a:pPr>
+              <a:defRPr sz="1125">
+                <a:solidFill>
+                  <a:srgbClr val="DDE8F6"/>
+                </a:solidFill>
+                <a:latin typeface="Arial"/>
+                <a:ea typeface="Arial"/>
+                <a:cs typeface="Arial"/>
+              </a:defRPr>
+            </a:pPr>
+            <a:r>
+              <a:rPr sz="1125">
+                <a:solidFill>
+                  <a:srgbClr val="DDE8F6"/>
+                </a:solidFill>
+                <a:latin typeface="Arial"/>
+                <a:ea typeface="Arial"/>
+                <a:cs typeface="Arial"/>
+              </a:rPr>
+              <a:t>Voice and text access · approved clinical content · clear next action</a:t>
+            </a:r>
+          </a:p>
+        </p:txBody>
+      </p:sp>
+      <p:sp>
+        <p:nvSpPr>
+          <p:cNvPr id="8" name="">
+            <a:extLst xmlns:a="http://schemas.openxmlformats.org/drawingml/2006/main">
+              <a:ext uri="{FF2B5EF4-FFF2-40B4-BE49-F238E27FC236}">
+                <a16:creationId xmlns:a16="http://schemas.microsoft.com/office/drawing/2014/main" id="{6FED4DD0-BFF1-40AD-B312-D5A501AA5E05}"/>
+              </a:ext>
+            </a:extLst>
+          </p:cNvPr>
+          <p:cNvSpPr>
+            <a:spLocks xmlns:a="http://schemas.openxmlformats.org/drawingml/2006/main" noGrp="1"/>
+          </p:cNvSpPr>
+          <p:nvPr/>
+        </p:nvSpPr>
+        <p:spPr>
+          <a:xfrm xmlns:a="http://schemas.openxmlformats.org/drawingml/2006/main">
+            <a:off x="990600" y="6153150"/>
+            <a:ext cx="10210800" cy="28575"/>
+          </a:xfrm>
+          <a:prstGeom xmlns:a="http://schemas.openxmlformats.org/drawingml/2006/main" prst="rect">
+            <a:avLst/>
+          </a:prstGeom>
+          <a:solidFill xmlns:a="http://schemas.openxmlformats.org/drawingml/2006/main">
+            <a:srgbClr val="E7A048"/>
+          </a:solidFill>
+          <a:ln xmlns:a="http://schemas.openxmlformats.org/drawingml/2006/main" w="0">
+            <a:noFill/>
+          </a:ln>
+        </p:spPr>
+      </p:sp>
+      <p:sp>
+        <p:nvSpPr>
+          <p:cNvPr id="9" name="">
+            <a:extLst xmlns:a="http://schemas.openxmlformats.org/drawingml/2006/main">
+              <a:ext uri="{FF2B5EF4-FFF2-40B4-BE49-F238E27FC236}">
+                <a16:creationId xmlns:a16="http://schemas.microsoft.com/office/drawing/2014/main" id="{D5EDF10E-4D21-4CD3-B527-586A1BC6A839}"/>
+              </a:ext>
+            </a:extLst>
+          </p:cNvPr>
+          <p:cNvSpPr>
+            <a:spLocks xmlns:a="http://schemas.openxmlformats.org/drawingml/2006/main" noGrp="1"/>
+          </p:cNvSpPr>
+          <p:nvPr/>
+        </p:nvSpPr>
+        <p:spPr>
+          <a:xfrm xmlns:a="http://schemas.openxmlformats.org/drawingml/2006/main">
+            <a:off x="990600" y="6343650"/>
+            <a:ext cx="2381250" cy="171450"/>
+          </a:xfrm>
+          <a:prstGeom xmlns:a="http://schemas.openxmlformats.org/drawingml/2006/main" prst="rect">
+            <a:avLst/>
+          </a:prstGeom>
+          <a:noFill xmlns:a="http://schemas.openxmlformats.org/drawingml/2006/main"/>
+          <a:ln xmlns:a="http://schemas.openxmlformats.org/drawingml/2006/main" w="0">
+            <a:noFill/>
+          </a:ln>
+        </p:spPr>
+        <p:txBody>
+          <a:bodyPr xmlns:a="http://schemas.openxmlformats.org/drawingml/2006/main">
+            <a:noAutofit/>
+          </a:bodyPr>
+          <a:lstStyle xmlns:a="http://schemas.openxmlformats.org/drawingml/2006/main"/>
+          <a:p xmlns:a="http://schemas.openxmlformats.org/drawingml/2006/main">
+            <a:pPr>
+              <a:defRPr sz="975" b="1">
+                <a:solidFill>
+                  <a:srgbClr val="E7A048"/>
+                </a:solidFill>
+                <a:latin typeface="Arial"/>
+                <a:ea typeface="Arial"/>
+                <a:cs typeface="Arial"/>
+              </a:defRPr>
+            </a:pPr>
+            <a:r>
+              <a:rPr sz="975" b="1">
+                <a:solidFill>
+                  <a:srgbClr val="E7A048"/>
+                </a:solidFill>
+                <a:latin typeface="Arial"/>
+                <a:ea typeface="Arial"/>
+                <a:cs typeface="Arial"/>
+              </a:rPr>
+              <a:t>NetraJyoti AI</a:t>
+            </a:r>
+          </a:p>
+        </p:txBody>
+      </p:sp>
+      <p:sp>
+        <p:nvSpPr>
+          <p:cNvPr id="10" name="">
+            <a:extLst xmlns:a="http://schemas.openxmlformats.org/drawingml/2006/main">
+              <a:ext uri="{FF2B5EF4-FFF2-40B4-BE49-F238E27FC236}">
+                <a16:creationId xmlns:a16="http://schemas.microsoft.com/office/drawing/2014/main" id="{3D8A0D5E-60A7-462B-8072-1D40BFB1F8BB}"/>
+              </a:ext>
+            </a:extLst>
+          </p:cNvPr>
+          <p:cNvSpPr>
+            <a:spLocks xmlns:a="http://schemas.openxmlformats.org/drawingml/2006/main" noGrp="1"/>
+          </p:cNvSpPr>
+          <p:nvPr/>
+        </p:nvSpPr>
+        <p:spPr>
+          <a:xfrm xmlns:a="http://schemas.openxmlformats.org/drawingml/2006/main">
+            <a:off x="11049000" y="6438900"/>
+            <a:ext cx="457200" cy="171450"/>
+          </a:xfrm>
+          <a:prstGeom xmlns:a="http://schemas.openxmlformats.org/drawingml/2006/main" prst="rect">
+            <a:avLst/>
+          </a:prstGeom>
+          <a:noFill xmlns:a="http://schemas.openxmlformats.org/drawingml/2006/main"/>
+          <a:ln xmlns:a="http://schemas.openxmlformats.org/drawingml/2006/main" w="0">
+            <a:noFill/>
+          </a:ln>
+        </p:spPr>
+        <p:txBody>
+          <a:bodyPr xmlns:a="http://schemas.openxmlformats.org/drawingml/2006/main">
+            <a:noAutofit/>
+          </a:bodyPr>
+          <a:lstStyle xmlns:a="http://schemas.openxmlformats.org/drawingml/2006/main"/>
+          <a:p xmlns:a="http://schemas.openxmlformats.org/drawingml/2006/main">
+            <a:pPr algn="r">
+              <a:defRPr sz="900">
+                <a:solidFill>
+                  <a:srgbClr val="56647A"/>
+                </a:solidFill>
+                <a:latin typeface="Arial"/>
+                <a:ea typeface="Arial"/>
+                <a:cs typeface="Arial"/>
+              </a:defRPr>
+            </a:pPr>
+            <a:r>
+              <a:rPr sz="900">
+                <a:solidFill>
+                  <a:srgbClr val="56647A"/>
+                </a:solidFill>
+                <a:latin typeface="Arial"/>
+                <a:ea typeface="Arial"/>
+                <a:cs typeface="Arial"/>
+              </a:rPr>
+              <a:t>13</a:t>
+            </a:r>
+          </a:p>
+        </p:txBody>
+      </p:sp>
+    </p:spTree>
+    <p:extLst>
+      <p:ext uri="{BB962C8B-B14F-4D97-AF65-F5344CB8AC3E}">
+        <p14:creationId xmlns:p14="http://schemas.microsoft.com/office/powerpoint/2010/main" val="2139598413"/>
       </p:ext>
     </p:extLst>
   </p:cSld>
@@ -6755,7 +8618,7 @@
           <p:cNvPr id="24" name="">
             <a:extLst xmlns:a="http://schemas.openxmlformats.org/drawingml/2006/main">
               <a:ext uri="{FF2B5EF4-FFF2-40B4-BE49-F238E27FC236}">
-                <a16:creationId xmlns:a16="http://schemas.microsoft.com/office/drawing/2014/main" id="{603C6DBF-F581-4CD2-8EA4-BEC252D431A0}"/>
+                <a16:creationId xmlns:a16="http://schemas.microsoft.com/office/drawing/2014/main" id="{8D85BB84-1C1C-48DD-8AF9-6BF5FA68DE9D}"/>
               </a:ext>
             </a:extLst>
           </p:cNvPr>
@@ -6785,7 +8648,7 @@
           <p:cNvPr id="25" name="">
             <a:extLst xmlns:a="http://schemas.openxmlformats.org/drawingml/2006/main">
               <a:ext uri="{FF2B5EF4-FFF2-40B4-BE49-F238E27FC236}">
-                <a16:creationId xmlns:a16="http://schemas.microsoft.com/office/drawing/2014/main" id="{DAB804A9-195B-4F16-A091-3781FEB2F97E}"/>
+                <a16:creationId xmlns:a16="http://schemas.microsoft.com/office/drawing/2014/main" id="{A60B646C-0FB1-4E91-8443-4E023C80B1B5}"/>
               </a:ext>
             </a:extLst>
           </p:cNvPr>
@@ -6842,7 +8705,7 @@
           <p:cNvPr id="26" name="">
             <a:extLst xmlns:a="http://schemas.openxmlformats.org/drawingml/2006/main">
               <a:ext uri="{FF2B5EF4-FFF2-40B4-BE49-F238E27FC236}">
-                <a16:creationId xmlns:a16="http://schemas.microsoft.com/office/drawing/2014/main" id="{3DC04F79-F8DC-4291-96BA-986431FF94EB}"/>
+                <a16:creationId xmlns:a16="http://schemas.microsoft.com/office/drawing/2014/main" id="{9C03CE6D-A554-4FFD-A38F-8610CFEA3344}"/>
               </a:ext>
             </a:extLst>
           </p:cNvPr>
@@ -6899,7 +8762,7 @@
           <p:cNvPr id="27" name="">
             <a:extLst xmlns:a="http://schemas.openxmlformats.org/drawingml/2006/main">
               <a:ext uri="{FF2B5EF4-FFF2-40B4-BE49-F238E27FC236}">
-                <a16:creationId xmlns:a16="http://schemas.microsoft.com/office/drawing/2014/main" id="{E5322F39-A57C-4A0B-9C76-18E04A3DA9D0}"/>
+                <a16:creationId xmlns:a16="http://schemas.microsoft.com/office/drawing/2014/main" id="{CC08DA37-D4CB-4CD9-82DF-E51ECE7FD2C9}"/>
               </a:ext>
             </a:extLst>
           </p:cNvPr>
@@ -6956,7 +8819,7 @@
           <p:cNvPr id="28" name="">
             <a:extLst xmlns:a="http://schemas.openxmlformats.org/drawingml/2006/main">
               <a:ext uri="{FF2B5EF4-FFF2-40B4-BE49-F238E27FC236}">
-                <a16:creationId xmlns:a16="http://schemas.microsoft.com/office/drawing/2014/main" id="{628260B5-ADBC-4297-B57F-1FF5D8C3639E}"/>
+                <a16:creationId xmlns:a16="http://schemas.microsoft.com/office/drawing/2014/main" id="{77543633-B5C5-4081-8948-9F5B1C4E725C}"/>
               </a:ext>
             </a:extLst>
           </p:cNvPr>
@@ -7013,7 +8876,7 @@
           <p:cNvPr id="29" name="">
             <a:extLst xmlns:a="http://schemas.openxmlformats.org/drawingml/2006/main">
               <a:ext uri="{FF2B5EF4-FFF2-40B4-BE49-F238E27FC236}">
-                <a16:creationId xmlns:a16="http://schemas.microsoft.com/office/drawing/2014/main" id="{AF797C27-1584-4547-AE52-16F2DBF4861E}"/>
+                <a16:creationId xmlns:a16="http://schemas.microsoft.com/office/drawing/2014/main" id="{94BBEF13-56C7-45A5-AF87-0B167B50CC6B}"/>
               </a:ext>
             </a:extLst>
           </p:cNvPr>
@@ -7043,7 +8906,7 @@
           <p:cNvPr id="30" name="">
             <a:extLst xmlns:a="http://schemas.openxmlformats.org/drawingml/2006/main">
               <a:ext uri="{FF2B5EF4-FFF2-40B4-BE49-F238E27FC236}">
-                <a16:creationId xmlns:a16="http://schemas.microsoft.com/office/drawing/2014/main" id="{A2CB6C15-DDC4-4A01-89CE-939F754ADFE6}"/>
+                <a16:creationId xmlns:a16="http://schemas.microsoft.com/office/drawing/2014/main" id="{A1416715-A47E-4A18-A5BF-FEC2019F0091}"/>
               </a:ext>
             </a:extLst>
           </p:cNvPr>
@@ -7100,7 +8963,7 @@
           <p:cNvPr id="31" name="">
             <a:extLst xmlns:a="http://schemas.openxmlformats.org/drawingml/2006/main">
               <a:ext uri="{FF2B5EF4-FFF2-40B4-BE49-F238E27FC236}">
-                <a16:creationId xmlns:a16="http://schemas.microsoft.com/office/drawing/2014/main" id="{4C238EAD-1716-4D8A-9625-F52127948996}"/>
+                <a16:creationId xmlns:a16="http://schemas.microsoft.com/office/drawing/2014/main" id="{DDBA980C-2F61-4993-9965-462218B14DA6}"/>
               </a:ext>
             </a:extLst>
           </p:cNvPr>
@@ -7180,7 +9043,7 @@
           <p:cNvPr id="32" name="">
             <a:extLst xmlns:a="http://schemas.openxmlformats.org/drawingml/2006/main">
               <a:ext uri="{FF2B5EF4-FFF2-40B4-BE49-F238E27FC236}">
-                <a16:creationId xmlns:a16="http://schemas.microsoft.com/office/drawing/2014/main" id="{E87C169A-A372-4532-8B97-9F682D11EA39}"/>
+                <a16:creationId xmlns:a16="http://schemas.microsoft.com/office/drawing/2014/main" id="{BB48A905-AB85-40D0-95B4-1FB5EBBE37F6}"/>
               </a:ext>
             </a:extLst>
           </p:cNvPr>
@@ -7237,7 +9100,7 @@
           <p:cNvPr id="33" name="">
             <a:extLst xmlns:a="http://schemas.openxmlformats.org/drawingml/2006/main">
               <a:ext uri="{FF2B5EF4-FFF2-40B4-BE49-F238E27FC236}">
-                <a16:creationId xmlns:a16="http://schemas.microsoft.com/office/drawing/2014/main" id="{29A995D1-18D4-4237-9EE1-1F74776554EB}"/>
+                <a16:creationId xmlns:a16="http://schemas.microsoft.com/office/drawing/2014/main" id="{171EED52-F918-4547-B3A8-328CB6272780}"/>
               </a:ext>
             </a:extLst>
           </p:cNvPr>
@@ -7267,7 +9130,7 @@
           <p:cNvPr id="34" name="">
             <a:extLst xmlns:a="http://schemas.openxmlformats.org/drawingml/2006/main">
               <a:ext uri="{FF2B5EF4-FFF2-40B4-BE49-F238E27FC236}">
-                <a16:creationId xmlns:a16="http://schemas.microsoft.com/office/drawing/2014/main" id="{446A555F-2825-4EDA-B1CC-27FB758AE89C}"/>
+                <a16:creationId xmlns:a16="http://schemas.microsoft.com/office/drawing/2014/main" id="{9D91DA50-59A9-4980-A637-1796077D70B7}"/>
               </a:ext>
             </a:extLst>
           </p:cNvPr>
@@ -7297,7 +9160,7 @@
           <p:cNvPr id="35" name="">
             <a:extLst xmlns:a="http://schemas.openxmlformats.org/drawingml/2006/main">
               <a:ext uri="{FF2B5EF4-FFF2-40B4-BE49-F238E27FC236}">
-                <a16:creationId xmlns:a16="http://schemas.microsoft.com/office/drawing/2014/main" id="{E01AB28F-FBED-4976-8D0A-447480C0564E}"/>
+                <a16:creationId xmlns:a16="http://schemas.microsoft.com/office/drawing/2014/main" id="{BC50F81E-19B3-47F1-85EF-29A576F7B216}"/>
               </a:ext>
             </a:extLst>
           </p:cNvPr>
@@ -7354,7 +9217,7 @@
           <p:cNvPr id="36" name="">
             <a:extLst xmlns:a="http://schemas.openxmlformats.org/drawingml/2006/main">
               <a:ext uri="{FF2B5EF4-FFF2-40B4-BE49-F238E27FC236}">
-                <a16:creationId xmlns:a16="http://schemas.microsoft.com/office/drawing/2014/main" id="{AC030863-B872-45F1-BA2A-D17A54D08287}"/>
+                <a16:creationId xmlns:a16="http://schemas.microsoft.com/office/drawing/2014/main" id="{B3331B13-DCF7-42D6-8DA2-DDC3EE4AF319}"/>
               </a:ext>
             </a:extLst>
           </p:cNvPr>
@@ -7411,7 +9274,7 @@
           <p:cNvPr id="37" name="">
             <a:extLst xmlns:a="http://schemas.openxmlformats.org/drawingml/2006/main">
               <a:ext uri="{FF2B5EF4-FFF2-40B4-BE49-F238E27FC236}">
-                <a16:creationId xmlns:a16="http://schemas.microsoft.com/office/drawing/2014/main" id="{C2CFE3AB-C43B-4A7E-B705-837BE58FE0A1}"/>
+                <a16:creationId xmlns:a16="http://schemas.microsoft.com/office/drawing/2014/main" id="{403A5069-9CBE-4C05-AF33-47A1C2487550}"/>
               </a:ext>
             </a:extLst>
           </p:cNvPr>
@@ -7468,7 +9331,7 @@
           <p:cNvPr id="38" name="">
             <a:extLst xmlns:a="http://schemas.openxmlformats.org/drawingml/2006/main">
               <a:ext uri="{FF2B5EF4-FFF2-40B4-BE49-F238E27FC236}">
-                <a16:creationId xmlns:a16="http://schemas.microsoft.com/office/drawing/2014/main" id="{F3092A3A-6F7A-4212-83C5-D1D544D49B4C}"/>
+                <a16:creationId xmlns:a16="http://schemas.microsoft.com/office/drawing/2014/main" id="{4D7A409B-0845-434D-8AE1-E552D528798E}"/>
               </a:ext>
             </a:extLst>
           </p:cNvPr>
@@ -7498,7 +9361,7 @@
           <p:cNvPr id="39" name="">
             <a:extLst xmlns:a="http://schemas.openxmlformats.org/drawingml/2006/main">
               <a:ext uri="{FF2B5EF4-FFF2-40B4-BE49-F238E27FC236}">
-                <a16:creationId xmlns:a16="http://schemas.microsoft.com/office/drawing/2014/main" id="{5356A950-E3A9-47CB-B307-1EBF0C5AC634}"/>
+                <a16:creationId xmlns:a16="http://schemas.microsoft.com/office/drawing/2014/main" id="{65D0BC3B-443F-4F86-9872-0D1FB8C78752}"/>
               </a:ext>
             </a:extLst>
           </p:cNvPr>
@@ -7555,7 +9418,7 @@
           <p:cNvPr id="40" name="">
             <a:extLst xmlns:a="http://schemas.openxmlformats.org/drawingml/2006/main">
               <a:ext uri="{FF2B5EF4-FFF2-40B4-BE49-F238E27FC236}">
-                <a16:creationId xmlns:a16="http://schemas.microsoft.com/office/drawing/2014/main" id="{211DCEB6-C22A-4171-B97C-9D916E76C2F9}"/>
+                <a16:creationId xmlns:a16="http://schemas.microsoft.com/office/drawing/2014/main" id="{85A6EF2B-7AF2-4786-83A3-4820C80E1C07}"/>
               </a:ext>
             </a:extLst>
           </p:cNvPr>
@@ -7612,7 +9475,7 @@
           <p:cNvPr id="41" name="">
             <a:extLst xmlns:a="http://schemas.openxmlformats.org/drawingml/2006/main">
               <a:ext uri="{FF2B5EF4-FFF2-40B4-BE49-F238E27FC236}">
-                <a16:creationId xmlns:a16="http://schemas.microsoft.com/office/drawing/2014/main" id="{D0DA7FAB-9A43-46A3-9839-6FF95CB029F2}"/>
+                <a16:creationId xmlns:a16="http://schemas.microsoft.com/office/drawing/2014/main" id="{2A879C0F-E071-47EF-96F8-3C111BFE54CB}"/>
               </a:ext>
             </a:extLst>
           </p:cNvPr>
@@ -7669,7 +9532,7 @@
           <p:cNvPr id="42" name="">
             <a:extLst xmlns:a="http://schemas.openxmlformats.org/drawingml/2006/main">
               <a:ext uri="{FF2B5EF4-FFF2-40B4-BE49-F238E27FC236}">
-                <a16:creationId xmlns:a16="http://schemas.microsoft.com/office/drawing/2014/main" id="{D7826C3E-0890-4CD4-9128-CB43A681A7B4}"/>
+                <a16:creationId xmlns:a16="http://schemas.microsoft.com/office/drawing/2014/main" id="{D031A442-CB90-46A3-89D8-265BA3AF8403}"/>
               </a:ext>
             </a:extLst>
           </p:cNvPr>
@@ -7699,7 +9562,7 @@
           <p:cNvPr id="43" name="">
             <a:extLst xmlns:a="http://schemas.openxmlformats.org/drawingml/2006/main">
               <a:ext uri="{FF2B5EF4-FFF2-40B4-BE49-F238E27FC236}">
-                <a16:creationId xmlns:a16="http://schemas.microsoft.com/office/drawing/2014/main" id="{EAE6C639-A796-4D23-A3ED-FB4A3E61436F}"/>
+                <a16:creationId xmlns:a16="http://schemas.microsoft.com/office/drawing/2014/main" id="{B9676435-6B17-45C8-AD22-CAC78FEAF51F}"/>
               </a:ext>
             </a:extLst>
           </p:cNvPr>
@@ -7756,7 +9619,7 @@
           <p:cNvPr id="44" name="">
             <a:extLst xmlns:a="http://schemas.openxmlformats.org/drawingml/2006/main">
               <a:ext uri="{FF2B5EF4-FFF2-40B4-BE49-F238E27FC236}">
-                <a16:creationId xmlns:a16="http://schemas.microsoft.com/office/drawing/2014/main" id="{DEAE9BA6-1C35-437B-BF38-4ACAAD530FFA}"/>
+                <a16:creationId xmlns:a16="http://schemas.microsoft.com/office/drawing/2014/main" id="{2AAB7ECB-F1A9-4D01-A297-D6F13A8C0BF9}"/>
               </a:ext>
             </a:extLst>
           </p:cNvPr>
@@ -7813,7 +9676,7 @@
           <p:cNvPr id="45" name="">
             <a:extLst xmlns:a="http://schemas.openxmlformats.org/drawingml/2006/main">
               <a:ext uri="{FF2B5EF4-FFF2-40B4-BE49-F238E27FC236}">
-                <a16:creationId xmlns:a16="http://schemas.microsoft.com/office/drawing/2014/main" id="{62E4B28D-9BB6-4770-94BB-4DD226C2BE5A}"/>
+                <a16:creationId xmlns:a16="http://schemas.microsoft.com/office/drawing/2014/main" id="{3CBA472B-8D97-4A15-978E-113BBC27B06B}"/>
               </a:ext>
             </a:extLst>
           </p:cNvPr>
@@ -7870,7 +9733,7 @@
           <p:cNvPr id="46" name="">
             <a:extLst xmlns:a="http://schemas.openxmlformats.org/drawingml/2006/main">
               <a:ext uri="{FF2B5EF4-FFF2-40B4-BE49-F238E27FC236}">
-                <a16:creationId xmlns:a16="http://schemas.microsoft.com/office/drawing/2014/main" id="{C6DE9EC6-2997-4133-8B6F-21A61D43ECD8}"/>
+                <a16:creationId xmlns:a16="http://schemas.microsoft.com/office/drawing/2014/main" id="{53320DA8-1EFC-406B-B6C1-F88F77F20039}"/>
               </a:ext>
             </a:extLst>
           </p:cNvPr>
@@ -7902,7 +9765,7 @@
           <p:cNvPr id="47" name="">
             <a:extLst xmlns:a="http://schemas.openxmlformats.org/drawingml/2006/main">
               <a:ext uri="{FF2B5EF4-FFF2-40B4-BE49-F238E27FC236}">
-                <a16:creationId xmlns:a16="http://schemas.microsoft.com/office/drawing/2014/main" id="{D11B9C62-1CCA-4335-B3A5-BEEC81BDBE14}"/>
+                <a16:creationId xmlns:a16="http://schemas.microsoft.com/office/drawing/2014/main" id="{092A23C4-D89C-48EB-93FE-4B395618E26C}"/>
               </a:ext>
             </a:extLst>
           </p:cNvPr>
@@ -7959,7 +9822,7 @@
           <p:cNvPr id="48" name="">
             <a:extLst xmlns:a="http://schemas.openxmlformats.org/drawingml/2006/main">
               <a:ext uri="{FF2B5EF4-FFF2-40B4-BE49-F238E27FC236}">
-                <a16:creationId xmlns:a16="http://schemas.microsoft.com/office/drawing/2014/main" id="{D4C806E4-D1AC-4D9A-AE3D-D203BF41778C}"/>
+                <a16:creationId xmlns:a16="http://schemas.microsoft.com/office/drawing/2014/main" id="{CCB46666-E96A-4D44-98DB-9E4448AC60C9}"/>
               </a:ext>
             </a:extLst>
           </p:cNvPr>
@@ -9557,7 +11420,7 @@
           <p:cNvPr id="29" name="">
             <a:extLst xmlns:a="http://schemas.openxmlformats.org/drawingml/2006/main">
               <a:ext uri="{FF2B5EF4-FFF2-40B4-BE49-F238E27FC236}">
-                <a16:creationId xmlns:a16="http://schemas.microsoft.com/office/drawing/2014/main" id="{5B3C2782-EEF9-4C67-854A-A1EFD800E426}"/>
+                <a16:creationId xmlns:a16="http://schemas.microsoft.com/office/drawing/2014/main" id="{83B1E89E-CD29-41A0-91B0-2DBE02268B6F}"/>
               </a:ext>
             </a:extLst>
           </p:cNvPr>
@@ -9587,7 +11450,7 @@
           <p:cNvPr id="30" name="">
             <a:extLst xmlns:a="http://schemas.openxmlformats.org/drawingml/2006/main">
               <a:ext uri="{FF2B5EF4-FFF2-40B4-BE49-F238E27FC236}">
-                <a16:creationId xmlns:a16="http://schemas.microsoft.com/office/drawing/2014/main" id="{CDE94F49-07E9-42DD-BEC6-FA937031D169}"/>
+                <a16:creationId xmlns:a16="http://schemas.microsoft.com/office/drawing/2014/main" id="{D7F704E7-CEFB-4D75-AC2E-04E67637378D}"/>
               </a:ext>
             </a:extLst>
           </p:cNvPr>
@@ -9644,7 +11507,7 @@
           <p:cNvPr id="31" name="">
             <a:extLst xmlns:a="http://schemas.openxmlformats.org/drawingml/2006/main">
               <a:ext uri="{FF2B5EF4-FFF2-40B4-BE49-F238E27FC236}">
-                <a16:creationId xmlns:a16="http://schemas.microsoft.com/office/drawing/2014/main" id="{1ECB6EF7-C338-486F-8127-E4160CD6058F}"/>
+                <a16:creationId xmlns:a16="http://schemas.microsoft.com/office/drawing/2014/main" id="{6D3CEF02-D8BA-4B25-99AE-07167BC4FEAE}"/>
               </a:ext>
             </a:extLst>
           </p:cNvPr>
@@ -9701,7 +11564,7 @@
           <p:cNvPr id="32" name="">
             <a:extLst xmlns:a="http://schemas.openxmlformats.org/drawingml/2006/main">
               <a:ext uri="{FF2B5EF4-FFF2-40B4-BE49-F238E27FC236}">
-                <a16:creationId xmlns:a16="http://schemas.microsoft.com/office/drawing/2014/main" id="{30C286AA-2BF2-41FC-9CB1-FEAF3CA4E691}"/>
+                <a16:creationId xmlns:a16="http://schemas.microsoft.com/office/drawing/2014/main" id="{DED72694-6430-4840-B2B9-B262090846E1}"/>
               </a:ext>
             </a:extLst>
           </p:cNvPr>
@@ -9758,7 +11621,7 @@
           <p:cNvPr id="33" name="">
             <a:extLst xmlns:a="http://schemas.openxmlformats.org/drawingml/2006/main">
               <a:ext uri="{FF2B5EF4-FFF2-40B4-BE49-F238E27FC236}">
-                <a16:creationId xmlns:a16="http://schemas.microsoft.com/office/drawing/2014/main" id="{D942D98A-0560-49AE-A76D-F8BAE40801CA}"/>
+                <a16:creationId xmlns:a16="http://schemas.microsoft.com/office/drawing/2014/main" id="{00929C0A-836A-4730-A0EE-A3435A5CB8E5}"/>
               </a:ext>
             </a:extLst>
           </p:cNvPr>
@@ -9815,7 +11678,7 @@
           <p:cNvPr id="34" name="">
             <a:extLst xmlns:a="http://schemas.openxmlformats.org/drawingml/2006/main">
               <a:ext uri="{FF2B5EF4-FFF2-40B4-BE49-F238E27FC236}">
-                <a16:creationId xmlns:a16="http://schemas.microsoft.com/office/drawing/2014/main" id="{9C675826-B9F1-4FC7-8DB2-53E73215C4F3}"/>
+                <a16:creationId xmlns:a16="http://schemas.microsoft.com/office/drawing/2014/main" id="{EF0210E1-0951-4854-B7D8-06A3578840D7}"/>
               </a:ext>
             </a:extLst>
           </p:cNvPr>
@@ -9845,7 +11708,7 @@
           <p:cNvPr id="35" name="">
             <a:extLst xmlns:a="http://schemas.openxmlformats.org/drawingml/2006/main">
               <a:ext uri="{FF2B5EF4-FFF2-40B4-BE49-F238E27FC236}">
-                <a16:creationId xmlns:a16="http://schemas.microsoft.com/office/drawing/2014/main" id="{ED22C848-265C-425C-98E4-A50FA8F53EEA}"/>
+                <a16:creationId xmlns:a16="http://schemas.microsoft.com/office/drawing/2014/main" id="{4092867C-328C-4B59-A9D8-CABABD4B622E}"/>
               </a:ext>
             </a:extLst>
           </p:cNvPr>
@@ -9902,7 +11765,7 @@
           <p:cNvPr id="36" name="">
             <a:extLst xmlns:a="http://schemas.openxmlformats.org/drawingml/2006/main">
               <a:ext uri="{FF2B5EF4-FFF2-40B4-BE49-F238E27FC236}">
-                <a16:creationId xmlns:a16="http://schemas.microsoft.com/office/drawing/2014/main" id="{DD807B1E-6B3B-4ED4-A811-7A22F4E2F355}"/>
+                <a16:creationId xmlns:a16="http://schemas.microsoft.com/office/drawing/2014/main" id="{1F91E083-3B1A-415B-9665-881AA30ACFEA}"/>
               </a:ext>
             </a:extLst>
           </p:cNvPr>
@@ -9934,7 +11797,7 @@
           <p:cNvPr id="37" name="">
             <a:extLst xmlns:a="http://schemas.openxmlformats.org/drawingml/2006/main">
               <a:ext uri="{FF2B5EF4-FFF2-40B4-BE49-F238E27FC236}">
-                <a16:creationId xmlns:a16="http://schemas.microsoft.com/office/drawing/2014/main" id="{982ACF58-D4B4-43DC-ACBE-C1CE4C7A0820}"/>
+                <a16:creationId xmlns:a16="http://schemas.microsoft.com/office/drawing/2014/main" id="{C063A936-5116-434B-AF0E-FCE225CC2E81}"/>
               </a:ext>
             </a:extLst>
           </p:cNvPr>
@@ -9991,7 +11854,7 @@
           <p:cNvPr id="38" name="">
             <a:extLst xmlns:a="http://schemas.openxmlformats.org/drawingml/2006/main">
               <a:ext uri="{FF2B5EF4-FFF2-40B4-BE49-F238E27FC236}">
-                <a16:creationId xmlns:a16="http://schemas.microsoft.com/office/drawing/2014/main" id="{F9DFD865-E48B-44F1-94E2-A629BD6E96AE}"/>
+                <a16:creationId xmlns:a16="http://schemas.microsoft.com/office/drawing/2014/main" id="{CA5EAC38-B612-405C-990C-D0C3EFFF881D}"/>
               </a:ext>
             </a:extLst>
           </p:cNvPr>
@@ -10048,7 +11911,7 @@
           <p:cNvPr id="39" name="">
             <a:extLst xmlns:a="http://schemas.openxmlformats.org/drawingml/2006/main">
               <a:ext uri="{FF2B5EF4-FFF2-40B4-BE49-F238E27FC236}">
-                <a16:creationId xmlns:a16="http://schemas.microsoft.com/office/drawing/2014/main" id="{9DCADFAF-8725-476D-8329-CEA8AEA74877}"/>
+                <a16:creationId xmlns:a16="http://schemas.microsoft.com/office/drawing/2014/main" id="{5019003D-58BD-420D-8251-B12BBA6249A5}"/>
               </a:ext>
             </a:extLst>
           </p:cNvPr>
@@ -10078,7 +11941,7 @@
           <p:cNvPr id="40" name="">
             <a:extLst xmlns:a="http://schemas.openxmlformats.org/drawingml/2006/main">
               <a:ext uri="{FF2B5EF4-FFF2-40B4-BE49-F238E27FC236}">
-                <a16:creationId xmlns:a16="http://schemas.microsoft.com/office/drawing/2014/main" id="{66781CCB-D0E3-40A5-BC1B-C68F5FFFF170}"/>
+                <a16:creationId xmlns:a16="http://schemas.microsoft.com/office/drawing/2014/main" id="{C652051E-9238-47FD-8FAE-05E71D5D81CD}"/>
               </a:ext>
             </a:extLst>
           </p:cNvPr>
@@ -10110,7 +11973,7 @@
           <p:cNvPr id="41" name="">
             <a:extLst xmlns:a="http://schemas.openxmlformats.org/drawingml/2006/main">
               <a:ext uri="{FF2B5EF4-FFF2-40B4-BE49-F238E27FC236}">
-                <a16:creationId xmlns:a16="http://schemas.microsoft.com/office/drawing/2014/main" id="{DBA1098F-7AF7-46EF-8192-D6A5B616240C}"/>
+                <a16:creationId xmlns:a16="http://schemas.microsoft.com/office/drawing/2014/main" id="{B34E1AFA-6FD2-4B88-BF18-E9EDEF5FBE34}"/>
               </a:ext>
             </a:extLst>
           </p:cNvPr>
@@ -10190,7 +12053,7 @@
           <p:cNvPr id="42" name="">
             <a:extLst xmlns:a="http://schemas.openxmlformats.org/drawingml/2006/main">
               <a:ext uri="{FF2B5EF4-FFF2-40B4-BE49-F238E27FC236}">
-                <a16:creationId xmlns:a16="http://schemas.microsoft.com/office/drawing/2014/main" id="{FBF9233C-E6CD-4452-A6BF-B2D6BB29C7FF}"/>
+                <a16:creationId xmlns:a16="http://schemas.microsoft.com/office/drawing/2014/main" id="{3CFFDAF4-6250-4012-9219-0651A90A0308}"/>
               </a:ext>
             </a:extLst>
           </p:cNvPr>
@@ -10247,7 +12110,7 @@
           <p:cNvPr id="43" name="">
             <a:extLst xmlns:a="http://schemas.openxmlformats.org/drawingml/2006/main">
               <a:ext uri="{FF2B5EF4-FFF2-40B4-BE49-F238E27FC236}">
-                <a16:creationId xmlns:a16="http://schemas.microsoft.com/office/drawing/2014/main" id="{99C7B795-560E-4331-BE87-22ECF6E5E75C}"/>
+                <a16:creationId xmlns:a16="http://schemas.microsoft.com/office/drawing/2014/main" id="{A7483D9A-F24A-4F0A-A130-7144D3F3F365}"/>
               </a:ext>
             </a:extLst>
           </p:cNvPr>
@@ -10277,7 +12140,7 @@
           <p:cNvPr id="44" name="">
             <a:extLst xmlns:a="http://schemas.openxmlformats.org/drawingml/2006/main">
               <a:ext uri="{FF2B5EF4-FFF2-40B4-BE49-F238E27FC236}">
-                <a16:creationId xmlns:a16="http://schemas.microsoft.com/office/drawing/2014/main" id="{4DD76D53-2DFC-4106-A37F-B9C7BF6CA4EA}"/>
+                <a16:creationId xmlns:a16="http://schemas.microsoft.com/office/drawing/2014/main" id="{25574400-EB29-490A-8DF9-A2C7A41B216B}"/>
               </a:ext>
             </a:extLst>
           </p:cNvPr>
@@ -10309,7 +12172,7 @@
           <p:cNvPr id="45" name="">
             <a:extLst xmlns:a="http://schemas.openxmlformats.org/drawingml/2006/main">
               <a:ext uri="{FF2B5EF4-FFF2-40B4-BE49-F238E27FC236}">
-                <a16:creationId xmlns:a16="http://schemas.microsoft.com/office/drawing/2014/main" id="{BA82D76E-500F-466B-946E-AA7BDADF11E3}"/>
+                <a16:creationId xmlns:a16="http://schemas.microsoft.com/office/drawing/2014/main" id="{1EEFD2D4-27D2-46BE-98E7-7A87FDE68246}"/>
               </a:ext>
             </a:extLst>
           </p:cNvPr>
@@ -10366,7 +12229,7 @@
           <p:cNvPr id="46" name="">
             <a:extLst xmlns:a="http://schemas.openxmlformats.org/drawingml/2006/main">
               <a:ext uri="{FF2B5EF4-FFF2-40B4-BE49-F238E27FC236}">
-                <a16:creationId xmlns:a16="http://schemas.microsoft.com/office/drawing/2014/main" id="{02328BD6-397E-427D-B954-4D691DBE52C8}"/>
+                <a16:creationId xmlns:a16="http://schemas.microsoft.com/office/drawing/2014/main" id="{8428BCC8-85FA-4337-AFE8-F78C8C51B979}"/>
               </a:ext>
             </a:extLst>
           </p:cNvPr>
@@ -10423,7 +12286,7 @@
           <p:cNvPr id="47" name="">
             <a:extLst xmlns:a="http://schemas.openxmlformats.org/drawingml/2006/main">
               <a:ext uri="{FF2B5EF4-FFF2-40B4-BE49-F238E27FC236}">
-                <a16:creationId xmlns:a16="http://schemas.microsoft.com/office/drawing/2014/main" id="{F477EB51-71B6-4988-ABB0-3BC381660A0E}"/>
+                <a16:creationId xmlns:a16="http://schemas.microsoft.com/office/drawing/2014/main" id="{BA670724-3D79-42AB-8620-E197B34E98DD}"/>
               </a:ext>
             </a:extLst>
           </p:cNvPr>
@@ -10453,7 +12316,7 @@
           <p:cNvPr id="48" name="">
             <a:extLst xmlns:a="http://schemas.openxmlformats.org/drawingml/2006/main">
               <a:ext uri="{FF2B5EF4-FFF2-40B4-BE49-F238E27FC236}">
-                <a16:creationId xmlns:a16="http://schemas.microsoft.com/office/drawing/2014/main" id="{059034EA-560A-43CF-8FC4-BF05B30A479C}"/>
+                <a16:creationId xmlns:a16="http://schemas.microsoft.com/office/drawing/2014/main" id="{158A0721-8F7F-483B-BA4C-078FD9489AEA}"/>
               </a:ext>
             </a:extLst>
           </p:cNvPr>
@@ -10485,7 +12348,7 @@
           <p:cNvPr id="49" name="">
             <a:extLst xmlns:a="http://schemas.openxmlformats.org/drawingml/2006/main">
               <a:ext uri="{FF2B5EF4-FFF2-40B4-BE49-F238E27FC236}">
-                <a16:creationId xmlns:a16="http://schemas.microsoft.com/office/drawing/2014/main" id="{7A637BE3-ACDC-4C37-822E-90F3E7491AAA}"/>
+                <a16:creationId xmlns:a16="http://schemas.microsoft.com/office/drawing/2014/main" id="{61CF34A7-8AA0-4770-9401-0615D075D50C}"/>
               </a:ext>
             </a:extLst>
           </p:cNvPr>
@@ -10542,7 +12405,7 @@
           <p:cNvPr id="50" name="">
             <a:extLst xmlns:a="http://schemas.openxmlformats.org/drawingml/2006/main">
               <a:ext uri="{FF2B5EF4-FFF2-40B4-BE49-F238E27FC236}">
-                <a16:creationId xmlns:a16="http://schemas.microsoft.com/office/drawing/2014/main" id="{1E17B823-E519-4F5E-8425-110E1421105D}"/>
+                <a16:creationId xmlns:a16="http://schemas.microsoft.com/office/drawing/2014/main" id="{17146716-4BED-47C7-87A3-6CA2F46F558D}"/>
               </a:ext>
             </a:extLst>
           </p:cNvPr>
@@ -10599,7 +12462,7 @@
           <p:cNvPr id="51" name="">
             <a:extLst xmlns:a="http://schemas.openxmlformats.org/drawingml/2006/main">
               <a:ext uri="{FF2B5EF4-FFF2-40B4-BE49-F238E27FC236}">
-                <a16:creationId xmlns:a16="http://schemas.microsoft.com/office/drawing/2014/main" id="{70FD3F5B-9DA0-49AD-B871-D63FA09FDFB2}"/>
+                <a16:creationId xmlns:a16="http://schemas.microsoft.com/office/drawing/2014/main" id="{F843CD03-563D-43C2-8158-18476BA215A3}"/>
               </a:ext>
             </a:extLst>
           </p:cNvPr>
@@ -10631,7 +12494,7 @@
           <p:cNvPr id="52" name="">
             <a:extLst xmlns:a="http://schemas.openxmlformats.org/drawingml/2006/main">
               <a:ext uri="{FF2B5EF4-FFF2-40B4-BE49-F238E27FC236}">
-                <a16:creationId xmlns:a16="http://schemas.microsoft.com/office/drawing/2014/main" id="{4296874D-A4F8-486D-A243-8C493119493B}"/>
+                <a16:creationId xmlns:a16="http://schemas.microsoft.com/office/drawing/2014/main" id="{37F2C559-B056-41EA-B2FD-BEEEFA19F480}"/>
               </a:ext>
             </a:extLst>
           </p:cNvPr>
@@ -10688,7 +12551,7 @@
           <p:cNvPr id="53" name="">
             <a:extLst xmlns:a="http://schemas.openxmlformats.org/drawingml/2006/main">
               <a:ext uri="{FF2B5EF4-FFF2-40B4-BE49-F238E27FC236}">
-                <a16:creationId xmlns:a16="http://schemas.microsoft.com/office/drawing/2014/main" id="{07E877E3-3AD4-43D3-ADD7-4F90BFDF8BC3}"/>
+                <a16:creationId xmlns:a16="http://schemas.microsoft.com/office/drawing/2014/main" id="{34EE8E1E-F950-4B0B-8121-69A60195F911}"/>
               </a:ext>
             </a:extLst>
           </p:cNvPr>
@@ -10745,7 +12608,7 @@
           <p:cNvPr id="54" name="">
             <a:extLst xmlns:a="http://schemas.openxmlformats.org/drawingml/2006/main">
               <a:ext uri="{FF2B5EF4-FFF2-40B4-BE49-F238E27FC236}">
-                <a16:creationId xmlns:a16="http://schemas.microsoft.com/office/drawing/2014/main" id="{5B453E28-6DF9-4D62-9766-135F3631917E}"/>
+                <a16:creationId xmlns:a16="http://schemas.microsoft.com/office/drawing/2014/main" id="{A8B3EC93-6066-4382-9A44-32DE56F0B011}"/>
               </a:ext>
             </a:extLst>
           </p:cNvPr>
@@ -10777,7 +12640,7 @@
           <p:cNvPr id="55" name="">
             <a:extLst xmlns:a="http://schemas.openxmlformats.org/drawingml/2006/main">
               <a:ext uri="{FF2B5EF4-FFF2-40B4-BE49-F238E27FC236}">
-                <a16:creationId xmlns:a16="http://schemas.microsoft.com/office/drawing/2014/main" id="{B7A67172-6B72-4394-8D43-C3C98BB2E4E6}"/>
+                <a16:creationId xmlns:a16="http://schemas.microsoft.com/office/drawing/2014/main" id="{25F76C5A-ABF3-4F2F-85FE-A677DBCF125D}"/>
               </a:ext>
             </a:extLst>
           </p:cNvPr>
@@ -10834,7 +12697,7 @@
           <p:cNvPr id="56" name="">
             <a:extLst xmlns:a="http://schemas.openxmlformats.org/drawingml/2006/main">
               <a:ext uri="{FF2B5EF4-FFF2-40B4-BE49-F238E27FC236}">
-                <a16:creationId xmlns:a16="http://schemas.microsoft.com/office/drawing/2014/main" id="{BD4E2DBC-39AC-46A5-ACD5-73C45E76EBD6}"/>
+                <a16:creationId xmlns:a16="http://schemas.microsoft.com/office/drawing/2014/main" id="{AA75B2B0-F0B1-4EDB-8CEE-77C5D200536A}"/>
               </a:ext>
             </a:extLst>
           </p:cNvPr>
@@ -10914,7 +12777,7 @@
           <p:cNvPr id="57" name="">
             <a:extLst xmlns:a="http://schemas.openxmlformats.org/drawingml/2006/main">
               <a:ext uri="{FF2B5EF4-FFF2-40B4-BE49-F238E27FC236}">
-                <a16:creationId xmlns:a16="http://schemas.microsoft.com/office/drawing/2014/main" id="{FF173A80-DC28-4E8D-BE7A-0948C59F62A1}"/>
+                <a16:creationId xmlns:a16="http://schemas.microsoft.com/office/drawing/2014/main" id="{3E33E262-109D-4097-AA24-4DC77A69299A}"/>
               </a:ext>
             </a:extLst>
           </p:cNvPr>
@@ -10944,7 +12807,7 @@
           <p:cNvPr id="58" name="">
             <a:extLst xmlns:a="http://schemas.openxmlformats.org/drawingml/2006/main">
               <a:ext uri="{FF2B5EF4-FFF2-40B4-BE49-F238E27FC236}">
-                <a16:creationId xmlns:a16="http://schemas.microsoft.com/office/drawing/2014/main" id="{561940C7-D975-4AA9-8803-DE69A3BE1D1D}"/>
+                <a16:creationId xmlns:a16="http://schemas.microsoft.com/office/drawing/2014/main" id="{1455884A-04E3-48A1-83F9-9A8B74D79B92}"/>
               </a:ext>
             </a:extLst>
           </p:cNvPr>
@@ -10976,7 +12839,7 @@
           <p:cNvPr id="59" name="">
             <a:extLst xmlns:a="http://schemas.openxmlformats.org/drawingml/2006/main">
               <a:ext uri="{FF2B5EF4-FFF2-40B4-BE49-F238E27FC236}">
-                <a16:creationId xmlns:a16="http://schemas.microsoft.com/office/drawing/2014/main" id="{F5B3A212-FA3D-4D40-A9B4-C569EDA22E4C}"/>
+                <a16:creationId xmlns:a16="http://schemas.microsoft.com/office/drawing/2014/main" id="{D049A514-4036-4171-B7EE-E5C26C4697D3}"/>
               </a:ext>
             </a:extLst>
           </p:cNvPr>
@@ -11033,7 +12896,7 @@
           <p:cNvPr id="60" name="">
             <a:extLst xmlns:a="http://schemas.openxmlformats.org/drawingml/2006/main">
               <a:ext uri="{FF2B5EF4-FFF2-40B4-BE49-F238E27FC236}">
-                <a16:creationId xmlns:a16="http://schemas.microsoft.com/office/drawing/2014/main" id="{12670197-4C95-409D-A55E-75E70BAE1CFF}"/>
+                <a16:creationId xmlns:a16="http://schemas.microsoft.com/office/drawing/2014/main" id="{47C19ACC-A01F-4895-9E9A-89DF6B7455A5}"/>
               </a:ext>
             </a:extLst>
           </p:cNvPr>
@@ -11113,7 +12976,7 @@
           <p:cNvPr id="61" name="">
             <a:extLst xmlns:a="http://schemas.openxmlformats.org/drawingml/2006/main">
               <a:ext uri="{FF2B5EF4-FFF2-40B4-BE49-F238E27FC236}">
-                <a16:creationId xmlns:a16="http://schemas.microsoft.com/office/drawing/2014/main" id="{97DCE435-89F8-4D7A-8953-15F7D8F6FB39}"/>
+                <a16:creationId xmlns:a16="http://schemas.microsoft.com/office/drawing/2014/main" id="{2EA59DF8-75DB-43E8-92AF-5BEBB42DB3EF}"/>
               </a:ext>
             </a:extLst>
           </p:cNvPr>
@@ -11143,7 +13006,7 @@
           <p:cNvPr id="62" name="">
             <a:extLst xmlns:a="http://schemas.openxmlformats.org/drawingml/2006/main">
               <a:ext uri="{FF2B5EF4-FFF2-40B4-BE49-F238E27FC236}">
-                <a16:creationId xmlns:a16="http://schemas.microsoft.com/office/drawing/2014/main" id="{6C334097-32D0-4F4B-ABBA-F5414E106827}"/>
+                <a16:creationId xmlns:a16="http://schemas.microsoft.com/office/drawing/2014/main" id="{95B9EA50-3F69-4847-ADD8-0ABFE322A0F6}"/>
               </a:ext>
             </a:extLst>
           </p:cNvPr>
@@ -11175,7 +13038,7 @@
           <p:cNvPr id="63" name="">
             <a:extLst xmlns:a="http://schemas.openxmlformats.org/drawingml/2006/main">
               <a:ext uri="{FF2B5EF4-FFF2-40B4-BE49-F238E27FC236}">
-                <a16:creationId xmlns:a16="http://schemas.microsoft.com/office/drawing/2014/main" id="{67DC1503-73E8-4542-8E15-9390FA80B4D9}"/>
+                <a16:creationId xmlns:a16="http://schemas.microsoft.com/office/drawing/2014/main" id="{017E0BAB-DE79-4282-A007-C0F2C41E07BB}"/>
               </a:ext>
             </a:extLst>
           </p:cNvPr>
@@ -11232,7 +13095,7 @@
           <p:cNvPr id="64" name="">
             <a:extLst xmlns:a="http://schemas.openxmlformats.org/drawingml/2006/main">
               <a:ext uri="{FF2B5EF4-FFF2-40B4-BE49-F238E27FC236}">
-                <a16:creationId xmlns:a16="http://schemas.microsoft.com/office/drawing/2014/main" id="{1552BE53-3216-4B84-895E-EA11A6760F15}"/>
+                <a16:creationId xmlns:a16="http://schemas.microsoft.com/office/drawing/2014/main" id="{88C24DE4-7E7F-4625-A8A4-13A3A58507F5}"/>
               </a:ext>
             </a:extLst>
           </p:cNvPr>
@@ -11289,7 +13152,7 @@
           <p:cNvPr id="65" name="">
             <a:extLst xmlns:a="http://schemas.openxmlformats.org/drawingml/2006/main">
               <a:ext uri="{FF2B5EF4-FFF2-40B4-BE49-F238E27FC236}">
-                <a16:creationId xmlns:a16="http://schemas.microsoft.com/office/drawing/2014/main" id="{E8FEC74E-2139-4936-B118-880560403872}"/>
+                <a16:creationId xmlns:a16="http://schemas.microsoft.com/office/drawing/2014/main" id="{1B8DDF0D-9929-43AE-A44D-8596A867638F}"/>
               </a:ext>
             </a:extLst>
           </p:cNvPr>
@@ -11346,7 +13209,7 @@
           <p:cNvPr id="66" name="">
             <a:extLst xmlns:a="http://schemas.openxmlformats.org/drawingml/2006/main">
               <a:ext uri="{FF2B5EF4-FFF2-40B4-BE49-F238E27FC236}">
-                <a16:creationId xmlns:a16="http://schemas.microsoft.com/office/drawing/2014/main" id="{FB57C87D-15F4-467D-A46F-B074F965D899}"/>
+                <a16:creationId xmlns:a16="http://schemas.microsoft.com/office/drawing/2014/main" id="{FCA94C60-BEB0-404A-B2A5-71D7244726E4}"/>
               </a:ext>
             </a:extLst>
           </p:cNvPr>
@@ -13492,7 +15355,7 @@
           <p:cNvPr id="41" name="">
             <a:extLst xmlns:a="http://schemas.openxmlformats.org/drawingml/2006/main">
               <a:ext uri="{FF2B5EF4-FFF2-40B4-BE49-F238E27FC236}">
-                <a16:creationId xmlns:a16="http://schemas.microsoft.com/office/drawing/2014/main" id="{2B5039E2-BE97-40C3-86C2-FA3175E9752B}"/>
+                <a16:creationId xmlns:a16="http://schemas.microsoft.com/office/drawing/2014/main" id="{E3A693FD-74AB-4CF9-8EBF-65A0DF3C969F}"/>
               </a:ext>
             </a:extLst>
           </p:cNvPr>
@@ -13522,7 +15385,7 @@
           <p:cNvPr id="42" name="">
             <a:extLst xmlns:a="http://schemas.openxmlformats.org/drawingml/2006/main">
               <a:ext uri="{FF2B5EF4-FFF2-40B4-BE49-F238E27FC236}">
-                <a16:creationId xmlns:a16="http://schemas.microsoft.com/office/drawing/2014/main" id="{F8FCD2AE-2563-4E05-B326-2546EA14C774}"/>
+                <a16:creationId xmlns:a16="http://schemas.microsoft.com/office/drawing/2014/main" id="{9FC56A02-F138-4E31-92E4-D0F5A795F143}"/>
               </a:ext>
             </a:extLst>
           </p:cNvPr>
@@ -13579,7 +15442,7 @@
           <p:cNvPr id="43" name="">
             <a:extLst xmlns:a="http://schemas.openxmlformats.org/drawingml/2006/main">
               <a:ext uri="{FF2B5EF4-FFF2-40B4-BE49-F238E27FC236}">
-                <a16:creationId xmlns:a16="http://schemas.microsoft.com/office/drawing/2014/main" id="{17B27F92-AB42-4550-9CDC-182186A9A86F}"/>
+                <a16:creationId xmlns:a16="http://schemas.microsoft.com/office/drawing/2014/main" id="{EAEF0BF3-988E-416F-B2C9-E317716FC549}"/>
               </a:ext>
             </a:extLst>
           </p:cNvPr>
@@ -13636,7 +15499,7 @@
           <p:cNvPr id="44" name="">
             <a:extLst xmlns:a="http://schemas.openxmlformats.org/drawingml/2006/main">
               <a:ext uri="{FF2B5EF4-FFF2-40B4-BE49-F238E27FC236}">
-                <a16:creationId xmlns:a16="http://schemas.microsoft.com/office/drawing/2014/main" id="{1B405CC6-A184-4BB4-9C0A-645DB2BD1897}"/>
+                <a16:creationId xmlns:a16="http://schemas.microsoft.com/office/drawing/2014/main" id="{B9E5C05B-6BC3-4413-8064-7364BF29C119}"/>
               </a:ext>
             </a:extLst>
           </p:cNvPr>
@@ -13693,7 +15556,7 @@
           <p:cNvPr id="45" name="">
             <a:extLst xmlns:a="http://schemas.openxmlformats.org/drawingml/2006/main">
               <a:ext uri="{FF2B5EF4-FFF2-40B4-BE49-F238E27FC236}">
-                <a16:creationId xmlns:a16="http://schemas.microsoft.com/office/drawing/2014/main" id="{79AB41EB-4084-44B7-AE3B-3352EBB73EB9}"/>
+                <a16:creationId xmlns:a16="http://schemas.microsoft.com/office/drawing/2014/main" id="{E0E72B31-ADCE-4D2C-8FDC-657287049C89}"/>
               </a:ext>
             </a:extLst>
           </p:cNvPr>
@@ -13750,7 +15613,7 @@
           <p:cNvPr id="46" name="">
             <a:extLst xmlns:a="http://schemas.openxmlformats.org/drawingml/2006/main">
               <a:ext uri="{FF2B5EF4-FFF2-40B4-BE49-F238E27FC236}">
-                <a16:creationId xmlns:a16="http://schemas.microsoft.com/office/drawing/2014/main" id="{A58E3F6B-0E57-4D74-8E34-EBB02F790856}"/>
+                <a16:creationId xmlns:a16="http://schemas.microsoft.com/office/drawing/2014/main" id="{CEE03F19-5AE5-43DA-84D3-4FE7F4BA3CE2}"/>
               </a:ext>
             </a:extLst>
           </p:cNvPr>
@@ -13780,7 +15643,7 @@
           <p:cNvPr id="47" name="">
             <a:extLst xmlns:a="http://schemas.openxmlformats.org/drawingml/2006/main">
               <a:ext uri="{FF2B5EF4-FFF2-40B4-BE49-F238E27FC236}">
-                <a16:creationId xmlns:a16="http://schemas.microsoft.com/office/drawing/2014/main" id="{68E206BF-61F8-46FE-9858-2E6B8C2AD917}"/>
+                <a16:creationId xmlns:a16="http://schemas.microsoft.com/office/drawing/2014/main" id="{4E6248F6-B6F0-473B-9C7D-1265BAB2EDF8}"/>
               </a:ext>
             </a:extLst>
           </p:cNvPr>
@@ -13814,7 +15677,7 @@
           <p:cNvPr id="48" name="">
             <a:extLst xmlns:a="http://schemas.openxmlformats.org/drawingml/2006/main">
               <a:ext uri="{FF2B5EF4-FFF2-40B4-BE49-F238E27FC236}">
-                <a16:creationId xmlns:a16="http://schemas.microsoft.com/office/drawing/2014/main" id="{0051D598-A4EE-4936-858E-5B396A46AF9F}"/>
+                <a16:creationId xmlns:a16="http://schemas.microsoft.com/office/drawing/2014/main" id="{6B14125A-6F3A-425F-8EA7-57349C8FFBC3}"/>
               </a:ext>
             </a:extLst>
           </p:cNvPr>
@@ -13846,7 +15709,7 @@
           <p:cNvPr id="49" name="">
             <a:extLst xmlns:a="http://schemas.openxmlformats.org/drawingml/2006/main">
               <a:ext uri="{FF2B5EF4-FFF2-40B4-BE49-F238E27FC236}">
-                <a16:creationId xmlns:a16="http://schemas.microsoft.com/office/drawing/2014/main" id="{444EFF8C-FF98-4C29-88AB-48F76BB1E085}"/>
+                <a16:creationId xmlns:a16="http://schemas.microsoft.com/office/drawing/2014/main" id="{E3BD7B36-BBCC-4A54-9CD8-07C30AF49D55}"/>
               </a:ext>
             </a:extLst>
           </p:cNvPr>
@@ -13903,7 +15766,7 @@
           <p:cNvPr id="50" name="">
             <a:extLst xmlns:a="http://schemas.openxmlformats.org/drawingml/2006/main">
               <a:ext uri="{FF2B5EF4-FFF2-40B4-BE49-F238E27FC236}">
-                <a16:creationId xmlns:a16="http://schemas.microsoft.com/office/drawing/2014/main" id="{D9E76C3A-FA73-4F6E-9499-2BC983AEB496}"/>
+                <a16:creationId xmlns:a16="http://schemas.microsoft.com/office/drawing/2014/main" id="{6F2A9A5A-32BB-4EBD-B698-EF90EA40E1B9}"/>
               </a:ext>
             </a:extLst>
           </p:cNvPr>
@@ -13960,7 +15823,7 @@
           <p:cNvPr id="51" name="">
             <a:extLst xmlns:a="http://schemas.openxmlformats.org/drawingml/2006/main">
               <a:ext uri="{FF2B5EF4-FFF2-40B4-BE49-F238E27FC236}">
-                <a16:creationId xmlns:a16="http://schemas.microsoft.com/office/drawing/2014/main" id="{B73E27BB-E8EE-4726-9C94-9E6F190C64FF}"/>
+                <a16:creationId xmlns:a16="http://schemas.microsoft.com/office/drawing/2014/main" id="{6D8A062A-BC49-4E36-8505-476446988357}"/>
               </a:ext>
             </a:extLst>
           </p:cNvPr>
@@ -14017,7 +15880,7 @@
           <p:cNvPr id="52" name="">
             <a:extLst xmlns:a="http://schemas.openxmlformats.org/drawingml/2006/main">
               <a:ext uri="{FF2B5EF4-FFF2-40B4-BE49-F238E27FC236}">
-                <a16:creationId xmlns:a16="http://schemas.microsoft.com/office/drawing/2014/main" id="{2467BA19-9714-443A-9FC4-6A96C40BA8CA}"/>
+                <a16:creationId xmlns:a16="http://schemas.microsoft.com/office/drawing/2014/main" id="{9CBE23EB-65E8-491F-A65E-A6BBCD3852D2}"/>
               </a:ext>
             </a:extLst>
           </p:cNvPr>
@@ -14051,7 +15914,7 @@
           <p:cNvPr id="53" name="">
             <a:extLst xmlns:a="http://schemas.openxmlformats.org/drawingml/2006/main">
               <a:ext uri="{FF2B5EF4-FFF2-40B4-BE49-F238E27FC236}">
-                <a16:creationId xmlns:a16="http://schemas.microsoft.com/office/drawing/2014/main" id="{42845D91-1603-407F-BBAB-D2B5D0B6C8FE}"/>
+                <a16:creationId xmlns:a16="http://schemas.microsoft.com/office/drawing/2014/main" id="{B0D33192-5F9F-4E85-8522-5E8CC2FCC108}"/>
               </a:ext>
             </a:extLst>
           </p:cNvPr>
@@ -14083,7 +15946,7 @@
           <p:cNvPr id="54" name="">
             <a:extLst xmlns:a="http://schemas.openxmlformats.org/drawingml/2006/main">
               <a:ext uri="{FF2B5EF4-FFF2-40B4-BE49-F238E27FC236}">
-                <a16:creationId xmlns:a16="http://schemas.microsoft.com/office/drawing/2014/main" id="{D2BAAD05-369B-4BD9-9043-AD834F9DAA67}"/>
+                <a16:creationId xmlns:a16="http://schemas.microsoft.com/office/drawing/2014/main" id="{4D6B43F3-9A9B-4802-AADE-A55010C74D1C}"/>
               </a:ext>
             </a:extLst>
           </p:cNvPr>
@@ -14140,7 +16003,7 @@
           <p:cNvPr id="55" name="">
             <a:extLst xmlns:a="http://schemas.openxmlformats.org/drawingml/2006/main">
               <a:ext uri="{FF2B5EF4-FFF2-40B4-BE49-F238E27FC236}">
-                <a16:creationId xmlns:a16="http://schemas.microsoft.com/office/drawing/2014/main" id="{8CBFAB0E-DCAD-491C-B1B5-CBA35123595F}"/>
+                <a16:creationId xmlns:a16="http://schemas.microsoft.com/office/drawing/2014/main" id="{91DCBB4D-7B8A-494A-A725-3825A4502F5A}"/>
               </a:ext>
             </a:extLst>
           </p:cNvPr>
@@ -14197,7 +16060,7 @@
           <p:cNvPr id="56" name="">
             <a:extLst xmlns:a="http://schemas.openxmlformats.org/drawingml/2006/main">
               <a:ext uri="{FF2B5EF4-FFF2-40B4-BE49-F238E27FC236}">
-                <a16:creationId xmlns:a16="http://schemas.microsoft.com/office/drawing/2014/main" id="{94BF993E-B449-4592-8741-9D6141DE244A}"/>
+                <a16:creationId xmlns:a16="http://schemas.microsoft.com/office/drawing/2014/main" id="{76F8FD65-3416-42A2-94A2-02BBE426F25E}"/>
               </a:ext>
             </a:extLst>
           </p:cNvPr>
@@ -14254,7 +16117,7 @@
           <p:cNvPr id="57" name="">
             <a:extLst xmlns:a="http://schemas.openxmlformats.org/drawingml/2006/main">
               <a:ext uri="{FF2B5EF4-FFF2-40B4-BE49-F238E27FC236}">
-                <a16:creationId xmlns:a16="http://schemas.microsoft.com/office/drawing/2014/main" id="{3C9D48D7-2902-4036-B3A7-AFEAC7502A69}"/>
+                <a16:creationId xmlns:a16="http://schemas.microsoft.com/office/drawing/2014/main" id="{67AAF4CB-286B-481E-BE19-910226C1F926}"/>
               </a:ext>
             </a:extLst>
           </p:cNvPr>
@@ -14288,7 +16151,7 @@
           <p:cNvPr id="58" name="">
             <a:extLst xmlns:a="http://schemas.openxmlformats.org/drawingml/2006/main">
               <a:ext uri="{FF2B5EF4-FFF2-40B4-BE49-F238E27FC236}">
-                <a16:creationId xmlns:a16="http://schemas.microsoft.com/office/drawing/2014/main" id="{EB27528C-401B-4B41-AACC-A41B774BCCEC}"/>
+                <a16:creationId xmlns:a16="http://schemas.microsoft.com/office/drawing/2014/main" id="{16E616E1-6960-4107-9762-2A241FE7E226}"/>
               </a:ext>
             </a:extLst>
           </p:cNvPr>
@@ -14320,7 +16183,7 @@
           <p:cNvPr id="59" name="">
             <a:extLst xmlns:a="http://schemas.openxmlformats.org/drawingml/2006/main">
               <a:ext uri="{FF2B5EF4-FFF2-40B4-BE49-F238E27FC236}">
-                <a16:creationId xmlns:a16="http://schemas.microsoft.com/office/drawing/2014/main" id="{ED7F0564-1F9E-4185-AB41-FB51BE345494}"/>
+                <a16:creationId xmlns:a16="http://schemas.microsoft.com/office/drawing/2014/main" id="{47D8A961-A864-46D4-AA80-B5033BB53ED7}"/>
               </a:ext>
             </a:extLst>
           </p:cNvPr>
@@ -14377,7 +16240,7 @@
           <p:cNvPr id="60" name="">
             <a:extLst xmlns:a="http://schemas.openxmlformats.org/drawingml/2006/main">
               <a:ext uri="{FF2B5EF4-FFF2-40B4-BE49-F238E27FC236}">
-                <a16:creationId xmlns:a16="http://schemas.microsoft.com/office/drawing/2014/main" id="{652191A0-600B-438B-ABAA-37D58B202E88}"/>
+                <a16:creationId xmlns:a16="http://schemas.microsoft.com/office/drawing/2014/main" id="{BF22A76C-1C10-4BFC-9494-2557B36B859A}"/>
               </a:ext>
             </a:extLst>
           </p:cNvPr>
@@ -14434,7 +16297,7 @@
           <p:cNvPr id="61" name="">
             <a:extLst xmlns:a="http://schemas.openxmlformats.org/drawingml/2006/main">
               <a:ext uri="{FF2B5EF4-FFF2-40B4-BE49-F238E27FC236}">
-                <a16:creationId xmlns:a16="http://schemas.microsoft.com/office/drawing/2014/main" id="{CBAD87C3-F7A2-4CB6-B8DA-81C209538920}"/>
+                <a16:creationId xmlns:a16="http://schemas.microsoft.com/office/drawing/2014/main" id="{4A037959-B642-488F-9250-D3935AE6C135}"/>
               </a:ext>
             </a:extLst>
           </p:cNvPr>
@@ -14491,7 +16354,7 @@
           <p:cNvPr id="62" name="">
             <a:extLst xmlns:a="http://schemas.openxmlformats.org/drawingml/2006/main">
               <a:ext uri="{FF2B5EF4-FFF2-40B4-BE49-F238E27FC236}">
-                <a16:creationId xmlns:a16="http://schemas.microsoft.com/office/drawing/2014/main" id="{A7A762F8-D4E8-48D7-9E6A-D3AF9691F208}"/>
+                <a16:creationId xmlns:a16="http://schemas.microsoft.com/office/drawing/2014/main" id="{1AC2AABA-7767-4101-984A-4F8ED33DE62A}"/>
               </a:ext>
             </a:extLst>
           </p:cNvPr>
@@ -14525,7 +16388,7 @@
           <p:cNvPr id="63" name="">
             <a:extLst xmlns:a="http://schemas.openxmlformats.org/drawingml/2006/main">
               <a:ext uri="{FF2B5EF4-FFF2-40B4-BE49-F238E27FC236}">
-                <a16:creationId xmlns:a16="http://schemas.microsoft.com/office/drawing/2014/main" id="{927F0A87-0E82-4383-9454-FBB57E986766}"/>
+                <a16:creationId xmlns:a16="http://schemas.microsoft.com/office/drawing/2014/main" id="{DC8F574E-729F-4DB2-8D4B-7D99D4BDC031}"/>
               </a:ext>
             </a:extLst>
           </p:cNvPr>
@@ -14557,7 +16420,7 @@
           <p:cNvPr id="64" name="">
             <a:extLst xmlns:a="http://schemas.openxmlformats.org/drawingml/2006/main">
               <a:ext uri="{FF2B5EF4-FFF2-40B4-BE49-F238E27FC236}">
-                <a16:creationId xmlns:a16="http://schemas.microsoft.com/office/drawing/2014/main" id="{502805AA-0E8C-4532-B760-9AE9F85BB953}"/>
+                <a16:creationId xmlns:a16="http://schemas.microsoft.com/office/drawing/2014/main" id="{DFA8C6C5-2DB1-4615-8149-01131A0B15E0}"/>
               </a:ext>
             </a:extLst>
           </p:cNvPr>
@@ -14614,7 +16477,7 @@
           <p:cNvPr id="65" name="">
             <a:extLst xmlns:a="http://schemas.openxmlformats.org/drawingml/2006/main">
               <a:ext uri="{FF2B5EF4-FFF2-40B4-BE49-F238E27FC236}">
-                <a16:creationId xmlns:a16="http://schemas.microsoft.com/office/drawing/2014/main" id="{0ACAF177-CE0B-46ED-8B30-D43E3CC6065F}"/>
+                <a16:creationId xmlns:a16="http://schemas.microsoft.com/office/drawing/2014/main" id="{2E032E2B-4E27-448A-BB3B-93A70B126D61}"/>
               </a:ext>
             </a:extLst>
           </p:cNvPr>
@@ -14671,7 +16534,7 @@
           <p:cNvPr id="66" name="">
             <a:extLst xmlns:a="http://schemas.openxmlformats.org/drawingml/2006/main">
               <a:ext uri="{FF2B5EF4-FFF2-40B4-BE49-F238E27FC236}">
-                <a16:creationId xmlns:a16="http://schemas.microsoft.com/office/drawing/2014/main" id="{9F17BA2F-0E85-43B3-94FA-AC620C667E6A}"/>
+                <a16:creationId xmlns:a16="http://schemas.microsoft.com/office/drawing/2014/main" id="{1E9DC06A-F10B-4E4D-8284-61C75EF38D19}"/>
               </a:ext>
             </a:extLst>
           </p:cNvPr>
@@ -14751,7 +16614,7 @@
           <p:cNvPr id="67" name="">
             <a:extLst xmlns:a="http://schemas.openxmlformats.org/drawingml/2006/main">
               <a:ext uri="{FF2B5EF4-FFF2-40B4-BE49-F238E27FC236}">
-                <a16:creationId xmlns:a16="http://schemas.microsoft.com/office/drawing/2014/main" id="{548959C0-5C65-4DE1-9206-28D640C6EDB9}"/>
+                <a16:creationId xmlns:a16="http://schemas.microsoft.com/office/drawing/2014/main" id="{B6B325B3-7423-4ACC-9A5E-23F1CF86F791}"/>
               </a:ext>
             </a:extLst>
           </p:cNvPr>
@@ -14783,7 +16646,7 @@
           <p:cNvPr id="68" name="">
             <a:extLst xmlns:a="http://schemas.openxmlformats.org/drawingml/2006/main">
               <a:ext uri="{FF2B5EF4-FFF2-40B4-BE49-F238E27FC236}">
-                <a16:creationId xmlns:a16="http://schemas.microsoft.com/office/drawing/2014/main" id="{D81F501C-D700-4252-8537-3D8A898B4957}"/>
+                <a16:creationId xmlns:a16="http://schemas.microsoft.com/office/drawing/2014/main" id="{BFA0A1F2-513E-409C-B6A6-4B655EFC37E1}"/>
               </a:ext>
             </a:extLst>
           </p:cNvPr>
@@ -14840,7 +16703,7 @@
           <p:cNvPr id="69" name="">
             <a:extLst xmlns:a="http://schemas.openxmlformats.org/drawingml/2006/main">
               <a:ext uri="{FF2B5EF4-FFF2-40B4-BE49-F238E27FC236}">
-                <a16:creationId xmlns:a16="http://schemas.microsoft.com/office/drawing/2014/main" id="{56A3FEBC-F45C-4F14-AF0C-95966982BE17}"/>
+                <a16:creationId xmlns:a16="http://schemas.microsoft.com/office/drawing/2014/main" id="{B4E27626-76C9-43B3-A391-358EB756212C}"/>
               </a:ext>
             </a:extLst>
           </p:cNvPr>
@@ -16219,7 +18082,7 @@
           <p:cNvPr id="27" name="">
             <a:extLst xmlns:a="http://schemas.openxmlformats.org/drawingml/2006/main">
               <a:ext uri="{FF2B5EF4-FFF2-40B4-BE49-F238E27FC236}">
-                <a16:creationId xmlns:a16="http://schemas.microsoft.com/office/drawing/2014/main" id="{1C4A4BB8-861B-4409-9CAA-0B9633BEC0F1}"/>
+                <a16:creationId xmlns:a16="http://schemas.microsoft.com/office/drawing/2014/main" id="{D8F80730-6613-48F1-AB3D-C0C9C42BC270}"/>
               </a:ext>
             </a:extLst>
           </p:cNvPr>
@@ -16249,7 +18112,7 @@
           <p:cNvPr id="28" name="">
             <a:extLst xmlns:a="http://schemas.openxmlformats.org/drawingml/2006/main">
               <a:ext uri="{FF2B5EF4-FFF2-40B4-BE49-F238E27FC236}">
-                <a16:creationId xmlns:a16="http://schemas.microsoft.com/office/drawing/2014/main" id="{C5C4A38A-CE7A-4160-8C79-86947E6456F9}"/>
+                <a16:creationId xmlns:a16="http://schemas.microsoft.com/office/drawing/2014/main" id="{AE9587B1-4457-47A2-A02B-8858A03B592B}"/>
               </a:ext>
             </a:extLst>
           </p:cNvPr>
@@ -16306,7 +18169,7 @@
           <p:cNvPr id="29" name="">
             <a:extLst xmlns:a="http://schemas.openxmlformats.org/drawingml/2006/main">
               <a:ext uri="{FF2B5EF4-FFF2-40B4-BE49-F238E27FC236}">
-                <a16:creationId xmlns:a16="http://schemas.microsoft.com/office/drawing/2014/main" id="{F3A0E616-2D8E-4D14-88AD-3635A6196BD4}"/>
+                <a16:creationId xmlns:a16="http://schemas.microsoft.com/office/drawing/2014/main" id="{1C52DDA8-F0DC-4297-B172-CF4779822E15}"/>
               </a:ext>
             </a:extLst>
           </p:cNvPr>
@@ -16363,7 +18226,7 @@
           <p:cNvPr id="30" name="">
             <a:extLst xmlns:a="http://schemas.openxmlformats.org/drawingml/2006/main">
               <a:ext uri="{FF2B5EF4-FFF2-40B4-BE49-F238E27FC236}">
-                <a16:creationId xmlns:a16="http://schemas.microsoft.com/office/drawing/2014/main" id="{A25CF144-636C-4EA1-89F0-E72FAEC82C8E}"/>
+                <a16:creationId xmlns:a16="http://schemas.microsoft.com/office/drawing/2014/main" id="{6E01A67E-9D2C-4DD7-B582-047CC583C45B}"/>
               </a:ext>
             </a:extLst>
           </p:cNvPr>
@@ -16420,7 +18283,7 @@
           <p:cNvPr id="31" name="">
             <a:extLst xmlns:a="http://schemas.openxmlformats.org/drawingml/2006/main">
               <a:ext uri="{FF2B5EF4-FFF2-40B4-BE49-F238E27FC236}">
-                <a16:creationId xmlns:a16="http://schemas.microsoft.com/office/drawing/2014/main" id="{A87D638A-6832-4674-9B52-E85A0BA7C1C8}"/>
+                <a16:creationId xmlns:a16="http://schemas.microsoft.com/office/drawing/2014/main" id="{D38E751B-8A38-4508-9811-A50C89EEFF69}"/>
               </a:ext>
             </a:extLst>
           </p:cNvPr>
@@ -16477,7 +18340,7 @@
           <p:cNvPr id="32" name="">
             <a:extLst xmlns:a="http://schemas.openxmlformats.org/drawingml/2006/main">
               <a:ext uri="{FF2B5EF4-FFF2-40B4-BE49-F238E27FC236}">
-                <a16:creationId xmlns:a16="http://schemas.microsoft.com/office/drawing/2014/main" id="{5CDD88B9-7AFD-4AFD-8F5F-5FE8695DF819}"/>
+                <a16:creationId xmlns:a16="http://schemas.microsoft.com/office/drawing/2014/main" id="{00B196DD-604E-47D2-B2F6-80EE83DA8796}"/>
               </a:ext>
             </a:extLst>
           </p:cNvPr>
@@ -16507,7 +18370,7 @@
           <p:cNvPr id="33" name="">
             <a:extLst xmlns:a="http://schemas.openxmlformats.org/drawingml/2006/main">
               <a:ext uri="{FF2B5EF4-FFF2-40B4-BE49-F238E27FC236}">
-                <a16:creationId xmlns:a16="http://schemas.microsoft.com/office/drawing/2014/main" id="{9FB2D609-A8D6-410B-99E4-C9A9ABF915D4}"/>
+                <a16:creationId xmlns:a16="http://schemas.microsoft.com/office/drawing/2014/main" id="{D5C3472D-B417-4BF7-8D04-235B978D5494}"/>
               </a:ext>
             </a:extLst>
           </p:cNvPr>
@@ -16537,7 +18400,7 @@
           <p:cNvPr id="34" name="">
             <a:extLst xmlns:a="http://schemas.openxmlformats.org/drawingml/2006/main">
               <a:ext uri="{FF2B5EF4-FFF2-40B4-BE49-F238E27FC236}">
-                <a16:creationId xmlns:a16="http://schemas.microsoft.com/office/drawing/2014/main" id="{E378DD27-799C-4708-B4D7-B97B5B6CCDFD}"/>
+                <a16:creationId xmlns:a16="http://schemas.microsoft.com/office/drawing/2014/main" id="{D9645F00-D4D3-4BF5-8980-6508F6D2137F}"/>
               </a:ext>
             </a:extLst>
           </p:cNvPr>
@@ -16567,7 +18430,7 @@
           <p:cNvPr id="35" name="">
             <a:extLst xmlns:a="http://schemas.openxmlformats.org/drawingml/2006/main">
               <a:ext uri="{FF2B5EF4-FFF2-40B4-BE49-F238E27FC236}">
-                <a16:creationId xmlns:a16="http://schemas.microsoft.com/office/drawing/2014/main" id="{C1ECDEFC-77BF-4EC8-A3A8-3FE6862C0023}"/>
+                <a16:creationId xmlns:a16="http://schemas.microsoft.com/office/drawing/2014/main" id="{A8A0BA39-7DFE-4201-B3D8-9D77403DDB01}"/>
               </a:ext>
             </a:extLst>
           </p:cNvPr>
@@ -16624,7 +18487,7 @@
           <p:cNvPr id="36" name="">
             <a:extLst xmlns:a="http://schemas.openxmlformats.org/drawingml/2006/main">
               <a:ext uri="{FF2B5EF4-FFF2-40B4-BE49-F238E27FC236}">
-                <a16:creationId xmlns:a16="http://schemas.microsoft.com/office/drawing/2014/main" id="{8844527F-CEF8-4DEC-A447-EDDE8BDA3248}"/>
+                <a16:creationId xmlns:a16="http://schemas.microsoft.com/office/drawing/2014/main" id="{2667EE31-1F93-4D06-9535-B80FCBE7E8BD}"/>
               </a:ext>
             </a:extLst>
           </p:cNvPr>
@@ -16681,7 +18544,7 @@
           <p:cNvPr id="37" name="">
             <a:extLst xmlns:a="http://schemas.openxmlformats.org/drawingml/2006/main">
               <a:ext uri="{FF2B5EF4-FFF2-40B4-BE49-F238E27FC236}">
-                <a16:creationId xmlns:a16="http://schemas.microsoft.com/office/drawing/2014/main" id="{7CF4B0A7-F18B-457D-9BED-C40DA4345EBB}"/>
+                <a16:creationId xmlns:a16="http://schemas.microsoft.com/office/drawing/2014/main" id="{02512B0E-82AC-4B18-A7FA-E14A1CCE5D45}"/>
               </a:ext>
             </a:extLst>
           </p:cNvPr>
@@ -16761,7 +18624,7 @@
           <p:cNvPr id="38" name="">
             <a:extLst xmlns:a="http://schemas.openxmlformats.org/drawingml/2006/main">
               <a:ext uri="{FF2B5EF4-FFF2-40B4-BE49-F238E27FC236}">
-                <a16:creationId xmlns:a16="http://schemas.microsoft.com/office/drawing/2014/main" id="{2B6CC462-CE8D-4867-AB28-4211484E08E9}"/>
+                <a16:creationId xmlns:a16="http://schemas.microsoft.com/office/drawing/2014/main" id="{9BEC85A1-CE7E-4A79-A082-627995F65474}"/>
               </a:ext>
             </a:extLst>
           </p:cNvPr>
@@ -16791,7 +18654,7 @@
           <p:cNvPr id="39" name="">
             <a:extLst xmlns:a="http://schemas.openxmlformats.org/drawingml/2006/main">
               <a:ext uri="{FF2B5EF4-FFF2-40B4-BE49-F238E27FC236}">
-                <a16:creationId xmlns:a16="http://schemas.microsoft.com/office/drawing/2014/main" id="{7140E700-5E17-4C08-8C3E-791EE55110B5}"/>
+                <a16:creationId xmlns:a16="http://schemas.microsoft.com/office/drawing/2014/main" id="{A4FD3B39-0F3A-4236-9BD2-0801C1B1BB9D}"/>
               </a:ext>
             </a:extLst>
           </p:cNvPr>
@@ -16821,7 +18684,7 @@
           <p:cNvPr id="40" name="">
             <a:extLst xmlns:a="http://schemas.openxmlformats.org/drawingml/2006/main">
               <a:ext uri="{FF2B5EF4-FFF2-40B4-BE49-F238E27FC236}">
-                <a16:creationId xmlns:a16="http://schemas.microsoft.com/office/drawing/2014/main" id="{0064F8CE-BD6A-466A-82A3-9E71C39A1D4F}"/>
+                <a16:creationId xmlns:a16="http://schemas.microsoft.com/office/drawing/2014/main" id="{AC7301E5-46B3-4FC0-BF30-5D427BDA3713}"/>
               </a:ext>
             </a:extLst>
           </p:cNvPr>
@@ -16878,7 +18741,7 @@
           <p:cNvPr id="41" name="">
             <a:extLst xmlns:a="http://schemas.openxmlformats.org/drawingml/2006/main">
               <a:ext uri="{FF2B5EF4-FFF2-40B4-BE49-F238E27FC236}">
-                <a16:creationId xmlns:a16="http://schemas.microsoft.com/office/drawing/2014/main" id="{7ED542A8-3C73-4065-A656-3F66D79E87AB}"/>
+                <a16:creationId xmlns:a16="http://schemas.microsoft.com/office/drawing/2014/main" id="{7F1DCCB5-6F0A-48C6-ABC7-38B0F74D280D}"/>
               </a:ext>
             </a:extLst>
           </p:cNvPr>
@@ -16935,7 +18798,7 @@
           <p:cNvPr id="42" name="">
             <a:extLst xmlns:a="http://schemas.openxmlformats.org/drawingml/2006/main">
               <a:ext uri="{FF2B5EF4-FFF2-40B4-BE49-F238E27FC236}">
-                <a16:creationId xmlns:a16="http://schemas.microsoft.com/office/drawing/2014/main" id="{2CB4B17B-4747-42DE-BC92-0300C7159EB8}"/>
+                <a16:creationId xmlns:a16="http://schemas.microsoft.com/office/drawing/2014/main" id="{8C7ABC10-CDA8-4A39-A75C-6B3C02220208}"/>
               </a:ext>
             </a:extLst>
           </p:cNvPr>
@@ -17015,7 +18878,7 @@
           <p:cNvPr id="43" name="">
             <a:extLst xmlns:a="http://schemas.openxmlformats.org/drawingml/2006/main">
               <a:ext uri="{FF2B5EF4-FFF2-40B4-BE49-F238E27FC236}">
-                <a16:creationId xmlns:a16="http://schemas.microsoft.com/office/drawing/2014/main" id="{651D1B1C-1FF1-48C4-9F98-7DCDADCAAEA4}"/>
+                <a16:creationId xmlns:a16="http://schemas.microsoft.com/office/drawing/2014/main" id="{2D29FF7E-F7D5-41D3-A01C-E609471CD147}"/>
               </a:ext>
             </a:extLst>
           </p:cNvPr>
@@ -17045,7 +18908,7 @@
           <p:cNvPr id="44" name="">
             <a:extLst xmlns:a="http://schemas.openxmlformats.org/drawingml/2006/main">
               <a:ext uri="{FF2B5EF4-FFF2-40B4-BE49-F238E27FC236}">
-                <a16:creationId xmlns:a16="http://schemas.microsoft.com/office/drawing/2014/main" id="{C357297C-BDDF-4A6F-92BE-521F97AC7A2B}"/>
+                <a16:creationId xmlns:a16="http://schemas.microsoft.com/office/drawing/2014/main" id="{44DC7F75-E629-43F3-BAC5-2AB6CEF31D46}"/>
               </a:ext>
             </a:extLst>
           </p:cNvPr>
@@ -17075,7 +18938,7 @@
           <p:cNvPr id="45" name="">
             <a:extLst xmlns:a="http://schemas.openxmlformats.org/drawingml/2006/main">
               <a:ext uri="{FF2B5EF4-FFF2-40B4-BE49-F238E27FC236}">
-                <a16:creationId xmlns:a16="http://schemas.microsoft.com/office/drawing/2014/main" id="{6EA3719B-BF71-4965-8AFC-1B07C31410A8}"/>
+                <a16:creationId xmlns:a16="http://schemas.microsoft.com/office/drawing/2014/main" id="{6DF2338E-4519-4E6D-B404-A54E7046FEBB}"/>
               </a:ext>
             </a:extLst>
           </p:cNvPr>
@@ -17132,7 +18995,7 @@
           <p:cNvPr id="46" name="">
             <a:extLst xmlns:a="http://schemas.openxmlformats.org/drawingml/2006/main">
               <a:ext uri="{FF2B5EF4-FFF2-40B4-BE49-F238E27FC236}">
-                <a16:creationId xmlns:a16="http://schemas.microsoft.com/office/drawing/2014/main" id="{6A74D5A4-B27E-4C50-AE77-CB74196B9C86}"/>
+                <a16:creationId xmlns:a16="http://schemas.microsoft.com/office/drawing/2014/main" id="{9DE12633-4838-49CA-8E54-BC72F4F94F98}"/>
               </a:ext>
             </a:extLst>
           </p:cNvPr>
@@ -17189,7 +19052,7 @@
           <p:cNvPr id="47" name="">
             <a:extLst xmlns:a="http://schemas.openxmlformats.org/drawingml/2006/main">
               <a:ext uri="{FF2B5EF4-FFF2-40B4-BE49-F238E27FC236}">
-                <a16:creationId xmlns:a16="http://schemas.microsoft.com/office/drawing/2014/main" id="{AE0DE79C-0B8A-4C71-912F-F301ED20CDE1}"/>
+                <a16:creationId xmlns:a16="http://schemas.microsoft.com/office/drawing/2014/main" id="{66FAAF04-8A93-429E-B152-8A19DCEED571}"/>
               </a:ext>
             </a:extLst>
           </p:cNvPr>
@@ -17269,7 +19132,7 @@
           <p:cNvPr id="48" name="">
             <a:extLst xmlns:a="http://schemas.openxmlformats.org/drawingml/2006/main">
               <a:ext uri="{FF2B5EF4-FFF2-40B4-BE49-F238E27FC236}">
-                <a16:creationId xmlns:a16="http://schemas.microsoft.com/office/drawing/2014/main" id="{FB5F7E99-A4BD-4D95-9A43-3A35CC0AFD52}"/>
+                <a16:creationId xmlns:a16="http://schemas.microsoft.com/office/drawing/2014/main" id="{860022DF-409A-4789-8EC5-D957A812575C}"/>
               </a:ext>
             </a:extLst>
           </p:cNvPr>
@@ -17299,7 +19162,7 @@
           <p:cNvPr id="49" name="">
             <a:extLst xmlns:a="http://schemas.openxmlformats.org/drawingml/2006/main">
               <a:ext uri="{FF2B5EF4-FFF2-40B4-BE49-F238E27FC236}">
-                <a16:creationId xmlns:a16="http://schemas.microsoft.com/office/drawing/2014/main" id="{862CFBAB-8E4A-4C07-B6C1-3433E307044E}"/>
+                <a16:creationId xmlns:a16="http://schemas.microsoft.com/office/drawing/2014/main" id="{D42CD3CF-A054-445A-B017-0CB43C255295}"/>
               </a:ext>
             </a:extLst>
           </p:cNvPr>
@@ -17329,7 +19192,7 @@
           <p:cNvPr id="50" name="">
             <a:extLst xmlns:a="http://schemas.openxmlformats.org/drawingml/2006/main">
               <a:ext uri="{FF2B5EF4-FFF2-40B4-BE49-F238E27FC236}">
-                <a16:creationId xmlns:a16="http://schemas.microsoft.com/office/drawing/2014/main" id="{D7330507-66F9-43CC-8C65-FB71DE2A1CCC}"/>
+                <a16:creationId xmlns:a16="http://schemas.microsoft.com/office/drawing/2014/main" id="{19F9BD2E-9888-4554-B752-DF6A098D7C46}"/>
               </a:ext>
             </a:extLst>
           </p:cNvPr>
@@ -17386,7 +19249,7 @@
           <p:cNvPr id="51" name="">
             <a:extLst xmlns:a="http://schemas.openxmlformats.org/drawingml/2006/main">
               <a:ext uri="{FF2B5EF4-FFF2-40B4-BE49-F238E27FC236}">
-                <a16:creationId xmlns:a16="http://schemas.microsoft.com/office/drawing/2014/main" id="{37C6955E-2F7A-47FD-8FF7-5D5BA03F00B9}"/>
+                <a16:creationId xmlns:a16="http://schemas.microsoft.com/office/drawing/2014/main" id="{E5FA0676-7079-4B92-85F0-A18A9C1B9814}"/>
               </a:ext>
             </a:extLst>
           </p:cNvPr>
@@ -17443,7 +19306,7 @@
           <p:cNvPr id="52" name="">
             <a:extLst xmlns:a="http://schemas.openxmlformats.org/drawingml/2006/main">
               <a:ext uri="{FF2B5EF4-FFF2-40B4-BE49-F238E27FC236}">
-                <a16:creationId xmlns:a16="http://schemas.microsoft.com/office/drawing/2014/main" id="{6DEFF757-9771-42CA-96AF-CFD03C356DEC}"/>
+                <a16:creationId xmlns:a16="http://schemas.microsoft.com/office/drawing/2014/main" id="{2A3C6A86-26FB-43AC-B8CA-FD0C244EE260}"/>
               </a:ext>
             </a:extLst>
           </p:cNvPr>
@@ -17523,7 +19386,7 @@
           <p:cNvPr id="53" name="">
             <a:extLst xmlns:a="http://schemas.openxmlformats.org/drawingml/2006/main">
               <a:ext uri="{FF2B5EF4-FFF2-40B4-BE49-F238E27FC236}">
-                <a16:creationId xmlns:a16="http://schemas.microsoft.com/office/drawing/2014/main" id="{BC4AB405-9B1B-4D4E-B992-F4B77336123B}"/>
+                <a16:creationId xmlns:a16="http://schemas.microsoft.com/office/drawing/2014/main" id="{432E8093-0C09-4090-8DFA-1AFBE2841B76}"/>
               </a:ext>
             </a:extLst>
           </p:cNvPr>
@@ -17553,7 +19416,7 @@
           <p:cNvPr id="54" name="">
             <a:extLst xmlns:a="http://schemas.openxmlformats.org/drawingml/2006/main">
               <a:ext uri="{FF2B5EF4-FFF2-40B4-BE49-F238E27FC236}">
-                <a16:creationId xmlns:a16="http://schemas.microsoft.com/office/drawing/2014/main" id="{FF6FC6FE-7CBF-43FB-83C8-6C793C197191}"/>
+                <a16:creationId xmlns:a16="http://schemas.microsoft.com/office/drawing/2014/main" id="{9B5DBCB2-5F3E-42E2-8475-A86D9AF25545}"/>
               </a:ext>
             </a:extLst>
           </p:cNvPr>
@@ -17583,7 +19446,7 @@
           <p:cNvPr id="55" name="">
             <a:extLst xmlns:a="http://schemas.openxmlformats.org/drawingml/2006/main">
               <a:ext uri="{FF2B5EF4-FFF2-40B4-BE49-F238E27FC236}">
-                <a16:creationId xmlns:a16="http://schemas.microsoft.com/office/drawing/2014/main" id="{6FAFECF0-3FAC-4E01-9E24-7F5F284FDBD0}"/>
+                <a16:creationId xmlns:a16="http://schemas.microsoft.com/office/drawing/2014/main" id="{1E1C1BF7-D01D-44BD-A72E-5C6073F9DD65}"/>
               </a:ext>
             </a:extLst>
           </p:cNvPr>
@@ -17640,7 +19503,7 @@
           <p:cNvPr id="56" name="">
             <a:extLst xmlns:a="http://schemas.openxmlformats.org/drawingml/2006/main">
               <a:ext uri="{FF2B5EF4-FFF2-40B4-BE49-F238E27FC236}">
-                <a16:creationId xmlns:a16="http://schemas.microsoft.com/office/drawing/2014/main" id="{01D6E164-0A02-42E5-AC7C-8F2BAB849FDE}"/>
+                <a16:creationId xmlns:a16="http://schemas.microsoft.com/office/drawing/2014/main" id="{31AA5408-4085-4BA4-976A-4FE8C44207B5}"/>
               </a:ext>
             </a:extLst>
           </p:cNvPr>
@@ -17697,7 +19560,7 @@
           <p:cNvPr id="57" name="">
             <a:extLst xmlns:a="http://schemas.openxmlformats.org/drawingml/2006/main">
               <a:ext uri="{FF2B5EF4-FFF2-40B4-BE49-F238E27FC236}">
-                <a16:creationId xmlns:a16="http://schemas.microsoft.com/office/drawing/2014/main" id="{6D2D04FE-6F10-4064-AB07-CA152104B09C}"/>
+                <a16:creationId xmlns:a16="http://schemas.microsoft.com/office/drawing/2014/main" id="{BAD7D620-A2BF-495C-9754-05C8C5A4F636}"/>
               </a:ext>
             </a:extLst>
           </p:cNvPr>
@@ -17777,7 +19640,7 @@
           <p:cNvPr id="58" name="">
             <a:extLst xmlns:a="http://schemas.openxmlformats.org/drawingml/2006/main">
               <a:ext uri="{FF2B5EF4-FFF2-40B4-BE49-F238E27FC236}">
-                <a16:creationId xmlns:a16="http://schemas.microsoft.com/office/drawing/2014/main" id="{49AD468B-2431-40C1-9C44-82C8782C4F32}"/>
+                <a16:creationId xmlns:a16="http://schemas.microsoft.com/office/drawing/2014/main" id="{00798421-854C-4AB1-BF76-ACD04EA16D03}"/>
               </a:ext>
             </a:extLst>
           </p:cNvPr>
@@ -17809,7 +19672,7 @@
           <p:cNvPr id="59" name="">
             <a:extLst xmlns:a="http://schemas.openxmlformats.org/drawingml/2006/main">
               <a:ext uri="{FF2B5EF4-FFF2-40B4-BE49-F238E27FC236}">
-                <a16:creationId xmlns:a16="http://schemas.microsoft.com/office/drawing/2014/main" id="{29CB49CD-180E-49A4-854D-502B3751A9A6}"/>
+                <a16:creationId xmlns:a16="http://schemas.microsoft.com/office/drawing/2014/main" id="{59323B60-07AC-44DB-B326-BF0FCF0E86E2}"/>
               </a:ext>
             </a:extLst>
           </p:cNvPr>
@@ -17889,7 +19752,7 @@
           <p:cNvPr id="60" name="">
             <a:extLst xmlns:a="http://schemas.openxmlformats.org/drawingml/2006/main">
               <a:ext uri="{FF2B5EF4-FFF2-40B4-BE49-F238E27FC236}">
-                <a16:creationId xmlns:a16="http://schemas.microsoft.com/office/drawing/2014/main" id="{DE3CF37B-A4E6-4B53-83AA-248A886665AC}"/>
+                <a16:creationId xmlns:a16="http://schemas.microsoft.com/office/drawing/2014/main" id="{4BFCFDF4-9601-4B78-96C9-570094CC87F0}"/>
               </a:ext>
             </a:extLst>
           </p:cNvPr>
@@ -19193,7 +21056,7 @@
           <p:cNvPr id="26" name="">
             <a:extLst xmlns:a="http://schemas.openxmlformats.org/drawingml/2006/main">
               <a:ext uri="{FF2B5EF4-FFF2-40B4-BE49-F238E27FC236}">
-                <a16:creationId xmlns:a16="http://schemas.microsoft.com/office/drawing/2014/main" id="{BA417FA7-A654-44C0-B2AA-35058A139F66}"/>
+                <a16:creationId xmlns:a16="http://schemas.microsoft.com/office/drawing/2014/main" id="{E71DD544-720A-415C-B9D9-F36C76EBB124}"/>
               </a:ext>
             </a:extLst>
           </p:cNvPr>
@@ -19223,7 +21086,7 @@
           <p:cNvPr id="27" name="">
             <a:extLst xmlns:a="http://schemas.openxmlformats.org/drawingml/2006/main">
               <a:ext uri="{FF2B5EF4-FFF2-40B4-BE49-F238E27FC236}">
-                <a16:creationId xmlns:a16="http://schemas.microsoft.com/office/drawing/2014/main" id="{105A41D7-ABE5-4259-BB60-54B5E3B15466}"/>
+                <a16:creationId xmlns:a16="http://schemas.microsoft.com/office/drawing/2014/main" id="{C9358991-9CD5-4B7E-BA2E-3E1AA1C702CE}"/>
               </a:ext>
             </a:extLst>
           </p:cNvPr>
@@ -19280,7 +21143,7 @@
           <p:cNvPr id="28" name="">
             <a:extLst xmlns:a="http://schemas.openxmlformats.org/drawingml/2006/main">
               <a:ext uri="{FF2B5EF4-FFF2-40B4-BE49-F238E27FC236}">
-                <a16:creationId xmlns:a16="http://schemas.microsoft.com/office/drawing/2014/main" id="{8AF6CD62-D77B-4941-9581-A17FDDA6B2B1}"/>
+                <a16:creationId xmlns:a16="http://schemas.microsoft.com/office/drawing/2014/main" id="{FA931439-5EE6-41A7-8863-89597E0C4963}"/>
               </a:ext>
             </a:extLst>
           </p:cNvPr>
@@ -19337,7 +21200,7 @@
           <p:cNvPr id="29" name="">
             <a:extLst xmlns:a="http://schemas.openxmlformats.org/drawingml/2006/main">
               <a:ext uri="{FF2B5EF4-FFF2-40B4-BE49-F238E27FC236}">
-                <a16:creationId xmlns:a16="http://schemas.microsoft.com/office/drawing/2014/main" id="{A2724B94-037F-4174-8DBF-B2F30AB727E6}"/>
+                <a16:creationId xmlns:a16="http://schemas.microsoft.com/office/drawing/2014/main" id="{8C191C58-E31E-4519-8333-75492D57382E}"/>
               </a:ext>
             </a:extLst>
           </p:cNvPr>
@@ -19394,7 +21257,7 @@
           <p:cNvPr id="30" name="">
             <a:extLst xmlns:a="http://schemas.openxmlformats.org/drawingml/2006/main">
               <a:ext uri="{FF2B5EF4-FFF2-40B4-BE49-F238E27FC236}">
-                <a16:creationId xmlns:a16="http://schemas.microsoft.com/office/drawing/2014/main" id="{3119DF8A-0744-4D15-B201-3EF7328C7394}"/>
+                <a16:creationId xmlns:a16="http://schemas.microsoft.com/office/drawing/2014/main" id="{5A1704F8-3075-4B28-9373-7FB9A8F0887D}"/>
               </a:ext>
             </a:extLst>
           </p:cNvPr>
@@ -19451,7 +21314,7 @@
           <p:cNvPr id="31" name="">
             <a:extLst xmlns:a="http://schemas.openxmlformats.org/drawingml/2006/main">
               <a:ext uri="{FF2B5EF4-FFF2-40B4-BE49-F238E27FC236}">
-                <a16:creationId xmlns:a16="http://schemas.microsoft.com/office/drawing/2014/main" id="{1A4CF963-ABB5-48BC-A33E-0C426462DB33}"/>
+                <a16:creationId xmlns:a16="http://schemas.microsoft.com/office/drawing/2014/main" id="{2C959646-6610-4858-87EE-9FEDE02DF322}"/>
               </a:ext>
             </a:extLst>
           </p:cNvPr>
@@ -19481,7 +21344,7 @@
           <p:cNvPr id="32" name="">
             <a:extLst xmlns:a="http://schemas.openxmlformats.org/drawingml/2006/main">
               <a:ext uri="{FF2B5EF4-FFF2-40B4-BE49-F238E27FC236}">
-                <a16:creationId xmlns:a16="http://schemas.microsoft.com/office/drawing/2014/main" id="{871E126A-F0C3-4317-9FF9-0A003857EDEC}"/>
+                <a16:creationId xmlns:a16="http://schemas.microsoft.com/office/drawing/2014/main" id="{84714960-D7AE-4387-A2A4-6166F7DE059C}"/>
               </a:ext>
             </a:extLst>
           </p:cNvPr>
@@ -19515,7 +21378,7 @@
           <p:cNvPr id="33" name="">
             <a:extLst xmlns:a="http://schemas.openxmlformats.org/drawingml/2006/main">
               <a:ext uri="{FF2B5EF4-FFF2-40B4-BE49-F238E27FC236}">
-                <a16:creationId xmlns:a16="http://schemas.microsoft.com/office/drawing/2014/main" id="{D3B8D804-7C9A-49A0-B81B-0827201BC469}"/>
+                <a16:creationId xmlns:a16="http://schemas.microsoft.com/office/drawing/2014/main" id="{C665A722-9E1F-4C26-AFA7-8EAF6D5C6B58}"/>
               </a:ext>
             </a:extLst>
           </p:cNvPr>
@@ -19549,7 +21412,7 @@
           <p:cNvPr id="34" name="">
             <a:extLst xmlns:a="http://schemas.openxmlformats.org/drawingml/2006/main">
               <a:ext uri="{FF2B5EF4-FFF2-40B4-BE49-F238E27FC236}">
-                <a16:creationId xmlns:a16="http://schemas.microsoft.com/office/drawing/2014/main" id="{2E2CE3E1-9C43-4893-8531-FBE3A01C2E69}"/>
+                <a16:creationId xmlns:a16="http://schemas.microsoft.com/office/drawing/2014/main" id="{B7FF0442-1C04-4757-8771-7E4B29E2F1FB}"/>
               </a:ext>
             </a:extLst>
           </p:cNvPr>
@@ -19606,7 +21469,7 @@
           <p:cNvPr id="35" name="">
             <a:extLst xmlns:a="http://schemas.openxmlformats.org/drawingml/2006/main">
               <a:ext uri="{FF2B5EF4-FFF2-40B4-BE49-F238E27FC236}">
-                <a16:creationId xmlns:a16="http://schemas.microsoft.com/office/drawing/2014/main" id="{86F93031-87B4-4C32-B06A-2695C4E01566}"/>
+                <a16:creationId xmlns:a16="http://schemas.microsoft.com/office/drawing/2014/main" id="{D382E1F0-0E5C-4378-B682-3A022F4BAC9C}"/>
               </a:ext>
             </a:extLst>
           </p:cNvPr>
@@ -19686,7 +21549,7 @@
           <p:cNvPr id="36" name="">
             <a:extLst xmlns:a="http://schemas.openxmlformats.org/drawingml/2006/main">
               <a:ext uri="{FF2B5EF4-FFF2-40B4-BE49-F238E27FC236}">
-                <a16:creationId xmlns:a16="http://schemas.microsoft.com/office/drawing/2014/main" id="{AAF735A2-FC03-46C6-9C66-B65FEFA24DC8}"/>
+                <a16:creationId xmlns:a16="http://schemas.microsoft.com/office/drawing/2014/main" id="{EE6CB31E-6AA6-4F00-B4C8-BF45A0B2D6A8}"/>
               </a:ext>
             </a:extLst>
           </p:cNvPr>
@@ -19743,7 +21606,7 @@
           <p:cNvPr id="37" name="">
             <a:extLst xmlns:a="http://schemas.openxmlformats.org/drawingml/2006/main">
               <a:ext uri="{FF2B5EF4-FFF2-40B4-BE49-F238E27FC236}">
-                <a16:creationId xmlns:a16="http://schemas.microsoft.com/office/drawing/2014/main" id="{5389F665-F0B5-43AE-AF16-E1FC41876CF6}"/>
+                <a16:creationId xmlns:a16="http://schemas.microsoft.com/office/drawing/2014/main" id="{CE89FADF-0B6F-440D-A5D6-88892D569D50}"/>
               </a:ext>
             </a:extLst>
           </p:cNvPr>
@@ -19775,7 +21638,7 @@
           <p:cNvPr id="38" name="">
             <a:extLst xmlns:a="http://schemas.openxmlformats.org/drawingml/2006/main">
               <a:ext uri="{FF2B5EF4-FFF2-40B4-BE49-F238E27FC236}">
-                <a16:creationId xmlns:a16="http://schemas.microsoft.com/office/drawing/2014/main" id="{0BB90253-A47E-4577-AF07-81B077DFF0CE}"/>
+                <a16:creationId xmlns:a16="http://schemas.microsoft.com/office/drawing/2014/main" id="{FCECD796-111D-46A6-A8A6-AA4CA29C9D25}"/>
               </a:ext>
             </a:extLst>
           </p:cNvPr>
@@ -19832,7 +21695,7 @@
           <p:cNvPr id="39" name="">
             <a:extLst xmlns:a="http://schemas.openxmlformats.org/drawingml/2006/main">
               <a:ext uri="{FF2B5EF4-FFF2-40B4-BE49-F238E27FC236}">
-                <a16:creationId xmlns:a16="http://schemas.microsoft.com/office/drawing/2014/main" id="{A829A19C-B25B-491F-BEA9-B9CC4F29A82B}"/>
+                <a16:creationId xmlns:a16="http://schemas.microsoft.com/office/drawing/2014/main" id="{6280B796-6727-4511-B1E0-8153F6C72180}"/>
               </a:ext>
             </a:extLst>
           </p:cNvPr>
@@ -19889,7 +21752,7 @@
           <p:cNvPr id="40" name="">
             <a:extLst xmlns:a="http://schemas.openxmlformats.org/drawingml/2006/main">
               <a:ext uri="{FF2B5EF4-FFF2-40B4-BE49-F238E27FC236}">
-                <a16:creationId xmlns:a16="http://schemas.microsoft.com/office/drawing/2014/main" id="{5A039130-2C84-4E0E-84EE-93DA62A161F1}"/>
+                <a16:creationId xmlns:a16="http://schemas.microsoft.com/office/drawing/2014/main" id="{153074DD-1822-43E4-82AD-9B54DE8DEB66}"/>
               </a:ext>
             </a:extLst>
           </p:cNvPr>
@@ -19969,7 +21832,7 @@
           <p:cNvPr id="41" name="">
             <a:extLst xmlns:a="http://schemas.openxmlformats.org/drawingml/2006/main">
               <a:ext uri="{FF2B5EF4-FFF2-40B4-BE49-F238E27FC236}">
-                <a16:creationId xmlns:a16="http://schemas.microsoft.com/office/drawing/2014/main" id="{6719D043-4ECC-4D4C-9D67-AD76EA5049D1}"/>
+                <a16:creationId xmlns:a16="http://schemas.microsoft.com/office/drawing/2014/main" id="{4958A960-D87E-4927-9BA6-77B73397F3D6}"/>
               </a:ext>
             </a:extLst>
           </p:cNvPr>
@@ -20026,7 +21889,7 @@
           <p:cNvPr id="42" name="">
             <a:extLst xmlns:a="http://schemas.openxmlformats.org/drawingml/2006/main">
               <a:ext uri="{FF2B5EF4-FFF2-40B4-BE49-F238E27FC236}">
-                <a16:creationId xmlns:a16="http://schemas.microsoft.com/office/drawing/2014/main" id="{C0F0DA31-E4F2-4729-B982-DBBDF84A715E}"/>
+                <a16:creationId xmlns:a16="http://schemas.microsoft.com/office/drawing/2014/main" id="{7F900AB7-CFA4-4D97-B31E-70A4A42798A4}"/>
               </a:ext>
             </a:extLst>
           </p:cNvPr>
@@ -20058,7 +21921,7 @@
           <p:cNvPr id="43" name="">
             <a:extLst xmlns:a="http://schemas.openxmlformats.org/drawingml/2006/main">
               <a:ext uri="{FF2B5EF4-FFF2-40B4-BE49-F238E27FC236}">
-                <a16:creationId xmlns:a16="http://schemas.microsoft.com/office/drawing/2014/main" id="{F23238D1-D308-406E-AA8A-0E18D102A8EA}"/>
+                <a16:creationId xmlns:a16="http://schemas.microsoft.com/office/drawing/2014/main" id="{3ACD40BB-60A2-4AE7-9B0C-6B944C96E76A}"/>
               </a:ext>
             </a:extLst>
           </p:cNvPr>
@@ -20115,7 +21978,7 @@
           <p:cNvPr id="44" name="">
             <a:extLst xmlns:a="http://schemas.openxmlformats.org/drawingml/2006/main">
               <a:ext uri="{FF2B5EF4-FFF2-40B4-BE49-F238E27FC236}">
-                <a16:creationId xmlns:a16="http://schemas.microsoft.com/office/drawing/2014/main" id="{0EC5F189-5759-4C2C-B4EB-566F30C7278E}"/>
+                <a16:creationId xmlns:a16="http://schemas.microsoft.com/office/drawing/2014/main" id="{95C0C1DA-B5C2-4390-AB68-792B2986CE52}"/>
               </a:ext>
             </a:extLst>
           </p:cNvPr>
@@ -20147,7 +22010,7 @@
           <p:cNvPr id="45" name="">
             <a:extLst xmlns:a="http://schemas.openxmlformats.org/drawingml/2006/main">
               <a:ext uri="{FF2B5EF4-FFF2-40B4-BE49-F238E27FC236}">
-                <a16:creationId xmlns:a16="http://schemas.microsoft.com/office/drawing/2014/main" id="{E81DB323-4DE9-4C38-8EF1-2A4112C495FA}"/>
+                <a16:creationId xmlns:a16="http://schemas.microsoft.com/office/drawing/2014/main" id="{8DFD56FF-05A1-4330-9954-C674EB06502C}"/>
               </a:ext>
             </a:extLst>
           </p:cNvPr>
@@ -20204,7 +22067,7 @@
           <p:cNvPr id="46" name="">
             <a:extLst xmlns:a="http://schemas.openxmlformats.org/drawingml/2006/main">
               <a:ext uri="{FF2B5EF4-FFF2-40B4-BE49-F238E27FC236}">
-                <a16:creationId xmlns:a16="http://schemas.microsoft.com/office/drawing/2014/main" id="{96F8B030-FB58-4BBE-95EC-65D0CF6CBB6C}"/>
+                <a16:creationId xmlns:a16="http://schemas.microsoft.com/office/drawing/2014/main" id="{8F4F230E-5061-4661-B6C9-297C59A14E27}"/>
               </a:ext>
             </a:extLst>
           </p:cNvPr>
@@ -20283,7 +22146,7 @@
           <p:cNvPr id="29" name="">
             <a:extLst xmlns:a="http://schemas.openxmlformats.org/drawingml/2006/main">
               <a:ext uri="{FF2B5EF4-FFF2-40B4-BE49-F238E27FC236}">
-                <a16:creationId xmlns:a16="http://schemas.microsoft.com/office/drawing/2014/main" id="{A2438928-3F02-4D06-BE53-128090F1EA08}"/>
+                <a16:creationId xmlns:a16="http://schemas.microsoft.com/office/drawing/2014/main" id="{89163915-E413-4F7D-BAEF-1133CECBF7B8}"/>
               </a:ext>
             </a:extLst>
           </p:cNvPr>
@@ -20313,7 +22176,7 @@
           <p:cNvPr id="2" name="">
             <a:extLst xmlns:a="http://schemas.openxmlformats.org/drawingml/2006/main">
               <a:ext uri="{FF2B5EF4-FFF2-40B4-BE49-F238E27FC236}">
-                <a16:creationId xmlns:a16="http://schemas.microsoft.com/office/drawing/2014/main" id="{3DE0EFEA-FBA3-4AB5-A080-338C9EDA87EB}"/>
+                <a16:creationId xmlns:a16="http://schemas.microsoft.com/office/drawing/2014/main" id="{BCF81911-0B08-4066-927F-CABB7503283D}"/>
               </a:ext>
             </a:extLst>
           </p:cNvPr>
@@ -20370,7 +22233,7 @@
           <p:cNvPr id="3" name="">
             <a:extLst xmlns:a="http://schemas.openxmlformats.org/drawingml/2006/main">
               <a:ext uri="{FF2B5EF4-FFF2-40B4-BE49-F238E27FC236}">
-                <a16:creationId xmlns:a16="http://schemas.microsoft.com/office/drawing/2014/main" id="{37DC9105-1538-4196-9BD5-3F5C284A9754}"/>
+                <a16:creationId xmlns:a16="http://schemas.microsoft.com/office/drawing/2014/main" id="{EF8FCB23-97D4-4D30-8E44-3B7D0F0A838D}"/>
               </a:ext>
             </a:extLst>
           </p:cNvPr>
@@ -20427,7 +22290,7 @@
           <p:cNvPr id="4" name="">
             <a:extLst xmlns:a="http://schemas.openxmlformats.org/drawingml/2006/main">
               <a:ext uri="{FF2B5EF4-FFF2-40B4-BE49-F238E27FC236}">
-                <a16:creationId xmlns:a16="http://schemas.microsoft.com/office/drawing/2014/main" id="{BAD56E5C-6F2E-47BD-9BE1-85CAFBAFBAA3}"/>
+                <a16:creationId xmlns:a16="http://schemas.microsoft.com/office/drawing/2014/main" id="{AB9DB70B-D18A-4D7B-85E1-BEB5A02DF942}"/>
               </a:ext>
             </a:extLst>
           </p:cNvPr>
@@ -20484,7 +22347,7 @@
           <p:cNvPr id="5" name="">
             <a:extLst xmlns:a="http://schemas.openxmlformats.org/drawingml/2006/main">
               <a:ext uri="{FF2B5EF4-FFF2-40B4-BE49-F238E27FC236}">
-                <a16:creationId xmlns:a16="http://schemas.microsoft.com/office/drawing/2014/main" id="{0A461159-2C99-4BB6-9841-19F831B79515}"/>
+                <a16:creationId xmlns:a16="http://schemas.microsoft.com/office/drawing/2014/main" id="{83E9DABF-7886-43AB-9568-EAA1C551CFEB}"/>
               </a:ext>
             </a:extLst>
           </p:cNvPr>
@@ -20541,7 +22404,7 @@
           <p:cNvPr id="6" name="">
             <a:extLst xmlns:a="http://schemas.openxmlformats.org/drawingml/2006/main">
               <a:ext uri="{FF2B5EF4-FFF2-40B4-BE49-F238E27FC236}">
-                <a16:creationId xmlns:a16="http://schemas.microsoft.com/office/drawing/2014/main" id="{5530ED59-25EF-4AFF-ACBC-CFB308B8AD0D}"/>
+                <a16:creationId xmlns:a16="http://schemas.microsoft.com/office/drawing/2014/main" id="{F7DFC767-171C-4044-BCFA-91F61A4B923A}"/>
               </a:ext>
             </a:extLst>
           </p:cNvPr>
@@ -20571,7 +22434,7 @@
           <p:cNvPr id="7" name="">
             <a:extLst xmlns:a="http://schemas.openxmlformats.org/drawingml/2006/main">
               <a:ext uri="{FF2B5EF4-FFF2-40B4-BE49-F238E27FC236}">
-                <a16:creationId xmlns:a16="http://schemas.microsoft.com/office/drawing/2014/main" id="{89CD9FD8-C5E6-49D7-838B-E4C7718DA17E}"/>
+                <a16:creationId xmlns:a16="http://schemas.microsoft.com/office/drawing/2014/main" id="{4CCE1B46-0520-40C1-8634-F3C7F074ABE6}"/>
               </a:ext>
             </a:extLst>
           </p:cNvPr>
@@ -20603,7 +22466,7 @@
           <p:cNvPr id="8" name="">
             <a:extLst xmlns:a="http://schemas.openxmlformats.org/drawingml/2006/main">
               <a:ext uri="{FF2B5EF4-FFF2-40B4-BE49-F238E27FC236}">
-                <a16:creationId xmlns:a16="http://schemas.microsoft.com/office/drawing/2014/main" id="{3EE2D8B6-DA6C-4E85-83E4-B49E7FC5847A}"/>
+                <a16:creationId xmlns:a16="http://schemas.microsoft.com/office/drawing/2014/main" id="{E7D816B0-33B0-47F1-B0D9-9BFA248F4D9F}"/>
               </a:ext>
             </a:extLst>
           </p:cNvPr>
@@ -20660,7 +22523,7 @@
           <p:cNvPr id="9" name="">
             <a:extLst xmlns:a="http://schemas.openxmlformats.org/drawingml/2006/main">
               <a:ext uri="{FF2B5EF4-FFF2-40B4-BE49-F238E27FC236}">
-                <a16:creationId xmlns:a16="http://schemas.microsoft.com/office/drawing/2014/main" id="{27918E59-F4DB-40C2-855F-B7D0CA659961}"/>
+                <a16:creationId xmlns:a16="http://schemas.microsoft.com/office/drawing/2014/main" id="{4446B95A-FF64-415E-8DE1-182FF4D024FF}"/>
               </a:ext>
             </a:extLst>
           </p:cNvPr>
@@ -20694,7 +22557,7 @@
           <p:cNvPr id="10" name="">
             <a:extLst xmlns:a="http://schemas.openxmlformats.org/drawingml/2006/main">
               <a:ext uri="{FF2B5EF4-FFF2-40B4-BE49-F238E27FC236}">
-                <a16:creationId xmlns:a16="http://schemas.microsoft.com/office/drawing/2014/main" id="{5DBECDE3-6457-4A38-A8CD-7C94BF1D1331}"/>
+                <a16:creationId xmlns:a16="http://schemas.microsoft.com/office/drawing/2014/main" id="{C9280428-4E3C-4ACE-9143-0482DEB1C4DD}"/>
               </a:ext>
             </a:extLst>
           </p:cNvPr>
@@ -20726,7 +22589,7 @@
           <p:cNvPr id="11" name="">
             <a:extLst xmlns:a="http://schemas.openxmlformats.org/drawingml/2006/main">
               <a:ext uri="{FF2B5EF4-FFF2-40B4-BE49-F238E27FC236}">
-                <a16:creationId xmlns:a16="http://schemas.microsoft.com/office/drawing/2014/main" id="{3DE7F3A9-7FF5-4CA5-812B-8CA809044426}"/>
+                <a16:creationId xmlns:a16="http://schemas.microsoft.com/office/drawing/2014/main" id="{11499B3D-1ADA-46F1-8C12-2DF6BAED1F09}"/>
               </a:ext>
             </a:extLst>
           </p:cNvPr>
@@ -20783,7 +22646,7 @@
           <p:cNvPr id="12" name="">
             <a:extLst xmlns:a="http://schemas.openxmlformats.org/drawingml/2006/main">
               <a:ext uri="{FF2B5EF4-FFF2-40B4-BE49-F238E27FC236}">
-                <a16:creationId xmlns:a16="http://schemas.microsoft.com/office/drawing/2014/main" id="{4AAF860E-4492-4F7A-905C-B9B8D1BFB2A4}"/>
+                <a16:creationId xmlns:a16="http://schemas.microsoft.com/office/drawing/2014/main" id="{FD62DE0A-50A7-44FF-9764-E83CF9A9D648}"/>
               </a:ext>
             </a:extLst>
           </p:cNvPr>
@@ -20863,7 +22726,7 @@
           <p:cNvPr id="13" name="">
             <a:extLst xmlns:a="http://schemas.openxmlformats.org/drawingml/2006/main">
               <a:ext uri="{FF2B5EF4-FFF2-40B4-BE49-F238E27FC236}">
-                <a16:creationId xmlns:a16="http://schemas.microsoft.com/office/drawing/2014/main" id="{7A74776E-FFA5-4037-9565-A7A4E3397444}"/>
+                <a16:creationId xmlns:a16="http://schemas.microsoft.com/office/drawing/2014/main" id="{A1F992CF-498D-442E-A9F6-4B2FEA5DA368}"/>
               </a:ext>
             </a:extLst>
           </p:cNvPr>
@@ -20943,7 +22806,7 @@
           <p:cNvPr id="14" name="">
             <a:extLst xmlns:a="http://schemas.openxmlformats.org/drawingml/2006/main">
               <a:ext uri="{FF2B5EF4-FFF2-40B4-BE49-F238E27FC236}">
-                <a16:creationId xmlns:a16="http://schemas.microsoft.com/office/drawing/2014/main" id="{3F6CD178-818C-45B9-8F6B-F823ADD2C1B4}"/>
+                <a16:creationId xmlns:a16="http://schemas.microsoft.com/office/drawing/2014/main" id="{369CDF04-183F-4545-90A5-DC27FD8C33BC}"/>
               </a:ext>
             </a:extLst>
           </p:cNvPr>
@@ -21000,7 +22863,7 @@
           <p:cNvPr id="15" name="">
             <a:extLst xmlns:a="http://schemas.openxmlformats.org/drawingml/2006/main">
               <a:ext uri="{FF2B5EF4-FFF2-40B4-BE49-F238E27FC236}">
-                <a16:creationId xmlns:a16="http://schemas.microsoft.com/office/drawing/2014/main" id="{8BB20584-2412-410D-90AD-7240D4000548}"/>
+                <a16:creationId xmlns:a16="http://schemas.microsoft.com/office/drawing/2014/main" id="{E5DED342-8BC9-44F3-A7D1-7E4B79BD7A69}"/>
               </a:ext>
             </a:extLst>
           </p:cNvPr>
@@ -21034,7 +22897,7 @@
           <p:cNvPr id="16" name="">
             <a:extLst xmlns:a="http://schemas.openxmlformats.org/drawingml/2006/main">
               <a:ext uri="{FF2B5EF4-FFF2-40B4-BE49-F238E27FC236}">
-                <a16:creationId xmlns:a16="http://schemas.microsoft.com/office/drawing/2014/main" id="{D567787D-E790-49A2-A4A8-D97935BF757E}"/>
+                <a16:creationId xmlns:a16="http://schemas.microsoft.com/office/drawing/2014/main" id="{913766C8-8BFF-463A-A09E-34C61EEAB715}"/>
               </a:ext>
             </a:extLst>
           </p:cNvPr>
@@ -21066,7 +22929,7 @@
           <p:cNvPr id="17" name="">
             <a:extLst xmlns:a="http://schemas.openxmlformats.org/drawingml/2006/main">
               <a:ext uri="{FF2B5EF4-FFF2-40B4-BE49-F238E27FC236}">
-                <a16:creationId xmlns:a16="http://schemas.microsoft.com/office/drawing/2014/main" id="{C48ABB22-679B-46B3-BACC-DB0CA171AF4A}"/>
+                <a16:creationId xmlns:a16="http://schemas.microsoft.com/office/drawing/2014/main" id="{8525D018-963A-4EDF-92FB-0C35D0A1BF8C}"/>
               </a:ext>
             </a:extLst>
           </p:cNvPr>
@@ -21123,7 +22986,7 @@
           <p:cNvPr id="18" name="">
             <a:extLst xmlns:a="http://schemas.openxmlformats.org/drawingml/2006/main">
               <a:ext uri="{FF2B5EF4-FFF2-40B4-BE49-F238E27FC236}">
-                <a16:creationId xmlns:a16="http://schemas.microsoft.com/office/drawing/2014/main" id="{C3386675-AB88-4F04-BE16-82269FF05372}"/>
+                <a16:creationId xmlns:a16="http://schemas.microsoft.com/office/drawing/2014/main" id="{EB8CA945-4699-47DB-9EB8-E0132FE76DA8}"/>
               </a:ext>
             </a:extLst>
           </p:cNvPr>
@@ -21203,7 +23066,7 @@
           <p:cNvPr id="19" name="">
             <a:extLst xmlns:a="http://schemas.openxmlformats.org/drawingml/2006/main">
               <a:ext uri="{FF2B5EF4-FFF2-40B4-BE49-F238E27FC236}">
-                <a16:creationId xmlns:a16="http://schemas.microsoft.com/office/drawing/2014/main" id="{E58FB47D-7E94-4BB4-A83E-A3F042FE209E}"/>
+                <a16:creationId xmlns:a16="http://schemas.microsoft.com/office/drawing/2014/main" id="{4DABC403-0D22-475B-A773-F02ABD8EE337}"/>
               </a:ext>
             </a:extLst>
           </p:cNvPr>
@@ -21283,7 +23146,7 @@
           <p:cNvPr id="20" name="">
             <a:extLst xmlns:a="http://schemas.openxmlformats.org/drawingml/2006/main">
               <a:ext uri="{FF2B5EF4-FFF2-40B4-BE49-F238E27FC236}">
-                <a16:creationId xmlns:a16="http://schemas.microsoft.com/office/drawing/2014/main" id="{2B51149F-AD5F-4D53-A874-F20A4C8737A0}"/>
+                <a16:creationId xmlns:a16="http://schemas.microsoft.com/office/drawing/2014/main" id="{79E2C17B-2C68-44DB-984E-6B279253646D}"/>
               </a:ext>
             </a:extLst>
           </p:cNvPr>
@@ -21317,7 +23180,7 @@
           <p:cNvPr id="21" name="">
             <a:extLst xmlns:a="http://schemas.openxmlformats.org/drawingml/2006/main">
               <a:ext uri="{FF2B5EF4-FFF2-40B4-BE49-F238E27FC236}">
-                <a16:creationId xmlns:a16="http://schemas.microsoft.com/office/drawing/2014/main" id="{50378E80-77E3-4207-BA94-E6FD8432B3DE}"/>
+                <a16:creationId xmlns:a16="http://schemas.microsoft.com/office/drawing/2014/main" id="{BA692FAF-CFBF-4EC6-A15F-2CA52441D46E}"/>
               </a:ext>
             </a:extLst>
           </p:cNvPr>
@@ -21349,7 +23212,7 @@
           <p:cNvPr id="22" name="">
             <a:extLst xmlns:a="http://schemas.openxmlformats.org/drawingml/2006/main">
               <a:ext uri="{FF2B5EF4-FFF2-40B4-BE49-F238E27FC236}">
-                <a16:creationId xmlns:a16="http://schemas.microsoft.com/office/drawing/2014/main" id="{EB96552C-1A8F-430F-BBC7-5999391107F3}"/>
+                <a16:creationId xmlns:a16="http://schemas.microsoft.com/office/drawing/2014/main" id="{40BB36D7-7CD5-44AE-87FE-21BC4DBE98FC}"/>
               </a:ext>
             </a:extLst>
           </p:cNvPr>
@@ -21406,7 +23269,7 @@
           <p:cNvPr id="23" name="">
             <a:extLst xmlns:a="http://schemas.openxmlformats.org/drawingml/2006/main">
               <a:ext uri="{FF2B5EF4-FFF2-40B4-BE49-F238E27FC236}">
-                <a16:creationId xmlns:a16="http://schemas.microsoft.com/office/drawing/2014/main" id="{63DC4E90-7FD0-495E-8C41-5EFEE4E7F031}"/>
+                <a16:creationId xmlns:a16="http://schemas.microsoft.com/office/drawing/2014/main" id="{6853A022-D3C2-4663-9D8C-A21FD589491A}"/>
               </a:ext>
             </a:extLst>
           </p:cNvPr>
@@ -21486,7 +23349,7 @@
           <p:cNvPr id="24" name="">
             <a:extLst xmlns:a="http://schemas.openxmlformats.org/drawingml/2006/main">
               <a:ext uri="{FF2B5EF4-FFF2-40B4-BE49-F238E27FC236}">
-                <a16:creationId xmlns:a16="http://schemas.microsoft.com/office/drawing/2014/main" id="{E523B7FF-50B4-4668-9E21-8D17CD9AFDE1}"/>
+                <a16:creationId xmlns:a16="http://schemas.microsoft.com/office/drawing/2014/main" id="{A39006C5-91F7-4892-A992-3FB74A11C129}"/>
               </a:ext>
             </a:extLst>
           </p:cNvPr>
@@ -21566,7 +23429,7 @@
           <p:cNvPr id="25" name="">
             <a:extLst xmlns:a="http://schemas.openxmlformats.org/drawingml/2006/main">
               <a:ext uri="{FF2B5EF4-FFF2-40B4-BE49-F238E27FC236}">
-                <a16:creationId xmlns:a16="http://schemas.microsoft.com/office/drawing/2014/main" id="{FE693997-F665-4E08-9D60-61E87D8C1AD0}"/>
+                <a16:creationId xmlns:a16="http://schemas.microsoft.com/office/drawing/2014/main" id="{E40C2E33-4CAB-426E-B0B1-7EBD431637ED}"/>
               </a:ext>
             </a:extLst>
           </p:cNvPr>
@@ -21623,7 +23486,7 @@
           <p:cNvPr id="26" name="">
             <a:extLst xmlns:a="http://schemas.openxmlformats.org/drawingml/2006/main">
               <a:ext uri="{FF2B5EF4-FFF2-40B4-BE49-F238E27FC236}">
-                <a16:creationId xmlns:a16="http://schemas.microsoft.com/office/drawing/2014/main" id="{4349BCC2-8EC3-4E49-9985-D34909A85609}"/>
+                <a16:creationId xmlns:a16="http://schemas.microsoft.com/office/drawing/2014/main" id="{93D3BAA3-7629-4ADC-B28D-B2E0A595ECBA}"/>
               </a:ext>
             </a:extLst>
           </p:cNvPr>
@@ -21655,7 +23518,7 @@
           <p:cNvPr id="27" name="">
             <a:extLst xmlns:a="http://schemas.openxmlformats.org/drawingml/2006/main">
               <a:ext uri="{FF2B5EF4-FFF2-40B4-BE49-F238E27FC236}">
-                <a16:creationId xmlns:a16="http://schemas.microsoft.com/office/drawing/2014/main" id="{2BCAA79C-42DF-423A-BFCE-E3A1C8D5A1DA}"/>
+                <a16:creationId xmlns:a16="http://schemas.microsoft.com/office/drawing/2014/main" id="{DDD1D4A2-08D2-4F95-9C2B-BCACF9B5AE5F}"/>
               </a:ext>
             </a:extLst>
           </p:cNvPr>
@@ -21712,7 +23575,7 @@
           <p:cNvPr id="28" name="">
             <a:extLst xmlns:a="http://schemas.openxmlformats.org/drawingml/2006/main">
               <a:ext uri="{FF2B5EF4-FFF2-40B4-BE49-F238E27FC236}">
-                <a16:creationId xmlns:a16="http://schemas.microsoft.com/office/drawing/2014/main" id="{38D8C6D4-CF0E-41F1-8F54-F5F6559BCD24}"/>
+                <a16:creationId xmlns:a16="http://schemas.microsoft.com/office/drawing/2014/main" id="{08425EE8-75E9-456A-8209-03E051E3C6F5}"/>
               </a:ext>
             </a:extLst>
           </p:cNvPr>
@@ -21767,7 +23630,7 @@
     </p:spTree>
     <p:extLst>
       <p:ext uri="{BB962C8B-B14F-4D97-AF65-F5344CB8AC3E}">
-        <p14:creationId xmlns:p14="http://schemas.microsoft.com/office/powerpoint/2010/main" val="413769237"/>
+        <p14:creationId xmlns:p14="http://schemas.microsoft.com/office/powerpoint/2010/main" val="444000715"/>
       </p:ext>
     </p:extLst>
   </p:cSld>
@@ -21791,7 +23654,7 @@
           <p:cNvPr id="44" name="">
             <a:extLst xmlns:a="http://schemas.openxmlformats.org/drawingml/2006/main">
               <a:ext uri="{FF2B5EF4-FFF2-40B4-BE49-F238E27FC236}">
-                <a16:creationId xmlns:a16="http://schemas.microsoft.com/office/drawing/2014/main" id="{882DDE8A-C99C-4812-BA21-834BC62CD5E0}"/>
+                <a16:creationId xmlns:a16="http://schemas.microsoft.com/office/drawing/2014/main" id="{7EE41111-1A01-457C-8BB9-372EF804B5BE}"/>
               </a:ext>
             </a:extLst>
           </p:cNvPr>
@@ -21821,7 +23684,7 @@
           <p:cNvPr id="2" name="">
             <a:extLst xmlns:a="http://schemas.openxmlformats.org/drawingml/2006/main">
               <a:ext uri="{FF2B5EF4-FFF2-40B4-BE49-F238E27FC236}">
-                <a16:creationId xmlns:a16="http://schemas.microsoft.com/office/drawing/2014/main" id="{E6A76D11-9983-4A97-8D17-4B58E2FFC0BC}"/>
+                <a16:creationId xmlns:a16="http://schemas.microsoft.com/office/drawing/2014/main" id="{BC9C4CA0-E817-49F4-ADDE-98A2596252F1}"/>
               </a:ext>
             </a:extLst>
           </p:cNvPr>
@@ -21878,7 +23741,7 @@
           <p:cNvPr id="3" name="">
             <a:extLst xmlns:a="http://schemas.openxmlformats.org/drawingml/2006/main">
               <a:ext uri="{FF2B5EF4-FFF2-40B4-BE49-F238E27FC236}">
-                <a16:creationId xmlns:a16="http://schemas.microsoft.com/office/drawing/2014/main" id="{B9ECFA36-909C-4A8E-BC3D-71534882E566}"/>
+                <a16:creationId xmlns:a16="http://schemas.microsoft.com/office/drawing/2014/main" id="{BF1E86B8-1AAD-499F-9147-4925CAD7DF45}"/>
               </a:ext>
             </a:extLst>
           </p:cNvPr>
@@ -21935,7 +23798,7 @@
           <p:cNvPr id="4" name="">
             <a:extLst xmlns:a="http://schemas.openxmlformats.org/drawingml/2006/main">
               <a:ext uri="{FF2B5EF4-FFF2-40B4-BE49-F238E27FC236}">
-                <a16:creationId xmlns:a16="http://schemas.microsoft.com/office/drawing/2014/main" id="{9DFC19DC-3274-433B-A8B5-04F46704B2F5}"/>
+                <a16:creationId xmlns:a16="http://schemas.microsoft.com/office/drawing/2014/main" id="{1CCF11C5-4164-4CB8-BBA0-96ED19EBD617}"/>
               </a:ext>
             </a:extLst>
           </p:cNvPr>
@@ -21992,7 +23855,7 @@
           <p:cNvPr id="5" name="">
             <a:extLst xmlns:a="http://schemas.openxmlformats.org/drawingml/2006/main">
               <a:ext uri="{FF2B5EF4-FFF2-40B4-BE49-F238E27FC236}">
-                <a16:creationId xmlns:a16="http://schemas.microsoft.com/office/drawing/2014/main" id="{1469FE25-B761-4BD8-B7C9-A5FD32034BF1}"/>
+                <a16:creationId xmlns:a16="http://schemas.microsoft.com/office/drawing/2014/main" id="{66C891B4-D11F-435E-89BE-204318330875}"/>
               </a:ext>
             </a:extLst>
           </p:cNvPr>
@@ -22049,7 +23912,7 @@
           <p:cNvPr id="6" name="">
             <a:extLst xmlns:a="http://schemas.openxmlformats.org/drawingml/2006/main">
               <a:ext uri="{FF2B5EF4-FFF2-40B4-BE49-F238E27FC236}">
-                <a16:creationId xmlns:a16="http://schemas.microsoft.com/office/drawing/2014/main" id="{036F095F-666B-4075-B12C-F707FC04269E}"/>
+                <a16:creationId xmlns:a16="http://schemas.microsoft.com/office/drawing/2014/main" id="{EFCAB98B-D850-4183-9C94-BC9D2C87BF4D}"/>
               </a:ext>
             </a:extLst>
           </p:cNvPr>
@@ -22079,7 +23942,7 @@
           <p:cNvPr id="7" name="">
             <a:extLst xmlns:a="http://schemas.openxmlformats.org/drawingml/2006/main">
               <a:ext uri="{FF2B5EF4-FFF2-40B4-BE49-F238E27FC236}">
-                <a16:creationId xmlns:a16="http://schemas.microsoft.com/office/drawing/2014/main" id="{072EB719-2A9C-4E2D-B7F4-8A4D3B3752D4}"/>
+                <a16:creationId xmlns:a16="http://schemas.microsoft.com/office/drawing/2014/main" id="{03D15E21-81CB-4D47-8BB5-81E98979501A}"/>
               </a:ext>
             </a:extLst>
           </p:cNvPr>
@@ -22113,7 +23976,7 @@
           <p:cNvPr id="8" name="">
             <a:extLst xmlns:a="http://schemas.openxmlformats.org/drawingml/2006/main">
               <a:ext uri="{FF2B5EF4-FFF2-40B4-BE49-F238E27FC236}">
-                <a16:creationId xmlns:a16="http://schemas.microsoft.com/office/drawing/2014/main" id="{448B9530-153C-4444-B1C5-EEFECE6270F0}"/>
+                <a16:creationId xmlns:a16="http://schemas.microsoft.com/office/drawing/2014/main" id="{CB9E1EBD-15C4-48F8-96C3-7A7ACFD9EFA3}"/>
               </a:ext>
             </a:extLst>
           </p:cNvPr>
@@ -22170,7 +24033,7 @@
           <p:cNvPr id="9" name="">
             <a:extLst xmlns:a="http://schemas.openxmlformats.org/drawingml/2006/main">
               <a:ext uri="{FF2B5EF4-FFF2-40B4-BE49-F238E27FC236}">
-                <a16:creationId xmlns:a16="http://schemas.microsoft.com/office/drawing/2014/main" id="{468171A6-7B22-472D-BAC2-18870D9C541A}"/>
+                <a16:creationId xmlns:a16="http://schemas.microsoft.com/office/drawing/2014/main" id="{1FCBA14E-3FAF-4D95-AE42-DBD85A0F55D7}"/>
               </a:ext>
             </a:extLst>
           </p:cNvPr>
@@ -22200,7 +24063,7 @@
           <p:cNvPr id="10" name="">
             <a:extLst xmlns:a="http://schemas.openxmlformats.org/drawingml/2006/main">
               <a:ext uri="{FF2B5EF4-FFF2-40B4-BE49-F238E27FC236}">
-                <a16:creationId xmlns:a16="http://schemas.microsoft.com/office/drawing/2014/main" id="{2D666024-C2A5-4F49-B7BA-EFAE2C4D1EF6}"/>
+                <a16:creationId xmlns:a16="http://schemas.microsoft.com/office/drawing/2014/main" id="{7F633CB1-E3DC-4406-BC15-2AB1F8DBEF71}"/>
               </a:ext>
             </a:extLst>
           </p:cNvPr>
@@ -22257,7 +24120,7 @@
           <p:cNvPr id="11" name="">
             <a:extLst xmlns:a="http://schemas.openxmlformats.org/drawingml/2006/main">
               <a:ext uri="{FF2B5EF4-FFF2-40B4-BE49-F238E27FC236}">
-                <a16:creationId xmlns:a16="http://schemas.microsoft.com/office/drawing/2014/main" id="{F0C8FE9B-81A8-49CC-B22F-3EF0E70D2030}"/>
+                <a16:creationId xmlns:a16="http://schemas.microsoft.com/office/drawing/2014/main" id="{7BA24D27-0247-4713-A807-1D139EA2D5ED}"/>
               </a:ext>
             </a:extLst>
           </p:cNvPr>
@@ -22314,7 +24177,7 @@
           <p:cNvPr id="12" name="">
             <a:extLst xmlns:a="http://schemas.openxmlformats.org/drawingml/2006/main">
               <a:ext uri="{FF2B5EF4-FFF2-40B4-BE49-F238E27FC236}">
-                <a16:creationId xmlns:a16="http://schemas.microsoft.com/office/drawing/2014/main" id="{135B84BC-E473-4779-B8B1-B8AA1B7EC195}"/>
+                <a16:creationId xmlns:a16="http://schemas.microsoft.com/office/drawing/2014/main" id="{6D247565-2F56-406A-96D1-6673DDAD3B08}"/>
               </a:ext>
             </a:extLst>
           </p:cNvPr>
@@ -22344,7 +24207,7 @@
           <p:cNvPr id="13" name="">
             <a:extLst xmlns:a="http://schemas.openxmlformats.org/drawingml/2006/main">
               <a:ext uri="{FF2B5EF4-FFF2-40B4-BE49-F238E27FC236}">
-                <a16:creationId xmlns:a16="http://schemas.microsoft.com/office/drawing/2014/main" id="{E7CBA965-26A6-4E6E-84AC-49B9EBAD0C64}"/>
+                <a16:creationId xmlns:a16="http://schemas.microsoft.com/office/drawing/2014/main" id="{46AC1B8F-E7AD-439D-A890-C2211A8BECDF}"/>
               </a:ext>
             </a:extLst>
           </p:cNvPr>
@@ -22401,7 +24264,7 @@
           <p:cNvPr id="14" name="">
             <a:extLst xmlns:a="http://schemas.openxmlformats.org/drawingml/2006/main">
               <a:ext uri="{FF2B5EF4-FFF2-40B4-BE49-F238E27FC236}">
-                <a16:creationId xmlns:a16="http://schemas.microsoft.com/office/drawing/2014/main" id="{37E9F60D-8EC9-4467-894B-2E8114A5367D}"/>
+                <a16:creationId xmlns:a16="http://schemas.microsoft.com/office/drawing/2014/main" id="{95519340-223A-4672-ACBF-DB1167C2A8F6}"/>
               </a:ext>
             </a:extLst>
           </p:cNvPr>
@@ -22458,7 +24321,7 @@
           <p:cNvPr id="15" name="">
             <a:extLst xmlns:a="http://schemas.openxmlformats.org/drawingml/2006/main">
               <a:ext uri="{FF2B5EF4-FFF2-40B4-BE49-F238E27FC236}">
-                <a16:creationId xmlns:a16="http://schemas.microsoft.com/office/drawing/2014/main" id="{2CDCF1E5-3929-49E8-9630-DB34A9E00A80}"/>
+                <a16:creationId xmlns:a16="http://schemas.microsoft.com/office/drawing/2014/main" id="{8FDFCCAE-8884-4738-BFAF-328AE1822EB9}"/>
               </a:ext>
             </a:extLst>
           </p:cNvPr>
@@ -22488,7 +24351,7 @@
           <p:cNvPr id="16" name="">
             <a:extLst xmlns:a="http://schemas.openxmlformats.org/drawingml/2006/main">
               <a:ext uri="{FF2B5EF4-FFF2-40B4-BE49-F238E27FC236}">
-                <a16:creationId xmlns:a16="http://schemas.microsoft.com/office/drawing/2014/main" id="{B9D9FBD7-948D-48A0-83A6-26795D1ACED1}"/>
+                <a16:creationId xmlns:a16="http://schemas.microsoft.com/office/drawing/2014/main" id="{9F2C45B3-DAE8-44F4-B73E-508C900E27C2}"/>
               </a:ext>
             </a:extLst>
           </p:cNvPr>
@@ -22545,7 +24408,7 @@
           <p:cNvPr id="17" name="">
             <a:extLst xmlns:a="http://schemas.openxmlformats.org/drawingml/2006/main">
               <a:ext uri="{FF2B5EF4-FFF2-40B4-BE49-F238E27FC236}">
-                <a16:creationId xmlns:a16="http://schemas.microsoft.com/office/drawing/2014/main" id="{5C186D54-C857-433D-80B6-EEE779B1BF4D}"/>
+                <a16:creationId xmlns:a16="http://schemas.microsoft.com/office/drawing/2014/main" id="{025C26B3-B242-4B00-B800-4469685178FF}"/>
               </a:ext>
             </a:extLst>
           </p:cNvPr>
@@ -22602,7 +24465,7 @@
           <p:cNvPr id="18" name="">
             <a:extLst xmlns:a="http://schemas.openxmlformats.org/drawingml/2006/main">
               <a:ext uri="{FF2B5EF4-FFF2-40B4-BE49-F238E27FC236}">
-                <a16:creationId xmlns:a16="http://schemas.microsoft.com/office/drawing/2014/main" id="{F9BD6193-341F-47ED-B370-63683CB3BBC3}"/>
+                <a16:creationId xmlns:a16="http://schemas.microsoft.com/office/drawing/2014/main" id="{777B5F32-F28A-4B7A-91FB-256B98B157F9}"/>
               </a:ext>
             </a:extLst>
           </p:cNvPr>
@@ -22632,7 +24495,7 @@
           <p:cNvPr id="19" name="">
             <a:extLst xmlns:a="http://schemas.openxmlformats.org/drawingml/2006/main">
               <a:ext uri="{FF2B5EF4-FFF2-40B4-BE49-F238E27FC236}">
-                <a16:creationId xmlns:a16="http://schemas.microsoft.com/office/drawing/2014/main" id="{D731D2B0-DBA1-4D16-B163-AA48555B729B}"/>
+                <a16:creationId xmlns:a16="http://schemas.microsoft.com/office/drawing/2014/main" id="{862D9B42-65BF-4FEA-A997-478C87DFAB36}"/>
               </a:ext>
             </a:extLst>
           </p:cNvPr>
@@ -22689,7 +24552,7 @@
           <p:cNvPr id="20" name="">
             <a:extLst xmlns:a="http://schemas.openxmlformats.org/drawingml/2006/main">
               <a:ext uri="{FF2B5EF4-FFF2-40B4-BE49-F238E27FC236}">
-                <a16:creationId xmlns:a16="http://schemas.microsoft.com/office/drawing/2014/main" id="{C5934D32-50CE-4BB6-86D7-B4EF935C9D47}"/>
+                <a16:creationId xmlns:a16="http://schemas.microsoft.com/office/drawing/2014/main" id="{FBFA244D-539D-4339-8A9D-CB4182C79CBE}"/>
               </a:ext>
             </a:extLst>
           </p:cNvPr>
@@ -22746,7 +24609,7 @@
           <p:cNvPr id="21" name="">
             <a:extLst xmlns:a="http://schemas.openxmlformats.org/drawingml/2006/main">
               <a:ext uri="{FF2B5EF4-FFF2-40B4-BE49-F238E27FC236}">
-                <a16:creationId xmlns:a16="http://schemas.microsoft.com/office/drawing/2014/main" id="{3A28BC33-605E-4045-8CE4-0AED76F28144}"/>
+                <a16:creationId xmlns:a16="http://schemas.microsoft.com/office/drawing/2014/main" id="{AB75E30D-ED88-4AC6-9177-49D450C762A7}"/>
               </a:ext>
             </a:extLst>
           </p:cNvPr>
@@ -22776,7 +24639,7 @@
           <p:cNvPr id="22" name="">
             <a:extLst xmlns:a="http://schemas.openxmlformats.org/drawingml/2006/main">
               <a:ext uri="{FF2B5EF4-FFF2-40B4-BE49-F238E27FC236}">
-                <a16:creationId xmlns:a16="http://schemas.microsoft.com/office/drawing/2014/main" id="{03E78971-B00E-4346-9C7E-DCEA3DC6C2AE}"/>
+                <a16:creationId xmlns:a16="http://schemas.microsoft.com/office/drawing/2014/main" id="{3DC89255-C0F8-49B2-9923-D1436BEE9515}"/>
               </a:ext>
             </a:extLst>
           </p:cNvPr>
@@ -22833,7 +24696,7 @@
           <p:cNvPr id="23" name="">
             <a:extLst xmlns:a="http://schemas.openxmlformats.org/drawingml/2006/main">
               <a:ext uri="{FF2B5EF4-FFF2-40B4-BE49-F238E27FC236}">
-                <a16:creationId xmlns:a16="http://schemas.microsoft.com/office/drawing/2014/main" id="{762E7AD5-220A-4330-9551-9E502A1D7BF6}"/>
+                <a16:creationId xmlns:a16="http://schemas.microsoft.com/office/drawing/2014/main" id="{8494D2DC-16F7-4198-905D-60081447227A}"/>
               </a:ext>
             </a:extLst>
           </p:cNvPr>
@@ -22890,7 +24753,7 @@
           <p:cNvPr id="24" name="">
             <a:extLst xmlns:a="http://schemas.openxmlformats.org/drawingml/2006/main">
               <a:ext uri="{FF2B5EF4-FFF2-40B4-BE49-F238E27FC236}">
-                <a16:creationId xmlns:a16="http://schemas.microsoft.com/office/drawing/2014/main" id="{D1FEC0D0-A0E1-4379-B886-06ECC5E6E94C}"/>
+                <a16:creationId xmlns:a16="http://schemas.microsoft.com/office/drawing/2014/main" id="{9B36D125-9F90-49EF-BC1E-E85620C817DE}"/>
               </a:ext>
             </a:extLst>
           </p:cNvPr>
@@ -22924,7 +24787,7 @@
           <p:cNvPr id="25" name="">
             <a:extLst xmlns:a="http://schemas.openxmlformats.org/drawingml/2006/main">
               <a:ext uri="{FF2B5EF4-FFF2-40B4-BE49-F238E27FC236}">
-                <a16:creationId xmlns:a16="http://schemas.microsoft.com/office/drawing/2014/main" id="{4E1821F9-3FFD-44A0-A445-C2A619C8C46C}"/>
+                <a16:creationId xmlns:a16="http://schemas.microsoft.com/office/drawing/2014/main" id="{FA2DCD7E-B3FD-4826-A99C-EF92EB26B046}"/>
               </a:ext>
             </a:extLst>
           </p:cNvPr>
@@ -22981,7 +24844,7 @@
           <p:cNvPr id="26" name="">
             <a:extLst xmlns:a="http://schemas.openxmlformats.org/drawingml/2006/main">
               <a:ext uri="{FF2B5EF4-FFF2-40B4-BE49-F238E27FC236}">
-                <a16:creationId xmlns:a16="http://schemas.microsoft.com/office/drawing/2014/main" id="{827D6F25-18CE-4BA3-A082-D1FE0F3AB073}"/>
+                <a16:creationId xmlns:a16="http://schemas.microsoft.com/office/drawing/2014/main" id="{F510C50C-DB4B-414A-AC46-E71487936FA3}"/>
               </a:ext>
             </a:extLst>
           </p:cNvPr>
@@ -23011,7 +24874,7 @@
           <p:cNvPr id="27" name="">
             <a:extLst xmlns:a="http://schemas.openxmlformats.org/drawingml/2006/main">
               <a:ext uri="{FF2B5EF4-FFF2-40B4-BE49-F238E27FC236}">
-                <a16:creationId xmlns:a16="http://schemas.microsoft.com/office/drawing/2014/main" id="{5BC924B6-C127-4A5B-AD8B-F5D8C3C4D4EE}"/>
+                <a16:creationId xmlns:a16="http://schemas.microsoft.com/office/drawing/2014/main" id="{D8EF0FA5-93C2-45AB-8399-7BE6D363C25B}"/>
               </a:ext>
             </a:extLst>
           </p:cNvPr>
@@ -23068,7 +24931,7 @@
           <p:cNvPr id="28" name="">
             <a:extLst xmlns:a="http://schemas.openxmlformats.org/drawingml/2006/main">
               <a:ext uri="{FF2B5EF4-FFF2-40B4-BE49-F238E27FC236}">
-                <a16:creationId xmlns:a16="http://schemas.microsoft.com/office/drawing/2014/main" id="{F522D6CC-F049-4618-A788-E4E37FACAE74}"/>
+                <a16:creationId xmlns:a16="http://schemas.microsoft.com/office/drawing/2014/main" id="{19924067-0B2B-45FC-937B-91285D50B335}"/>
               </a:ext>
             </a:extLst>
           </p:cNvPr>
@@ -23125,7 +24988,7 @@
           <p:cNvPr id="29" name="">
             <a:extLst xmlns:a="http://schemas.openxmlformats.org/drawingml/2006/main">
               <a:ext uri="{FF2B5EF4-FFF2-40B4-BE49-F238E27FC236}">
-                <a16:creationId xmlns:a16="http://schemas.microsoft.com/office/drawing/2014/main" id="{9A2BFD01-FF87-46C6-947F-444808B5FAE2}"/>
+                <a16:creationId xmlns:a16="http://schemas.microsoft.com/office/drawing/2014/main" id="{60DAE377-237C-4730-B3C8-528EEAE548FE}"/>
               </a:ext>
             </a:extLst>
           </p:cNvPr>
@@ -23155,7 +25018,7 @@
           <p:cNvPr id="30" name="">
             <a:extLst xmlns:a="http://schemas.openxmlformats.org/drawingml/2006/main">
               <a:ext uri="{FF2B5EF4-FFF2-40B4-BE49-F238E27FC236}">
-                <a16:creationId xmlns:a16="http://schemas.microsoft.com/office/drawing/2014/main" id="{A66ABED9-975C-42E1-BF5B-76B5290A0D0E}"/>
+                <a16:creationId xmlns:a16="http://schemas.microsoft.com/office/drawing/2014/main" id="{B3BF63A8-1090-4F5A-8E60-13F4B212B06A}"/>
               </a:ext>
             </a:extLst>
           </p:cNvPr>
@@ -23212,7 +25075,7 @@
           <p:cNvPr id="31" name="">
             <a:extLst xmlns:a="http://schemas.openxmlformats.org/drawingml/2006/main">
               <a:ext uri="{FF2B5EF4-FFF2-40B4-BE49-F238E27FC236}">
-                <a16:creationId xmlns:a16="http://schemas.microsoft.com/office/drawing/2014/main" id="{85749E1F-4B0A-4BF0-A8AF-AFA7BB902918}"/>
+                <a16:creationId xmlns:a16="http://schemas.microsoft.com/office/drawing/2014/main" id="{91681D8E-593A-4A11-9192-06984D143510}"/>
               </a:ext>
             </a:extLst>
           </p:cNvPr>
@@ -23269,7 +25132,7 @@
           <p:cNvPr id="32" name="">
             <a:extLst xmlns:a="http://schemas.openxmlformats.org/drawingml/2006/main">
               <a:ext uri="{FF2B5EF4-FFF2-40B4-BE49-F238E27FC236}">
-                <a16:creationId xmlns:a16="http://schemas.microsoft.com/office/drawing/2014/main" id="{C4ED0B47-663B-45A0-B0A1-1FB318FB50CF}"/>
+                <a16:creationId xmlns:a16="http://schemas.microsoft.com/office/drawing/2014/main" id="{39F65F0B-7C58-42E4-A939-9F28AB3B4E44}"/>
               </a:ext>
             </a:extLst>
           </p:cNvPr>
@@ -23299,7 +25162,7 @@
           <p:cNvPr id="33" name="">
             <a:extLst xmlns:a="http://schemas.openxmlformats.org/drawingml/2006/main">
               <a:ext uri="{FF2B5EF4-FFF2-40B4-BE49-F238E27FC236}">
-                <a16:creationId xmlns:a16="http://schemas.microsoft.com/office/drawing/2014/main" id="{C471BC29-EB8C-4406-8A0F-267EDD2A3A83}"/>
+                <a16:creationId xmlns:a16="http://schemas.microsoft.com/office/drawing/2014/main" id="{A689CBA0-05F7-4B62-8C98-AB48F55284A3}"/>
               </a:ext>
             </a:extLst>
           </p:cNvPr>
@@ -23356,7 +25219,7 @@
           <p:cNvPr id="34" name="">
             <a:extLst xmlns:a="http://schemas.openxmlformats.org/drawingml/2006/main">
               <a:ext uri="{FF2B5EF4-FFF2-40B4-BE49-F238E27FC236}">
-                <a16:creationId xmlns:a16="http://schemas.microsoft.com/office/drawing/2014/main" id="{38EA2722-52B2-46F2-B6CA-2E98ACD11C95}"/>
+                <a16:creationId xmlns:a16="http://schemas.microsoft.com/office/drawing/2014/main" id="{B295720D-E1A5-48ED-B794-BDCE23220A7C}"/>
               </a:ext>
             </a:extLst>
           </p:cNvPr>
@@ -23413,7 +25276,7 @@
           <p:cNvPr id="35" name="">
             <a:extLst xmlns:a="http://schemas.openxmlformats.org/drawingml/2006/main">
               <a:ext uri="{FF2B5EF4-FFF2-40B4-BE49-F238E27FC236}">
-                <a16:creationId xmlns:a16="http://schemas.microsoft.com/office/drawing/2014/main" id="{D6861D39-04CD-4DB0-A918-5B0E29BE131A}"/>
+                <a16:creationId xmlns:a16="http://schemas.microsoft.com/office/drawing/2014/main" id="{928D3B5D-B42F-49FC-ACDF-1D89E75C7000}"/>
               </a:ext>
             </a:extLst>
           </p:cNvPr>
@@ -23443,7 +25306,7 @@
           <p:cNvPr id="36" name="">
             <a:extLst xmlns:a="http://schemas.openxmlformats.org/drawingml/2006/main">
               <a:ext uri="{FF2B5EF4-FFF2-40B4-BE49-F238E27FC236}">
-                <a16:creationId xmlns:a16="http://schemas.microsoft.com/office/drawing/2014/main" id="{4952D827-FDD6-4085-B6E6-5BAC576998D1}"/>
+                <a16:creationId xmlns:a16="http://schemas.microsoft.com/office/drawing/2014/main" id="{EA16F1DD-0ABD-4AAD-A0F9-0E33589F1B03}"/>
               </a:ext>
             </a:extLst>
           </p:cNvPr>
@@ -23500,7 +25363,7 @@
           <p:cNvPr id="37" name="">
             <a:extLst xmlns:a="http://schemas.openxmlformats.org/drawingml/2006/main">
               <a:ext uri="{FF2B5EF4-FFF2-40B4-BE49-F238E27FC236}">
-                <a16:creationId xmlns:a16="http://schemas.microsoft.com/office/drawing/2014/main" id="{9927039C-5C45-4A0F-BA5D-E6E24A236934}"/>
+                <a16:creationId xmlns:a16="http://schemas.microsoft.com/office/drawing/2014/main" id="{A53A172C-C15A-464A-A8FD-A9241F83F234}"/>
               </a:ext>
             </a:extLst>
           </p:cNvPr>
@@ -23557,7 +25420,7 @@
           <p:cNvPr id="38" name="">
             <a:extLst xmlns:a="http://schemas.openxmlformats.org/drawingml/2006/main">
               <a:ext uri="{FF2B5EF4-FFF2-40B4-BE49-F238E27FC236}">
-                <a16:creationId xmlns:a16="http://schemas.microsoft.com/office/drawing/2014/main" id="{86EC0119-7488-4F3F-81F4-BB9D68EE4F09}"/>
+                <a16:creationId xmlns:a16="http://schemas.microsoft.com/office/drawing/2014/main" id="{EAD36CA5-35BC-4621-BC15-029309A35A99}"/>
               </a:ext>
             </a:extLst>
           </p:cNvPr>
@@ -23587,7 +25450,7 @@
           <p:cNvPr id="39" name="">
             <a:extLst xmlns:a="http://schemas.openxmlformats.org/drawingml/2006/main">
               <a:ext uri="{FF2B5EF4-FFF2-40B4-BE49-F238E27FC236}">
-                <a16:creationId xmlns:a16="http://schemas.microsoft.com/office/drawing/2014/main" id="{A8DFD141-4AEA-451A-8AB1-F01A8B2E2F58}"/>
+                <a16:creationId xmlns:a16="http://schemas.microsoft.com/office/drawing/2014/main" id="{BD849AC9-AC83-48C1-85C7-27A5773B5F86}"/>
               </a:ext>
             </a:extLst>
           </p:cNvPr>
@@ -23644,7 +25507,7 @@
           <p:cNvPr id="40" name="">
             <a:extLst xmlns:a="http://schemas.openxmlformats.org/drawingml/2006/main">
               <a:ext uri="{FF2B5EF4-FFF2-40B4-BE49-F238E27FC236}">
-                <a16:creationId xmlns:a16="http://schemas.microsoft.com/office/drawing/2014/main" id="{FFC4F33D-22B6-498B-8785-C1205D3C7FAF}"/>
+                <a16:creationId xmlns:a16="http://schemas.microsoft.com/office/drawing/2014/main" id="{98F65563-767D-47B9-BCAF-780221EF1CAF}"/>
               </a:ext>
             </a:extLst>
           </p:cNvPr>
@@ -23701,7 +25564,7 @@
           <p:cNvPr id="41" name="">
             <a:extLst xmlns:a="http://schemas.openxmlformats.org/drawingml/2006/main">
               <a:ext uri="{FF2B5EF4-FFF2-40B4-BE49-F238E27FC236}">
-                <a16:creationId xmlns:a16="http://schemas.microsoft.com/office/drawing/2014/main" id="{5C9EE4EE-07B3-4416-8E16-051A8716B6A1}"/>
+                <a16:creationId xmlns:a16="http://schemas.microsoft.com/office/drawing/2014/main" id="{3A132019-833E-48E3-99AF-BD0CC856FA51}"/>
               </a:ext>
             </a:extLst>
           </p:cNvPr>
@@ -23733,7 +25596,7 @@
           <p:cNvPr id="42" name="">
             <a:extLst xmlns:a="http://schemas.openxmlformats.org/drawingml/2006/main">
               <a:ext uri="{FF2B5EF4-FFF2-40B4-BE49-F238E27FC236}">
-                <a16:creationId xmlns:a16="http://schemas.microsoft.com/office/drawing/2014/main" id="{A2618466-D680-4166-9983-E966C84F012E}"/>
+                <a16:creationId xmlns:a16="http://schemas.microsoft.com/office/drawing/2014/main" id="{B6BE6284-7402-41D7-8948-064DCF5AC7FE}"/>
               </a:ext>
             </a:extLst>
           </p:cNvPr>
@@ -23790,7 +25653,7 @@
           <p:cNvPr id="43" name="">
             <a:extLst xmlns:a="http://schemas.openxmlformats.org/drawingml/2006/main">
               <a:ext uri="{FF2B5EF4-FFF2-40B4-BE49-F238E27FC236}">
-                <a16:creationId xmlns:a16="http://schemas.microsoft.com/office/drawing/2014/main" id="{6E5A1A0E-5E05-4E82-A198-D70B20D0DCD6}"/>
+                <a16:creationId xmlns:a16="http://schemas.microsoft.com/office/drawing/2014/main" id="{16F71565-B604-42C8-BDDB-0DAFEF79DFD1}"/>
               </a:ext>
             </a:extLst>
           </p:cNvPr>
@@ -23845,7 +25708,7 @@
     </p:spTree>
     <p:extLst>
       <p:ext uri="{BB962C8B-B14F-4D97-AF65-F5344CB8AC3E}">
-        <p14:creationId xmlns:p14="http://schemas.microsoft.com/office/powerpoint/2010/main" val="1852653645"/>
+        <p14:creationId xmlns:p14="http://schemas.microsoft.com/office/powerpoint/2010/main" val="1313688188"/>
       </p:ext>
     </p:extLst>
   </p:cSld>
@@ -23869,7 +25732,7 @@
           <p:cNvPr id="32" name="">
             <a:extLst xmlns:a="http://schemas.openxmlformats.org/drawingml/2006/main">
               <a:ext uri="{FF2B5EF4-FFF2-40B4-BE49-F238E27FC236}">
-                <a16:creationId xmlns:a16="http://schemas.microsoft.com/office/drawing/2014/main" id="{4709FF71-FDEB-4E9A-BC72-03881442E27E}"/>
+                <a16:creationId xmlns:a16="http://schemas.microsoft.com/office/drawing/2014/main" id="{55DDBA9E-910D-46DB-8E96-971B03EBE665}"/>
               </a:ext>
             </a:extLst>
           </p:cNvPr>
@@ -23899,7 +25762,7 @@
           <p:cNvPr id="2" name="">
             <a:extLst xmlns:a="http://schemas.openxmlformats.org/drawingml/2006/main">
               <a:ext uri="{FF2B5EF4-FFF2-40B4-BE49-F238E27FC236}">
-                <a16:creationId xmlns:a16="http://schemas.microsoft.com/office/drawing/2014/main" id="{18B0780E-F041-463A-AD05-7E5CA3809271}"/>
+                <a16:creationId xmlns:a16="http://schemas.microsoft.com/office/drawing/2014/main" id="{B102296C-1DC4-4CE2-9BED-AA2D89EA8EB0}"/>
               </a:ext>
             </a:extLst>
           </p:cNvPr>
@@ -23956,7 +25819,7 @@
           <p:cNvPr id="3" name="">
             <a:extLst xmlns:a="http://schemas.openxmlformats.org/drawingml/2006/main">
               <a:ext uri="{FF2B5EF4-FFF2-40B4-BE49-F238E27FC236}">
-                <a16:creationId xmlns:a16="http://schemas.microsoft.com/office/drawing/2014/main" id="{6279D028-CDED-48C8-9DB5-97A2FA0751FE}"/>
+                <a16:creationId xmlns:a16="http://schemas.microsoft.com/office/drawing/2014/main" id="{A81ED94E-F458-477C-A0ED-6DFD5FA1CF55}"/>
               </a:ext>
             </a:extLst>
           </p:cNvPr>
@@ -24013,7 +25876,7 @@
           <p:cNvPr id="4" name="">
             <a:extLst xmlns:a="http://schemas.openxmlformats.org/drawingml/2006/main">
               <a:ext uri="{FF2B5EF4-FFF2-40B4-BE49-F238E27FC236}">
-                <a16:creationId xmlns:a16="http://schemas.microsoft.com/office/drawing/2014/main" id="{CD219B69-4426-4F29-AC56-2007D5FDA809}"/>
+                <a16:creationId xmlns:a16="http://schemas.microsoft.com/office/drawing/2014/main" id="{73907B26-2DC6-4E6E-903F-62D5074E2DBE}"/>
               </a:ext>
             </a:extLst>
           </p:cNvPr>
@@ -24070,7 +25933,7 @@
           <p:cNvPr id="5" name="">
             <a:extLst xmlns:a="http://schemas.openxmlformats.org/drawingml/2006/main">
               <a:ext uri="{FF2B5EF4-FFF2-40B4-BE49-F238E27FC236}">
-                <a16:creationId xmlns:a16="http://schemas.microsoft.com/office/drawing/2014/main" id="{91B8CDEA-88A8-4817-99AA-7A1987A20598}"/>
+                <a16:creationId xmlns:a16="http://schemas.microsoft.com/office/drawing/2014/main" id="{C16FAAA9-AB02-4A93-8A0A-1D65588FAEB1}"/>
               </a:ext>
             </a:extLst>
           </p:cNvPr>
@@ -24127,7 +25990,7 @@
           <p:cNvPr id="6" name="">
             <a:extLst xmlns:a="http://schemas.openxmlformats.org/drawingml/2006/main">
               <a:ext uri="{FF2B5EF4-FFF2-40B4-BE49-F238E27FC236}">
-                <a16:creationId xmlns:a16="http://schemas.microsoft.com/office/drawing/2014/main" id="{215CAFA4-2FD9-440F-9BD8-DF52FE67902F}"/>
+                <a16:creationId xmlns:a16="http://schemas.microsoft.com/office/drawing/2014/main" id="{900D629A-11A3-4DF9-8AB5-440D2C6371FC}"/>
               </a:ext>
             </a:extLst>
           </p:cNvPr>
@@ -24157,7 +26020,7 @@
           <p:cNvPr id="7" name="">
             <a:extLst xmlns:a="http://schemas.openxmlformats.org/drawingml/2006/main">
               <a:ext uri="{FF2B5EF4-FFF2-40B4-BE49-F238E27FC236}">
-                <a16:creationId xmlns:a16="http://schemas.microsoft.com/office/drawing/2014/main" id="{9D4020EB-5000-4D5A-81C0-8C12630C3FA3}"/>
+                <a16:creationId xmlns:a16="http://schemas.microsoft.com/office/drawing/2014/main" id="{8A498DA5-1195-480B-B8BD-CC463F1CB1B2}"/>
               </a:ext>
             </a:extLst>
           </p:cNvPr>
@@ -24214,7 +26077,7 @@
           <p:cNvPr id="8" name="">
             <a:extLst xmlns:a="http://schemas.openxmlformats.org/drawingml/2006/main">
               <a:ext uri="{FF2B5EF4-FFF2-40B4-BE49-F238E27FC236}">
-                <a16:creationId xmlns:a16="http://schemas.microsoft.com/office/drawing/2014/main" id="{6D57DC98-2D1A-4281-A3EA-4D657A9CC992}"/>
+                <a16:creationId xmlns:a16="http://schemas.microsoft.com/office/drawing/2014/main" id="{2F6B6794-6C08-4728-90D6-B94EC9CB845A}"/>
               </a:ext>
             </a:extLst>
           </p:cNvPr>
@@ -24271,7 +26134,7 @@
           <p:cNvPr id="9" name="">
             <a:extLst xmlns:a="http://schemas.openxmlformats.org/drawingml/2006/main">
               <a:ext uri="{FF2B5EF4-FFF2-40B4-BE49-F238E27FC236}">
-                <a16:creationId xmlns:a16="http://schemas.microsoft.com/office/drawing/2014/main" id="{0930860F-CAF1-4E88-8310-8DDB047E3144}"/>
+                <a16:creationId xmlns:a16="http://schemas.microsoft.com/office/drawing/2014/main" id="{A674635C-8176-4CC9-B931-82DD2EE06FEF}"/>
               </a:ext>
             </a:extLst>
           </p:cNvPr>
@@ -24328,7 +26191,7 @@
           <p:cNvPr id="10" name="">
             <a:extLst xmlns:a="http://schemas.openxmlformats.org/drawingml/2006/main">
               <a:ext uri="{FF2B5EF4-FFF2-40B4-BE49-F238E27FC236}">
-                <a16:creationId xmlns:a16="http://schemas.microsoft.com/office/drawing/2014/main" id="{8D9D8BC7-2D8D-4634-AEAB-2C5A6748FBD2}"/>
+                <a16:creationId xmlns:a16="http://schemas.microsoft.com/office/drawing/2014/main" id="{4354514F-C7D9-4406-BC48-A6E0B2E898A1}"/>
               </a:ext>
             </a:extLst>
           </p:cNvPr>
@@ -24362,7 +26225,7 @@
           <p:cNvPr id="11" name="">
             <a:extLst xmlns:a="http://schemas.openxmlformats.org/drawingml/2006/main">
               <a:ext uri="{FF2B5EF4-FFF2-40B4-BE49-F238E27FC236}">
-                <a16:creationId xmlns:a16="http://schemas.microsoft.com/office/drawing/2014/main" id="{CB63F14C-1948-4BE5-8EFC-C1921066A3B6}"/>
+                <a16:creationId xmlns:a16="http://schemas.microsoft.com/office/drawing/2014/main" id="{06B40CF4-7828-44E3-A9D6-775F83082889}"/>
               </a:ext>
             </a:extLst>
           </p:cNvPr>
@@ -24419,7 +26282,7 @@
           <p:cNvPr id="12" name="">
             <a:extLst xmlns:a="http://schemas.openxmlformats.org/drawingml/2006/main">
               <a:ext uri="{FF2B5EF4-FFF2-40B4-BE49-F238E27FC236}">
-                <a16:creationId xmlns:a16="http://schemas.microsoft.com/office/drawing/2014/main" id="{3983A712-B3B9-4C83-B37A-4D990A1BDA77}"/>
+                <a16:creationId xmlns:a16="http://schemas.microsoft.com/office/drawing/2014/main" id="{21ABAF64-963C-42A8-B535-D80711987444}"/>
               </a:ext>
             </a:extLst>
           </p:cNvPr>
@@ -24499,7 +26362,7 @@
           <p:cNvPr id="13" name="">
             <a:extLst xmlns:a="http://schemas.openxmlformats.org/drawingml/2006/main">
               <a:ext uri="{FF2B5EF4-FFF2-40B4-BE49-F238E27FC236}">
-                <a16:creationId xmlns:a16="http://schemas.microsoft.com/office/drawing/2014/main" id="{506BDEFD-F694-49B3-9B25-7ACD42AC0597}"/>
+                <a16:creationId xmlns:a16="http://schemas.microsoft.com/office/drawing/2014/main" id="{8F9395AC-F887-4E63-BEAA-02C26564DFE6}"/>
               </a:ext>
             </a:extLst>
           </p:cNvPr>
@@ -24556,7 +26419,7 @@
           <p:cNvPr id="14" name="">
             <a:extLst xmlns:a="http://schemas.openxmlformats.org/drawingml/2006/main">
               <a:ext uri="{FF2B5EF4-FFF2-40B4-BE49-F238E27FC236}">
-                <a16:creationId xmlns:a16="http://schemas.microsoft.com/office/drawing/2014/main" id="{6554502A-B3C6-4A07-AF08-9CE138EBBD1C}"/>
+                <a16:creationId xmlns:a16="http://schemas.microsoft.com/office/drawing/2014/main" id="{7BC04F82-FEC8-468F-AAC1-A9EEBB27164D}"/>
               </a:ext>
             </a:extLst>
           </p:cNvPr>
@@ -24588,7 +26451,7 @@
           <p:cNvPr id="15" name="">
             <a:extLst xmlns:a="http://schemas.openxmlformats.org/drawingml/2006/main">
               <a:ext uri="{FF2B5EF4-FFF2-40B4-BE49-F238E27FC236}">
-                <a16:creationId xmlns:a16="http://schemas.microsoft.com/office/drawing/2014/main" id="{12BCAD4E-F344-4EF9-BA1F-77E081A552BC}"/>
+                <a16:creationId xmlns:a16="http://schemas.microsoft.com/office/drawing/2014/main" id="{249247BA-1DEA-4919-9C7D-32DEB20876B1}"/>
               </a:ext>
             </a:extLst>
           </p:cNvPr>
@@ -24668,7 +26531,7 @@
           <p:cNvPr id="16" name="">
             <a:extLst xmlns:a="http://schemas.openxmlformats.org/drawingml/2006/main">
               <a:ext uri="{FF2B5EF4-FFF2-40B4-BE49-F238E27FC236}">
-                <a16:creationId xmlns:a16="http://schemas.microsoft.com/office/drawing/2014/main" id="{C70377CD-C021-4381-A786-0EAC1C8BCCBD}"/>
+                <a16:creationId xmlns:a16="http://schemas.microsoft.com/office/drawing/2014/main" id="{6D92495F-497F-4E7C-9034-B84DB4063F87}"/>
               </a:ext>
             </a:extLst>
           </p:cNvPr>
@@ -24702,7 +26565,7 @@
           <p:cNvPr id="17" name="">
             <a:extLst xmlns:a="http://schemas.openxmlformats.org/drawingml/2006/main">
               <a:ext uri="{FF2B5EF4-FFF2-40B4-BE49-F238E27FC236}">
-                <a16:creationId xmlns:a16="http://schemas.microsoft.com/office/drawing/2014/main" id="{154314BA-38F9-4265-8794-A99E1EC1BB76}"/>
+                <a16:creationId xmlns:a16="http://schemas.microsoft.com/office/drawing/2014/main" id="{A51EF4B3-E03D-4268-B63F-1BF6E9E3A2FF}"/>
               </a:ext>
             </a:extLst>
           </p:cNvPr>
@@ -24759,7 +26622,7 @@
           <p:cNvPr id="18" name="">
             <a:extLst xmlns:a="http://schemas.openxmlformats.org/drawingml/2006/main">
               <a:ext uri="{FF2B5EF4-FFF2-40B4-BE49-F238E27FC236}">
-                <a16:creationId xmlns:a16="http://schemas.microsoft.com/office/drawing/2014/main" id="{646E08CD-31C8-4EC3-8168-7ADEDBD37B0B}"/>
+                <a16:creationId xmlns:a16="http://schemas.microsoft.com/office/drawing/2014/main" id="{65135081-F042-4314-9629-5D1C67DECAE1}"/>
               </a:ext>
             </a:extLst>
           </p:cNvPr>
@@ -24839,7 +26702,7 @@
           <p:cNvPr id="19" name="">
             <a:extLst xmlns:a="http://schemas.openxmlformats.org/drawingml/2006/main">
               <a:ext uri="{FF2B5EF4-FFF2-40B4-BE49-F238E27FC236}">
-                <a16:creationId xmlns:a16="http://schemas.microsoft.com/office/drawing/2014/main" id="{190BDAAD-B75F-4FC0-86CD-CA6CE1C6A472}"/>
+                <a16:creationId xmlns:a16="http://schemas.microsoft.com/office/drawing/2014/main" id="{E9F2BDE6-737E-48AB-8D0D-FFBDDAF099E8}"/>
               </a:ext>
             </a:extLst>
           </p:cNvPr>
@@ -24896,7 +26759,7 @@
           <p:cNvPr id="20" name="">
             <a:extLst xmlns:a="http://schemas.openxmlformats.org/drawingml/2006/main">
               <a:ext uri="{FF2B5EF4-FFF2-40B4-BE49-F238E27FC236}">
-                <a16:creationId xmlns:a16="http://schemas.microsoft.com/office/drawing/2014/main" id="{1A3788F4-EB87-40DA-99BE-4403DBC2AD02}"/>
+                <a16:creationId xmlns:a16="http://schemas.microsoft.com/office/drawing/2014/main" id="{A3855535-E3D4-4BC7-94BE-875B3F169AC5}"/>
               </a:ext>
             </a:extLst>
           </p:cNvPr>
@@ -24930,7 +26793,7 @@
           <p:cNvPr id="21" name="">
             <a:extLst xmlns:a="http://schemas.openxmlformats.org/drawingml/2006/main">
               <a:ext uri="{FF2B5EF4-FFF2-40B4-BE49-F238E27FC236}">
-                <a16:creationId xmlns:a16="http://schemas.microsoft.com/office/drawing/2014/main" id="{F89F011D-5A71-4DA3-AB95-55BC5644B4BA}"/>
+                <a16:creationId xmlns:a16="http://schemas.microsoft.com/office/drawing/2014/main" id="{D5086B73-459C-4FD8-9AE4-4F0C87AC1E8E}"/>
               </a:ext>
             </a:extLst>
           </p:cNvPr>
@@ -24987,7 +26850,7 @@
           <p:cNvPr id="22" name="">
             <a:extLst xmlns:a="http://schemas.openxmlformats.org/drawingml/2006/main">
               <a:ext uri="{FF2B5EF4-FFF2-40B4-BE49-F238E27FC236}">
-                <a16:creationId xmlns:a16="http://schemas.microsoft.com/office/drawing/2014/main" id="{768B7D63-F3E5-498F-8403-B2C7131C3C07}"/>
+                <a16:creationId xmlns:a16="http://schemas.microsoft.com/office/drawing/2014/main" id="{A33C7C45-BDBE-4439-AD4B-E356D8B6FB54}"/>
               </a:ext>
             </a:extLst>
           </p:cNvPr>
@@ -25067,7 +26930,7 @@
           <p:cNvPr id="23" name="">
             <a:extLst xmlns:a="http://schemas.openxmlformats.org/drawingml/2006/main">
               <a:ext uri="{FF2B5EF4-FFF2-40B4-BE49-F238E27FC236}">
-                <a16:creationId xmlns:a16="http://schemas.microsoft.com/office/drawing/2014/main" id="{3D194FAF-5624-4826-9DB9-77A247715A46}"/>
+                <a16:creationId xmlns:a16="http://schemas.microsoft.com/office/drawing/2014/main" id="{E0209A05-C6EC-418B-BFD8-7A6B382F2956}"/>
               </a:ext>
             </a:extLst>
           </p:cNvPr>
@@ -25124,7 +26987,7 @@
           <p:cNvPr id="24" name="">
             <a:extLst xmlns:a="http://schemas.openxmlformats.org/drawingml/2006/main">
               <a:ext uri="{FF2B5EF4-FFF2-40B4-BE49-F238E27FC236}">
-                <a16:creationId xmlns:a16="http://schemas.microsoft.com/office/drawing/2014/main" id="{DBCCA537-C198-4284-86CA-C3937C522705}"/>
+                <a16:creationId xmlns:a16="http://schemas.microsoft.com/office/drawing/2014/main" id="{30D99106-DF09-4C35-B92E-645837D1D823}"/>
               </a:ext>
             </a:extLst>
           </p:cNvPr>
@@ -25158,7 +27021,7 @@
           <p:cNvPr id="25" name="">
             <a:extLst xmlns:a="http://schemas.openxmlformats.org/drawingml/2006/main">
               <a:ext uri="{FF2B5EF4-FFF2-40B4-BE49-F238E27FC236}">
-                <a16:creationId xmlns:a16="http://schemas.microsoft.com/office/drawing/2014/main" id="{FB476849-7776-4E03-8970-7A4D46C3CAFD}"/>
+                <a16:creationId xmlns:a16="http://schemas.microsoft.com/office/drawing/2014/main" id="{073ABCAD-3057-48B7-82CA-6D5484D77A6C}"/>
               </a:ext>
             </a:extLst>
           </p:cNvPr>
@@ -25215,7 +27078,7 @@
           <p:cNvPr id="26" name="">
             <a:extLst xmlns:a="http://schemas.openxmlformats.org/drawingml/2006/main">
               <a:ext uri="{FF2B5EF4-FFF2-40B4-BE49-F238E27FC236}">
-                <a16:creationId xmlns:a16="http://schemas.microsoft.com/office/drawing/2014/main" id="{AAD732B5-20C3-4BAD-925A-D7061A1DC30D}"/>
+                <a16:creationId xmlns:a16="http://schemas.microsoft.com/office/drawing/2014/main" id="{25F9C17C-08CE-45E7-BD73-954699020761}"/>
               </a:ext>
             </a:extLst>
           </p:cNvPr>
@@ -25295,7 +27158,7 @@
           <p:cNvPr id="27" name="">
             <a:extLst xmlns:a="http://schemas.openxmlformats.org/drawingml/2006/main">
               <a:ext uri="{FF2B5EF4-FFF2-40B4-BE49-F238E27FC236}">
-                <a16:creationId xmlns:a16="http://schemas.microsoft.com/office/drawing/2014/main" id="{9ED2E529-C2C9-4AF1-AA6D-084800BBE7A5}"/>
+                <a16:creationId xmlns:a16="http://schemas.microsoft.com/office/drawing/2014/main" id="{F8C5F8D1-A331-4D93-BD42-0252AD207802}"/>
               </a:ext>
             </a:extLst>
           </p:cNvPr>
@@ -25352,7 +27215,7 @@
           <p:cNvPr id="28" name="">
             <a:extLst xmlns:a="http://schemas.openxmlformats.org/drawingml/2006/main">
               <a:ext uri="{FF2B5EF4-FFF2-40B4-BE49-F238E27FC236}">
-                <a16:creationId xmlns:a16="http://schemas.microsoft.com/office/drawing/2014/main" id="{0BB16861-1124-4C80-BF0F-508B4F63E220}"/>
+                <a16:creationId xmlns:a16="http://schemas.microsoft.com/office/drawing/2014/main" id="{BA6E891F-79E8-4F09-91F6-70DD9A5B5273}"/>
               </a:ext>
             </a:extLst>
           </p:cNvPr>
@@ -25384,7 +27247,7 @@
           <p:cNvPr id="29" name="">
             <a:extLst xmlns:a="http://schemas.openxmlformats.org/drawingml/2006/main">
               <a:ext uri="{FF2B5EF4-FFF2-40B4-BE49-F238E27FC236}">
-                <a16:creationId xmlns:a16="http://schemas.microsoft.com/office/drawing/2014/main" id="{1F050861-EE7F-4FB1-A96E-E1D468E64441}"/>
+                <a16:creationId xmlns:a16="http://schemas.microsoft.com/office/drawing/2014/main" id="{49CCCC64-CDD1-44BF-A81E-447AF9BAE11F}"/>
               </a:ext>
             </a:extLst>
           </p:cNvPr>
@@ -25441,7 +27304,7 @@
           <p:cNvPr id="30" name="">
             <a:extLst xmlns:a="http://schemas.openxmlformats.org/drawingml/2006/main">
               <a:ext uri="{FF2B5EF4-FFF2-40B4-BE49-F238E27FC236}">
-                <a16:creationId xmlns:a16="http://schemas.microsoft.com/office/drawing/2014/main" id="{FCF8CC7E-86F0-4351-A630-4C5D26BDB517}"/>
+                <a16:creationId xmlns:a16="http://schemas.microsoft.com/office/drawing/2014/main" id="{9715C5F5-681B-4D96-8F12-E7046670CF7A}"/>
               </a:ext>
             </a:extLst>
           </p:cNvPr>
@@ -25498,7 +27361,7 @@
           <p:cNvPr id="31" name="">
             <a:extLst xmlns:a="http://schemas.openxmlformats.org/drawingml/2006/main">
               <a:ext uri="{FF2B5EF4-FFF2-40B4-BE49-F238E27FC236}">
-                <a16:creationId xmlns:a16="http://schemas.microsoft.com/office/drawing/2014/main" id="{37D32062-4DD3-4C3F-9BE2-6FDD62ECAFA4}"/>
+                <a16:creationId xmlns:a16="http://schemas.microsoft.com/office/drawing/2014/main" id="{E119FD2A-1500-4797-947C-517B369D2326}"/>
               </a:ext>
             </a:extLst>
           </p:cNvPr>
@@ -25553,7 +27416,7 @@
     </p:spTree>
     <p:extLst>
       <p:ext uri="{BB962C8B-B14F-4D97-AF65-F5344CB8AC3E}">
-        <p14:creationId xmlns:p14="http://schemas.microsoft.com/office/powerpoint/2010/main" val="710782392"/>
+        <p14:creationId xmlns:p14="http://schemas.microsoft.com/office/powerpoint/2010/main" val="1521034268"/>
       </p:ext>
     </p:extLst>
   </p:cSld>

</xml_diff>

<commit_message>
Update NetraJyoti presentation deck
</commit_message>
<xml_diff>
--- a/docs/presentation/NetraJyoti_AI_Capstone_Demo_Deck.pptx
+++ b/docs/presentation/NetraJyoti_AI_Capstone_Demo_Deck.pptx
@@ -2,25 +2,25 @@
 <file path=ppt/presentation.xml><?xml version="1.0" encoding="utf-8"?>
 <p:presentation xmlns:p="http://schemas.openxmlformats.org/presentationml/2006/main">
   <p:sldMasterIdLst>
-    <p:sldMasterId xmlns:r="http://schemas.openxmlformats.org/officeDocument/2006/relationships" id="2147483648" r:id="Rf75708d4ee7c40b0"/>
+    <p:sldMasterId xmlns:r="http://schemas.openxmlformats.org/officeDocument/2006/relationships" id="2147483648" r:id="Rebfff7aaa4604330"/>
   </p:sldMasterIdLst>
   <p:notesMasterIdLst>
-    <p:notesMasterId xmlns:r="http://schemas.openxmlformats.org/officeDocument/2006/relationships" r:id="R2aaa831b0ee548f1"/>
+    <p:notesMasterId xmlns:r="http://schemas.openxmlformats.org/officeDocument/2006/relationships" r:id="R17cbc4a0cb484f5f"/>
   </p:notesMasterIdLst>
   <p:sldIdLst>
-    <p:sldId xmlns:r="http://schemas.openxmlformats.org/officeDocument/2006/relationships" id="256" r:id="R1d85e9daa84f4402"/>
-    <p:sldId xmlns:r="http://schemas.openxmlformats.org/officeDocument/2006/relationships" id="257" r:id="Rfa1277a1dff34b05"/>
-    <p:sldId xmlns:r="http://schemas.openxmlformats.org/officeDocument/2006/relationships" id="258" r:id="R381cd9b12f6d45f2"/>
-    <p:sldId xmlns:r="http://schemas.openxmlformats.org/officeDocument/2006/relationships" id="259" r:id="Rb109f643c1d04018"/>
-    <p:sldId xmlns:r="http://schemas.openxmlformats.org/officeDocument/2006/relationships" id="260" r:id="R0ed5b814fd6248c1"/>
-    <p:sldId xmlns:r="http://schemas.openxmlformats.org/officeDocument/2006/relationships" id="261" r:id="R0a73cb2175884d47"/>
-    <p:sldId xmlns:r="http://schemas.openxmlformats.org/officeDocument/2006/relationships" id="262" r:id="Rb58e79eec0df43b0"/>
-    <p:sldId xmlns:r="http://schemas.openxmlformats.org/officeDocument/2006/relationships" id="263" r:id="R42c8ca5eeb2341a1"/>
-    <p:sldId xmlns:r="http://schemas.openxmlformats.org/officeDocument/2006/relationships" id="264" r:id="R2f6c2a407c6e4abb"/>
-    <p:sldId xmlns:r="http://schemas.openxmlformats.org/officeDocument/2006/relationships" id="265" r:id="Rbf5e19ddc8174c33"/>
-    <p:sldId xmlns:r="http://schemas.openxmlformats.org/officeDocument/2006/relationships" id="266" r:id="R32051bcea67b468a"/>
-    <p:sldId xmlns:r="http://schemas.openxmlformats.org/officeDocument/2006/relationships" id="267" r:id="R8b8fe513eb504769"/>
-    <p:sldId xmlns:r="http://schemas.openxmlformats.org/officeDocument/2006/relationships" id="268" r:id="R619865c3b3e748da"/>
+    <p:sldId xmlns:r="http://schemas.openxmlformats.org/officeDocument/2006/relationships" id="256" r:id="R66bc48ab8d6649c3"/>
+    <p:sldId xmlns:r="http://schemas.openxmlformats.org/officeDocument/2006/relationships" id="257" r:id="Rc1f232db6f934275"/>
+    <p:sldId xmlns:r="http://schemas.openxmlformats.org/officeDocument/2006/relationships" id="258" r:id="Rdf8eb1b232f54f96"/>
+    <p:sldId xmlns:r="http://schemas.openxmlformats.org/officeDocument/2006/relationships" id="259" r:id="R4e0ebd61a2f34b5d"/>
+    <p:sldId xmlns:r="http://schemas.openxmlformats.org/officeDocument/2006/relationships" id="260" r:id="R6fceee3e9ebb4190"/>
+    <p:sldId xmlns:r="http://schemas.openxmlformats.org/officeDocument/2006/relationships" id="261" r:id="Rb6b546378a774f89"/>
+    <p:sldId xmlns:r="http://schemas.openxmlformats.org/officeDocument/2006/relationships" id="262" r:id="R84b0536df2a84d5d"/>
+    <p:sldId xmlns:r="http://schemas.openxmlformats.org/officeDocument/2006/relationships" id="263" r:id="R8c1feadbed53458b"/>
+    <p:sldId xmlns:r="http://schemas.openxmlformats.org/officeDocument/2006/relationships" id="264" r:id="R9bdb86b3d67a492d"/>
+    <p:sldId xmlns:r="http://schemas.openxmlformats.org/officeDocument/2006/relationships" id="265" r:id="Rfb237b858c874014"/>
+    <p:sldId xmlns:r="http://schemas.openxmlformats.org/officeDocument/2006/relationships" id="266" r:id="R6cbb3c567cc24e67"/>
+    <p:sldId xmlns:r="http://schemas.openxmlformats.org/officeDocument/2006/relationships" id="267" r:id="R83273a8423014017"/>
+    <p:sldId xmlns:r="http://schemas.openxmlformats.org/officeDocument/2006/relationships" id="268" r:id="R7ec56c1f30084fba"/>
   </p:sldIdLst>
   <p:sldSz cx="12192000" cy="6858000"/>
   <p:notesSz cx="6858000" cy="9144000"/>
@@ -1334,7 +1334,7 @@
   </p:cSld>
   <p:clrMap bg1="lt1" tx1="dk1" bg2="lt2" tx2="dk2" accent1="accent1" accent2="accent2" accent3="accent3" accent4="accent4" accent5="accent5" accent6="accent6" hlink="hlink" folHlink="folHlink"/>
   <p:sldLayoutIdLst>
-    <p:sldLayoutId xmlns:r="http://schemas.openxmlformats.org/officeDocument/2006/relationships" id="2147483649" r:id="R0c1f2f9357024e49"/>
+    <p:sldLayoutId xmlns:r="http://schemas.openxmlformats.org/officeDocument/2006/relationships" id="2147483649" r:id="R71729827c22f4ef8"/>
   </p:sldLayoutIdLst>
   <p:txStyles>
     <p:titleStyle>
@@ -2437,7 +2437,7 @@
           <p:cNvPr id="12" name="">
             <a:extLst xmlns:a="http://schemas.openxmlformats.org/drawingml/2006/main">
               <a:ext uri="{FF2B5EF4-FFF2-40B4-BE49-F238E27FC236}">
-                <a16:creationId xmlns:a16="http://schemas.microsoft.com/office/drawing/2014/main" id="{3EC45FE9-929E-4369-BC72-E13F633B42F7}"/>
+                <a16:creationId xmlns:a16="http://schemas.microsoft.com/office/drawing/2014/main" id="{4111D248-69A8-4DEE-8F9A-006E0E320C72}"/>
               </a:ext>
             </a:extLst>
           </p:cNvPr>
@@ -2467,7 +2467,7 @@
           <p:cNvPr id="13" name="">
             <a:extLst xmlns:a="http://schemas.openxmlformats.org/drawingml/2006/main">
               <a:ext uri="{FF2B5EF4-FFF2-40B4-BE49-F238E27FC236}">
-                <a16:creationId xmlns:a16="http://schemas.microsoft.com/office/drawing/2014/main" id="{B733FBF3-6E07-4412-B202-6E884FD0EC64}"/>
+                <a16:creationId xmlns:a16="http://schemas.microsoft.com/office/drawing/2014/main" id="{47247C34-4A64-46F6-B47D-611BD39EA1E4}"/>
               </a:ext>
             </a:extLst>
           </p:cNvPr>
@@ -2497,7 +2497,7 @@
           <p:cNvPr id="14" name="">
             <a:extLst xmlns:a="http://schemas.openxmlformats.org/drawingml/2006/main">
               <a:ext uri="{FF2B5EF4-FFF2-40B4-BE49-F238E27FC236}">
-                <a16:creationId xmlns:a16="http://schemas.microsoft.com/office/drawing/2014/main" id="{B2DD5855-FE6D-4166-8F8A-0A5B7E4CC85E}"/>
+                <a16:creationId xmlns:a16="http://schemas.microsoft.com/office/drawing/2014/main" id="{0DCD1AE7-81D0-4CD2-8E89-0ED284E34449}"/>
               </a:ext>
             </a:extLst>
           </p:cNvPr>
@@ -2527,7 +2527,7 @@
           <p:cNvPr id="15" name="">
             <a:extLst xmlns:a="http://schemas.openxmlformats.org/drawingml/2006/main">
               <a:ext uri="{FF2B5EF4-FFF2-40B4-BE49-F238E27FC236}">
-                <a16:creationId xmlns:a16="http://schemas.microsoft.com/office/drawing/2014/main" id="{8E45BAFA-1F15-45B2-A800-3A948E5B5722}"/>
+                <a16:creationId xmlns:a16="http://schemas.microsoft.com/office/drawing/2014/main" id="{EF1A34FA-4A86-4222-9F0D-C2C5E4E4ED50}"/>
               </a:ext>
             </a:extLst>
           </p:cNvPr>
@@ -2584,7 +2584,7 @@
           <p:cNvPr id="16" name="">
             <a:extLst xmlns:a="http://schemas.openxmlformats.org/drawingml/2006/main">
               <a:ext uri="{FF2B5EF4-FFF2-40B4-BE49-F238E27FC236}">
-                <a16:creationId xmlns:a16="http://schemas.microsoft.com/office/drawing/2014/main" id="{43C2B640-615D-4B55-88EA-E64A9E0B736C}"/>
+                <a16:creationId xmlns:a16="http://schemas.microsoft.com/office/drawing/2014/main" id="{B66F25E2-F812-4D62-AF82-1CA9F8123A5F}"/>
               </a:ext>
             </a:extLst>
           </p:cNvPr>
@@ -2664,7 +2664,7 @@
           <p:cNvPr id="17" name="">
             <a:extLst xmlns:a="http://schemas.openxmlformats.org/drawingml/2006/main">
               <a:ext uri="{FF2B5EF4-FFF2-40B4-BE49-F238E27FC236}">
-                <a16:creationId xmlns:a16="http://schemas.microsoft.com/office/drawing/2014/main" id="{82A9AB05-00EB-4167-A9DD-0D01E974FA04}"/>
+                <a16:creationId xmlns:a16="http://schemas.microsoft.com/office/drawing/2014/main" id="{80274F59-3C43-42E8-AA85-A195C551F7C5}"/>
               </a:ext>
             </a:extLst>
           </p:cNvPr>
@@ -2694,7 +2694,7 @@
           <p:cNvPr id="18" name="">
             <a:extLst xmlns:a="http://schemas.openxmlformats.org/drawingml/2006/main">
               <a:ext uri="{FF2B5EF4-FFF2-40B4-BE49-F238E27FC236}">
-                <a16:creationId xmlns:a16="http://schemas.microsoft.com/office/drawing/2014/main" id="{E47D6B2A-0413-48E1-AFFB-C08918341641}"/>
+                <a16:creationId xmlns:a16="http://schemas.microsoft.com/office/drawing/2014/main" id="{1514DC4E-D581-4411-B2FE-66F67D0803B3}"/>
               </a:ext>
             </a:extLst>
           </p:cNvPr>
@@ -2706,7 +2706,7 @@
         <p:spPr>
           <a:xfrm xmlns:a="http://schemas.openxmlformats.org/drawingml/2006/main">
             <a:off x="704850" y="3352800"/>
-            <a:ext cx="2667000" cy="619125"/>
+            <a:ext cx="2952750" cy="619125"/>
           </a:xfrm>
           <a:prstGeom xmlns:a="http://schemas.openxmlformats.org/drawingml/2006/main" prst="rect">
             <a:avLst/>
@@ -2741,7 +2741,7 @@
                 <a:ea typeface="Arial"/>
                 <a:cs typeface="Arial"/>
               </a:rPr>
-              <a:t>Voice and text access</a:t>
+              <a:t>Clear Bengali guidance</a:t>
             </a:r>
           </a:p>
           <a:p xmlns:a="http://schemas.openxmlformats.org/drawingml/2006/main">
@@ -2764,7 +2764,7 @@
                 <a:ea typeface="Arial"/>
                 <a:cs typeface="Arial"/>
               </a:rPr>
-              <a:t>with a fixed safety route</a:t>
+              <a:t>for your next eye-care step</a:t>
             </a:r>
           </a:p>
         </p:txBody>
@@ -2774,7 +2774,7 @@
           <p:cNvPr id="19" name="">
             <a:extLst xmlns:a="http://schemas.openxmlformats.org/drawingml/2006/main">
               <a:ext uri="{FF2B5EF4-FFF2-40B4-BE49-F238E27FC236}">
-                <a16:creationId xmlns:a16="http://schemas.microsoft.com/office/drawing/2014/main" id="{53764A19-B9E1-4404-9E62-22AF753EE05F}"/>
+                <a16:creationId xmlns:a16="http://schemas.microsoft.com/office/drawing/2014/main" id="{79A964B3-AA9A-4177-B4FC-8EF2DD3CBD02}"/>
               </a:ext>
             </a:extLst>
           </p:cNvPr>
@@ -2786,7 +2786,7 @@
         <p:spPr>
           <a:xfrm xmlns:a="http://schemas.openxmlformats.org/drawingml/2006/main">
             <a:off x="704850" y="5715000"/>
-            <a:ext cx="2667000" cy="457200"/>
+            <a:ext cx="2857500" cy="457200"/>
           </a:xfrm>
           <a:prstGeom xmlns:a="http://schemas.openxmlformats.org/drawingml/2006/main" prst="rect">
             <a:avLst/>
@@ -2854,7 +2854,7 @@
           <p:cNvPr id="20" name="">
             <a:extLst xmlns:a="http://schemas.openxmlformats.org/drawingml/2006/main">
               <a:ext uri="{FF2B5EF4-FFF2-40B4-BE49-F238E27FC236}">
-                <a16:creationId xmlns:a16="http://schemas.microsoft.com/office/drawing/2014/main" id="{39FB8633-CFF7-41C0-AC7A-C7698BBA9F95}"/>
+                <a16:creationId xmlns:a16="http://schemas.microsoft.com/office/drawing/2014/main" id="{1A39089A-EC06-452A-BA3F-B31746CC34DE}"/>
               </a:ext>
             </a:extLst>
           </p:cNvPr>
@@ -2911,7 +2911,7 @@
           <p:cNvPr id="21" name="">
             <a:extLst xmlns:a="http://schemas.openxmlformats.org/drawingml/2006/main">
               <a:ext uri="{FF2B5EF4-FFF2-40B4-BE49-F238E27FC236}">
-                <a16:creationId xmlns:a16="http://schemas.microsoft.com/office/drawing/2014/main" id="{07A4D393-200C-486E-8BEF-6D329C3AD57D}"/>
+                <a16:creationId xmlns:a16="http://schemas.microsoft.com/office/drawing/2014/main" id="{5EE365DB-6857-4576-81CC-B173DE0DF910}"/>
               </a:ext>
             </a:extLst>
           </p:cNvPr>
@@ -2968,7 +2968,7 @@
           <p:cNvPr id="22" name="">
             <a:extLst xmlns:a="http://schemas.openxmlformats.org/drawingml/2006/main">
               <a:ext uri="{FF2B5EF4-FFF2-40B4-BE49-F238E27FC236}">
-                <a16:creationId xmlns:a16="http://schemas.microsoft.com/office/drawing/2014/main" id="{589D2D31-11F1-4568-A40B-C1AF6963E729}"/>
+                <a16:creationId xmlns:a16="http://schemas.microsoft.com/office/drawing/2014/main" id="{F1525FAB-5963-4EF7-99CE-9D8FCE2904D6}"/>
               </a:ext>
             </a:extLst>
           </p:cNvPr>
@@ -3015,7 +3015,7 @@
                 <a:ea typeface="Arial"/>
                 <a:cs typeface="Arial"/>
               </a:rPr>
-              <a:t>Bengali voice or text</a:t>
+              <a:t>Fixed Bengali selections</a:t>
             </a:r>
           </a:p>
         </p:txBody>
@@ -3025,7 +3025,7 @@
           <p:cNvPr id="23" name="">
             <a:extLst xmlns:a="http://schemas.openxmlformats.org/drawingml/2006/main">
               <a:ext uri="{FF2B5EF4-FFF2-40B4-BE49-F238E27FC236}">
-                <a16:creationId xmlns:a16="http://schemas.microsoft.com/office/drawing/2014/main" id="{CBEE1D33-BF5D-4CAA-A035-0AAEAA7C3EFA}"/>
+                <a16:creationId xmlns:a16="http://schemas.microsoft.com/office/drawing/2014/main" id="{41C791DE-9F0D-4E4A-8D4A-5F46B85FC542}"/>
               </a:ext>
             </a:extLst>
           </p:cNvPr>
@@ -3055,7 +3055,7 @@
           <p:cNvPr id="24" name="">
             <a:extLst xmlns:a="http://schemas.openxmlformats.org/drawingml/2006/main">
               <a:ext uri="{FF2B5EF4-FFF2-40B4-BE49-F238E27FC236}">
-                <a16:creationId xmlns:a16="http://schemas.microsoft.com/office/drawing/2014/main" id="{AF4D1115-108B-4A13-A4A2-644416BA2173}"/>
+                <a16:creationId xmlns:a16="http://schemas.microsoft.com/office/drawing/2014/main" id="{4095C6DC-B15A-4914-9EBD-680767F85372}"/>
               </a:ext>
             </a:extLst>
           </p:cNvPr>
@@ -3112,7 +3112,7 @@
           <p:cNvPr id="25" name="">
             <a:extLst xmlns:a="http://schemas.openxmlformats.org/drawingml/2006/main">
               <a:ext uri="{FF2B5EF4-FFF2-40B4-BE49-F238E27FC236}">
-                <a16:creationId xmlns:a16="http://schemas.microsoft.com/office/drawing/2014/main" id="{684A5E74-13C4-483E-B1A8-09E2C98BAF22}"/>
+                <a16:creationId xmlns:a16="http://schemas.microsoft.com/office/drawing/2014/main" id="{8918F76F-4A54-4968-A685-7355FFF0C594}"/>
               </a:ext>
             </a:extLst>
           </p:cNvPr>
@@ -3142,7 +3142,7 @@
           <p:cNvPr id="26" name="">
             <a:extLst xmlns:a="http://schemas.openxmlformats.org/drawingml/2006/main">
               <a:ext uri="{FF2B5EF4-FFF2-40B4-BE49-F238E27FC236}">
-                <a16:creationId xmlns:a16="http://schemas.microsoft.com/office/drawing/2014/main" id="{0C778DD6-3F2C-4CDE-BB63-7B117307920A}"/>
+                <a16:creationId xmlns:a16="http://schemas.microsoft.com/office/drawing/2014/main" id="{0CE05A5C-16C4-4697-8ACE-4CC5D5463A0C}"/>
               </a:ext>
             </a:extLst>
           </p:cNvPr>
@@ -3221,7 +3221,7 @@
           <p:cNvPr id="29" name="">
             <a:extLst xmlns:a="http://schemas.openxmlformats.org/drawingml/2006/main">
               <a:ext uri="{FF2B5EF4-FFF2-40B4-BE49-F238E27FC236}">
-                <a16:creationId xmlns:a16="http://schemas.microsoft.com/office/drawing/2014/main" id="{F5F5C9FF-8B10-4C16-B0EC-E6805985CC91}"/>
+                <a16:creationId xmlns:a16="http://schemas.microsoft.com/office/drawing/2014/main" id="{1D949BEC-D133-42F3-A7FD-B048A4506448}"/>
               </a:ext>
             </a:extLst>
           </p:cNvPr>
@@ -3251,7 +3251,7 @@
           <p:cNvPr id="2" name="">
             <a:extLst xmlns:a="http://schemas.openxmlformats.org/drawingml/2006/main">
               <a:ext uri="{FF2B5EF4-FFF2-40B4-BE49-F238E27FC236}">
-                <a16:creationId xmlns:a16="http://schemas.microsoft.com/office/drawing/2014/main" id="{C35AF737-13EC-4FB1-BD52-B3DB7D474482}"/>
+                <a16:creationId xmlns:a16="http://schemas.microsoft.com/office/drawing/2014/main" id="{8ECB2678-3816-435A-A209-FD65E0AC9B2D}"/>
               </a:ext>
             </a:extLst>
           </p:cNvPr>
@@ -3308,7 +3308,7 @@
           <p:cNvPr id="3" name="">
             <a:extLst xmlns:a="http://schemas.openxmlformats.org/drawingml/2006/main">
               <a:ext uri="{FF2B5EF4-FFF2-40B4-BE49-F238E27FC236}">
-                <a16:creationId xmlns:a16="http://schemas.microsoft.com/office/drawing/2014/main" id="{08ADA32A-B9D9-4CA3-B56C-207524321E03}"/>
+                <a16:creationId xmlns:a16="http://schemas.microsoft.com/office/drawing/2014/main" id="{7745FF17-9074-48AE-BACB-68C67DF6ABBF}"/>
               </a:ext>
             </a:extLst>
           </p:cNvPr>
@@ -3365,7 +3365,7 @@
           <p:cNvPr id="4" name="">
             <a:extLst xmlns:a="http://schemas.openxmlformats.org/drawingml/2006/main">
               <a:ext uri="{FF2B5EF4-FFF2-40B4-BE49-F238E27FC236}">
-                <a16:creationId xmlns:a16="http://schemas.microsoft.com/office/drawing/2014/main" id="{A19C072D-FFB0-4024-8714-F3F5A1F08D28}"/>
+                <a16:creationId xmlns:a16="http://schemas.microsoft.com/office/drawing/2014/main" id="{9CBD2893-DF95-4725-BA67-04EADB1506A4}"/>
               </a:ext>
             </a:extLst>
           </p:cNvPr>
@@ -3422,7 +3422,7 @@
           <p:cNvPr id="5" name="">
             <a:extLst xmlns:a="http://schemas.openxmlformats.org/drawingml/2006/main">
               <a:ext uri="{FF2B5EF4-FFF2-40B4-BE49-F238E27FC236}">
-                <a16:creationId xmlns:a16="http://schemas.microsoft.com/office/drawing/2014/main" id="{E9ED07BD-9BC1-4C8B-B704-BF5D9F3DDFA5}"/>
+                <a16:creationId xmlns:a16="http://schemas.microsoft.com/office/drawing/2014/main" id="{A0B88717-46D4-4FC6-8285-A23A286622AB}"/>
               </a:ext>
             </a:extLst>
           </p:cNvPr>
@@ -3479,7 +3479,7 @@
           <p:cNvPr id="6" name="">
             <a:extLst xmlns:a="http://schemas.openxmlformats.org/drawingml/2006/main">
               <a:ext uri="{FF2B5EF4-FFF2-40B4-BE49-F238E27FC236}">
-                <a16:creationId xmlns:a16="http://schemas.microsoft.com/office/drawing/2014/main" id="{72247874-A5A8-4E98-B9E3-4725AAF9787F}"/>
+                <a16:creationId xmlns:a16="http://schemas.microsoft.com/office/drawing/2014/main" id="{1D3F69CE-BEDE-4589-B648-E65CBD0CB15C}"/>
               </a:ext>
             </a:extLst>
           </p:cNvPr>
@@ -3509,7 +3509,7 @@
           <p:cNvPr id="7" name="">
             <a:extLst xmlns:a="http://schemas.openxmlformats.org/drawingml/2006/main">
               <a:ext uri="{FF2B5EF4-FFF2-40B4-BE49-F238E27FC236}">
-                <a16:creationId xmlns:a16="http://schemas.microsoft.com/office/drawing/2014/main" id="{2E22E02B-D2D9-496E-916F-7887477AB85D}"/>
+                <a16:creationId xmlns:a16="http://schemas.microsoft.com/office/drawing/2014/main" id="{DA923E83-98F7-49CE-AB1C-9D9C205D8C94}"/>
               </a:ext>
             </a:extLst>
           </p:cNvPr>
@@ -3543,7 +3543,7 @@
           <p:cNvPr id="8" name="">
             <a:extLst xmlns:a="http://schemas.openxmlformats.org/drawingml/2006/main">
               <a:ext uri="{FF2B5EF4-FFF2-40B4-BE49-F238E27FC236}">
-                <a16:creationId xmlns:a16="http://schemas.microsoft.com/office/drawing/2014/main" id="{58B39B4D-27D5-43DB-AB17-A838C603960D}"/>
+                <a16:creationId xmlns:a16="http://schemas.microsoft.com/office/drawing/2014/main" id="{A6939C80-A517-4142-9939-37C073BE36D3}"/>
               </a:ext>
             </a:extLst>
           </p:cNvPr>
@@ -3575,7 +3575,7 @@
           <p:cNvPr id="9" name="">
             <a:extLst xmlns:a="http://schemas.openxmlformats.org/drawingml/2006/main">
               <a:ext uri="{FF2B5EF4-FFF2-40B4-BE49-F238E27FC236}">
-                <a16:creationId xmlns:a16="http://schemas.microsoft.com/office/drawing/2014/main" id="{1A7127CF-3163-4A20-BEB7-BC6DDEBA7827}"/>
+                <a16:creationId xmlns:a16="http://schemas.microsoft.com/office/drawing/2014/main" id="{464B95B5-5C27-44E2-A365-24F018D055A2}"/>
               </a:ext>
             </a:extLst>
           </p:cNvPr>
@@ -3632,7 +3632,7 @@
           <p:cNvPr id="10" name="">
             <a:extLst xmlns:a="http://schemas.openxmlformats.org/drawingml/2006/main">
               <a:ext uri="{FF2B5EF4-FFF2-40B4-BE49-F238E27FC236}">
-                <a16:creationId xmlns:a16="http://schemas.microsoft.com/office/drawing/2014/main" id="{63E5101E-96E8-416F-A6AD-85CB0324BAF0}"/>
+                <a16:creationId xmlns:a16="http://schemas.microsoft.com/office/drawing/2014/main" id="{82B8A059-20EB-43F4-AF72-2C59BA234804}"/>
               </a:ext>
             </a:extLst>
           </p:cNvPr>
@@ -3689,7 +3689,7 @@
           <p:cNvPr id="11" name="">
             <a:extLst xmlns:a="http://schemas.openxmlformats.org/drawingml/2006/main">
               <a:ext uri="{FF2B5EF4-FFF2-40B4-BE49-F238E27FC236}">
-                <a16:creationId xmlns:a16="http://schemas.microsoft.com/office/drawing/2014/main" id="{3EFBF571-659C-47E7-AF8C-95C4A2B653F5}"/>
+                <a16:creationId xmlns:a16="http://schemas.microsoft.com/office/drawing/2014/main" id="{EA681AB9-C785-483F-8F84-F208057DF416}"/>
               </a:ext>
             </a:extLst>
           </p:cNvPr>
@@ -3746,7 +3746,7 @@
           <p:cNvPr id="12" name="">
             <a:extLst xmlns:a="http://schemas.openxmlformats.org/drawingml/2006/main">
               <a:ext uri="{FF2B5EF4-FFF2-40B4-BE49-F238E27FC236}">
-                <a16:creationId xmlns:a16="http://schemas.microsoft.com/office/drawing/2014/main" id="{B56A4123-4C31-4D45-BA77-4F56A86C2436}"/>
+                <a16:creationId xmlns:a16="http://schemas.microsoft.com/office/drawing/2014/main" id="{EEFDDBA5-80CE-4DB6-917C-A3D95514D9FD}"/>
               </a:ext>
             </a:extLst>
           </p:cNvPr>
@@ -3803,7 +3803,7 @@
           <p:cNvPr id="13" name="">
             <a:extLst xmlns:a="http://schemas.openxmlformats.org/drawingml/2006/main">
               <a:ext uri="{FF2B5EF4-FFF2-40B4-BE49-F238E27FC236}">
-                <a16:creationId xmlns:a16="http://schemas.microsoft.com/office/drawing/2014/main" id="{76BA06DD-57C7-4EF4-8362-2CA709632DEC}"/>
+                <a16:creationId xmlns:a16="http://schemas.microsoft.com/office/drawing/2014/main" id="{64B61711-21CA-41BB-9FB3-2710F476E74B}"/>
               </a:ext>
             </a:extLst>
           </p:cNvPr>
@@ -3837,7 +3837,7 @@
           <p:cNvPr id="14" name="">
             <a:extLst xmlns:a="http://schemas.openxmlformats.org/drawingml/2006/main">
               <a:ext uri="{FF2B5EF4-FFF2-40B4-BE49-F238E27FC236}">
-                <a16:creationId xmlns:a16="http://schemas.microsoft.com/office/drawing/2014/main" id="{7BF4832C-3EC7-4C63-A78A-9F96917AD0FC}"/>
+                <a16:creationId xmlns:a16="http://schemas.microsoft.com/office/drawing/2014/main" id="{1F8A9B45-7783-4C33-AEC9-1ADD8F819BBF}"/>
               </a:ext>
             </a:extLst>
           </p:cNvPr>
@@ -3869,7 +3869,7 @@
           <p:cNvPr id="15" name="">
             <a:extLst xmlns:a="http://schemas.openxmlformats.org/drawingml/2006/main">
               <a:ext uri="{FF2B5EF4-FFF2-40B4-BE49-F238E27FC236}">
-                <a16:creationId xmlns:a16="http://schemas.microsoft.com/office/drawing/2014/main" id="{ACC62658-BBC3-40F9-8F66-F23BFFD32E1C}"/>
+                <a16:creationId xmlns:a16="http://schemas.microsoft.com/office/drawing/2014/main" id="{4F26B981-F638-4896-8F53-B496A638D039}"/>
               </a:ext>
             </a:extLst>
           </p:cNvPr>
@@ -3926,7 +3926,7 @@
           <p:cNvPr id="16" name="">
             <a:extLst xmlns:a="http://schemas.openxmlformats.org/drawingml/2006/main">
               <a:ext uri="{FF2B5EF4-FFF2-40B4-BE49-F238E27FC236}">
-                <a16:creationId xmlns:a16="http://schemas.microsoft.com/office/drawing/2014/main" id="{FA48AC3A-7C4C-4DCA-9467-7758430F08D3}"/>
+                <a16:creationId xmlns:a16="http://schemas.microsoft.com/office/drawing/2014/main" id="{29374AAA-CAFC-4067-BEC3-4D6F106ECCF2}"/>
               </a:ext>
             </a:extLst>
           </p:cNvPr>
@@ -3983,7 +3983,7 @@
           <p:cNvPr id="17" name="">
             <a:extLst xmlns:a="http://schemas.openxmlformats.org/drawingml/2006/main">
               <a:ext uri="{FF2B5EF4-FFF2-40B4-BE49-F238E27FC236}">
-                <a16:creationId xmlns:a16="http://schemas.microsoft.com/office/drawing/2014/main" id="{8BBCF0BF-A7E2-48BF-86FA-270137CA492D}"/>
+                <a16:creationId xmlns:a16="http://schemas.microsoft.com/office/drawing/2014/main" id="{61AB6813-FA93-4B4F-B348-8AD6B21C23E6}"/>
               </a:ext>
             </a:extLst>
           </p:cNvPr>
@@ -4040,7 +4040,7 @@
           <p:cNvPr id="18" name="">
             <a:extLst xmlns:a="http://schemas.openxmlformats.org/drawingml/2006/main">
               <a:ext uri="{FF2B5EF4-FFF2-40B4-BE49-F238E27FC236}">
-                <a16:creationId xmlns:a16="http://schemas.microsoft.com/office/drawing/2014/main" id="{4F4130B3-2ABC-41C3-A0E5-B2DFA7C7F477}"/>
+                <a16:creationId xmlns:a16="http://schemas.microsoft.com/office/drawing/2014/main" id="{B3C4C9AE-A7F4-46DA-ABC0-A8A9093D668B}"/>
               </a:ext>
             </a:extLst>
           </p:cNvPr>
@@ -4097,7 +4097,7 @@
           <p:cNvPr id="19" name="">
             <a:extLst xmlns:a="http://schemas.openxmlformats.org/drawingml/2006/main">
               <a:ext uri="{FF2B5EF4-FFF2-40B4-BE49-F238E27FC236}">
-                <a16:creationId xmlns:a16="http://schemas.microsoft.com/office/drawing/2014/main" id="{E7B42ACA-219C-4917-9B25-6A20F83D2BC6}"/>
+                <a16:creationId xmlns:a16="http://schemas.microsoft.com/office/drawing/2014/main" id="{826000EB-EC2B-4F37-9E2E-6A1547099154}"/>
               </a:ext>
             </a:extLst>
           </p:cNvPr>
@@ -4131,7 +4131,7 @@
           <p:cNvPr id="20" name="">
             <a:extLst xmlns:a="http://schemas.openxmlformats.org/drawingml/2006/main">
               <a:ext uri="{FF2B5EF4-FFF2-40B4-BE49-F238E27FC236}">
-                <a16:creationId xmlns:a16="http://schemas.microsoft.com/office/drawing/2014/main" id="{346FC3ED-7C18-44B3-8C70-CF49328BE00B}"/>
+                <a16:creationId xmlns:a16="http://schemas.microsoft.com/office/drawing/2014/main" id="{487466EA-88A8-4A77-9444-993C9B81E437}"/>
               </a:ext>
             </a:extLst>
           </p:cNvPr>
@@ -4163,7 +4163,7 @@
           <p:cNvPr id="21" name="">
             <a:extLst xmlns:a="http://schemas.openxmlformats.org/drawingml/2006/main">
               <a:ext uri="{FF2B5EF4-FFF2-40B4-BE49-F238E27FC236}">
-                <a16:creationId xmlns:a16="http://schemas.microsoft.com/office/drawing/2014/main" id="{65D27B71-DE06-4A3E-906C-0050DB0E5869}"/>
+                <a16:creationId xmlns:a16="http://schemas.microsoft.com/office/drawing/2014/main" id="{20F43CF3-B9CB-48A5-949B-99F59FA9B738}"/>
               </a:ext>
             </a:extLst>
           </p:cNvPr>
@@ -4220,7 +4220,7 @@
           <p:cNvPr id="22" name="">
             <a:extLst xmlns:a="http://schemas.openxmlformats.org/drawingml/2006/main">
               <a:ext uri="{FF2B5EF4-FFF2-40B4-BE49-F238E27FC236}">
-                <a16:creationId xmlns:a16="http://schemas.microsoft.com/office/drawing/2014/main" id="{AD2571AD-BEEA-4DA3-A41C-484CE0ED601D}"/>
+                <a16:creationId xmlns:a16="http://schemas.microsoft.com/office/drawing/2014/main" id="{ADB259F6-3983-4CFD-9E0B-C6A99B2E7DF0}"/>
               </a:ext>
             </a:extLst>
           </p:cNvPr>
@@ -4277,7 +4277,7 @@
           <p:cNvPr id="23" name="">
             <a:extLst xmlns:a="http://schemas.openxmlformats.org/drawingml/2006/main">
               <a:ext uri="{FF2B5EF4-FFF2-40B4-BE49-F238E27FC236}">
-                <a16:creationId xmlns:a16="http://schemas.microsoft.com/office/drawing/2014/main" id="{8E35905E-1765-4EB3-8027-C8780788702B}"/>
+                <a16:creationId xmlns:a16="http://schemas.microsoft.com/office/drawing/2014/main" id="{05601F4F-F6D5-4129-8E28-5229CABD88D8}"/>
               </a:ext>
             </a:extLst>
           </p:cNvPr>
@@ -4334,7 +4334,7 @@
           <p:cNvPr id="24" name="">
             <a:extLst xmlns:a="http://schemas.openxmlformats.org/drawingml/2006/main">
               <a:ext uri="{FF2B5EF4-FFF2-40B4-BE49-F238E27FC236}">
-                <a16:creationId xmlns:a16="http://schemas.microsoft.com/office/drawing/2014/main" id="{5ED6821C-1675-45AD-88EC-7257C39459C7}"/>
+                <a16:creationId xmlns:a16="http://schemas.microsoft.com/office/drawing/2014/main" id="{AD31C90F-4031-48F3-923A-94F2DE876ECC}"/>
               </a:ext>
             </a:extLst>
           </p:cNvPr>
@@ -4391,7 +4391,7 @@
           <p:cNvPr id="25" name="">
             <a:extLst xmlns:a="http://schemas.openxmlformats.org/drawingml/2006/main">
               <a:ext uri="{FF2B5EF4-FFF2-40B4-BE49-F238E27FC236}">
-                <a16:creationId xmlns:a16="http://schemas.microsoft.com/office/drawing/2014/main" id="{32700AB2-7DD9-4C95-9F08-7E50AE09F23F}"/>
+                <a16:creationId xmlns:a16="http://schemas.microsoft.com/office/drawing/2014/main" id="{045E35C9-F222-4A56-A654-6348A32E5A8C}"/>
               </a:ext>
             </a:extLst>
           </p:cNvPr>
@@ -4423,7 +4423,7 @@
           <p:cNvPr id="26" name="">
             <a:extLst xmlns:a="http://schemas.openxmlformats.org/drawingml/2006/main">
               <a:ext uri="{FF2B5EF4-FFF2-40B4-BE49-F238E27FC236}">
-                <a16:creationId xmlns:a16="http://schemas.microsoft.com/office/drawing/2014/main" id="{082C6631-162B-406F-BF50-2519975816C1}"/>
+                <a16:creationId xmlns:a16="http://schemas.microsoft.com/office/drawing/2014/main" id="{5BC5792E-D86D-4DC3-93F1-7C038F25CAFA}"/>
               </a:ext>
             </a:extLst>
           </p:cNvPr>
@@ -4480,7 +4480,7 @@
           <p:cNvPr id="27" name="">
             <a:extLst xmlns:a="http://schemas.openxmlformats.org/drawingml/2006/main">
               <a:ext uri="{FF2B5EF4-FFF2-40B4-BE49-F238E27FC236}">
-                <a16:creationId xmlns:a16="http://schemas.microsoft.com/office/drawing/2014/main" id="{494C142E-FB2D-4127-B5B6-5F0BF17AE02C}"/>
+                <a16:creationId xmlns:a16="http://schemas.microsoft.com/office/drawing/2014/main" id="{53BD486C-65F4-4445-B764-D7A27DB9E587}"/>
               </a:ext>
             </a:extLst>
           </p:cNvPr>
@@ -4537,7 +4537,7 @@
           <p:cNvPr id="28" name="">
             <a:extLst xmlns:a="http://schemas.openxmlformats.org/drawingml/2006/main">
               <a:ext uri="{FF2B5EF4-FFF2-40B4-BE49-F238E27FC236}">
-                <a16:creationId xmlns:a16="http://schemas.microsoft.com/office/drawing/2014/main" id="{68FEBAF1-D49E-4C67-874A-5F8977FF4397}"/>
+                <a16:creationId xmlns:a16="http://schemas.microsoft.com/office/drawing/2014/main" id="{E8D36233-3083-4722-977A-44E722EA2C6E}"/>
               </a:ext>
             </a:extLst>
           </p:cNvPr>
@@ -4592,7 +4592,7 @@
     </p:spTree>
     <p:extLst>
       <p:ext uri="{BB962C8B-B14F-4D97-AF65-F5344CB8AC3E}">
-        <p14:creationId xmlns:p14="http://schemas.microsoft.com/office/powerpoint/2010/main" val="10996520"/>
+        <p14:creationId xmlns:p14="http://schemas.microsoft.com/office/powerpoint/2010/main" val="1976903896"/>
       </p:ext>
     </p:extLst>
   </p:cSld>
@@ -4616,7 +4616,7 @@
           <p:cNvPr id="23" name="">
             <a:extLst xmlns:a="http://schemas.openxmlformats.org/drawingml/2006/main">
               <a:ext uri="{FF2B5EF4-FFF2-40B4-BE49-F238E27FC236}">
-                <a16:creationId xmlns:a16="http://schemas.microsoft.com/office/drawing/2014/main" id="{CE3210AA-2902-447B-8CDE-E1FD6E0EC0A5}"/>
+                <a16:creationId xmlns:a16="http://schemas.microsoft.com/office/drawing/2014/main" id="{5E39AAC7-F047-4388-8C26-6F68C46B7B11}"/>
               </a:ext>
             </a:extLst>
           </p:cNvPr>
@@ -4646,7 +4646,7 @@
           <p:cNvPr id="2" name="">
             <a:extLst xmlns:a="http://schemas.openxmlformats.org/drawingml/2006/main">
               <a:ext uri="{FF2B5EF4-FFF2-40B4-BE49-F238E27FC236}">
-                <a16:creationId xmlns:a16="http://schemas.microsoft.com/office/drawing/2014/main" id="{10915634-A6CB-4417-B2BB-44721772C712}"/>
+                <a16:creationId xmlns:a16="http://schemas.microsoft.com/office/drawing/2014/main" id="{45639FF1-34C5-4FE9-A44F-529C7478F700}"/>
               </a:ext>
             </a:extLst>
           </p:cNvPr>
@@ -4703,7 +4703,7 @@
           <p:cNvPr id="3" name="">
             <a:extLst xmlns:a="http://schemas.openxmlformats.org/drawingml/2006/main">
               <a:ext uri="{FF2B5EF4-FFF2-40B4-BE49-F238E27FC236}">
-                <a16:creationId xmlns:a16="http://schemas.microsoft.com/office/drawing/2014/main" id="{B9DFA4FE-8155-48DE-B31C-E288815B4F0E}"/>
+                <a16:creationId xmlns:a16="http://schemas.microsoft.com/office/drawing/2014/main" id="{87ACF265-93E5-4F18-A4B5-5A257E399773}"/>
               </a:ext>
             </a:extLst>
           </p:cNvPr>
@@ -4760,7 +4760,7 @@
           <p:cNvPr id="4" name="">
             <a:extLst xmlns:a="http://schemas.openxmlformats.org/drawingml/2006/main">
               <a:ext uri="{FF2B5EF4-FFF2-40B4-BE49-F238E27FC236}">
-                <a16:creationId xmlns:a16="http://schemas.microsoft.com/office/drawing/2014/main" id="{7B499BFA-43E6-41E4-B410-E3F36769011A}"/>
+                <a16:creationId xmlns:a16="http://schemas.microsoft.com/office/drawing/2014/main" id="{6E7C7EA2-31C4-49E3-8AFE-4E84A5F05DAE}"/>
               </a:ext>
             </a:extLst>
           </p:cNvPr>
@@ -4817,7 +4817,7 @@
           <p:cNvPr id="5" name="">
             <a:extLst xmlns:a="http://schemas.openxmlformats.org/drawingml/2006/main">
               <a:ext uri="{FF2B5EF4-FFF2-40B4-BE49-F238E27FC236}">
-                <a16:creationId xmlns:a16="http://schemas.microsoft.com/office/drawing/2014/main" id="{ADD949DB-61DF-4576-A37E-35370D2F3927}"/>
+                <a16:creationId xmlns:a16="http://schemas.microsoft.com/office/drawing/2014/main" id="{091E6548-6FFC-4245-892F-F3A040CD979D}"/>
               </a:ext>
             </a:extLst>
           </p:cNvPr>
@@ -4874,7 +4874,7 @@
           <p:cNvPr id="6" name="">
             <a:extLst xmlns:a="http://schemas.openxmlformats.org/drawingml/2006/main">
               <a:ext uri="{FF2B5EF4-FFF2-40B4-BE49-F238E27FC236}">
-                <a16:creationId xmlns:a16="http://schemas.microsoft.com/office/drawing/2014/main" id="{FA102D37-BF07-4993-A3A2-66DC019CC64E}"/>
+                <a16:creationId xmlns:a16="http://schemas.microsoft.com/office/drawing/2014/main" id="{46EB2BCB-F9DF-43E3-8B6F-547C9F505C9C}"/>
               </a:ext>
             </a:extLst>
           </p:cNvPr>
@@ -4904,7 +4904,7 @@
           <p:cNvPr id="7" name="">
             <a:extLst xmlns:a="http://schemas.openxmlformats.org/drawingml/2006/main">
               <a:ext uri="{FF2B5EF4-FFF2-40B4-BE49-F238E27FC236}">
-                <a16:creationId xmlns:a16="http://schemas.microsoft.com/office/drawing/2014/main" id="{CA7A335F-EDE4-472F-9AED-DF0CB8660DEB}"/>
+                <a16:creationId xmlns:a16="http://schemas.microsoft.com/office/drawing/2014/main" id="{17EDCAEA-49EC-46EF-905B-560F794296D1}"/>
               </a:ext>
             </a:extLst>
           </p:cNvPr>
@@ -4934,7 +4934,7 @@
           <p:cNvPr id="8" name="">
             <a:extLst xmlns:a="http://schemas.openxmlformats.org/drawingml/2006/main">
               <a:ext uri="{FF2B5EF4-FFF2-40B4-BE49-F238E27FC236}">
-                <a16:creationId xmlns:a16="http://schemas.microsoft.com/office/drawing/2014/main" id="{DD778004-5755-4676-966C-F61D3719A4E9}"/>
+                <a16:creationId xmlns:a16="http://schemas.microsoft.com/office/drawing/2014/main" id="{E134A21E-0FB0-4043-9204-AE958CC8BC45}"/>
               </a:ext>
             </a:extLst>
           </p:cNvPr>
@@ -4968,7 +4968,7 @@
           <p:cNvPr id="9" name="">
             <a:extLst xmlns:a="http://schemas.openxmlformats.org/drawingml/2006/main">
               <a:ext uri="{FF2B5EF4-FFF2-40B4-BE49-F238E27FC236}">
-                <a16:creationId xmlns:a16="http://schemas.microsoft.com/office/drawing/2014/main" id="{5E0C9C77-C8E5-4501-9867-778BC6AEE359}"/>
+                <a16:creationId xmlns:a16="http://schemas.microsoft.com/office/drawing/2014/main" id="{8A767AFE-B647-4D74-A424-571BAD82DEE4}"/>
               </a:ext>
             </a:extLst>
           </p:cNvPr>
@@ -5000,7 +5000,7 @@
           <p:cNvPr id="10" name="">
             <a:extLst xmlns:a="http://schemas.openxmlformats.org/drawingml/2006/main">
               <a:ext uri="{FF2B5EF4-FFF2-40B4-BE49-F238E27FC236}">
-                <a16:creationId xmlns:a16="http://schemas.microsoft.com/office/drawing/2014/main" id="{F109EE29-2449-4050-BC3C-C0147FAB6843}"/>
+                <a16:creationId xmlns:a16="http://schemas.microsoft.com/office/drawing/2014/main" id="{E2E2D2A0-029E-4BB0-A6FD-3CB83FF1FE9D}"/>
               </a:ext>
             </a:extLst>
           </p:cNvPr>
@@ -5057,7 +5057,7 @@
           <p:cNvPr id="11" name="">
             <a:extLst xmlns:a="http://schemas.openxmlformats.org/drawingml/2006/main">
               <a:ext uri="{FF2B5EF4-FFF2-40B4-BE49-F238E27FC236}">
-                <a16:creationId xmlns:a16="http://schemas.microsoft.com/office/drawing/2014/main" id="{4FA68A43-1FA8-4586-8F3C-484E3F812EC1}"/>
+                <a16:creationId xmlns:a16="http://schemas.microsoft.com/office/drawing/2014/main" id="{E6A0F10F-D64B-46AA-9305-B4D24EC96BD1}"/>
               </a:ext>
             </a:extLst>
           </p:cNvPr>
@@ -5137,7 +5137,7 @@
           <p:cNvPr id="12" name="">
             <a:extLst xmlns:a="http://schemas.openxmlformats.org/drawingml/2006/main">
               <a:ext uri="{FF2B5EF4-FFF2-40B4-BE49-F238E27FC236}">
-                <a16:creationId xmlns:a16="http://schemas.microsoft.com/office/drawing/2014/main" id="{FC969F34-1C30-48DA-9D58-2B17569B5FA8}"/>
+                <a16:creationId xmlns:a16="http://schemas.microsoft.com/office/drawing/2014/main" id="{229F102D-94D9-4212-88C2-8C078FEC51F3}"/>
               </a:ext>
             </a:extLst>
           </p:cNvPr>
@@ -5171,7 +5171,7 @@
           <p:cNvPr id="13" name="">
             <a:extLst xmlns:a="http://schemas.openxmlformats.org/drawingml/2006/main">
               <a:ext uri="{FF2B5EF4-FFF2-40B4-BE49-F238E27FC236}">
-                <a16:creationId xmlns:a16="http://schemas.microsoft.com/office/drawing/2014/main" id="{A26F0EAA-0C8A-47EB-8206-4E0346952D9F}"/>
+                <a16:creationId xmlns:a16="http://schemas.microsoft.com/office/drawing/2014/main" id="{085ECFBE-5AB4-43E8-BEE3-2A00F8F1642C}"/>
               </a:ext>
             </a:extLst>
           </p:cNvPr>
@@ -5203,7 +5203,7 @@
           <p:cNvPr id="14" name="">
             <a:extLst xmlns:a="http://schemas.openxmlformats.org/drawingml/2006/main">
               <a:ext uri="{FF2B5EF4-FFF2-40B4-BE49-F238E27FC236}">
-                <a16:creationId xmlns:a16="http://schemas.microsoft.com/office/drawing/2014/main" id="{381D84C4-F1CE-4D1E-B341-5B10E700DDC9}"/>
+                <a16:creationId xmlns:a16="http://schemas.microsoft.com/office/drawing/2014/main" id="{615AE174-620B-4FF9-A0BB-5C36659209D2}"/>
               </a:ext>
             </a:extLst>
           </p:cNvPr>
@@ -5260,7 +5260,7 @@
           <p:cNvPr id="15" name="">
             <a:extLst xmlns:a="http://schemas.openxmlformats.org/drawingml/2006/main">
               <a:ext uri="{FF2B5EF4-FFF2-40B4-BE49-F238E27FC236}">
-                <a16:creationId xmlns:a16="http://schemas.microsoft.com/office/drawing/2014/main" id="{67DDE95F-9DAC-4577-A600-728A12ACA75E}"/>
+                <a16:creationId xmlns:a16="http://schemas.microsoft.com/office/drawing/2014/main" id="{B551F7D4-9870-48CB-A373-FDD050744CE8}"/>
               </a:ext>
             </a:extLst>
           </p:cNvPr>
@@ -5340,7 +5340,7 @@
           <p:cNvPr id="16" name="">
             <a:extLst xmlns:a="http://schemas.openxmlformats.org/drawingml/2006/main">
               <a:ext uri="{FF2B5EF4-FFF2-40B4-BE49-F238E27FC236}">
-                <a16:creationId xmlns:a16="http://schemas.microsoft.com/office/drawing/2014/main" id="{07EE7B8A-857E-4160-AC3B-583856FC85CB}"/>
+                <a16:creationId xmlns:a16="http://schemas.microsoft.com/office/drawing/2014/main" id="{628BF55E-EF4B-4186-9364-ACD81EDA4262}"/>
               </a:ext>
             </a:extLst>
           </p:cNvPr>
@@ -5374,7 +5374,7 @@
           <p:cNvPr id="17" name="">
             <a:extLst xmlns:a="http://schemas.openxmlformats.org/drawingml/2006/main">
               <a:ext uri="{FF2B5EF4-FFF2-40B4-BE49-F238E27FC236}">
-                <a16:creationId xmlns:a16="http://schemas.microsoft.com/office/drawing/2014/main" id="{96844FA9-9F61-47C8-97FF-5A0CEF64B7B9}"/>
+                <a16:creationId xmlns:a16="http://schemas.microsoft.com/office/drawing/2014/main" id="{490FDCFF-12AC-48FD-B6AB-4E447B77FF9A}"/>
               </a:ext>
             </a:extLst>
           </p:cNvPr>
@@ -5406,7 +5406,7 @@
           <p:cNvPr id="18" name="">
             <a:extLst xmlns:a="http://schemas.openxmlformats.org/drawingml/2006/main">
               <a:ext uri="{FF2B5EF4-FFF2-40B4-BE49-F238E27FC236}">
-                <a16:creationId xmlns:a16="http://schemas.microsoft.com/office/drawing/2014/main" id="{18EC2F2F-5345-4024-92F6-D26693A28630}"/>
+                <a16:creationId xmlns:a16="http://schemas.microsoft.com/office/drawing/2014/main" id="{3C0EBA94-DF60-4B14-BEFD-F054CFEB699E}"/>
               </a:ext>
             </a:extLst>
           </p:cNvPr>
@@ -5463,7 +5463,7 @@
           <p:cNvPr id="19" name="">
             <a:extLst xmlns:a="http://schemas.openxmlformats.org/drawingml/2006/main">
               <a:ext uri="{FF2B5EF4-FFF2-40B4-BE49-F238E27FC236}">
-                <a16:creationId xmlns:a16="http://schemas.microsoft.com/office/drawing/2014/main" id="{583C2BBD-8BEF-40A7-8071-5EB3AD88FEFC}"/>
+                <a16:creationId xmlns:a16="http://schemas.microsoft.com/office/drawing/2014/main" id="{7CFEF121-6440-42F0-A99B-9C7ACEDDDE7E}"/>
               </a:ext>
             </a:extLst>
           </p:cNvPr>
@@ -5543,7 +5543,7 @@
           <p:cNvPr id="20" name="">
             <a:extLst xmlns:a="http://schemas.openxmlformats.org/drawingml/2006/main">
               <a:ext uri="{FF2B5EF4-FFF2-40B4-BE49-F238E27FC236}">
-                <a16:creationId xmlns:a16="http://schemas.microsoft.com/office/drawing/2014/main" id="{54C6E585-30E4-41D0-91A1-C5806B49AD06}"/>
+                <a16:creationId xmlns:a16="http://schemas.microsoft.com/office/drawing/2014/main" id="{92CF4271-AE3F-470D-ABA3-43D297C9C16B}"/>
               </a:ext>
             </a:extLst>
           </p:cNvPr>
@@ -5600,7 +5600,7 @@
           <p:cNvPr id="21" name="">
             <a:extLst xmlns:a="http://schemas.openxmlformats.org/drawingml/2006/main">
               <a:ext uri="{FF2B5EF4-FFF2-40B4-BE49-F238E27FC236}">
-                <a16:creationId xmlns:a16="http://schemas.microsoft.com/office/drawing/2014/main" id="{3A6E89C9-F6BE-46D8-810C-2E768043555A}"/>
+                <a16:creationId xmlns:a16="http://schemas.microsoft.com/office/drawing/2014/main" id="{7BD30EB4-6E1C-4170-8D68-93B228DA100F}"/>
               </a:ext>
             </a:extLst>
           </p:cNvPr>
@@ -5657,7 +5657,7 @@
           <p:cNvPr id="22" name="">
             <a:extLst xmlns:a="http://schemas.openxmlformats.org/drawingml/2006/main">
               <a:ext uri="{FF2B5EF4-FFF2-40B4-BE49-F238E27FC236}">
-                <a16:creationId xmlns:a16="http://schemas.microsoft.com/office/drawing/2014/main" id="{BA612B66-CDAD-438C-A7E1-4FB9A1D268A5}"/>
+                <a16:creationId xmlns:a16="http://schemas.microsoft.com/office/drawing/2014/main" id="{F03B9674-9E29-4696-8BF1-A1C62589A06F}"/>
               </a:ext>
             </a:extLst>
           </p:cNvPr>
@@ -5712,7 +5712,7 @@
     </p:spTree>
     <p:extLst>
       <p:ext uri="{BB962C8B-B14F-4D97-AF65-F5344CB8AC3E}">
-        <p14:creationId xmlns:p14="http://schemas.microsoft.com/office/powerpoint/2010/main" val="1805129058"/>
+        <p14:creationId xmlns:p14="http://schemas.microsoft.com/office/powerpoint/2010/main" val="1787341300"/>
       </p:ext>
     </p:extLst>
   </p:cSld>
@@ -5736,7 +5736,7 @@
           <p:cNvPr id="26" name="">
             <a:extLst xmlns:a="http://schemas.openxmlformats.org/drawingml/2006/main">
               <a:ext uri="{FF2B5EF4-FFF2-40B4-BE49-F238E27FC236}">
-                <a16:creationId xmlns:a16="http://schemas.microsoft.com/office/drawing/2014/main" id="{4F0E697E-754C-47C4-A0E2-E627211B6A80}"/>
+                <a16:creationId xmlns:a16="http://schemas.microsoft.com/office/drawing/2014/main" id="{F2E63DC5-2CAB-40C4-958B-9BC3BC9E833B}"/>
               </a:ext>
             </a:extLst>
           </p:cNvPr>
@@ -5766,7 +5766,7 @@
           <p:cNvPr id="2" name="">
             <a:extLst xmlns:a="http://schemas.openxmlformats.org/drawingml/2006/main">
               <a:ext uri="{FF2B5EF4-FFF2-40B4-BE49-F238E27FC236}">
-                <a16:creationId xmlns:a16="http://schemas.microsoft.com/office/drawing/2014/main" id="{720EA545-27DA-4A6E-B2A2-4F3EB1AE6F9C}"/>
+                <a16:creationId xmlns:a16="http://schemas.microsoft.com/office/drawing/2014/main" id="{B3C62762-9E44-4108-AB56-D3C791F29CA1}"/>
               </a:ext>
             </a:extLst>
           </p:cNvPr>
@@ -5823,7 +5823,7 @@
           <p:cNvPr id="3" name="">
             <a:extLst xmlns:a="http://schemas.openxmlformats.org/drawingml/2006/main">
               <a:ext uri="{FF2B5EF4-FFF2-40B4-BE49-F238E27FC236}">
-                <a16:creationId xmlns:a16="http://schemas.microsoft.com/office/drawing/2014/main" id="{BC752B34-FF07-4259-8E84-21B22739D155}"/>
+                <a16:creationId xmlns:a16="http://schemas.microsoft.com/office/drawing/2014/main" id="{3300F1F6-443F-40D7-8FDB-F85041B58165}"/>
               </a:ext>
             </a:extLst>
           </p:cNvPr>
@@ -5880,7 +5880,7 @@
           <p:cNvPr id="4" name="">
             <a:extLst xmlns:a="http://schemas.openxmlformats.org/drawingml/2006/main">
               <a:ext uri="{FF2B5EF4-FFF2-40B4-BE49-F238E27FC236}">
-                <a16:creationId xmlns:a16="http://schemas.microsoft.com/office/drawing/2014/main" id="{9BEC4659-FBBA-4175-819D-AEA48668BCA1}"/>
+                <a16:creationId xmlns:a16="http://schemas.microsoft.com/office/drawing/2014/main" id="{BDB492E5-B430-4C37-B53A-D31BD734BAE6}"/>
               </a:ext>
             </a:extLst>
           </p:cNvPr>
@@ -5937,7 +5937,7 @@
           <p:cNvPr id="5" name="">
             <a:extLst xmlns:a="http://schemas.openxmlformats.org/drawingml/2006/main">
               <a:ext uri="{FF2B5EF4-FFF2-40B4-BE49-F238E27FC236}">
-                <a16:creationId xmlns:a16="http://schemas.microsoft.com/office/drawing/2014/main" id="{3A841A6A-EC76-40FC-B5AE-F09837975FB8}"/>
+                <a16:creationId xmlns:a16="http://schemas.microsoft.com/office/drawing/2014/main" id="{0EAFCEA7-FA8A-4470-9228-33D2AE8EFD40}"/>
               </a:ext>
             </a:extLst>
           </p:cNvPr>
@@ -5994,7 +5994,7 @@
           <p:cNvPr id="6" name="">
             <a:extLst xmlns:a="http://schemas.openxmlformats.org/drawingml/2006/main">
               <a:ext uri="{FF2B5EF4-FFF2-40B4-BE49-F238E27FC236}">
-                <a16:creationId xmlns:a16="http://schemas.microsoft.com/office/drawing/2014/main" id="{E33EAA7A-4905-4827-B158-36F7AE6A86FD}"/>
+                <a16:creationId xmlns:a16="http://schemas.microsoft.com/office/drawing/2014/main" id="{699B7133-D675-43F4-8C75-D02A06DCF3EC}"/>
               </a:ext>
             </a:extLst>
           </p:cNvPr>
@@ -6024,7 +6024,7 @@
           <p:cNvPr id="7" name="">
             <a:extLst xmlns:a="http://schemas.openxmlformats.org/drawingml/2006/main">
               <a:ext uri="{FF2B5EF4-FFF2-40B4-BE49-F238E27FC236}">
-                <a16:creationId xmlns:a16="http://schemas.microsoft.com/office/drawing/2014/main" id="{211EE4B8-4581-448A-A05A-F7D17713EB39}"/>
+                <a16:creationId xmlns:a16="http://schemas.microsoft.com/office/drawing/2014/main" id="{C0FFA98B-F7FD-4D48-91C6-4F13A22315F5}"/>
               </a:ext>
             </a:extLst>
           </p:cNvPr>
@@ -6081,7 +6081,7 @@
           <p:cNvPr id="8" name="">
             <a:extLst xmlns:a="http://schemas.openxmlformats.org/drawingml/2006/main">
               <a:ext uri="{FF2B5EF4-FFF2-40B4-BE49-F238E27FC236}">
-                <a16:creationId xmlns:a16="http://schemas.microsoft.com/office/drawing/2014/main" id="{00FC1634-FBA3-4C15-9B2E-3EDF9E22FFB6}"/>
+                <a16:creationId xmlns:a16="http://schemas.microsoft.com/office/drawing/2014/main" id="{6478A9E1-C3EF-467F-9794-88A0EFAFCD73}"/>
               </a:ext>
             </a:extLst>
           </p:cNvPr>
@@ -6115,7 +6115,7 @@
           <p:cNvPr id="9" name="">
             <a:extLst xmlns:a="http://schemas.openxmlformats.org/drawingml/2006/main">
               <a:ext uri="{FF2B5EF4-FFF2-40B4-BE49-F238E27FC236}">
-                <a16:creationId xmlns:a16="http://schemas.microsoft.com/office/drawing/2014/main" id="{DC6D74A0-FF8D-4EEC-8146-3E5EF6D6DE64}"/>
+                <a16:creationId xmlns:a16="http://schemas.microsoft.com/office/drawing/2014/main" id="{D754E0C4-6606-4BD1-88C0-2CEB8E3301E1}"/>
               </a:ext>
             </a:extLst>
           </p:cNvPr>
@@ -6145,7 +6145,7 @@
           <p:cNvPr id="10" name="">
             <a:extLst xmlns:a="http://schemas.openxmlformats.org/drawingml/2006/main">
               <a:ext uri="{FF2B5EF4-FFF2-40B4-BE49-F238E27FC236}">
-                <a16:creationId xmlns:a16="http://schemas.microsoft.com/office/drawing/2014/main" id="{7B3A0C1A-0ED5-4721-A0D9-A912C4380BDD}"/>
+                <a16:creationId xmlns:a16="http://schemas.microsoft.com/office/drawing/2014/main" id="{7F068363-0E47-4EE9-9C97-0F2BF06BA616}"/>
               </a:ext>
             </a:extLst>
           </p:cNvPr>
@@ -6202,7 +6202,7 @@
           <p:cNvPr id="11" name="">
             <a:extLst xmlns:a="http://schemas.openxmlformats.org/drawingml/2006/main">
               <a:ext uri="{FF2B5EF4-FFF2-40B4-BE49-F238E27FC236}">
-                <a16:creationId xmlns:a16="http://schemas.microsoft.com/office/drawing/2014/main" id="{201139BA-8712-4F70-8909-021870918B29}"/>
+                <a16:creationId xmlns:a16="http://schemas.microsoft.com/office/drawing/2014/main" id="{AFC4F48F-5633-4213-BEC1-ACA6E76C1F84}"/>
               </a:ext>
             </a:extLst>
           </p:cNvPr>
@@ -6259,7 +6259,7 @@
           <p:cNvPr id="12" name="">
             <a:extLst xmlns:a="http://schemas.openxmlformats.org/drawingml/2006/main">
               <a:ext uri="{FF2B5EF4-FFF2-40B4-BE49-F238E27FC236}">
-                <a16:creationId xmlns:a16="http://schemas.microsoft.com/office/drawing/2014/main" id="{00FD03B9-F1B5-41B6-AB95-8EBB68316011}"/>
+                <a16:creationId xmlns:a16="http://schemas.microsoft.com/office/drawing/2014/main" id="{1D9182E7-5156-4902-B5B3-0A226E297749}"/>
               </a:ext>
             </a:extLst>
           </p:cNvPr>
@@ -6306,7 +6306,7 @@
                 <a:ea typeface="Arial"/>
                 <a:cs typeface="Arial"/>
               </a:rPr>
-              <a:t>Choose voice or text input</a:t>
+              <a:t>Select Bengali options</a:t>
             </a:r>
           </a:p>
         </p:txBody>
@@ -6316,7 +6316,7 @@
           <p:cNvPr id="13" name="">
             <a:extLst xmlns:a="http://schemas.openxmlformats.org/drawingml/2006/main">
               <a:ext uri="{FF2B5EF4-FFF2-40B4-BE49-F238E27FC236}">
-                <a16:creationId xmlns:a16="http://schemas.microsoft.com/office/drawing/2014/main" id="{F1B68324-3409-4414-83D2-DB5FAFAB97DB}"/>
+                <a16:creationId xmlns:a16="http://schemas.microsoft.com/office/drawing/2014/main" id="{C7F73EE2-B3FA-4FB8-8314-76218AC2876A}"/>
               </a:ext>
             </a:extLst>
           </p:cNvPr>
@@ -6350,7 +6350,7 @@
           <p:cNvPr id="14" name="">
             <a:extLst xmlns:a="http://schemas.openxmlformats.org/drawingml/2006/main">
               <a:ext uri="{FF2B5EF4-FFF2-40B4-BE49-F238E27FC236}">
-                <a16:creationId xmlns:a16="http://schemas.microsoft.com/office/drawing/2014/main" id="{CCD1B659-2D31-4E4E-9233-A59069F53318}"/>
+                <a16:creationId xmlns:a16="http://schemas.microsoft.com/office/drawing/2014/main" id="{AF3BF458-486A-4834-99B0-C58F99055B17}"/>
               </a:ext>
             </a:extLst>
           </p:cNvPr>
@@ -6380,7 +6380,7 @@
           <p:cNvPr id="15" name="">
             <a:extLst xmlns:a="http://schemas.openxmlformats.org/drawingml/2006/main">
               <a:ext uri="{FF2B5EF4-FFF2-40B4-BE49-F238E27FC236}">
-                <a16:creationId xmlns:a16="http://schemas.microsoft.com/office/drawing/2014/main" id="{4FA4FB7A-AC2F-498B-850A-E6A27E5A4602}"/>
+                <a16:creationId xmlns:a16="http://schemas.microsoft.com/office/drawing/2014/main" id="{E0DE8259-72EB-40FF-97EC-102FF88192D2}"/>
               </a:ext>
             </a:extLst>
           </p:cNvPr>
@@ -6437,7 +6437,7 @@
           <p:cNvPr id="16" name="">
             <a:extLst xmlns:a="http://schemas.openxmlformats.org/drawingml/2006/main">
               <a:ext uri="{FF2B5EF4-FFF2-40B4-BE49-F238E27FC236}">
-                <a16:creationId xmlns:a16="http://schemas.microsoft.com/office/drawing/2014/main" id="{C5F77B76-FAB4-4340-BEB5-734999411E7F}"/>
+                <a16:creationId xmlns:a16="http://schemas.microsoft.com/office/drawing/2014/main" id="{C5C19343-0B4B-4140-8FBA-88AB9959EBB9}"/>
               </a:ext>
             </a:extLst>
           </p:cNvPr>
@@ -6484,7 +6484,7 @@
                 <a:ea typeface="Arial"/>
                 <a:cs typeface="Arial"/>
               </a:rPr>
-              <a:t>Select eye symptoms</a:t>
+              <a:t>Select symptoms</a:t>
             </a:r>
           </a:p>
         </p:txBody>
@@ -6494,7 +6494,7 @@
           <p:cNvPr id="17" name="">
             <a:extLst xmlns:a="http://schemas.openxmlformats.org/drawingml/2006/main">
               <a:ext uri="{FF2B5EF4-FFF2-40B4-BE49-F238E27FC236}">
-                <a16:creationId xmlns:a16="http://schemas.microsoft.com/office/drawing/2014/main" id="{E21567ED-89FA-4823-ABD7-EE7C54C99846}"/>
+                <a16:creationId xmlns:a16="http://schemas.microsoft.com/office/drawing/2014/main" id="{5342998F-A047-4E91-9C24-1599F9DFB046}"/>
               </a:ext>
             </a:extLst>
           </p:cNvPr>
@@ -6541,7 +6541,7 @@
                 <a:ea typeface="Arial"/>
                 <a:cs typeface="Arial"/>
               </a:rPr>
-              <a:t>Use fixed, Bengali-first options</a:t>
+              <a:t>Fixed selections determine the route</a:t>
             </a:r>
           </a:p>
         </p:txBody>
@@ -6551,7 +6551,7 @@
           <p:cNvPr id="18" name="">
             <a:extLst xmlns:a="http://schemas.openxmlformats.org/drawingml/2006/main">
               <a:ext uri="{FF2B5EF4-FFF2-40B4-BE49-F238E27FC236}">
-                <a16:creationId xmlns:a16="http://schemas.microsoft.com/office/drawing/2014/main" id="{5BD90F13-FDAD-456B-AA0E-7D7C528CCCF7}"/>
+                <a16:creationId xmlns:a16="http://schemas.microsoft.com/office/drawing/2014/main" id="{A80490DC-E19A-41BC-B011-8EEE100216D2}"/>
               </a:ext>
             </a:extLst>
           </p:cNvPr>
@@ -6585,7 +6585,7 @@
           <p:cNvPr id="19" name="">
             <a:extLst xmlns:a="http://schemas.openxmlformats.org/drawingml/2006/main">
               <a:ext uri="{FF2B5EF4-FFF2-40B4-BE49-F238E27FC236}">
-                <a16:creationId xmlns:a16="http://schemas.microsoft.com/office/drawing/2014/main" id="{0AC7620D-65EE-4405-B6E2-2294C718078E}"/>
+                <a16:creationId xmlns:a16="http://schemas.microsoft.com/office/drawing/2014/main" id="{3DF38E60-65AA-47CE-A9E8-5509F785AFFB}"/>
               </a:ext>
             </a:extLst>
           </p:cNvPr>
@@ -6615,7 +6615,7 @@
           <p:cNvPr id="20" name="">
             <a:extLst xmlns:a="http://schemas.openxmlformats.org/drawingml/2006/main">
               <a:ext uri="{FF2B5EF4-FFF2-40B4-BE49-F238E27FC236}">
-                <a16:creationId xmlns:a16="http://schemas.microsoft.com/office/drawing/2014/main" id="{0207001C-5BC3-4073-9964-2378F25A823A}"/>
+                <a16:creationId xmlns:a16="http://schemas.microsoft.com/office/drawing/2014/main" id="{B5DCFAC9-0588-485E-9B7B-646B1386E01D}"/>
               </a:ext>
             </a:extLst>
           </p:cNvPr>
@@ -6672,7 +6672,7 @@
           <p:cNvPr id="21" name="">
             <a:extLst xmlns:a="http://schemas.openxmlformats.org/drawingml/2006/main">
               <a:ext uri="{FF2B5EF4-FFF2-40B4-BE49-F238E27FC236}">
-                <a16:creationId xmlns:a16="http://schemas.microsoft.com/office/drawing/2014/main" id="{A2ADBB6B-C8AE-41C4-90CE-07104FD7FABE}"/>
+                <a16:creationId xmlns:a16="http://schemas.microsoft.com/office/drawing/2014/main" id="{40341530-DAD4-4F78-BD5D-972F66D4D50F}"/>
               </a:ext>
             </a:extLst>
           </p:cNvPr>
@@ -6729,7 +6729,7 @@
           <p:cNvPr id="22" name="">
             <a:extLst xmlns:a="http://schemas.openxmlformats.org/drawingml/2006/main">
               <a:ext uri="{FF2B5EF4-FFF2-40B4-BE49-F238E27FC236}">
-                <a16:creationId xmlns:a16="http://schemas.microsoft.com/office/drawing/2014/main" id="{E2D73620-BEDB-4B1C-8683-9B37D817A76C}"/>
+                <a16:creationId xmlns:a16="http://schemas.microsoft.com/office/drawing/2014/main" id="{7D6AE49C-59A0-47FE-88D8-CA14A25BF7E9}"/>
               </a:ext>
             </a:extLst>
           </p:cNvPr>
@@ -6786,7 +6786,7 @@
           <p:cNvPr id="23" name="">
             <a:extLst xmlns:a="http://schemas.openxmlformats.org/drawingml/2006/main">
               <a:ext uri="{FF2B5EF4-FFF2-40B4-BE49-F238E27FC236}">
-                <a16:creationId xmlns:a16="http://schemas.microsoft.com/office/drawing/2014/main" id="{C918394C-8C5B-41E9-90D1-86111E30DA6B}"/>
+                <a16:creationId xmlns:a16="http://schemas.microsoft.com/office/drawing/2014/main" id="{F158FCC9-A7FA-480A-912C-B2DBE7A35385}"/>
               </a:ext>
             </a:extLst>
           </p:cNvPr>
@@ -6818,7 +6818,7 @@
           <p:cNvPr id="24" name="">
             <a:extLst xmlns:a="http://schemas.openxmlformats.org/drawingml/2006/main">
               <a:ext uri="{FF2B5EF4-FFF2-40B4-BE49-F238E27FC236}">
-                <a16:creationId xmlns:a16="http://schemas.microsoft.com/office/drawing/2014/main" id="{1814A6B4-270F-4151-9248-6BF577B036CD}"/>
+                <a16:creationId xmlns:a16="http://schemas.microsoft.com/office/drawing/2014/main" id="{4AC8F6B4-6C3F-46E1-B510-EFFAB8706A64}"/>
               </a:ext>
             </a:extLst>
           </p:cNvPr>
@@ -6875,7 +6875,7 @@
           <p:cNvPr id="25" name="">
             <a:extLst xmlns:a="http://schemas.openxmlformats.org/drawingml/2006/main">
               <a:ext uri="{FF2B5EF4-FFF2-40B4-BE49-F238E27FC236}">
-                <a16:creationId xmlns:a16="http://schemas.microsoft.com/office/drawing/2014/main" id="{07486BA9-0D2F-4EB5-935E-96FC0272881D}"/>
+                <a16:creationId xmlns:a16="http://schemas.microsoft.com/office/drawing/2014/main" id="{9AC1E56D-B820-48E2-83AB-6C3BBBC15B3F}"/>
               </a:ext>
             </a:extLst>
           </p:cNvPr>
@@ -6930,7 +6930,7 @@
     </p:spTree>
     <p:extLst>
       <p:ext uri="{BB962C8B-B14F-4D97-AF65-F5344CB8AC3E}">
-        <p14:creationId xmlns:p14="http://schemas.microsoft.com/office/powerpoint/2010/main" val="863634096"/>
+        <p14:creationId xmlns:p14="http://schemas.microsoft.com/office/powerpoint/2010/main" val="1463066256"/>
       </p:ext>
     </p:extLst>
   </p:cSld>
@@ -6954,7 +6954,7 @@
           <p:cNvPr id="11" name="">
             <a:extLst xmlns:a="http://schemas.openxmlformats.org/drawingml/2006/main">
               <a:ext uri="{FF2B5EF4-FFF2-40B4-BE49-F238E27FC236}">
-                <a16:creationId xmlns:a16="http://schemas.microsoft.com/office/drawing/2014/main" id="{33279760-B390-488A-B7E9-D50332061FAF}"/>
+                <a16:creationId xmlns:a16="http://schemas.microsoft.com/office/drawing/2014/main" id="{5ADDA1D3-D28B-4C9A-B8D1-81127A98EEED}"/>
               </a:ext>
             </a:extLst>
           </p:cNvPr>
@@ -6984,7 +6984,7 @@
           <p:cNvPr id="2" name="">
             <a:extLst xmlns:a="http://schemas.openxmlformats.org/drawingml/2006/main">
               <a:ext uri="{FF2B5EF4-FFF2-40B4-BE49-F238E27FC236}">
-                <a16:creationId xmlns:a16="http://schemas.microsoft.com/office/drawing/2014/main" id="{76445375-8A88-4350-A90F-2B2CA10F8030}"/>
+                <a16:creationId xmlns:a16="http://schemas.microsoft.com/office/drawing/2014/main" id="{526460E9-AD2F-44EF-AD4B-472BA7D37F55}"/>
               </a:ext>
             </a:extLst>
           </p:cNvPr>
@@ -7041,7 +7041,7 @@
           <p:cNvPr id="3" name="">
             <a:extLst xmlns:a="http://schemas.openxmlformats.org/drawingml/2006/main">
               <a:ext uri="{FF2B5EF4-FFF2-40B4-BE49-F238E27FC236}">
-                <a16:creationId xmlns:a16="http://schemas.microsoft.com/office/drawing/2014/main" id="{A599CC87-C68D-41B1-9801-E4A44BFB29A3}"/>
+                <a16:creationId xmlns:a16="http://schemas.microsoft.com/office/drawing/2014/main" id="{2E2245CA-48F0-43F3-94AF-D964954B1B38}"/>
               </a:ext>
             </a:extLst>
           </p:cNvPr>
@@ -7071,7 +7071,7 @@
           <p:cNvPr id="4" name="">
             <a:extLst xmlns:a="http://schemas.openxmlformats.org/drawingml/2006/main">
               <a:ext uri="{FF2B5EF4-FFF2-40B4-BE49-F238E27FC236}">
-                <a16:creationId xmlns:a16="http://schemas.microsoft.com/office/drawing/2014/main" id="{BCBCBE3A-B580-4276-A427-E7AE623208F2}"/>
+                <a16:creationId xmlns:a16="http://schemas.microsoft.com/office/drawing/2014/main" id="{4A5CD425-9B51-49D3-8F26-0B4975F62375}"/>
               </a:ext>
             </a:extLst>
           </p:cNvPr>
@@ -7128,7 +7128,7 @@
           <p:cNvPr id="5" name="">
             <a:extLst xmlns:a="http://schemas.openxmlformats.org/drawingml/2006/main">
               <a:ext uri="{FF2B5EF4-FFF2-40B4-BE49-F238E27FC236}">
-                <a16:creationId xmlns:a16="http://schemas.microsoft.com/office/drawing/2014/main" id="{7F04372B-E69E-451A-84F0-8F21C83D5B57}"/>
+                <a16:creationId xmlns:a16="http://schemas.microsoft.com/office/drawing/2014/main" id="{3E6E1E4F-9884-41A4-899A-F977E2549AC0}"/>
               </a:ext>
             </a:extLst>
           </p:cNvPr>
@@ -7185,7 +7185,7 @@
           <p:cNvPr id="6" name="">
             <a:extLst xmlns:a="http://schemas.openxmlformats.org/drawingml/2006/main">
               <a:ext uri="{FF2B5EF4-FFF2-40B4-BE49-F238E27FC236}">
-                <a16:creationId xmlns:a16="http://schemas.microsoft.com/office/drawing/2014/main" id="{7A7215BD-1577-4A16-A1E6-C497889D3C33}"/>
+                <a16:creationId xmlns:a16="http://schemas.microsoft.com/office/drawing/2014/main" id="{229682B5-91D7-4167-9832-E5AD16597A60}"/>
               </a:ext>
             </a:extLst>
           </p:cNvPr>
@@ -7242,7 +7242,7 @@
           <p:cNvPr id="7" name="">
             <a:extLst xmlns:a="http://schemas.openxmlformats.org/drawingml/2006/main">
               <a:ext uri="{FF2B5EF4-FFF2-40B4-BE49-F238E27FC236}">
-                <a16:creationId xmlns:a16="http://schemas.microsoft.com/office/drawing/2014/main" id="{BB619EFA-9B7F-43D0-A2C2-DE42286911D6}"/>
+                <a16:creationId xmlns:a16="http://schemas.microsoft.com/office/drawing/2014/main" id="{6E2C729F-877F-4BCB-BA1A-D705E4034E20}"/>
               </a:ext>
             </a:extLst>
           </p:cNvPr>
@@ -7289,7 +7289,7 @@
                 <a:ea typeface="Arial"/>
                 <a:cs typeface="Arial"/>
               </a:rPr>
-              <a:t>Voice and text access · approved clinical content · clear next action</a:t>
+              <a:t>Fixed Bengali selections · approved clinical content · clear next action</a:t>
             </a:r>
           </a:p>
         </p:txBody>
@@ -7299,7 +7299,7 @@
           <p:cNvPr id="8" name="">
             <a:extLst xmlns:a="http://schemas.openxmlformats.org/drawingml/2006/main">
               <a:ext uri="{FF2B5EF4-FFF2-40B4-BE49-F238E27FC236}">
-                <a16:creationId xmlns:a16="http://schemas.microsoft.com/office/drawing/2014/main" id="{6FED4DD0-BFF1-40AD-B312-D5A501AA5E05}"/>
+                <a16:creationId xmlns:a16="http://schemas.microsoft.com/office/drawing/2014/main" id="{E3C76C89-C177-4713-93B6-0994C98363A6}"/>
               </a:ext>
             </a:extLst>
           </p:cNvPr>
@@ -7329,7 +7329,7 @@
           <p:cNvPr id="9" name="">
             <a:extLst xmlns:a="http://schemas.openxmlformats.org/drawingml/2006/main">
               <a:ext uri="{FF2B5EF4-FFF2-40B4-BE49-F238E27FC236}">
-                <a16:creationId xmlns:a16="http://schemas.microsoft.com/office/drawing/2014/main" id="{D5EDF10E-4D21-4CD3-B527-586A1BC6A839}"/>
+                <a16:creationId xmlns:a16="http://schemas.microsoft.com/office/drawing/2014/main" id="{2E6E03ED-DE67-4210-9AA1-E69B09A4E143}"/>
               </a:ext>
             </a:extLst>
           </p:cNvPr>
@@ -7386,7 +7386,7 @@
           <p:cNvPr id="10" name="">
             <a:extLst xmlns:a="http://schemas.openxmlformats.org/drawingml/2006/main">
               <a:ext uri="{FF2B5EF4-FFF2-40B4-BE49-F238E27FC236}">
-                <a16:creationId xmlns:a16="http://schemas.microsoft.com/office/drawing/2014/main" id="{3D8A0D5E-60A7-462B-8072-1D40BFB1F8BB}"/>
+                <a16:creationId xmlns:a16="http://schemas.microsoft.com/office/drawing/2014/main" id="{0D0D7C25-4297-4C3D-9106-55A3B3920598}"/>
               </a:ext>
             </a:extLst>
           </p:cNvPr>
@@ -7441,7 +7441,7 @@
     </p:spTree>
     <p:extLst>
       <p:ext uri="{BB962C8B-B14F-4D97-AF65-F5344CB8AC3E}">
-        <p14:creationId xmlns:p14="http://schemas.microsoft.com/office/powerpoint/2010/main" val="2139598413"/>
+        <p14:creationId xmlns:p14="http://schemas.microsoft.com/office/powerpoint/2010/main" val="1139470588"/>
       </p:ext>
     </p:extLst>
   </p:cSld>
@@ -8618,7 +8618,7 @@
           <p:cNvPr id="24" name="">
             <a:extLst xmlns:a="http://schemas.openxmlformats.org/drawingml/2006/main">
               <a:ext uri="{FF2B5EF4-FFF2-40B4-BE49-F238E27FC236}">
-                <a16:creationId xmlns:a16="http://schemas.microsoft.com/office/drawing/2014/main" id="{8D85BB84-1C1C-48DD-8AF9-6BF5FA68DE9D}"/>
+                <a16:creationId xmlns:a16="http://schemas.microsoft.com/office/drawing/2014/main" id="{3EAB6764-04B5-4122-875B-13EC11AEB76C}"/>
               </a:ext>
             </a:extLst>
           </p:cNvPr>
@@ -8648,7 +8648,7 @@
           <p:cNvPr id="25" name="">
             <a:extLst xmlns:a="http://schemas.openxmlformats.org/drawingml/2006/main">
               <a:ext uri="{FF2B5EF4-FFF2-40B4-BE49-F238E27FC236}">
-                <a16:creationId xmlns:a16="http://schemas.microsoft.com/office/drawing/2014/main" id="{A60B646C-0FB1-4E91-8443-4E023C80B1B5}"/>
+                <a16:creationId xmlns:a16="http://schemas.microsoft.com/office/drawing/2014/main" id="{9BACBC0C-E111-4211-8E00-731F8C140940}"/>
               </a:ext>
             </a:extLst>
           </p:cNvPr>
@@ -8705,7 +8705,7 @@
           <p:cNvPr id="26" name="">
             <a:extLst xmlns:a="http://schemas.openxmlformats.org/drawingml/2006/main">
               <a:ext uri="{FF2B5EF4-FFF2-40B4-BE49-F238E27FC236}">
-                <a16:creationId xmlns:a16="http://schemas.microsoft.com/office/drawing/2014/main" id="{9C03CE6D-A554-4FFD-A38F-8610CFEA3344}"/>
+                <a16:creationId xmlns:a16="http://schemas.microsoft.com/office/drawing/2014/main" id="{CEF1BA06-4FE7-4FD0-963D-812FFA99F17A}"/>
               </a:ext>
             </a:extLst>
           </p:cNvPr>
@@ -8762,7 +8762,7 @@
           <p:cNvPr id="27" name="">
             <a:extLst xmlns:a="http://schemas.openxmlformats.org/drawingml/2006/main">
               <a:ext uri="{FF2B5EF4-FFF2-40B4-BE49-F238E27FC236}">
-                <a16:creationId xmlns:a16="http://schemas.microsoft.com/office/drawing/2014/main" id="{CC08DA37-D4CB-4CD9-82DF-E51ECE7FD2C9}"/>
+                <a16:creationId xmlns:a16="http://schemas.microsoft.com/office/drawing/2014/main" id="{38A9455C-C93D-434E-9D7C-89884D61328D}"/>
               </a:ext>
             </a:extLst>
           </p:cNvPr>
@@ -8819,7 +8819,7 @@
           <p:cNvPr id="28" name="">
             <a:extLst xmlns:a="http://schemas.openxmlformats.org/drawingml/2006/main">
               <a:ext uri="{FF2B5EF4-FFF2-40B4-BE49-F238E27FC236}">
-                <a16:creationId xmlns:a16="http://schemas.microsoft.com/office/drawing/2014/main" id="{77543633-B5C5-4081-8948-9F5B1C4E725C}"/>
+                <a16:creationId xmlns:a16="http://schemas.microsoft.com/office/drawing/2014/main" id="{7B6B016A-8F1A-4956-B098-3E5D001DCF1F}"/>
               </a:ext>
             </a:extLst>
           </p:cNvPr>
@@ -8876,7 +8876,7 @@
           <p:cNvPr id="29" name="">
             <a:extLst xmlns:a="http://schemas.openxmlformats.org/drawingml/2006/main">
               <a:ext uri="{FF2B5EF4-FFF2-40B4-BE49-F238E27FC236}">
-                <a16:creationId xmlns:a16="http://schemas.microsoft.com/office/drawing/2014/main" id="{94BBEF13-56C7-45A5-AF87-0B167B50CC6B}"/>
+                <a16:creationId xmlns:a16="http://schemas.microsoft.com/office/drawing/2014/main" id="{A251AE8B-9272-441A-BDCE-506C9B680E36}"/>
               </a:ext>
             </a:extLst>
           </p:cNvPr>
@@ -8906,7 +8906,7 @@
           <p:cNvPr id="30" name="">
             <a:extLst xmlns:a="http://schemas.openxmlformats.org/drawingml/2006/main">
               <a:ext uri="{FF2B5EF4-FFF2-40B4-BE49-F238E27FC236}">
-                <a16:creationId xmlns:a16="http://schemas.microsoft.com/office/drawing/2014/main" id="{A1416715-A47E-4A18-A5BF-FEC2019F0091}"/>
+                <a16:creationId xmlns:a16="http://schemas.microsoft.com/office/drawing/2014/main" id="{C1376710-5CEA-4D98-82E8-749E6DD65A13}"/>
               </a:ext>
             </a:extLst>
           </p:cNvPr>
@@ -8963,7 +8963,7 @@
           <p:cNvPr id="31" name="">
             <a:extLst xmlns:a="http://schemas.openxmlformats.org/drawingml/2006/main">
               <a:ext uri="{FF2B5EF4-FFF2-40B4-BE49-F238E27FC236}">
-                <a16:creationId xmlns:a16="http://schemas.microsoft.com/office/drawing/2014/main" id="{DDBA980C-2F61-4993-9965-462218B14DA6}"/>
+                <a16:creationId xmlns:a16="http://schemas.microsoft.com/office/drawing/2014/main" id="{0600D846-2CEC-40DB-84A4-36B9BD442DB2}"/>
               </a:ext>
             </a:extLst>
           </p:cNvPr>
@@ -9043,7 +9043,7 @@
           <p:cNvPr id="32" name="">
             <a:extLst xmlns:a="http://schemas.openxmlformats.org/drawingml/2006/main">
               <a:ext uri="{FF2B5EF4-FFF2-40B4-BE49-F238E27FC236}">
-                <a16:creationId xmlns:a16="http://schemas.microsoft.com/office/drawing/2014/main" id="{BB48A905-AB85-40D0-95B4-1FB5EBBE37F6}"/>
+                <a16:creationId xmlns:a16="http://schemas.microsoft.com/office/drawing/2014/main" id="{599952C2-D74B-42D4-8CDB-81F53EAC6917}"/>
               </a:ext>
             </a:extLst>
           </p:cNvPr>
@@ -9100,7 +9100,7 @@
           <p:cNvPr id="33" name="">
             <a:extLst xmlns:a="http://schemas.openxmlformats.org/drawingml/2006/main">
               <a:ext uri="{FF2B5EF4-FFF2-40B4-BE49-F238E27FC236}">
-                <a16:creationId xmlns:a16="http://schemas.microsoft.com/office/drawing/2014/main" id="{171EED52-F918-4547-B3A8-328CB6272780}"/>
+                <a16:creationId xmlns:a16="http://schemas.microsoft.com/office/drawing/2014/main" id="{C10B35E9-7798-4BD8-97FD-660951865D4D}"/>
               </a:ext>
             </a:extLst>
           </p:cNvPr>
@@ -9130,7 +9130,7 @@
           <p:cNvPr id="34" name="">
             <a:extLst xmlns:a="http://schemas.openxmlformats.org/drawingml/2006/main">
               <a:ext uri="{FF2B5EF4-FFF2-40B4-BE49-F238E27FC236}">
-                <a16:creationId xmlns:a16="http://schemas.microsoft.com/office/drawing/2014/main" id="{9D91DA50-59A9-4980-A637-1796077D70B7}"/>
+                <a16:creationId xmlns:a16="http://schemas.microsoft.com/office/drawing/2014/main" id="{7D99DB74-AE95-4DE9-AF7B-31BCF55026CD}"/>
               </a:ext>
             </a:extLst>
           </p:cNvPr>
@@ -9160,7 +9160,7 @@
           <p:cNvPr id="35" name="">
             <a:extLst xmlns:a="http://schemas.openxmlformats.org/drawingml/2006/main">
               <a:ext uri="{FF2B5EF4-FFF2-40B4-BE49-F238E27FC236}">
-                <a16:creationId xmlns:a16="http://schemas.microsoft.com/office/drawing/2014/main" id="{BC50F81E-19B3-47F1-85EF-29A576F7B216}"/>
+                <a16:creationId xmlns:a16="http://schemas.microsoft.com/office/drawing/2014/main" id="{47BE0796-C284-41DA-9B0D-3C1243300A6E}"/>
               </a:ext>
             </a:extLst>
           </p:cNvPr>
@@ -9217,7 +9217,7 @@
           <p:cNvPr id="36" name="">
             <a:extLst xmlns:a="http://schemas.openxmlformats.org/drawingml/2006/main">
               <a:ext uri="{FF2B5EF4-FFF2-40B4-BE49-F238E27FC236}">
-                <a16:creationId xmlns:a16="http://schemas.microsoft.com/office/drawing/2014/main" id="{B3331B13-DCF7-42D6-8DA2-DDC3EE4AF319}"/>
+                <a16:creationId xmlns:a16="http://schemas.microsoft.com/office/drawing/2014/main" id="{E88C1010-F2BA-4C1B-B37A-0F0503EE355B}"/>
               </a:ext>
             </a:extLst>
           </p:cNvPr>
@@ -9274,7 +9274,7 @@
           <p:cNvPr id="37" name="">
             <a:extLst xmlns:a="http://schemas.openxmlformats.org/drawingml/2006/main">
               <a:ext uri="{FF2B5EF4-FFF2-40B4-BE49-F238E27FC236}">
-                <a16:creationId xmlns:a16="http://schemas.microsoft.com/office/drawing/2014/main" id="{403A5069-9CBE-4C05-AF33-47A1C2487550}"/>
+                <a16:creationId xmlns:a16="http://schemas.microsoft.com/office/drawing/2014/main" id="{6132D8CA-E88D-4B89-88C2-2191852797AD}"/>
               </a:ext>
             </a:extLst>
           </p:cNvPr>
@@ -9331,7 +9331,7 @@
           <p:cNvPr id="38" name="">
             <a:extLst xmlns:a="http://schemas.openxmlformats.org/drawingml/2006/main">
               <a:ext uri="{FF2B5EF4-FFF2-40B4-BE49-F238E27FC236}">
-                <a16:creationId xmlns:a16="http://schemas.microsoft.com/office/drawing/2014/main" id="{4D7A409B-0845-434D-8AE1-E552D528798E}"/>
+                <a16:creationId xmlns:a16="http://schemas.microsoft.com/office/drawing/2014/main" id="{94F83D33-C10D-4766-868D-270BDD7112D5}"/>
               </a:ext>
             </a:extLst>
           </p:cNvPr>
@@ -9361,7 +9361,7 @@
           <p:cNvPr id="39" name="">
             <a:extLst xmlns:a="http://schemas.openxmlformats.org/drawingml/2006/main">
               <a:ext uri="{FF2B5EF4-FFF2-40B4-BE49-F238E27FC236}">
-                <a16:creationId xmlns:a16="http://schemas.microsoft.com/office/drawing/2014/main" id="{65D0BC3B-443F-4F86-9872-0D1FB8C78752}"/>
+                <a16:creationId xmlns:a16="http://schemas.microsoft.com/office/drawing/2014/main" id="{26645ACE-4332-4794-A6BE-DA933CA11F83}"/>
               </a:ext>
             </a:extLst>
           </p:cNvPr>
@@ -9418,7 +9418,7 @@
           <p:cNvPr id="40" name="">
             <a:extLst xmlns:a="http://schemas.openxmlformats.org/drawingml/2006/main">
               <a:ext uri="{FF2B5EF4-FFF2-40B4-BE49-F238E27FC236}">
-                <a16:creationId xmlns:a16="http://schemas.microsoft.com/office/drawing/2014/main" id="{85A6EF2B-7AF2-4786-83A3-4820C80E1C07}"/>
+                <a16:creationId xmlns:a16="http://schemas.microsoft.com/office/drawing/2014/main" id="{407874D0-92E0-4B3F-A6BC-3835D7B60A4C}"/>
               </a:ext>
             </a:extLst>
           </p:cNvPr>
@@ -9475,7 +9475,7 @@
           <p:cNvPr id="41" name="">
             <a:extLst xmlns:a="http://schemas.openxmlformats.org/drawingml/2006/main">
               <a:ext uri="{FF2B5EF4-FFF2-40B4-BE49-F238E27FC236}">
-                <a16:creationId xmlns:a16="http://schemas.microsoft.com/office/drawing/2014/main" id="{2A879C0F-E071-47EF-96F8-3C111BFE54CB}"/>
+                <a16:creationId xmlns:a16="http://schemas.microsoft.com/office/drawing/2014/main" id="{FB2656AA-C234-4DFC-9821-76C912C7528D}"/>
               </a:ext>
             </a:extLst>
           </p:cNvPr>
@@ -9532,7 +9532,7 @@
           <p:cNvPr id="42" name="">
             <a:extLst xmlns:a="http://schemas.openxmlformats.org/drawingml/2006/main">
               <a:ext uri="{FF2B5EF4-FFF2-40B4-BE49-F238E27FC236}">
-                <a16:creationId xmlns:a16="http://schemas.microsoft.com/office/drawing/2014/main" id="{D031A442-CB90-46A3-89D8-265BA3AF8403}"/>
+                <a16:creationId xmlns:a16="http://schemas.microsoft.com/office/drawing/2014/main" id="{779FE83E-1AB9-4BC7-812E-D20E411EDA3A}"/>
               </a:ext>
             </a:extLst>
           </p:cNvPr>
@@ -9562,7 +9562,7 @@
           <p:cNvPr id="43" name="">
             <a:extLst xmlns:a="http://schemas.openxmlformats.org/drawingml/2006/main">
               <a:ext uri="{FF2B5EF4-FFF2-40B4-BE49-F238E27FC236}">
-                <a16:creationId xmlns:a16="http://schemas.microsoft.com/office/drawing/2014/main" id="{B9676435-6B17-45C8-AD22-CAC78FEAF51F}"/>
+                <a16:creationId xmlns:a16="http://schemas.microsoft.com/office/drawing/2014/main" id="{64928274-04A3-449B-8ADE-F1FB0C5AB920}"/>
               </a:ext>
             </a:extLst>
           </p:cNvPr>
@@ -9619,7 +9619,7 @@
           <p:cNvPr id="44" name="">
             <a:extLst xmlns:a="http://schemas.openxmlformats.org/drawingml/2006/main">
               <a:ext uri="{FF2B5EF4-FFF2-40B4-BE49-F238E27FC236}">
-                <a16:creationId xmlns:a16="http://schemas.microsoft.com/office/drawing/2014/main" id="{2AAB7ECB-F1A9-4D01-A297-D6F13A8C0BF9}"/>
+                <a16:creationId xmlns:a16="http://schemas.microsoft.com/office/drawing/2014/main" id="{167225F4-1A3E-4A15-B3A2-A7E5FB8E04C0}"/>
               </a:ext>
             </a:extLst>
           </p:cNvPr>
@@ -9676,7 +9676,7 @@
           <p:cNvPr id="45" name="">
             <a:extLst xmlns:a="http://schemas.openxmlformats.org/drawingml/2006/main">
               <a:ext uri="{FF2B5EF4-FFF2-40B4-BE49-F238E27FC236}">
-                <a16:creationId xmlns:a16="http://schemas.microsoft.com/office/drawing/2014/main" id="{3CBA472B-8D97-4A15-978E-113BBC27B06B}"/>
+                <a16:creationId xmlns:a16="http://schemas.microsoft.com/office/drawing/2014/main" id="{915B29EF-2E6B-47F1-8552-1A7E9B80CC62}"/>
               </a:ext>
             </a:extLst>
           </p:cNvPr>
@@ -9733,7 +9733,7 @@
           <p:cNvPr id="46" name="">
             <a:extLst xmlns:a="http://schemas.openxmlformats.org/drawingml/2006/main">
               <a:ext uri="{FF2B5EF4-FFF2-40B4-BE49-F238E27FC236}">
-                <a16:creationId xmlns:a16="http://schemas.microsoft.com/office/drawing/2014/main" id="{53320DA8-1EFC-406B-B6C1-F88F77F20039}"/>
+                <a16:creationId xmlns:a16="http://schemas.microsoft.com/office/drawing/2014/main" id="{66297210-DF81-4FDE-BA90-06E5BB2FDBFF}"/>
               </a:ext>
             </a:extLst>
           </p:cNvPr>
@@ -9765,7 +9765,7 @@
           <p:cNvPr id="47" name="">
             <a:extLst xmlns:a="http://schemas.openxmlformats.org/drawingml/2006/main">
               <a:ext uri="{FF2B5EF4-FFF2-40B4-BE49-F238E27FC236}">
-                <a16:creationId xmlns:a16="http://schemas.microsoft.com/office/drawing/2014/main" id="{092A23C4-D89C-48EB-93FE-4B395618E26C}"/>
+                <a16:creationId xmlns:a16="http://schemas.microsoft.com/office/drawing/2014/main" id="{F0CA141A-FF61-49AC-A48A-3B5C712CA383}"/>
               </a:ext>
             </a:extLst>
           </p:cNvPr>
@@ -9822,7 +9822,7 @@
           <p:cNvPr id="48" name="">
             <a:extLst xmlns:a="http://schemas.openxmlformats.org/drawingml/2006/main">
               <a:ext uri="{FF2B5EF4-FFF2-40B4-BE49-F238E27FC236}">
-                <a16:creationId xmlns:a16="http://schemas.microsoft.com/office/drawing/2014/main" id="{CCB46666-E96A-4D44-98DB-9E4448AC60C9}"/>
+                <a16:creationId xmlns:a16="http://schemas.microsoft.com/office/drawing/2014/main" id="{05B9DDCF-75C2-42E2-880A-9F4075CE4551}"/>
               </a:ext>
             </a:extLst>
           </p:cNvPr>
@@ -11420,7 +11420,7 @@
           <p:cNvPr id="29" name="">
             <a:extLst xmlns:a="http://schemas.openxmlformats.org/drawingml/2006/main">
               <a:ext uri="{FF2B5EF4-FFF2-40B4-BE49-F238E27FC236}">
-                <a16:creationId xmlns:a16="http://schemas.microsoft.com/office/drawing/2014/main" id="{83B1E89E-CD29-41A0-91B0-2DBE02268B6F}"/>
+                <a16:creationId xmlns:a16="http://schemas.microsoft.com/office/drawing/2014/main" id="{A14A3A0C-6D2E-4C79-8ED4-31B65EEFAC2A}"/>
               </a:ext>
             </a:extLst>
           </p:cNvPr>
@@ -11450,7 +11450,7 @@
           <p:cNvPr id="30" name="">
             <a:extLst xmlns:a="http://schemas.openxmlformats.org/drawingml/2006/main">
               <a:ext uri="{FF2B5EF4-FFF2-40B4-BE49-F238E27FC236}">
-                <a16:creationId xmlns:a16="http://schemas.microsoft.com/office/drawing/2014/main" id="{D7F704E7-CEFB-4D75-AC2E-04E67637378D}"/>
+                <a16:creationId xmlns:a16="http://schemas.microsoft.com/office/drawing/2014/main" id="{5216B448-F0A2-415B-913B-44058DAEE9A0}"/>
               </a:ext>
             </a:extLst>
           </p:cNvPr>
@@ -11507,7 +11507,7 @@
           <p:cNvPr id="31" name="">
             <a:extLst xmlns:a="http://schemas.openxmlformats.org/drawingml/2006/main">
               <a:ext uri="{FF2B5EF4-FFF2-40B4-BE49-F238E27FC236}">
-                <a16:creationId xmlns:a16="http://schemas.microsoft.com/office/drawing/2014/main" id="{6D3CEF02-D8BA-4B25-99AE-07167BC4FEAE}"/>
+                <a16:creationId xmlns:a16="http://schemas.microsoft.com/office/drawing/2014/main" id="{205A2551-5C04-46B7-8270-DB995817737E}"/>
               </a:ext>
             </a:extLst>
           </p:cNvPr>
@@ -11564,7 +11564,7 @@
           <p:cNvPr id="32" name="">
             <a:extLst xmlns:a="http://schemas.openxmlformats.org/drawingml/2006/main">
               <a:ext uri="{FF2B5EF4-FFF2-40B4-BE49-F238E27FC236}">
-                <a16:creationId xmlns:a16="http://schemas.microsoft.com/office/drawing/2014/main" id="{DED72694-6430-4840-B2B9-B262090846E1}"/>
+                <a16:creationId xmlns:a16="http://schemas.microsoft.com/office/drawing/2014/main" id="{9AB0113C-11DD-49A8-9545-E250271AECA1}"/>
               </a:ext>
             </a:extLst>
           </p:cNvPr>
@@ -11621,7 +11621,7 @@
           <p:cNvPr id="33" name="">
             <a:extLst xmlns:a="http://schemas.openxmlformats.org/drawingml/2006/main">
               <a:ext uri="{FF2B5EF4-FFF2-40B4-BE49-F238E27FC236}">
-                <a16:creationId xmlns:a16="http://schemas.microsoft.com/office/drawing/2014/main" id="{00929C0A-836A-4730-A0EE-A3435A5CB8E5}"/>
+                <a16:creationId xmlns:a16="http://schemas.microsoft.com/office/drawing/2014/main" id="{9CA4CDF0-9BF8-4A36-BFD3-CECDDA0C6F5F}"/>
               </a:ext>
             </a:extLst>
           </p:cNvPr>
@@ -11678,7 +11678,7 @@
           <p:cNvPr id="34" name="">
             <a:extLst xmlns:a="http://schemas.openxmlformats.org/drawingml/2006/main">
               <a:ext uri="{FF2B5EF4-FFF2-40B4-BE49-F238E27FC236}">
-                <a16:creationId xmlns:a16="http://schemas.microsoft.com/office/drawing/2014/main" id="{EF0210E1-0951-4854-B7D8-06A3578840D7}"/>
+                <a16:creationId xmlns:a16="http://schemas.microsoft.com/office/drawing/2014/main" id="{CD0B0DEB-C526-498A-A6D3-A4CD05E50B9B}"/>
               </a:ext>
             </a:extLst>
           </p:cNvPr>
@@ -11708,7 +11708,7 @@
           <p:cNvPr id="35" name="">
             <a:extLst xmlns:a="http://schemas.openxmlformats.org/drawingml/2006/main">
               <a:ext uri="{FF2B5EF4-FFF2-40B4-BE49-F238E27FC236}">
-                <a16:creationId xmlns:a16="http://schemas.microsoft.com/office/drawing/2014/main" id="{4092867C-328C-4B59-A9D8-CABABD4B622E}"/>
+                <a16:creationId xmlns:a16="http://schemas.microsoft.com/office/drawing/2014/main" id="{589D1668-AD2E-488B-843E-2BAD29F0ECC6}"/>
               </a:ext>
             </a:extLst>
           </p:cNvPr>
@@ -11765,7 +11765,7 @@
           <p:cNvPr id="36" name="">
             <a:extLst xmlns:a="http://schemas.openxmlformats.org/drawingml/2006/main">
               <a:ext uri="{FF2B5EF4-FFF2-40B4-BE49-F238E27FC236}">
-                <a16:creationId xmlns:a16="http://schemas.microsoft.com/office/drawing/2014/main" id="{1F91E083-3B1A-415B-9665-881AA30ACFEA}"/>
+                <a16:creationId xmlns:a16="http://schemas.microsoft.com/office/drawing/2014/main" id="{556556F1-5ADD-44E1-A82B-8A5E80482FA3}"/>
               </a:ext>
             </a:extLst>
           </p:cNvPr>
@@ -11797,7 +11797,7 @@
           <p:cNvPr id="37" name="">
             <a:extLst xmlns:a="http://schemas.openxmlformats.org/drawingml/2006/main">
               <a:ext uri="{FF2B5EF4-FFF2-40B4-BE49-F238E27FC236}">
-                <a16:creationId xmlns:a16="http://schemas.microsoft.com/office/drawing/2014/main" id="{C063A936-5116-434B-AF0E-FCE225CC2E81}"/>
+                <a16:creationId xmlns:a16="http://schemas.microsoft.com/office/drawing/2014/main" id="{DA7F8BA5-1888-4DF9-9C94-4C3CDD201DCF}"/>
               </a:ext>
             </a:extLst>
           </p:cNvPr>
@@ -11854,7 +11854,7 @@
           <p:cNvPr id="38" name="">
             <a:extLst xmlns:a="http://schemas.openxmlformats.org/drawingml/2006/main">
               <a:ext uri="{FF2B5EF4-FFF2-40B4-BE49-F238E27FC236}">
-                <a16:creationId xmlns:a16="http://schemas.microsoft.com/office/drawing/2014/main" id="{CA5EAC38-B612-405C-990C-D0C3EFFF881D}"/>
+                <a16:creationId xmlns:a16="http://schemas.microsoft.com/office/drawing/2014/main" id="{BEBFC636-EF4B-46B4-92DF-6C67BF021C63}"/>
               </a:ext>
             </a:extLst>
           </p:cNvPr>
@@ -11901,7 +11901,7 @@
                 <a:ea typeface="Arial"/>
                 <a:cs typeface="Arial"/>
               </a:rPr>
-              <a:t>Fixed voice or text input</a:t>
+              <a:t>Fixed symptom selections</a:t>
             </a:r>
           </a:p>
         </p:txBody>
@@ -11911,7 +11911,7 @@
           <p:cNvPr id="39" name="">
             <a:extLst xmlns:a="http://schemas.openxmlformats.org/drawingml/2006/main">
               <a:ext uri="{FF2B5EF4-FFF2-40B4-BE49-F238E27FC236}">
-                <a16:creationId xmlns:a16="http://schemas.microsoft.com/office/drawing/2014/main" id="{5019003D-58BD-420D-8251-B12BBA6249A5}"/>
+                <a16:creationId xmlns:a16="http://schemas.microsoft.com/office/drawing/2014/main" id="{D23B9221-E2EA-459A-B8CE-B6C65C7DBF2A}"/>
               </a:ext>
             </a:extLst>
           </p:cNvPr>
@@ -11941,7 +11941,7 @@
           <p:cNvPr id="40" name="">
             <a:extLst xmlns:a="http://schemas.openxmlformats.org/drawingml/2006/main">
               <a:ext uri="{FF2B5EF4-FFF2-40B4-BE49-F238E27FC236}">
-                <a16:creationId xmlns:a16="http://schemas.microsoft.com/office/drawing/2014/main" id="{C652051E-9238-47FD-8FAE-05E71D5D81CD}"/>
+                <a16:creationId xmlns:a16="http://schemas.microsoft.com/office/drawing/2014/main" id="{BECF3084-4730-472F-A87E-E5B387593130}"/>
               </a:ext>
             </a:extLst>
           </p:cNvPr>
@@ -11973,7 +11973,7 @@
           <p:cNvPr id="41" name="">
             <a:extLst xmlns:a="http://schemas.openxmlformats.org/drawingml/2006/main">
               <a:ext uri="{FF2B5EF4-FFF2-40B4-BE49-F238E27FC236}">
-                <a16:creationId xmlns:a16="http://schemas.microsoft.com/office/drawing/2014/main" id="{B34E1AFA-6FD2-4B88-BF18-E9EDEF5FBE34}"/>
+                <a16:creationId xmlns:a16="http://schemas.microsoft.com/office/drawing/2014/main" id="{991FD7F9-2CD2-4C07-8FD6-F406766FA41D}"/>
               </a:ext>
             </a:extLst>
           </p:cNvPr>
@@ -12053,7 +12053,7 @@
           <p:cNvPr id="42" name="">
             <a:extLst xmlns:a="http://schemas.openxmlformats.org/drawingml/2006/main">
               <a:ext uri="{FF2B5EF4-FFF2-40B4-BE49-F238E27FC236}">
-                <a16:creationId xmlns:a16="http://schemas.microsoft.com/office/drawing/2014/main" id="{3CFFDAF4-6250-4012-9219-0651A90A0308}"/>
+                <a16:creationId xmlns:a16="http://schemas.microsoft.com/office/drawing/2014/main" id="{5C492D52-C5F9-4F48-A466-8A5B67EAF3F2}"/>
               </a:ext>
             </a:extLst>
           </p:cNvPr>
@@ -12110,7 +12110,7 @@
           <p:cNvPr id="43" name="">
             <a:extLst xmlns:a="http://schemas.openxmlformats.org/drawingml/2006/main">
               <a:ext uri="{FF2B5EF4-FFF2-40B4-BE49-F238E27FC236}">
-                <a16:creationId xmlns:a16="http://schemas.microsoft.com/office/drawing/2014/main" id="{A7483D9A-F24A-4F0A-A130-7144D3F3F365}"/>
+                <a16:creationId xmlns:a16="http://schemas.microsoft.com/office/drawing/2014/main" id="{A2928540-C6AB-49EA-B548-2CA1B04277E9}"/>
               </a:ext>
             </a:extLst>
           </p:cNvPr>
@@ -12140,7 +12140,7 @@
           <p:cNvPr id="44" name="">
             <a:extLst xmlns:a="http://schemas.openxmlformats.org/drawingml/2006/main">
               <a:ext uri="{FF2B5EF4-FFF2-40B4-BE49-F238E27FC236}">
-                <a16:creationId xmlns:a16="http://schemas.microsoft.com/office/drawing/2014/main" id="{25574400-EB29-490A-8DF9-A2C7A41B216B}"/>
+                <a16:creationId xmlns:a16="http://schemas.microsoft.com/office/drawing/2014/main" id="{FFA0BFB9-2B41-4351-91A5-D5BD4D53E1BE}"/>
               </a:ext>
             </a:extLst>
           </p:cNvPr>
@@ -12172,7 +12172,7 @@
           <p:cNvPr id="45" name="">
             <a:extLst xmlns:a="http://schemas.openxmlformats.org/drawingml/2006/main">
               <a:ext uri="{FF2B5EF4-FFF2-40B4-BE49-F238E27FC236}">
-                <a16:creationId xmlns:a16="http://schemas.microsoft.com/office/drawing/2014/main" id="{1EEFD2D4-27D2-46BE-98E7-7A87FDE68246}"/>
+                <a16:creationId xmlns:a16="http://schemas.microsoft.com/office/drawing/2014/main" id="{E1DD059E-6BA8-46CC-8A96-FC64ABFC4955}"/>
               </a:ext>
             </a:extLst>
           </p:cNvPr>
@@ -12229,7 +12229,7 @@
           <p:cNvPr id="46" name="">
             <a:extLst xmlns:a="http://schemas.openxmlformats.org/drawingml/2006/main">
               <a:ext uri="{FF2B5EF4-FFF2-40B4-BE49-F238E27FC236}">
-                <a16:creationId xmlns:a16="http://schemas.microsoft.com/office/drawing/2014/main" id="{8428BCC8-85FA-4337-AFE8-F78C8C51B979}"/>
+                <a16:creationId xmlns:a16="http://schemas.microsoft.com/office/drawing/2014/main" id="{DF7A856E-73E4-4F9E-9EAC-B0D4F0EC8207}"/>
               </a:ext>
             </a:extLst>
           </p:cNvPr>
@@ -12286,7 +12286,7 @@
           <p:cNvPr id="47" name="">
             <a:extLst xmlns:a="http://schemas.openxmlformats.org/drawingml/2006/main">
               <a:ext uri="{FF2B5EF4-FFF2-40B4-BE49-F238E27FC236}">
-                <a16:creationId xmlns:a16="http://schemas.microsoft.com/office/drawing/2014/main" id="{BA670724-3D79-42AB-8620-E197B34E98DD}"/>
+                <a16:creationId xmlns:a16="http://schemas.microsoft.com/office/drawing/2014/main" id="{EB0A8314-3C7A-410D-8E10-DE5D20980EEF}"/>
               </a:ext>
             </a:extLst>
           </p:cNvPr>
@@ -12316,7 +12316,7 @@
           <p:cNvPr id="48" name="">
             <a:extLst xmlns:a="http://schemas.openxmlformats.org/drawingml/2006/main">
               <a:ext uri="{FF2B5EF4-FFF2-40B4-BE49-F238E27FC236}">
-                <a16:creationId xmlns:a16="http://schemas.microsoft.com/office/drawing/2014/main" id="{158A0721-8F7F-483B-BA4C-078FD9489AEA}"/>
+                <a16:creationId xmlns:a16="http://schemas.microsoft.com/office/drawing/2014/main" id="{03E2D8C4-D89F-4083-A6B6-807DA133D897}"/>
               </a:ext>
             </a:extLst>
           </p:cNvPr>
@@ -12348,7 +12348,7 @@
           <p:cNvPr id="49" name="">
             <a:extLst xmlns:a="http://schemas.openxmlformats.org/drawingml/2006/main">
               <a:ext uri="{FF2B5EF4-FFF2-40B4-BE49-F238E27FC236}">
-                <a16:creationId xmlns:a16="http://schemas.microsoft.com/office/drawing/2014/main" id="{61CF34A7-8AA0-4770-9401-0615D075D50C}"/>
+                <a16:creationId xmlns:a16="http://schemas.microsoft.com/office/drawing/2014/main" id="{14374A33-C257-4568-B464-EA2A48D9DE07}"/>
               </a:ext>
             </a:extLst>
           </p:cNvPr>
@@ -12405,7 +12405,7 @@
           <p:cNvPr id="50" name="">
             <a:extLst xmlns:a="http://schemas.openxmlformats.org/drawingml/2006/main">
               <a:ext uri="{FF2B5EF4-FFF2-40B4-BE49-F238E27FC236}">
-                <a16:creationId xmlns:a16="http://schemas.microsoft.com/office/drawing/2014/main" id="{17146716-4BED-47C7-87A3-6CA2F46F558D}"/>
+                <a16:creationId xmlns:a16="http://schemas.microsoft.com/office/drawing/2014/main" id="{5C0B88BC-83FA-46E1-9810-10F11DF5AE5E}"/>
               </a:ext>
             </a:extLst>
           </p:cNvPr>
@@ -12462,7 +12462,7 @@
           <p:cNvPr id="51" name="">
             <a:extLst xmlns:a="http://schemas.openxmlformats.org/drawingml/2006/main">
               <a:ext uri="{FF2B5EF4-FFF2-40B4-BE49-F238E27FC236}">
-                <a16:creationId xmlns:a16="http://schemas.microsoft.com/office/drawing/2014/main" id="{F843CD03-563D-43C2-8158-18476BA215A3}"/>
+                <a16:creationId xmlns:a16="http://schemas.microsoft.com/office/drawing/2014/main" id="{FA31637F-9DE0-4A85-A45B-257CF9D4CEF7}"/>
               </a:ext>
             </a:extLst>
           </p:cNvPr>
@@ -12494,7 +12494,7 @@
           <p:cNvPr id="52" name="">
             <a:extLst xmlns:a="http://schemas.openxmlformats.org/drawingml/2006/main">
               <a:ext uri="{FF2B5EF4-FFF2-40B4-BE49-F238E27FC236}">
-                <a16:creationId xmlns:a16="http://schemas.microsoft.com/office/drawing/2014/main" id="{37F2C559-B056-41EA-B2FD-BEEEFA19F480}"/>
+                <a16:creationId xmlns:a16="http://schemas.microsoft.com/office/drawing/2014/main" id="{3A8A35CE-0A38-48C5-8FBF-E5E9FF3B5CE2}"/>
               </a:ext>
             </a:extLst>
           </p:cNvPr>
@@ -12551,7 +12551,64 @@
           <p:cNvPr id="53" name="">
             <a:extLst xmlns:a="http://schemas.openxmlformats.org/drawingml/2006/main">
               <a:ext uri="{FF2B5EF4-FFF2-40B4-BE49-F238E27FC236}">
-                <a16:creationId xmlns:a16="http://schemas.microsoft.com/office/drawing/2014/main" id="{34EE8E1E-F950-4B0B-8121-69A60195F911}"/>
+                <a16:creationId xmlns:a16="http://schemas.microsoft.com/office/drawing/2014/main" id="{155D5982-10C9-4DC2-9748-B3F4E90CF30D}"/>
+              </a:ext>
+            </a:extLst>
+          </p:cNvPr>
+          <p:cNvSpPr>
+            <a:spLocks xmlns:a="http://schemas.openxmlformats.org/drawingml/2006/main" noGrp="1"/>
+          </p:cNvSpPr>
+          <p:nvPr/>
+        </p:nvSpPr>
+        <p:spPr>
+          <a:xfrm xmlns:a="http://schemas.openxmlformats.org/drawingml/2006/main">
+            <a:off x="1466850" y="4133850"/>
+            <a:ext cx="8572500" cy="152400"/>
+          </a:xfrm>
+          <a:prstGeom xmlns:a="http://schemas.openxmlformats.org/drawingml/2006/main" prst="rect">
+            <a:avLst/>
+          </a:prstGeom>
+          <a:noFill xmlns:a="http://schemas.openxmlformats.org/drawingml/2006/main"/>
+          <a:ln xmlns:a="http://schemas.openxmlformats.org/drawingml/2006/main" w="0">
+            <a:noFill/>
+          </a:ln>
+        </p:spPr>
+        <p:txBody>
+          <a:bodyPr xmlns:a="http://schemas.openxmlformats.org/drawingml/2006/main">
+            <a:noAutofit/>
+          </a:bodyPr>
+          <a:lstStyle xmlns:a="http://schemas.openxmlformats.org/drawingml/2006/main"/>
+          <a:p xmlns:a="http://schemas.openxmlformats.org/drawingml/2006/main">
+            <a:pPr algn="ctr">
+              <a:defRPr sz="900">
+                <a:solidFill>
+                  <a:srgbClr val="DCE4F3"/>
+                </a:solidFill>
+                <a:latin typeface="Arial"/>
+                <a:ea typeface="Arial"/>
+                <a:cs typeface="Arial"/>
+              </a:defRPr>
+            </a:pPr>
+            <a:r>
+              <a:rPr sz="900">
+                <a:solidFill>
+                  <a:srgbClr val="DCE4F3"/>
+                </a:solidFill>
+                <a:latin typeface="Arial"/>
+                <a:ea typeface="Arial"/>
+                <a:cs typeface="Arial"/>
+              </a:rPr>
+              <a:t>Optional voice and free-text notes provide context only. They do not determine the route.</a:t>
+            </a:r>
+          </a:p>
+        </p:txBody>
+      </p:sp>
+      <p:sp>
+        <p:nvSpPr>
+          <p:cNvPr id="54" name="">
+            <a:extLst xmlns:a="http://schemas.openxmlformats.org/drawingml/2006/main">
+              <a:ext uri="{FF2B5EF4-FFF2-40B4-BE49-F238E27FC236}">
+                <a16:creationId xmlns:a16="http://schemas.microsoft.com/office/drawing/2014/main" id="{4EB55AEE-5E93-4D1D-8DCA-ED21670866C4}"/>
               </a:ext>
             </a:extLst>
           </p:cNvPr>
@@ -12605,10 +12662,10 @@
       </p:sp>
       <p:sp>
         <p:nvSpPr>
-          <p:cNvPr id="54" name="">
-            <a:extLst xmlns:a="http://schemas.openxmlformats.org/drawingml/2006/main">
-              <a:ext uri="{FF2B5EF4-FFF2-40B4-BE49-F238E27FC236}">
-                <a16:creationId xmlns:a16="http://schemas.microsoft.com/office/drawing/2014/main" id="{A8B3EC93-6066-4382-9A44-32DE56F0B011}"/>
+          <p:cNvPr id="55" name="">
+            <a:extLst xmlns:a="http://schemas.openxmlformats.org/drawingml/2006/main">
+              <a:ext uri="{FF2B5EF4-FFF2-40B4-BE49-F238E27FC236}">
+                <a16:creationId xmlns:a16="http://schemas.microsoft.com/office/drawing/2014/main" id="{EE33D6EC-A0DC-4546-AF5F-F035CDCF64C4}"/>
               </a:ext>
             </a:extLst>
           </p:cNvPr>
@@ -12637,10 +12694,10 @@
       </p:sp>
       <p:sp>
         <p:nvSpPr>
-          <p:cNvPr id="55" name="">
-            <a:extLst xmlns:a="http://schemas.openxmlformats.org/drawingml/2006/main">
-              <a:ext uri="{FF2B5EF4-FFF2-40B4-BE49-F238E27FC236}">
-                <a16:creationId xmlns:a16="http://schemas.microsoft.com/office/drawing/2014/main" id="{25F76C5A-ABF3-4F2F-85FE-A677DBCF125D}"/>
+          <p:cNvPr id="56" name="">
+            <a:extLst xmlns:a="http://schemas.openxmlformats.org/drawingml/2006/main">
+              <a:ext uri="{FF2B5EF4-FFF2-40B4-BE49-F238E27FC236}">
+                <a16:creationId xmlns:a16="http://schemas.microsoft.com/office/drawing/2014/main" id="{6B339183-94A2-4323-A8EF-10A25761304D}"/>
               </a:ext>
             </a:extLst>
           </p:cNvPr>
@@ -12694,10 +12751,10 @@
       </p:sp>
       <p:sp>
         <p:nvSpPr>
-          <p:cNvPr id="56" name="">
-            <a:extLst xmlns:a="http://schemas.openxmlformats.org/drawingml/2006/main">
-              <a:ext uri="{FF2B5EF4-FFF2-40B4-BE49-F238E27FC236}">
-                <a16:creationId xmlns:a16="http://schemas.microsoft.com/office/drawing/2014/main" id="{AA75B2B0-F0B1-4EDB-8CEE-77C5D200536A}"/>
+          <p:cNvPr id="57" name="">
+            <a:extLst xmlns:a="http://schemas.openxmlformats.org/drawingml/2006/main">
+              <a:ext uri="{FF2B5EF4-FFF2-40B4-BE49-F238E27FC236}">
+                <a16:creationId xmlns:a16="http://schemas.microsoft.com/office/drawing/2014/main" id="{BFAD9299-93F1-4ED8-B35E-EE62A6F56EDF}"/>
               </a:ext>
             </a:extLst>
           </p:cNvPr>
@@ -12774,10 +12831,10 @@
       </p:sp>
       <p:sp>
         <p:nvSpPr>
-          <p:cNvPr id="57" name="">
-            <a:extLst xmlns:a="http://schemas.openxmlformats.org/drawingml/2006/main">
-              <a:ext uri="{FF2B5EF4-FFF2-40B4-BE49-F238E27FC236}">
-                <a16:creationId xmlns:a16="http://schemas.microsoft.com/office/drawing/2014/main" id="{3E33E262-109D-4097-AA24-4DC77A69299A}"/>
+          <p:cNvPr id="58" name="">
+            <a:extLst xmlns:a="http://schemas.openxmlformats.org/drawingml/2006/main">
+              <a:ext uri="{FF2B5EF4-FFF2-40B4-BE49-F238E27FC236}">
+                <a16:creationId xmlns:a16="http://schemas.microsoft.com/office/drawing/2014/main" id="{89648EDE-976B-4F1D-9536-B335CF7DD497}"/>
               </a:ext>
             </a:extLst>
           </p:cNvPr>
@@ -12804,10 +12861,10 @@
       </p:sp>
       <p:sp>
         <p:nvSpPr>
-          <p:cNvPr id="58" name="">
-            <a:extLst xmlns:a="http://schemas.openxmlformats.org/drawingml/2006/main">
-              <a:ext uri="{FF2B5EF4-FFF2-40B4-BE49-F238E27FC236}">
-                <a16:creationId xmlns:a16="http://schemas.microsoft.com/office/drawing/2014/main" id="{1455884A-04E3-48A1-83F9-9A8B74D79B92}"/>
+          <p:cNvPr id="59" name="">
+            <a:extLst xmlns:a="http://schemas.openxmlformats.org/drawingml/2006/main">
+              <a:ext uri="{FF2B5EF4-FFF2-40B4-BE49-F238E27FC236}">
+                <a16:creationId xmlns:a16="http://schemas.microsoft.com/office/drawing/2014/main" id="{E74FD7DA-4B62-45FE-97BE-E5F52C0F3FC5}"/>
               </a:ext>
             </a:extLst>
           </p:cNvPr>
@@ -12836,10 +12893,10 @@
       </p:sp>
       <p:sp>
         <p:nvSpPr>
-          <p:cNvPr id="59" name="">
-            <a:extLst xmlns:a="http://schemas.openxmlformats.org/drawingml/2006/main">
-              <a:ext uri="{FF2B5EF4-FFF2-40B4-BE49-F238E27FC236}">
-                <a16:creationId xmlns:a16="http://schemas.microsoft.com/office/drawing/2014/main" id="{D049A514-4036-4171-B7EE-E5C26C4697D3}"/>
+          <p:cNvPr id="60" name="">
+            <a:extLst xmlns:a="http://schemas.openxmlformats.org/drawingml/2006/main">
+              <a:ext uri="{FF2B5EF4-FFF2-40B4-BE49-F238E27FC236}">
+                <a16:creationId xmlns:a16="http://schemas.microsoft.com/office/drawing/2014/main" id="{418E9FBA-6456-4C29-9332-D9B521CDC59F}"/>
               </a:ext>
             </a:extLst>
           </p:cNvPr>
@@ -12893,10 +12950,10 @@
       </p:sp>
       <p:sp>
         <p:nvSpPr>
-          <p:cNvPr id="60" name="">
-            <a:extLst xmlns:a="http://schemas.openxmlformats.org/drawingml/2006/main">
-              <a:ext uri="{FF2B5EF4-FFF2-40B4-BE49-F238E27FC236}">
-                <a16:creationId xmlns:a16="http://schemas.microsoft.com/office/drawing/2014/main" id="{47C19ACC-A01F-4895-9E9A-89DF6B7455A5}"/>
+          <p:cNvPr id="61" name="">
+            <a:extLst xmlns:a="http://schemas.openxmlformats.org/drawingml/2006/main">
+              <a:ext uri="{FF2B5EF4-FFF2-40B4-BE49-F238E27FC236}">
+                <a16:creationId xmlns:a16="http://schemas.microsoft.com/office/drawing/2014/main" id="{53519254-ACBE-4594-8220-5E8BDEE9B601}"/>
               </a:ext>
             </a:extLst>
           </p:cNvPr>
@@ -12973,10 +13030,10 @@
       </p:sp>
       <p:sp>
         <p:nvSpPr>
-          <p:cNvPr id="61" name="">
-            <a:extLst xmlns:a="http://schemas.openxmlformats.org/drawingml/2006/main">
-              <a:ext uri="{FF2B5EF4-FFF2-40B4-BE49-F238E27FC236}">
-                <a16:creationId xmlns:a16="http://schemas.microsoft.com/office/drawing/2014/main" id="{2EA59DF8-75DB-43E8-92AF-5BEBB42DB3EF}"/>
+          <p:cNvPr id="62" name="">
+            <a:extLst xmlns:a="http://schemas.openxmlformats.org/drawingml/2006/main">
+              <a:ext uri="{FF2B5EF4-FFF2-40B4-BE49-F238E27FC236}">
+                <a16:creationId xmlns:a16="http://schemas.microsoft.com/office/drawing/2014/main" id="{10524C5E-FA1E-4290-B94C-939EECD7D788}"/>
               </a:ext>
             </a:extLst>
           </p:cNvPr>
@@ -13003,10 +13060,10 @@
       </p:sp>
       <p:sp>
         <p:nvSpPr>
-          <p:cNvPr id="62" name="">
-            <a:extLst xmlns:a="http://schemas.openxmlformats.org/drawingml/2006/main">
-              <a:ext uri="{FF2B5EF4-FFF2-40B4-BE49-F238E27FC236}">
-                <a16:creationId xmlns:a16="http://schemas.microsoft.com/office/drawing/2014/main" id="{95B9EA50-3F69-4847-ADD8-0ABFE322A0F6}"/>
+          <p:cNvPr id="63" name="">
+            <a:extLst xmlns:a="http://schemas.openxmlformats.org/drawingml/2006/main">
+              <a:ext uri="{FF2B5EF4-FFF2-40B4-BE49-F238E27FC236}">
+                <a16:creationId xmlns:a16="http://schemas.microsoft.com/office/drawing/2014/main" id="{94074482-00DA-431E-8AD0-C483FC69DA4A}"/>
               </a:ext>
             </a:extLst>
           </p:cNvPr>
@@ -13035,10 +13092,10 @@
       </p:sp>
       <p:sp>
         <p:nvSpPr>
-          <p:cNvPr id="63" name="">
-            <a:extLst xmlns:a="http://schemas.openxmlformats.org/drawingml/2006/main">
-              <a:ext uri="{FF2B5EF4-FFF2-40B4-BE49-F238E27FC236}">
-                <a16:creationId xmlns:a16="http://schemas.microsoft.com/office/drawing/2014/main" id="{017E0BAB-DE79-4282-A007-C0F2C41E07BB}"/>
+          <p:cNvPr id="64" name="">
+            <a:extLst xmlns:a="http://schemas.openxmlformats.org/drawingml/2006/main">
+              <a:ext uri="{FF2B5EF4-FFF2-40B4-BE49-F238E27FC236}">
+                <a16:creationId xmlns:a16="http://schemas.microsoft.com/office/drawing/2014/main" id="{A3A7D547-CE33-4E2A-9634-671165664B78}"/>
               </a:ext>
             </a:extLst>
           </p:cNvPr>
@@ -13092,10 +13149,10 @@
       </p:sp>
       <p:sp>
         <p:nvSpPr>
-          <p:cNvPr id="64" name="">
-            <a:extLst xmlns:a="http://schemas.openxmlformats.org/drawingml/2006/main">
-              <a:ext uri="{FF2B5EF4-FFF2-40B4-BE49-F238E27FC236}">
-                <a16:creationId xmlns:a16="http://schemas.microsoft.com/office/drawing/2014/main" id="{88C24DE4-7E7F-4625-A8A4-13A3A58507F5}"/>
+          <p:cNvPr id="65" name="">
+            <a:extLst xmlns:a="http://schemas.openxmlformats.org/drawingml/2006/main">
+              <a:ext uri="{FF2B5EF4-FFF2-40B4-BE49-F238E27FC236}">
+                <a16:creationId xmlns:a16="http://schemas.microsoft.com/office/drawing/2014/main" id="{4E1F98ED-8EA4-477E-85DC-CCDCA7E56518}"/>
               </a:ext>
             </a:extLst>
           </p:cNvPr>
@@ -13149,10 +13206,10 @@
       </p:sp>
       <p:sp>
         <p:nvSpPr>
-          <p:cNvPr id="65" name="">
-            <a:extLst xmlns:a="http://schemas.openxmlformats.org/drawingml/2006/main">
-              <a:ext uri="{FF2B5EF4-FFF2-40B4-BE49-F238E27FC236}">
-                <a16:creationId xmlns:a16="http://schemas.microsoft.com/office/drawing/2014/main" id="{1B8DDF0D-9929-43AE-A44D-8596A867638F}"/>
+          <p:cNvPr id="66" name="">
+            <a:extLst xmlns:a="http://schemas.openxmlformats.org/drawingml/2006/main">
+              <a:ext uri="{FF2B5EF4-FFF2-40B4-BE49-F238E27FC236}">
+                <a16:creationId xmlns:a16="http://schemas.microsoft.com/office/drawing/2014/main" id="{BAADF5DB-D52C-4541-A6CC-80A3190CA2EC}"/>
               </a:ext>
             </a:extLst>
           </p:cNvPr>
@@ -13206,10 +13263,10 @@
       </p:sp>
       <p:sp>
         <p:nvSpPr>
-          <p:cNvPr id="66" name="">
-            <a:extLst xmlns:a="http://schemas.openxmlformats.org/drawingml/2006/main">
-              <a:ext uri="{FF2B5EF4-FFF2-40B4-BE49-F238E27FC236}">
-                <a16:creationId xmlns:a16="http://schemas.microsoft.com/office/drawing/2014/main" id="{FCA94C60-BEB0-404A-B2A5-71D7244726E4}"/>
+          <p:cNvPr id="67" name="">
+            <a:extLst xmlns:a="http://schemas.openxmlformats.org/drawingml/2006/main">
+              <a:ext uri="{FF2B5EF4-FFF2-40B4-BE49-F238E27FC236}">
+                <a16:creationId xmlns:a16="http://schemas.microsoft.com/office/drawing/2014/main" id="{6792340E-FD18-4ED5-978F-2CBEC442BCB7}"/>
               </a:ext>
             </a:extLst>
           </p:cNvPr>
@@ -15355,7 +15412,7 @@
           <p:cNvPr id="41" name="">
             <a:extLst xmlns:a="http://schemas.openxmlformats.org/drawingml/2006/main">
               <a:ext uri="{FF2B5EF4-FFF2-40B4-BE49-F238E27FC236}">
-                <a16:creationId xmlns:a16="http://schemas.microsoft.com/office/drawing/2014/main" id="{E3A693FD-74AB-4CF9-8EBF-65A0DF3C969F}"/>
+                <a16:creationId xmlns:a16="http://schemas.microsoft.com/office/drawing/2014/main" id="{8CB2902A-56B9-4E2D-AA66-023EC0AA5B65}"/>
               </a:ext>
             </a:extLst>
           </p:cNvPr>
@@ -15385,7 +15442,7 @@
           <p:cNvPr id="42" name="">
             <a:extLst xmlns:a="http://schemas.openxmlformats.org/drawingml/2006/main">
               <a:ext uri="{FF2B5EF4-FFF2-40B4-BE49-F238E27FC236}">
-                <a16:creationId xmlns:a16="http://schemas.microsoft.com/office/drawing/2014/main" id="{9FC56A02-F138-4E31-92E4-D0F5A795F143}"/>
+                <a16:creationId xmlns:a16="http://schemas.microsoft.com/office/drawing/2014/main" id="{5214BDDA-5145-4BB5-B841-3FD742064BB6}"/>
               </a:ext>
             </a:extLst>
           </p:cNvPr>
@@ -15442,7 +15499,7 @@
           <p:cNvPr id="43" name="">
             <a:extLst xmlns:a="http://schemas.openxmlformats.org/drawingml/2006/main">
               <a:ext uri="{FF2B5EF4-FFF2-40B4-BE49-F238E27FC236}">
-                <a16:creationId xmlns:a16="http://schemas.microsoft.com/office/drawing/2014/main" id="{EAEF0BF3-988E-416F-B2C9-E317716FC549}"/>
+                <a16:creationId xmlns:a16="http://schemas.microsoft.com/office/drawing/2014/main" id="{6AADA492-2116-4E4C-AFE1-3555B4DEA02D}"/>
               </a:ext>
             </a:extLst>
           </p:cNvPr>
@@ -15499,7 +15556,7 @@
           <p:cNvPr id="44" name="">
             <a:extLst xmlns:a="http://schemas.openxmlformats.org/drawingml/2006/main">
               <a:ext uri="{FF2B5EF4-FFF2-40B4-BE49-F238E27FC236}">
-                <a16:creationId xmlns:a16="http://schemas.microsoft.com/office/drawing/2014/main" id="{B9E5C05B-6BC3-4413-8064-7364BF29C119}"/>
+                <a16:creationId xmlns:a16="http://schemas.microsoft.com/office/drawing/2014/main" id="{6E12C83A-979D-4640-904E-1AD4CAB0DC18}"/>
               </a:ext>
             </a:extLst>
           </p:cNvPr>
@@ -15556,7 +15613,7 @@
           <p:cNvPr id="45" name="">
             <a:extLst xmlns:a="http://schemas.openxmlformats.org/drawingml/2006/main">
               <a:ext uri="{FF2B5EF4-FFF2-40B4-BE49-F238E27FC236}">
-                <a16:creationId xmlns:a16="http://schemas.microsoft.com/office/drawing/2014/main" id="{E0E72B31-ADCE-4D2C-8FDC-657287049C89}"/>
+                <a16:creationId xmlns:a16="http://schemas.microsoft.com/office/drawing/2014/main" id="{D4059C87-37ED-4C90-BCB3-97E8E82461F8}"/>
               </a:ext>
             </a:extLst>
           </p:cNvPr>
@@ -15613,7 +15670,7 @@
           <p:cNvPr id="46" name="">
             <a:extLst xmlns:a="http://schemas.openxmlformats.org/drawingml/2006/main">
               <a:ext uri="{FF2B5EF4-FFF2-40B4-BE49-F238E27FC236}">
-                <a16:creationId xmlns:a16="http://schemas.microsoft.com/office/drawing/2014/main" id="{CEE03F19-5AE5-43DA-84D3-4FE7F4BA3CE2}"/>
+                <a16:creationId xmlns:a16="http://schemas.microsoft.com/office/drawing/2014/main" id="{636B973D-9A3A-4B6A-A125-E4F94166B5F6}"/>
               </a:ext>
             </a:extLst>
           </p:cNvPr>
@@ -15643,7 +15700,7 @@
           <p:cNvPr id="47" name="">
             <a:extLst xmlns:a="http://schemas.openxmlformats.org/drawingml/2006/main">
               <a:ext uri="{FF2B5EF4-FFF2-40B4-BE49-F238E27FC236}">
-                <a16:creationId xmlns:a16="http://schemas.microsoft.com/office/drawing/2014/main" id="{4E6248F6-B6F0-473B-9C7D-1265BAB2EDF8}"/>
+                <a16:creationId xmlns:a16="http://schemas.microsoft.com/office/drawing/2014/main" id="{A96C5F0B-2387-45A0-AB24-B1C3610CB103}"/>
               </a:ext>
             </a:extLst>
           </p:cNvPr>
@@ -15677,7 +15734,7 @@
           <p:cNvPr id="48" name="">
             <a:extLst xmlns:a="http://schemas.openxmlformats.org/drawingml/2006/main">
               <a:ext uri="{FF2B5EF4-FFF2-40B4-BE49-F238E27FC236}">
-                <a16:creationId xmlns:a16="http://schemas.microsoft.com/office/drawing/2014/main" id="{6B14125A-6F3A-425F-8EA7-57349C8FFBC3}"/>
+                <a16:creationId xmlns:a16="http://schemas.microsoft.com/office/drawing/2014/main" id="{E56C05AC-EF13-4C31-A3EF-131C84446A67}"/>
               </a:ext>
             </a:extLst>
           </p:cNvPr>
@@ -15709,7 +15766,7 @@
           <p:cNvPr id="49" name="">
             <a:extLst xmlns:a="http://schemas.openxmlformats.org/drawingml/2006/main">
               <a:ext uri="{FF2B5EF4-FFF2-40B4-BE49-F238E27FC236}">
-                <a16:creationId xmlns:a16="http://schemas.microsoft.com/office/drawing/2014/main" id="{E3BD7B36-BBCC-4A54-9CD8-07C30AF49D55}"/>
+                <a16:creationId xmlns:a16="http://schemas.microsoft.com/office/drawing/2014/main" id="{07833797-1F69-4601-AF93-65DB69791DC5}"/>
               </a:ext>
             </a:extLst>
           </p:cNvPr>
@@ -15766,7 +15823,7 @@
           <p:cNvPr id="50" name="">
             <a:extLst xmlns:a="http://schemas.openxmlformats.org/drawingml/2006/main">
               <a:ext uri="{FF2B5EF4-FFF2-40B4-BE49-F238E27FC236}">
-                <a16:creationId xmlns:a16="http://schemas.microsoft.com/office/drawing/2014/main" id="{6F2A9A5A-32BB-4EBD-B698-EF90EA40E1B9}"/>
+                <a16:creationId xmlns:a16="http://schemas.microsoft.com/office/drawing/2014/main" id="{903FEC1B-BA8E-4472-84E1-5AFB3C3CF128}"/>
               </a:ext>
             </a:extLst>
           </p:cNvPr>
@@ -15823,7 +15880,7 @@
           <p:cNvPr id="51" name="">
             <a:extLst xmlns:a="http://schemas.openxmlformats.org/drawingml/2006/main">
               <a:ext uri="{FF2B5EF4-FFF2-40B4-BE49-F238E27FC236}">
-                <a16:creationId xmlns:a16="http://schemas.microsoft.com/office/drawing/2014/main" id="{6D8A062A-BC49-4E36-8505-476446988357}"/>
+                <a16:creationId xmlns:a16="http://schemas.microsoft.com/office/drawing/2014/main" id="{8DD63BD9-43AB-474B-9FD9-C810CF28927A}"/>
               </a:ext>
             </a:extLst>
           </p:cNvPr>
@@ -15880,7 +15937,7 @@
           <p:cNvPr id="52" name="">
             <a:extLst xmlns:a="http://schemas.openxmlformats.org/drawingml/2006/main">
               <a:ext uri="{FF2B5EF4-FFF2-40B4-BE49-F238E27FC236}">
-                <a16:creationId xmlns:a16="http://schemas.microsoft.com/office/drawing/2014/main" id="{9CBE23EB-65E8-491F-A65E-A6BBCD3852D2}"/>
+                <a16:creationId xmlns:a16="http://schemas.microsoft.com/office/drawing/2014/main" id="{1189172A-7162-4D77-979D-A372CB860C6D}"/>
               </a:ext>
             </a:extLst>
           </p:cNvPr>
@@ -15914,7 +15971,7 @@
           <p:cNvPr id="53" name="">
             <a:extLst xmlns:a="http://schemas.openxmlformats.org/drawingml/2006/main">
               <a:ext uri="{FF2B5EF4-FFF2-40B4-BE49-F238E27FC236}">
-                <a16:creationId xmlns:a16="http://schemas.microsoft.com/office/drawing/2014/main" id="{B0D33192-5F9F-4E85-8522-5E8CC2FCC108}"/>
+                <a16:creationId xmlns:a16="http://schemas.microsoft.com/office/drawing/2014/main" id="{61369A2D-81CC-4A2A-8BE1-83EF241A275D}"/>
               </a:ext>
             </a:extLst>
           </p:cNvPr>
@@ -15946,7 +16003,7 @@
           <p:cNvPr id="54" name="">
             <a:extLst xmlns:a="http://schemas.openxmlformats.org/drawingml/2006/main">
               <a:ext uri="{FF2B5EF4-FFF2-40B4-BE49-F238E27FC236}">
-                <a16:creationId xmlns:a16="http://schemas.microsoft.com/office/drawing/2014/main" id="{4D6B43F3-9A9B-4802-AADE-A55010C74D1C}"/>
+                <a16:creationId xmlns:a16="http://schemas.microsoft.com/office/drawing/2014/main" id="{53A59EA9-372D-4FA7-BEFF-0F22FACA8A4D}"/>
               </a:ext>
             </a:extLst>
           </p:cNvPr>
@@ -16003,7 +16060,7 @@
           <p:cNvPr id="55" name="">
             <a:extLst xmlns:a="http://schemas.openxmlformats.org/drawingml/2006/main">
               <a:ext uri="{FF2B5EF4-FFF2-40B4-BE49-F238E27FC236}">
-                <a16:creationId xmlns:a16="http://schemas.microsoft.com/office/drawing/2014/main" id="{91DCBB4D-7B8A-494A-A725-3825A4502F5A}"/>
+                <a16:creationId xmlns:a16="http://schemas.microsoft.com/office/drawing/2014/main" id="{E7D25EB6-12DD-4B6F-8AFC-FAAA32B78D89}"/>
               </a:ext>
             </a:extLst>
           </p:cNvPr>
@@ -16060,7 +16117,7 @@
           <p:cNvPr id="56" name="">
             <a:extLst xmlns:a="http://schemas.openxmlformats.org/drawingml/2006/main">
               <a:ext uri="{FF2B5EF4-FFF2-40B4-BE49-F238E27FC236}">
-                <a16:creationId xmlns:a16="http://schemas.microsoft.com/office/drawing/2014/main" id="{76F8FD65-3416-42A2-94A2-02BBE426F25E}"/>
+                <a16:creationId xmlns:a16="http://schemas.microsoft.com/office/drawing/2014/main" id="{C691E553-AD0E-4424-81DD-087BF8EA829D}"/>
               </a:ext>
             </a:extLst>
           </p:cNvPr>
@@ -16117,7 +16174,7 @@
           <p:cNvPr id="57" name="">
             <a:extLst xmlns:a="http://schemas.openxmlformats.org/drawingml/2006/main">
               <a:ext uri="{FF2B5EF4-FFF2-40B4-BE49-F238E27FC236}">
-                <a16:creationId xmlns:a16="http://schemas.microsoft.com/office/drawing/2014/main" id="{67AAF4CB-286B-481E-BE19-910226C1F926}"/>
+                <a16:creationId xmlns:a16="http://schemas.microsoft.com/office/drawing/2014/main" id="{A268E9E4-732E-4E3F-AC4C-D03AC53DA291}"/>
               </a:ext>
             </a:extLst>
           </p:cNvPr>
@@ -16151,7 +16208,7 @@
           <p:cNvPr id="58" name="">
             <a:extLst xmlns:a="http://schemas.openxmlformats.org/drawingml/2006/main">
               <a:ext uri="{FF2B5EF4-FFF2-40B4-BE49-F238E27FC236}">
-                <a16:creationId xmlns:a16="http://schemas.microsoft.com/office/drawing/2014/main" id="{16E616E1-6960-4107-9762-2A241FE7E226}"/>
+                <a16:creationId xmlns:a16="http://schemas.microsoft.com/office/drawing/2014/main" id="{86214F27-AE83-422E-9DE7-910CB4991DEC}"/>
               </a:ext>
             </a:extLst>
           </p:cNvPr>
@@ -16183,7 +16240,7 @@
           <p:cNvPr id="59" name="">
             <a:extLst xmlns:a="http://schemas.openxmlformats.org/drawingml/2006/main">
               <a:ext uri="{FF2B5EF4-FFF2-40B4-BE49-F238E27FC236}">
-                <a16:creationId xmlns:a16="http://schemas.microsoft.com/office/drawing/2014/main" id="{47D8A961-A864-46D4-AA80-B5033BB53ED7}"/>
+                <a16:creationId xmlns:a16="http://schemas.microsoft.com/office/drawing/2014/main" id="{09A74310-F391-483C-91BE-5CB0DC75AB68}"/>
               </a:ext>
             </a:extLst>
           </p:cNvPr>
@@ -16240,7 +16297,7 @@
           <p:cNvPr id="60" name="">
             <a:extLst xmlns:a="http://schemas.openxmlformats.org/drawingml/2006/main">
               <a:ext uri="{FF2B5EF4-FFF2-40B4-BE49-F238E27FC236}">
-                <a16:creationId xmlns:a16="http://schemas.microsoft.com/office/drawing/2014/main" id="{BF22A76C-1C10-4BFC-9494-2557B36B859A}"/>
+                <a16:creationId xmlns:a16="http://schemas.microsoft.com/office/drawing/2014/main" id="{6A61B25E-1467-457C-8352-C5962BBE4305}"/>
               </a:ext>
             </a:extLst>
           </p:cNvPr>
@@ -16297,7 +16354,7 @@
           <p:cNvPr id="61" name="">
             <a:extLst xmlns:a="http://schemas.openxmlformats.org/drawingml/2006/main">
               <a:ext uri="{FF2B5EF4-FFF2-40B4-BE49-F238E27FC236}">
-                <a16:creationId xmlns:a16="http://schemas.microsoft.com/office/drawing/2014/main" id="{4A037959-B642-488F-9250-D3935AE6C135}"/>
+                <a16:creationId xmlns:a16="http://schemas.microsoft.com/office/drawing/2014/main" id="{9B6B7303-88ED-4544-AFE8-AFAB3C481F99}"/>
               </a:ext>
             </a:extLst>
           </p:cNvPr>
@@ -16354,7 +16411,7 @@
           <p:cNvPr id="62" name="">
             <a:extLst xmlns:a="http://schemas.openxmlformats.org/drawingml/2006/main">
               <a:ext uri="{FF2B5EF4-FFF2-40B4-BE49-F238E27FC236}">
-                <a16:creationId xmlns:a16="http://schemas.microsoft.com/office/drawing/2014/main" id="{1AC2AABA-7767-4101-984A-4F8ED33DE62A}"/>
+                <a16:creationId xmlns:a16="http://schemas.microsoft.com/office/drawing/2014/main" id="{85F68E95-A7C7-4845-A214-F73D5D081C8D}"/>
               </a:ext>
             </a:extLst>
           </p:cNvPr>
@@ -16388,7 +16445,7 @@
           <p:cNvPr id="63" name="">
             <a:extLst xmlns:a="http://schemas.openxmlformats.org/drawingml/2006/main">
               <a:ext uri="{FF2B5EF4-FFF2-40B4-BE49-F238E27FC236}">
-                <a16:creationId xmlns:a16="http://schemas.microsoft.com/office/drawing/2014/main" id="{DC8F574E-729F-4DB2-8D4B-7D99D4BDC031}"/>
+                <a16:creationId xmlns:a16="http://schemas.microsoft.com/office/drawing/2014/main" id="{0F549AE6-5C5A-4A9E-8EF7-7CD4C1184CE1}"/>
               </a:ext>
             </a:extLst>
           </p:cNvPr>
@@ -16420,7 +16477,7 @@
           <p:cNvPr id="64" name="">
             <a:extLst xmlns:a="http://schemas.openxmlformats.org/drawingml/2006/main">
               <a:ext uri="{FF2B5EF4-FFF2-40B4-BE49-F238E27FC236}">
-                <a16:creationId xmlns:a16="http://schemas.microsoft.com/office/drawing/2014/main" id="{DFA8C6C5-2DB1-4615-8149-01131A0B15E0}"/>
+                <a16:creationId xmlns:a16="http://schemas.microsoft.com/office/drawing/2014/main" id="{09FE5DD7-69A5-49D6-8524-25A8C236705B}"/>
               </a:ext>
             </a:extLst>
           </p:cNvPr>
@@ -16477,7 +16534,7 @@
           <p:cNvPr id="65" name="">
             <a:extLst xmlns:a="http://schemas.openxmlformats.org/drawingml/2006/main">
               <a:ext uri="{FF2B5EF4-FFF2-40B4-BE49-F238E27FC236}">
-                <a16:creationId xmlns:a16="http://schemas.microsoft.com/office/drawing/2014/main" id="{2E032E2B-4E27-448A-BB3B-93A70B126D61}"/>
+                <a16:creationId xmlns:a16="http://schemas.microsoft.com/office/drawing/2014/main" id="{9EA86D13-3986-4C2D-AF48-042741004AB6}"/>
               </a:ext>
             </a:extLst>
           </p:cNvPr>
@@ -16534,7 +16591,7 @@
           <p:cNvPr id="66" name="">
             <a:extLst xmlns:a="http://schemas.openxmlformats.org/drawingml/2006/main">
               <a:ext uri="{FF2B5EF4-FFF2-40B4-BE49-F238E27FC236}">
-                <a16:creationId xmlns:a16="http://schemas.microsoft.com/office/drawing/2014/main" id="{1E9DC06A-F10B-4E4D-8284-61C75EF38D19}"/>
+                <a16:creationId xmlns:a16="http://schemas.microsoft.com/office/drawing/2014/main" id="{ED7F14AA-6509-42A2-B35F-9B4B87A16036}"/>
               </a:ext>
             </a:extLst>
           </p:cNvPr>
@@ -16614,7 +16671,7 @@
           <p:cNvPr id="67" name="">
             <a:extLst xmlns:a="http://schemas.openxmlformats.org/drawingml/2006/main">
               <a:ext uri="{FF2B5EF4-FFF2-40B4-BE49-F238E27FC236}">
-                <a16:creationId xmlns:a16="http://schemas.microsoft.com/office/drawing/2014/main" id="{B6B325B3-7423-4ACC-9A5E-23F1CF86F791}"/>
+                <a16:creationId xmlns:a16="http://schemas.microsoft.com/office/drawing/2014/main" id="{1751E3FE-CDB7-4328-90CB-6E77BEA2F923}"/>
               </a:ext>
             </a:extLst>
           </p:cNvPr>
@@ -16646,7 +16703,7 @@
           <p:cNvPr id="68" name="">
             <a:extLst xmlns:a="http://schemas.openxmlformats.org/drawingml/2006/main">
               <a:ext uri="{FF2B5EF4-FFF2-40B4-BE49-F238E27FC236}">
-                <a16:creationId xmlns:a16="http://schemas.microsoft.com/office/drawing/2014/main" id="{BFA0A1F2-513E-409C-B6A6-4B655EFC37E1}"/>
+                <a16:creationId xmlns:a16="http://schemas.microsoft.com/office/drawing/2014/main" id="{1FC6B526-2502-4F53-BE0F-27EFE10E18FA}"/>
               </a:ext>
             </a:extLst>
           </p:cNvPr>
@@ -16703,7 +16760,7 @@
           <p:cNvPr id="69" name="">
             <a:extLst xmlns:a="http://schemas.openxmlformats.org/drawingml/2006/main">
               <a:ext uri="{FF2B5EF4-FFF2-40B4-BE49-F238E27FC236}">
-                <a16:creationId xmlns:a16="http://schemas.microsoft.com/office/drawing/2014/main" id="{B4E27626-76C9-43B3-A391-358EB756212C}"/>
+                <a16:creationId xmlns:a16="http://schemas.microsoft.com/office/drawing/2014/main" id="{63DC29E8-871A-4BC3-A7A2-235E4F75D061}"/>
               </a:ext>
             </a:extLst>
           </p:cNvPr>
@@ -18082,7 +18139,7 @@
           <p:cNvPr id="27" name="">
             <a:extLst xmlns:a="http://schemas.openxmlformats.org/drawingml/2006/main">
               <a:ext uri="{FF2B5EF4-FFF2-40B4-BE49-F238E27FC236}">
-                <a16:creationId xmlns:a16="http://schemas.microsoft.com/office/drawing/2014/main" id="{D8F80730-6613-48F1-AB3D-C0C9C42BC270}"/>
+                <a16:creationId xmlns:a16="http://schemas.microsoft.com/office/drawing/2014/main" id="{CF6B5FE1-74E7-44AD-BB3A-9595E388B49E}"/>
               </a:ext>
             </a:extLst>
           </p:cNvPr>
@@ -18112,7 +18169,7 @@
           <p:cNvPr id="28" name="">
             <a:extLst xmlns:a="http://schemas.openxmlformats.org/drawingml/2006/main">
               <a:ext uri="{FF2B5EF4-FFF2-40B4-BE49-F238E27FC236}">
-                <a16:creationId xmlns:a16="http://schemas.microsoft.com/office/drawing/2014/main" id="{AE9587B1-4457-47A2-A02B-8858A03B592B}"/>
+                <a16:creationId xmlns:a16="http://schemas.microsoft.com/office/drawing/2014/main" id="{EC8DFB18-839B-4CF8-B15C-D07331E45DCB}"/>
               </a:ext>
             </a:extLst>
           </p:cNvPr>
@@ -18169,7 +18226,7 @@
           <p:cNvPr id="29" name="">
             <a:extLst xmlns:a="http://schemas.openxmlformats.org/drawingml/2006/main">
               <a:ext uri="{FF2B5EF4-FFF2-40B4-BE49-F238E27FC236}">
-                <a16:creationId xmlns:a16="http://schemas.microsoft.com/office/drawing/2014/main" id="{1C52DDA8-F0DC-4297-B172-CF4779822E15}"/>
+                <a16:creationId xmlns:a16="http://schemas.microsoft.com/office/drawing/2014/main" id="{7F14BA99-94B4-45A6-812D-B2F72A20651D}"/>
               </a:ext>
             </a:extLst>
           </p:cNvPr>
@@ -18226,7 +18283,7 @@
           <p:cNvPr id="30" name="">
             <a:extLst xmlns:a="http://schemas.openxmlformats.org/drawingml/2006/main">
               <a:ext uri="{FF2B5EF4-FFF2-40B4-BE49-F238E27FC236}">
-                <a16:creationId xmlns:a16="http://schemas.microsoft.com/office/drawing/2014/main" id="{6E01A67E-9D2C-4DD7-B582-047CC583C45B}"/>
+                <a16:creationId xmlns:a16="http://schemas.microsoft.com/office/drawing/2014/main" id="{01798C12-3B3F-4B5B-BF5C-72A65D2F4F9E}"/>
               </a:ext>
             </a:extLst>
           </p:cNvPr>
@@ -18283,7 +18340,7 @@
           <p:cNvPr id="31" name="">
             <a:extLst xmlns:a="http://schemas.openxmlformats.org/drawingml/2006/main">
               <a:ext uri="{FF2B5EF4-FFF2-40B4-BE49-F238E27FC236}">
-                <a16:creationId xmlns:a16="http://schemas.microsoft.com/office/drawing/2014/main" id="{D38E751B-8A38-4508-9811-A50C89EEFF69}"/>
+                <a16:creationId xmlns:a16="http://schemas.microsoft.com/office/drawing/2014/main" id="{279575AA-2EE5-46D2-8553-92687C027905}"/>
               </a:ext>
             </a:extLst>
           </p:cNvPr>
@@ -18340,7 +18397,7 @@
           <p:cNvPr id="32" name="">
             <a:extLst xmlns:a="http://schemas.openxmlformats.org/drawingml/2006/main">
               <a:ext uri="{FF2B5EF4-FFF2-40B4-BE49-F238E27FC236}">
-                <a16:creationId xmlns:a16="http://schemas.microsoft.com/office/drawing/2014/main" id="{00B196DD-604E-47D2-B2F6-80EE83DA8796}"/>
+                <a16:creationId xmlns:a16="http://schemas.microsoft.com/office/drawing/2014/main" id="{A9EBF57E-7760-4F46-A9B0-F3DC8876327C}"/>
               </a:ext>
             </a:extLst>
           </p:cNvPr>
@@ -18370,7 +18427,7 @@
           <p:cNvPr id="33" name="">
             <a:extLst xmlns:a="http://schemas.openxmlformats.org/drawingml/2006/main">
               <a:ext uri="{FF2B5EF4-FFF2-40B4-BE49-F238E27FC236}">
-                <a16:creationId xmlns:a16="http://schemas.microsoft.com/office/drawing/2014/main" id="{D5C3472D-B417-4BF7-8D04-235B978D5494}"/>
+                <a16:creationId xmlns:a16="http://schemas.microsoft.com/office/drawing/2014/main" id="{B04BFB26-CDAD-490E-82ED-3716C6077E25}"/>
               </a:ext>
             </a:extLst>
           </p:cNvPr>
@@ -18400,7 +18457,7 @@
           <p:cNvPr id="34" name="">
             <a:extLst xmlns:a="http://schemas.openxmlformats.org/drawingml/2006/main">
               <a:ext uri="{FF2B5EF4-FFF2-40B4-BE49-F238E27FC236}">
-                <a16:creationId xmlns:a16="http://schemas.microsoft.com/office/drawing/2014/main" id="{D9645F00-D4D3-4BF5-8980-6508F6D2137F}"/>
+                <a16:creationId xmlns:a16="http://schemas.microsoft.com/office/drawing/2014/main" id="{DE5589C0-2873-4E35-93B6-0D035BB4D979}"/>
               </a:ext>
             </a:extLst>
           </p:cNvPr>
@@ -18430,7 +18487,7 @@
           <p:cNvPr id="35" name="">
             <a:extLst xmlns:a="http://schemas.openxmlformats.org/drawingml/2006/main">
               <a:ext uri="{FF2B5EF4-FFF2-40B4-BE49-F238E27FC236}">
-                <a16:creationId xmlns:a16="http://schemas.microsoft.com/office/drawing/2014/main" id="{A8A0BA39-7DFE-4201-B3D8-9D77403DDB01}"/>
+                <a16:creationId xmlns:a16="http://schemas.microsoft.com/office/drawing/2014/main" id="{1D3BF33D-F61E-4918-9B00-6FE07D20D5DE}"/>
               </a:ext>
             </a:extLst>
           </p:cNvPr>
@@ -18487,7 +18544,7 @@
           <p:cNvPr id="36" name="">
             <a:extLst xmlns:a="http://schemas.openxmlformats.org/drawingml/2006/main">
               <a:ext uri="{FF2B5EF4-FFF2-40B4-BE49-F238E27FC236}">
-                <a16:creationId xmlns:a16="http://schemas.microsoft.com/office/drawing/2014/main" id="{2667EE31-1F93-4D06-9535-B80FCBE7E8BD}"/>
+                <a16:creationId xmlns:a16="http://schemas.microsoft.com/office/drawing/2014/main" id="{09D5ACE1-E941-40AF-99F4-9B8B65213C20}"/>
               </a:ext>
             </a:extLst>
           </p:cNvPr>
@@ -18544,7 +18601,7 @@
           <p:cNvPr id="37" name="">
             <a:extLst xmlns:a="http://schemas.openxmlformats.org/drawingml/2006/main">
               <a:ext uri="{FF2B5EF4-FFF2-40B4-BE49-F238E27FC236}">
-                <a16:creationId xmlns:a16="http://schemas.microsoft.com/office/drawing/2014/main" id="{02512B0E-82AC-4B18-A7FA-E14A1CCE5D45}"/>
+                <a16:creationId xmlns:a16="http://schemas.microsoft.com/office/drawing/2014/main" id="{738B27AC-2F7A-4E2A-92EE-CB3697C7BE24}"/>
               </a:ext>
             </a:extLst>
           </p:cNvPr>
@@ -18624,7 +18681,7 @@
           <p:cNvPr id="38" name="">
             <a:extLst xmlns:a="http://schemas.openxmlformats.org/drawingml/2006/main">
               <a:ext uri="{FF2B5EF4-FFF2-40B4-BE49-F238E27FC236}">
-                <a16:creationId xmlns:a16="http://schemas.microsoft.com/office/drawing/2014/main" id="{9BEC85A1-CE7E-4A79-A082-627995F65474}"/>
+                <a16:creationId xmlns:a16="http://schemas.microsoft.com/office/drawing/2014/main" id="{3E619982-382F-4AC7-85E2-409E700E892A}"/>
               </a:ext>
             </a:extLst>
           </p:cNvPr>
@@ -18654,7 +18711,7 @@
           <p:cNvPr id="39" name="">
             <a:extLst xmlns:a="http://schemas.openxmlformats.org/drawingml/2006/main">
               <a:ext uri="{FF2B5EF4-FFF2-40B4-BE49-F238E27FC236}">
-                <a16:creationId xmlns:a16="http://schemas.microsoft.com/office/drawing/2014/main" id="{A4FD3B39-0F3A-4236-9BD2-0801C1B1BB9D}"/>
+                <a16:creationId xmlns:a16="http://schemas.microsoft.com/office/drawing/2014/main" id="{9798DF25-73D1-4233-9DB2-88D6782889CA}"/>
               </a:ext>
             </a:extLst>
           </p:cNvPr>
@@ -18684,7 +18741,7 @@
           <p:cNvPr id="40" name="">
             <a:extLst xmlns:a="http://schemas.openxmlformats.org/drawingml/2006/main">
               <a:ext uri="{FF2B5EF4-FFF2-40B4-BE49-F238E27FC236}">
-                <a16:creationId xmlns:a16="http://schemas.microsoft.com/office/drawing/2014/main" id="{AC7301E5-46B3-4FC0-BF30-5D427BDA3713}"/>
+                <a16:creationId xmlns:a16="http://schemas.microsoft.com/office/drawing/2014/main" id="{1AF6A539-75BB-40CA-B008-190D0B750FBD}"/>
               </a:ext>
             </a:extLst>
           </p:cNvPr>
@@ -18741,7 +18798,7 @@
           <p:cNvPr id="41" name="">
             <a:extLst xmlns:a="http://schemas.openxmlformats.org/drawingml/2006/main">
               <a:ext uri="{FF2B5EF4-FFF2-40B4-BE49-F238E27FC236}">
-                <a16:creationId xmlns:a16="http://schemas.microsoft.com/office/drawing/2014/main" id="{7F1DCCB5-6F0A-48C6-ABC7-38B0F74D280D}"/>
+                <a16:creationId xmlns:a16="http://schemas.microsoft.com/office/drawing/2014/main" id="{A4254C37-CE41-475B-877E-1996DDF73A7E}"/>
               </a:ext>
             </a:extLst>
           </p:cNvPr>
@@ -18798,7 +18855,7 @@
           <p:cNvPr id="42" name="">
             <a:extLst xmlns:a="http://schemas.openxmlformats.org/drawingml/2006/main">
               <a:ext uri="{FF2B5EF4-FFF2-40B4-BE49-F238E27FC236}">
-                <a16:creationId xmlns:a16="http://schemas.microsoft.com/office/drawing/2014/main" id="{8C7ABC10-CDA8-4A39-A75C-6B3C02220208}"/>
+                <a16:creationId xmlns:a16="http://schemas.microsoft.com/office/drawing/2014/main" id="{F1A4F89A-F698-4FE6-A19E-9DA6B538CEF4}"/>
               </a:ext>
             </a:extLst>
           </p:cNvPr>
@@ -18878,7 +18935,7 @@
           <p:cNvPr id="43" name="">
             <a:extLst xmlns:a="http://schemas.openxmlformats.org/drawingml/2006/main">
               <a:ext uri="{FF2B5EF4-FFF2-40B4-BE49-F238E27FC236}">
-                <a16:creationId xmlns:a16="http://schemas.microsoft.com/office/drawing/2014/main" id="{2D29FF7E-F7D5-41D3-A01C-E609471CD147}"/>
+                <a16:creationId xmlns:a16="http://schemas.microsoft.com/office/drawing/2014/main" id="{B19A865A-541C-4993-ABFA-1EAC0A37396A}"/>
               </a:ext>
             </a:extLst>
           </p:cNvPr>
@@ -18908,7 +18965,7 @@
           <p:cNvPr id="44" name="">
             <a:extLst xmlns:a="http://schemas.openxmlformats.org/drawingml/2006/main">
               <a:ext uri="{FF2B5EF4-FFF2-40B4-BE49-F238E27FC236}">
-                <a16:creationId xmlns:a16="http://schemas.microsoft.com/office/drawing/2014/main" id="{44DC7F75-E629-43F3-BAC5-2AB6CEF31D46}"/>
+                <a16:creationId xmlns:a16="http://schemas.microsoft.com/office/drawing/2014/main" id="{83520088-BFE2-40EB-8383-3664B5EFB891}"/>
               </a:ext>
             </a:extLst>
           </p:cNvPr>
@@ -18938,7 +18995,7 @@
           <p:cNvPr id="45" name="">
             <a:extLst xmlns:a="http://schemas.openxmlformats.org/drawingml/2006/main">
               <a:ext uri="{FF2B5EF4-FFF2-40B4-BE49-F238E27FC236}">
-                <a16:creationId xmlns:a16="http://schemas.microsoft.com/office/drawing/2014/main" id="{6DF2338E-4519-4E6D-B404-A54E7046FEBB}"/>
+                <a16:creationId xmlns:a16="http://schemas.microsoft.com/office/drawing/2014/main" id="{513437FD-F6B7-40D1-A912-BF4CE47437A6}"/>
               </a:ext>
             </a:extLst>
           </p:cNvPr>
@@ -18995,7 +19052,7 @@
           <p:cNvPr id="46" name="">
             <a:extLst xmlns:a="http://schemas.openxmlformats.org/drawingml/2006/main">
               <a:ext uri="{FF2B5EF4-FFF2-40B4-BE49-F238E27FC236}">
-                <a16:creationId xmlns:a16="http://schemas.microsoft.com/office/drawing/2014/main" id="{9DE12633-4838-49CA-8E54-BC72F4F94F98}"/>
+                <a16:creationId xmlns:a16="http://schemas.microsoft.com/office/drawing/2014/main" id="{CBAC1890-AB61-4E74-A091-58EC4BB4CEBE}"/>
               </a:ext>
             </a:extLst>
           </p:cNvPr>
@@ -19052,7 +19109,7 @@
           <p:cNvPr id="47" name="">
             <a:extLst xmlns:a="http://schemas.openxmlformats.org/drawingml/2006/main">
               <a:ext uri="{FF2B5EF4-FFF2-40B4-BE49-F238E27FC236}">
-                <a16:creationId xmlns:a16="http://schemas.microsoft.com/office/drawing/2014/main" id="{66FAAF04-8A93-429E-B152-8A19DCEED571}"/>
+                <a16:creationId xmlns:a16="http://schemas.microsoft.com/office/drawing/2014/main" id="{B1855DC1-0B1C-48AF-8B2C-C2805BCDFCCB}"/>
               </a:ext>
             </a:extLst>
           </p:cNvPr>
@@ -19132,7 +19189,7 @@
           <p:cNvPr id="48" name="">
             <a:extLst xmlns:a="http://schemas.openxmlformats.org/drawingml/2006/main">
               <a:ext uri="{FF2B5EF4-FFF2-40B4-BE49-F238E27FC236}">
-                <a16:creationId xmlns:a16="http://schemas.microsoft.com/office/drawing/2014/main" id="{860022DF-409A-4789-8EC5-D957A812575C}"/>
+                <a16:creationId xmlns:a16="http://schemas.microsoft.com/office/drawing/2014/main" id="{8AB0E81F-7F31-4732-B469-214074A0520A}"/>
               </a:ext>
             </a:extLst>
           </p:cNvPr>
@@ -19162,7 +19219,7 @@
           <p:cNvPr id="49" name="">
             <a:extLst xmlns:a="http://schemas.openxmlformats.org/drawingml/2006/main">
               <a:ext uri="{FF2B5EF4-FFF2-40B4-BE49-F238E27FC236}">
-                <a16:creationId xmlns:a16="http://schemas.microsoft.com/office/drawing/2014/main" id="{D42CD3CF-A054-445A-B017-0CB43C255295}"/>
+                <a16:creationId xmlns:a16="http://schemas.microsoft.com/office/drawing/2014/main" id="{48126197-AFC0-4CDB-81B3-B5829C2B33DC}"/>
               </a:ext>
             </a:extLst>
           </p:cNvPr>
@@ -19192,7 +19249,7 @@
           <p:cNvPr id="50" name="">
             <a:extLst xmlns:a="http://schemas.openxmlformats.org/drawingml/2006/main">
               <a:ext uri="{FF2B5EF4-FFF2-40B4-BE49-F238E27FC236}">
-                <a16:creationId xmlns:a16="http://schemas.microsoft.com/office/drawing/2014/main" id="{19F9BD2E-9888-4554-B752-DF6A098D7C46}"/>
+                <a16:creationId xmlns:a16="http://schemas.microsoft.com/office/drawing/2014/main" id="{F62738CE-4B7D-4811-B8BB-8E04702A9289}"/>
               </a:ext>
             </a:extLst>
           </p:cNvPr>
@@ -19249,7 +19306,7 @@
           <p:cNvPr id="51" name="">
             <a:extLst xmlns:a="http://schemas.openxmlformats.org/drawingml/2006/main">
               <a:ext uri="{FF2B5EF4-FFF2-40B4-BE49-F238E27FC236}">
-                <a16:creationId xmlns:a16="http://schemas.microsoft.com/office/drawing/2014/main" id="{E5FA0676-7079-4B92-85F0-A18A9C1B9814}"/>
+                <a16:creationId xmlns:a16="http://schemas.microsoft.com/office/drawing/2014/main" id="{4DCA4FC7-C3F5-4340-9B9F-77DE56629674}"/>
               </a:ext>
             </a:extLst>
           </p:cNvPr>
@@ -19306,7 +19363,7 @@
           <p:cNvPr id="52" name="">
             <a:extLst xmlns:a="http://schemas.openxmlformats.org/drawingml/2006/main">
               <a:ext uri="{FF2B5EF4-FFF2-40B4-BE49-F238E27FC236}">
-                <a16:creationId xmlns:a16="http://schemas.microsoft.com/office/drawing/2014/main" id="{2A3C6A86-26FB-43AC-B8CA-FD0C244EE260}"/>
+                <a16:creationId xmlns:a16="http://schemas.microsoft.com/office/drawing/2014/main" id="{78EA62D1-B2F7-41B8-A5FF-C2C0A9679282}"/>
               </a:ext>
             </a:extLst>
           </p:cNvPr>
@@ -19386,7 +19443,7 @@
           <p:cNvPr id="53" name="">
             <a:extLst xmlns:a="http://schemas.openxmlformats.org/drawingml/2006/main">
               <a:ext uri="{FF2B5EF4-FFF2-40B4-BE49-F238E27FC236}">
-                <a16:creationId xmlns:a16="http://schemas.microsoft.com/office/drawing/2014/main" id="{432E8093-0C09-4090-8DFA-1AFBE2841B76}"/>
+                <a16:creationId xmlns:a16="http://schemas.microsoft.com/office/drawing/2014/main" id="{5C8FC8CB-EE61-4B36-9911-9020556CB082}"/>
               </a:ext>
             </a:extLst>
           </p:cNvPr>
@@ -19416,7 +19473,7 @@
           <p:cNvPr id="54" name="">
             <a:extLst xmlns:a="http://schemas.openxmlformats.org/drawingml/2006/main">
               <a:ext uri="{FF2B5EF4-FFF2-40B4-BE49-F238E27FC236}">
-                <a16:creationId xmlns:a16="http://schemas.microsoft.com/office/drawing/2014/main" id="{9B5DBCB2-5F3E-42E2-8475-A86D9AF25545}"/>
+                <a16:creationId xmlns:a16="http://schemas.microsoft.com/office/drawing/2014/main" id="{78BC831F-C6AA-454D-ABB5-EBC61F360EA1}"/>
               </a:ext>
             </a:extLst>
           </p:cNvPr>
@@ -19446,7 +19503,7 @@
           <p:cNvPr id="55" name="">
             <a:extLst xmlns:a="http://schemas.openxmlformats.org/drawingml/2006/main">
               <a:ext uri="{FF2B5EF4-FFF2-40B4-BE49-F238E27FC236}">
-                <a16:creationId xmlns:a16="http://schemas.microsoft.com/office/drawing/2014/main" id="{1E1C1BF7-D01D-44BD-A72E-5C6073F9DD65}"/>
+                <a16:creationId xmlns:a16="http://schemas.microsoft.com/office/drawing/2014/main" id="{48CD07ED-4629-4C5A-BD4A-B3A8A909463C}"/>
               </a:ext>
             </a:extLst>
           </p:cNvPr>
@@ -19503,7 +19560,7 @@
           <p:cNvPr id="56" name="">
             <a:extLst xmlns:a="http://schemas.openxmlformats.org/drawingml/2006/main">
               <a:ext uri="{FF2B5EF4-FFF2-40B4-BE49-F238E27FC236}">
-                <a16:creationId xmlns:a16="http://schemas.microsoft.com/office/drawing/2014/main" id="{31AA5408-4085-4BA4-976A-4FE8C44207B5}"/>
+                <a16:creationId xmlns:a16="http://schemas.microsoft.com/office/drawing/2014/main" id="{456B9774-0CE8-4E99-B7AE-381372C7DD9C}"/>
               </a:ext>
             </a:extLst>
           </p:cNvPr>
@@ -19560,7 +19617,7 @@
           <p:cNvPr id="57" name="">
             <a:extLst xmlns:a="http://schemas.openxmlformats.org/drawingml/2006/main">
               <a:ext uri="{FF2B5EF4-FFF2-40B4-BE49-F238E27FC236}">
-                <a16:creationId xmlns:a16="http://schemas.microsoft.com/office/drawing/2014/main" id="{BAD7D620-A2BF-495C-9754-05C8C5A4F636}"/>
+                <a16:creationId xmlns:a16="http://schemas.microsoft.com/office/drawing/2014/main" id="{06452303-EDFC-4F2A-8704-2AF06273424B}"/>
               </a:ext>
             </a:extLst>
           </p:cNvPr>
@@ -19640,7 +19697,7 @@
           <p:cNvPr id="58" name="">
             <a:extLst xmlns:a="http://schemas.openxmlformats.org/drawingml/2006/main">
               <a:ext uri="{FF2B5EF4-FFF2-40B4-BE49-F238E27FC236}">
-                <a16:creationId xmlns:a16="http://schemas.microsoft.com/office/drawing/2014/main" id="{00798421-854C-4AB1-BF76-ACD04EA16D03}"/>
+                <a16:creationId xmlns:a16="http://schemas.microsoft.com/office/drawing/2014/main" id="{A1EA363B-8A57-4D48-B321-F7DA9FF795EB}"/>
               </a:ext>
             </a:extLst>
           </p:cNvPr>
@@ -19672,7 +19729,7 @@
           <p:cNvPr id="59" name="">
             <a:extLst xmlns:a="http://schemas.openxmlformats.org/drawingml/2006/main">
               <a:ext uri="{FF2B5EF4-FFF2-40B4-BE49-F238E27FC236}">
-                <a16:creationId xmlns:a16="http://schemas.microsoft.com/office/drawing/2014/main" id="{59323B60-07AC-44DB-B326-BF0FCF0E86E2}"/>
+                <a16:creationId xmlns:a16="http://schemas.microsoft.com/office/drawing/2014/main" id="{E0CBD234-018D-4CCA-89B8-286938FBCCEE}"/>
               </a:ext>
             </a:extLst>
           </p:cNvPr>
@@ -19752,7 +19809,7 @@
           <p:cNvPr id="60" name="">
             <a:extLst xmlns:a="http://schemas.openxmlformats.org/drawingml/2006/main">
               <a:ext uri="{FF2B5EF4-FFF2-40B4-BE49-F238E27FC236}">
-                <a16:creationId xmlns:a16="http://schemas.microsoft.com/office/drawing/2014/main" id="{4BFCFDF4-9601-4B78-96C9-570094CC87F0}"/>
+                <a16:creationId xmlns:a16="http://schemas.microsoft.com/office/drawing/2014/main" id="{57A760AE-3083-45A7-AE43-710380D28AF4}"/>
               </a:ext>
             </a:extLst>
           </p:cNvPr>
@@ -21056,7 +21113,7 @@
           <p:cNvPr id="26" name="">
             <a:extLst xmlns:a="http://schemas.openxmlformats.org/drawingml/2006/main">
               <a:ext uri="{FF2B5EF4-FFF2-40B4-BE49-F238E27FC236}">
-                <a16:creationId xmlns:a16="http://schemas.microsoft.com/office/drawing/2014/main" id="{E71DD544-720A-415C-B9D9-F36C76EBB124}"/>
+                <a16:creationId xmlns:a16="http://schemas.microsoft.com/office/drawing/2014/main" id="{D056A63D-DE41-4894-B5EF-441D483DC3BE}"/>
               </a:ext>
             </a:extLst>
           </p:cNvPr>
@@ -21086,7 +21143,7 @@
           <p:cNvPr id="27" name="">
             <a:extLst xmlns:a="http://schemas.openxmlformats.org/drawingml/2006/main">
               <a:ext uri="{FF2B5EF4-FFF2-40B4-BE49-F238E27FC236}">
-                <a16:creationId xmlns:a16="http://schemas.microsoft.com/office/drawing/2014/main" id="{C9358991-9CD5-4B7E-BA2E-3E1AA1C702CE}"/>
+                <a16:creationId xmlns:a16="http://schemas.microsoft.com/office/drawing/2014/main" id="{46308225-5FB3-45A3-9FCE-3735C84D67E5}"/>
               </a:ext>
             </a:extLst>
           </p:cNvPr>
@@ -21143,7 +21200,7 @@
           <p:cNvPr id="28" name="">
             <a:extLst xmlns:a="http://schemas.openxmlformats.org/drawingml/2006/main">
               <a:ext uri="{FF2B5EF4-FFF2-40B4-BE49-F238E27FC236}">
-                <a16:creationId xmlns:a16="http://schemas.microsoft.com/office/drawing/2014/main" id="{FA931439-5EE6-41A7-8863-89597E0C4963}"/>
+                <a16:creationId xmlns:a16="http://schemas.microsoft.com/office/drawing/2014/main" id="{E246A073-FBF4-4227-8625-F16359BF6BDC}"/>
               </a:ext>
             </a:extLst>
           </p:cNvPr>
@@ -21200,7 +21257,7 @@
           <p:cNvPr id="29" name="">
             <a:extLst xmlns:a="http://schemas.openxmlformats.org/drawingml/2006/main">
               <a:ext uri="{FF2B5EF4-FFF2-40B4-BE49-F238E27FC236}">
-                <a16:creationId xmlns:a16="http://schemas.microsoft.com/office/drawing/2014/main" id="{8C191C58-E31E-4519-8333-75492D57382E}"/>
+                <a16:creationId xmlns:a16="http://schemas.microsoft.com/office/drawing/2014/main" id="{C05B2570-CC77-4617-8CB2-0C12E51C4A74}"/>
               </a:ext>
             </a:extLst>
           </p:cNvPr>
@@ -21257,7 +21314,7 @@
           <p:cNvPr id="30" name="">
             <a:extLst xmlns:a="http://schemas.openxmlformats.org/drawingml/2006/main">
               <a:ext uri="{FF2B5EF4-FFF2-40B4-BE49-F238E27FC236}">
-                <a16:creationId xmlns:a16="http://schemas.microsoft.com/office/drawing/2014/main" id="{5A1704F8-3075-4B28-9373-7FB9A8F0887D}"/>
+                <a16:creationId xmlns:a16="http://schemas.microsoft.com/office/drawing/2014/main" id="{9241028F-EBF1-4291-AC53-59C297660795}"/>
               </a:ext>
             </a:extLst>
           </p:cNvPr>
@@ -21314,7 +21371,7 @@
           <p:cNvPr id="31" name="">
             <a:extLst xmlns:a="http://schemas.openxmlformats.org/drawingml/2006/main">
               <a:ext uri="{FF2B5EF4-FFF2-40B4-BE49-F238E27FC236}">
-                <a16:creationId xmlns:a16="http://schemas.microsoft.com/office/drawing/2014/main" id="{2C959646-6610-4858-87EE-9FEDE02DF322}"/>
+                <a16:creationId xmlns:a16="http://schemas.microsoft.com/office/drawing/2014/main" id="{F3964160-B616-4F38-A87C-042F92D7152B}"/>
               </a:ext>
             </a:extLst>
           </p:cNvPr>
@@ -21344,7 +21401,7 @@
           <p:cNvPr id="32" name="">
             <a:extLst xmlns:a="http://schemas.openxmlformats.org/drawingml/2006/main">
               <a:ext uri="{FF2B5EF4-FFF2-40B4-BE49-F238E27FC236}">
-                <a16:creationId xmlns:a16="http://schemas.microsoft.com/office/drawing/2014/main" id="{84714960-D7AE-4387-A2A4-6166F7DE059C}"/>
+                <a16:creationId xmlns:a16="http://schemas.microsoft.com/office/drawing/2014/main" id="{4A4234A7-EA0E-4889-91C3-A18843228956}"/>
               </a:ext>
             </a:extLst>
           </p:cNvPr>
@@ -21378,7 +21435,7 @@
           <p:cNvPr id="33" name="">
             <a:extLst xmlns:a="http://schemas.openxmlformats.org/drawingml/2006/main">
               <a:ext uri="{FF2B5EF4-FFF2-40B4-BE49-F238E27FC236}">
-                <a16:creationId xmlns:a16="http://schemas.microsoft.com/office/drawing/2014/main" id="{C665A722-9E1F-4C26-AFA7-8EAF6D5C6B58}"/>
+                <a16:creationId xmlns:a16="http://schemas.microsoft.com/office/drawing/2014/main" id="{1A9B9104-FDB4-465A-957D-1D0FC158754E}"/>
               </a:ext>
             </a:extLst>
           </p:cNvPr>
@@ -21412,7 +21469,7 @@
           <p:cNvPr id="34" name="">
             <a:extLst xmlns:a="http://schemas.openxmlformats.org/drawingml/2006/main">
               <a:ext uri="{FF2B5EF4-FFF2-40B4-BE49-F238E27FC236}">
-                <a16:creationId xmlns:a16="http://schemas.microsoft.com/office/drawing/2014/main" id="{B7FF0442-1C04-4757-8771-7E4B29E2F1FB}"/>
+                <a16:creationId xmlns:a16="http://schemas.microsoft.com/office/drawing/2014/main" id="{7F67F471-736A-44BD-AC09-9C66922A291D}"/>
               </a:ext>
             </a:extLst>
           </p:cNvPr>
@@ -21469,7 +21526,7 @@
           <p:cNvPr id="35" name="">
             <a:extLst xmlns:a="http://schemas.openxmlformats.org/drawingml/2006/main">
               <a:ext uri="{FF2B5EF4-FFF2-40B4-BE49-F238E27FC236}">
-                <a16:creationId xmlns:a16="http://schemas.microsoft.com/office/drawing/2014/main" id="{D382E1F0-0E5C-4378-B682-3A022F4BAC9C}"/>
+                <a16:creationId xmlns:a16="http://schemas.microsoft.com/office/drawing/2014/main" id="{A38CF3B4-2B1C-4396-99EF-5CFE8E1D98D1}"/>
               </a:ext>
             </a:extLst>
           </p:cNvPr>
@@ -21549,7 +21606,7 @@
           <p:cNvPr id="36" name="">
             <a:extLst xmlns:a="http://schemas.openxmlformats.org/drawingml/2006/main">
               <a:ext uri="{FF2B5EF4-FFF2-40B4-BE49-F238E27FC236}">
-                <a16:creationId xmlns:a16="http://schemas.microsoft.com/office/drawing/2014/main" id="{EE6CB31E-6AA6-4F00-B4C8-BF45A0B2D6A8}"/>
+                <a16:creationId xmlns:a16="http://schemas.microsoft.com/office/drawing/2014/main" id="{FA06A4DE-AA43-4F2B-B52A-91B749267FF7}"/>
               </a:ext>
             </a:extLst>
           </p:cNvPr>
@@ -21606,7 +21663,7 @@
           <p:cNvPr id="37" name="">
             <a:extLst xmlns:a="http://schemas.openxmlformats.org/drawingml/2006/main">
               <a:ext uri="{FF2B5EF4-FFF2-40B4-BE49-F238E27FC236}">
-                <a16:creationId xmlns:a16="http://schemas.microsoft.com/office/drawing/2014/main" id="{CE89FADF-0B6F-440D-A5D6-88892D569D50}"/>
+                <a16:creationId xmlns:a16="http://schemas.microsoft.com/office/drawing/2014/main" id="{7B8BD66D-78B9-46B5-9EB7-F09D530CB81E}"/>
               </a:ext>
             </a:extLst>
           </p:cNvPr>
@@ -21638,7 +21695,7 @@
           <p:cNvPr id="38" name="">
             <a:extLst xmlns:a="http://schemas.openxmlformats.org/drawingml/2006/main">
               <a:ext uri="{FF2B5EF4-FFF2-40B4-BE49-F238E27FC236}">
-                <a16:creationId xmlns:a16="http://schemas.microsoft.com/office/drawing/2014/main" id="{FCECD796-111D-46A6-A8A6-AA4CA29C9D25}"/>
+                <a16:creationId xmlns:a16="http://schemas.microsoft.com/office/drawing/2014/main" id="{88DF17A6-96C6-4101-90DF-6AF7A6A1790C}"/>
               </a:ext>
             </a:extLst>
           </p:cNvPr>
@@ -21695,7 +21752,7 @@
           <p:cNvPr id="39" name="">
             <a:extLst xmlns:a="http://schemas.openxmlformats.org/drawingml/2006/main">
               <a:ext uri="{FF2B5EF4-FFF2-40B4-BE49-F238E27FC236}">
-                <a16:creationId xmlns:a16="http://schemas.microsoft.com/office/drawing/2014/main" id="{6280B796-6727-4511-B1E0-8153F6C72180}"/>
+                <a16:creationId xmlns:a16="http://schemas.microsoft.com/office/drawing/2014/main" id="{09731691-A115-4F6B-B670-CF7591BDD142}"/>
               </a:ext>
             </a:extLst>
           </p:cNvPr>
@@ -21752,7 +21809,7 @@
           <p:cNvPr id="40" name="">
             <a:extLst xmlns:a="http://schemas.openxmlformats.org/drawingml/2006/main">
               <a:ext uri="{FF2B5EF4-FFF2-40B4-BE49-F238E27FC236}">
-                <a16:creationId xmlns:a16="http://schemas.microsoft.com/office/drawing/2014/main" id="{153074DD-1822-43E4-82AD-9B54DE8DEB66}"/>
+                <a16:creationId xmlns:a16="http://schemas.microsoft.com/office/drawing/2014/main" id="{81A4F90F-8F26-4E3A-8C9C-CA10D5B905E7}"/>
               </a:ext>
             </a:extLst>
           </p:cNvPr>
@@ -21832,7 +21889,7 @@
           <p:cNvPr id="41" name="">
             <a:extLst xmlns:a="http://schemas.openxmlformats.org/drawingml/2006/main">
               <a:ext uri="{FF2B5EF4-FFF2-40B4-BE49-F238E27FC236}">
-                <a16:creationId xmlns:a16="http://schemas.microsoft.com/office/drawing/2014/main" id="{4958A960-D87E-4927-9BA6-77B73397F3D6}"/>
+                <a16:creationId xmlns:a16="http://schemas.microsoft.com/office/drawing/2014/main" id="{77B499C7-5CA1-4D33-A2AB-80FF4E3520BF}"/>
               </a:ext>
             </a:extLst>
           </p:cNvPr>
@@ -21889,7 +21946,7 @@
           <p:cNvPr id="42" name="">
             <a:extLst xmlns:a="http://schemas.openxmlformats.org/drawingml/2006/main">
               <a:ext uri="{FF2B5EF4-FFF2-40B4-BE49-F238E27FC236}">
-                <a16:creationId xmlns:a16="http://schemas.microsoft.com/office/drawing/2014/main" id="{7F900AB7-CFA4-4D97-B31E-70A4A42798A4}"/>
+                <a16:creationId xmlns:a16="http://schemas.microsoft.com/office/drawing/2014/main" id="{92E9AD5A-BADB-4710-BFB9-B11D6FDE2B87}"/>
               </a:ext>
             </a:extLst>
           </p:cNvPr>
@@ -21921,7 +21978,7 @@
           <p:cNvPr id="43" name="">
             <a:extLst xmlns:a="http://schemas.openxmlformats.org/drawingml/2006/main">
               <a:ext uri="{FF2B5EF4-FFF2-40B4-BE49-F238E27FC236}">
-                <a16:creationId xmlns:a16="http://schemas.microsoft.com/office/drawing/2014/main" id="{3ACD40BB-60A2-4AE7-9B0C-6B944C96E76A}"/>
+                <a16:creationId xmlns:a16="http://schemas.microsoft.com/office/drawing/2014/main" id="{8DD28469-5B68-4124-9FA9-AA59677B9234}"/>
               </a:ext>
             </a:extLst>
           </p:cNvPr>
@@ -21978,7 +22035,7 @@
           <p:cNvPr id="44" name="">
             <a:extLst xmlns:a="http://schemas.openxmlformats.org/drawingml/2006/main">
               <a:ext uri="{FF2B5EF4-FFF2-40B4-BE49-F238E27FC236}">
-                <a16:creationId xmlns:a16="http://schemas.microsoft.com/office/drawing/2014/main" id="{95C0C1DA-B5C2-4390-AB68-792B2986CE52}"/>
+                <a16:creationId xmlns:a16="http://schemas.microsoft.com/office/drawing/2014/main" id="{E93FFD2A-96B1-4F52-BEEF-4530937A8A99}"/>
               </a:ext>
             </a:extLst>
           </p:cNvPr>
@@ -22010,7 +22067,7 @@
           <p:cNvPr id="45" name="">
             <a:extLst xmlns:a="http://schemas.openxmlformats.org/drawingml/2006/main">
               <a:ext uri="{FF2B5EF4-FFF2-40B4-BE49-F238E27FC236}">
-                <a16:creationId xmlns:a16="http://schemas.microsoft.com/office/drawing/2014/main" id="{8DFD56FF-05A1-4330-9954-C674EB06502C}"/>
+                <a16:creationId xmlns:a16="http://schemas.microsoft.com/office/drawing/2014/main" id="{12EF6C6F-0974-4857-B8FC-A5B5D6814990}"/>
               </a:ext>
             </a:extLst>
           </p:cNvPr>
@@ -22067,7 +22124,7 @@
           <p:cNvPr id="46" name="">
             <a:extLst xmlns:a="http://schemas.openxmlformats.org/drawingml/2006/main">
               <a:ext uri="{FF2B5EF4-FFF2-40B4-BE49-F238E27FC236}">
-                <a16:creationId xmlns:a16="http://schemas.microsoft.com/office/drawing/2014/main" id="{8F4F230E-5061-4661-B6C9-297C59A14E27}"/>
+                <a16:creationId xmlns:a16="http://schemas.microsoft.com/office/drawing/2014/main" id="{C7A6CD35-DF35-4036-B0CA-F5CE5754E840}"/>
               </a:ext>
             </a:extLst>
           </p:cNvPr>
@@ -22146,7 +22203,7 @@
           <p:cNvPr id="29" name="">
             <a:extLst xmlns:a="http://schemas.openxmlformats.org/drawingml/2006/main">
               <a:ext uri="{FF2B5EF4-FFF2-40B4-BE49-F238E27FC236}">
-                <a16:creationId xmlns:a16="http://schemas.microsoft.com/office/drawing/2014/main" id="{89163915-E413-4F7D-BAEF-1133CECBF7B8}"/>
+                <a16:creationId xmlns:a16="http://schemas.microsoft.com/office/drawing/2014/main" id="{56F5F5F5-91F5-49ED-9C3F-8E92FC7309E7}"/>
               </a:ext>
             </a:extLst>
           </p:cNvPr>
@@ -22176,7 +22233,7 @@
           <p:cNvPr id="2" name="">
             <a:extLst xmlns:a="http://schemas.openxmlformats.org/drawingml/2006/main">
               <a:ext uri="{FF2B5EF4-FFF2-40B4-BE49-F238E27FC236}">
-                <a16:creationId xmlns:a16="http://schemas.microsoft.com/office/drawing/2014/main" id="{BCF81911-0B08-4066-927F-CABB7503283D}"/>
+                <a16:creationId xmlns:a16="http://schemas.microsoft.com/office/drawing/2014/main" id="{9B5EF703-7191-4673-877A-BDC926240FB9}"/>
               </a:ext>
             </a:extLst>
           </p:cNvPr>
@@ -22233,7 +22290,7 @@
           <p:cNvPr id="3" name="">
             <a:extLst xmlns:a="http://schemas.openxmlformats.org/drawingml/2006/main">
               <a:ext uri="{FF2B5EF4-FFF2-40B4-BE49-F238E27FC236}">
-                <a16:creationId xmlns:a16="http://schemas.microsoft.com/office/drawing/2014/main" id="{EF8FCB23-97D4-4D30-8E44-3B7D0F0A838D}"/>
+                <a16:creationId xmlns:a16="http://schemas.microsoft.com/office/drawing/2014/main" id="{529B4C06-3D07-46C9-8103-232D7D0004F5}"/>
               </a:ext>
             </a:extLst>
           </p:cNvPr>
@@ -22290,7 +22347,7 @@
           <p:cNvPr id="4" name="">
             <a:extLst xmlns:a="http://schemas.openxmlformats.org/drawingml/2006/main">
               <a:ext uri="{FF2B5EF4-FFF2-40B4-BE49-F238E27FC236}">
-                <a16:creationId xmlns:a16="http://schemas.microsoft.com/office/drawing/2014/main" id="{AB9DB70B-D18A-4D7B-85E1-BEB5A02DF942}"/>
+                <a16:creationId xmlns:a16="http://schemas.microsoft.com/office/drawing/2014/main" id="{1E1826AB-96B1-4388-9987-BE4FB4B749E2}"/>
               </a:ext>
             </a:extLst>
           </p:cNvPr>
@@ -22347,7 +22404,7 @@
           <p:cNvPr id="5" name="">
             <a:extLst xmlns:a="http://schemas.openxmlformats.org/drawingml/2006/main">
               <a:ext uri="{FF2B5EF4-FFF2-40B4-BE49-F238E27FC236}">
-                <a16:creationId xmlns:a16="http://schemas.microsoft.com/office/drawing/2014/main" id="{83E9DABF-7886-43AB-9568-EAA1C551CFEB}"/>
+                <a16:creationId xmlns:a16="http://schemas.microsoft.com/office/drawing/2014/main" id="{CAD13D53-1DC4-4FF4-80CA-C3A21F2F506C}"/>
               </a:ext>
             </a:extLst>
           </p:cNvPr>
@@ -22404,7 +22461,7 @@
           <p:cNvPr id="6" name="">
             <a:extLst xmlns:a="http://schemas.openxmlformats.org/drawingml/2006/main">
               <a:ext uri="{FF2B5EF4-FFF2-40B4-BE49-F238E27FC236}">
-                <a16:creationId xmlns:a16="http://schemas.microsoft.com/office/drawing/2014/main" id="{F7DFC767-171C-4044-BCFA-91F61A4B923A}"/>
+                <a16:creationId xmlns:a16="http://schemas.microsoft.com/office/drawing/2014/main" id="{ED652E22-19BF-4DDE-B7F9-E1D317EEFBA4}"/>
               </a:ext>
             </a:extLst>
           </p:cNvPr>
@@ -22434,7 +22491,7 @@
           <p:cNvPr id="7" name="">
             <a:extLst xmlns:a="http://schemas.openxmlformats.org/drawingml/2006/main">
               <a:ext uri="{FF2B5EF4-FFF2-40B4-BE49-F238E27FC236}">
-                <a16:creationId xmlns:a16="http://schemas.microsoft.com/office/drawing/2014/main" id="{4CCE1B46-0520-40C1-8634-F3C7F074ABE6}"/>
+                <a16:creationId xmlns:a16="http://schemas.microsoft.com/office/drawing/2014/main" id="{6BA9A7E2-CC3B-4577-96F0-5CA50E9413D6}"/>
               </a:ext>
             </a:extLst>
           </p:cNvPr>
@@ -22466,7 +22523,7 @@
           <p:cNvPr id="8" name="">
             <a:extLst xmlns:a="http://schemas.openxmlformats.org/drawingml/2006/main">
               <a:ext uri="{FF2B5EF4-FFF2-40B4-BE49-F238E27FC236}">
-                <a16:creationId xmlns:a16="http://schemas.microsoft.com/office/drawing/2014/main" id="{E7D816B0-33B0-47F1-B0D9-9BFA248F4D9F}"/>
+                <a16:creationId xmlns:a16="http://schemas.microsoft.com/office/drawing/2014/main" id="{BDBA99F7-BA32-4F0D-9634-378E9AAFBAFA}"/>
               </a:ext>
             </a:extLst>
           </p:cNvPr>
@@ -22523,7 +22580,7 @@
           <p:cNvPr id="9" name="">
             <a:extLst xmlns:a="http://schemas.openxmlformats.org/drawingml/2006/main">
               <a:ext uri="{FF2B5EF4-FFF2-40B4-BE49-F238E27FC236}">
-                <a16:creationId xmlns:a16="http://schemas.microsoft.com/office/drawing/2014/main" id="{4446B95A-FF64-415E-8DE1-182FF4D024FF}"/>
+                <a16:creationId xmlns:a16="http://schemas.microsoft.com/office/drawing/2014/main" id="{53094566-1628-47A0-870C-9F7BF4C26ADF}"/>
               </a:ext>
             </a:extLst>
           </p:cNvPr>
@@ -22557,7 +22614,7 @@
           <p:cNvPr id="10" name="">
             <a:extLst xmlns:a="http://schemas.openxmlformats.org/drawingml/2006/main">
               <a:ext uri="{FF2B5EF4-FFF2-40B4-BE49-F238E27FC236}">
-                <a16:creationId xmlns:a16="http://schemas.microsoft.com/office/drawing/2014/main" id="{C9280428-4E3C-4ACE-9143-0482DEB1C4DD}"/>
+                <a16:creationId xmlns:a16="http://schemas.microsoft.com/office/drawing/2014/main" id="{DFFAB73C-048A-4E9C-B2C9-AC03924200B7}"/>
               </a:ext>
             </a:extLst>
           </p:cNvPr>
@@ -22589,7 +22646,7 @@
           <p:cNvPr id="11" name="">
             <a:extLst xmlns:a="http://schemas.openxmlformats.org/drawingml/2006/main">
               <a:ext uri="{FF2B5EF4-FFF2-40B4-BE49-F238E27FC236}">
-                <a16:creationId xmlns:a16="http://schemas.microsoft.com/office/drawing/2014/main" id="{11499B3D-1ADA-46F1-8C12-2DF6BAED1F09}"/>
+                <a16:creationId xmlns:a16="http://schemas.microsoft.com/office/drawing/2014/main" id="{B6BCAEC2-CB6A-4559-BDCF-DEF6E9C158F6}"/>
               </a:ext>
             </a:extLst>
           </p:cNvPr>
@@ -22646,7 +22703,7 @@
           <p:cNvPr id="12" name="">
             <a:extLst xmlns:a="http://schemas.openxmlformats.org/drawingml/2006/main">
               <a:ext uri="{FF2B5EF4-FFF2-40B4-BE49-F238E27FC236}">
-                <a16:creationId xmlns:a16="http://schemas.microsoft.com/office/drawing/2014/main" id="{FD62DE0A-50A7-44FF-9764-E83CF9A9D648}"/>
+                <a16:creationId xmlns:a16="http://schemas.microsoft.com/office/drawing/2014/main" id="{CBFCCB38-8978-437D-987B-8FCB5E63A30B}"/>
               </a:ext>
             </a:extLst>
           </p:cNvPr>
@@ -22726,7 +22783,7 @@
           <p:cNvPr id="13" name="">
             <a:extLst xmlns:a="http://schemas.openxmlformats.org/drawingml/2006/main">
               <a:ext uri="{FF2B5EF4-FFF2-40B4-BE49-F238E27FC236}">
-                <a16:creationId xmlns:a16="http://schemas.microsoft.com/office/drawing/2014/main" id="{A1F992CF-498D-442E-A9F6-4B2FEA5DA368}"/>
+                <a16:creationId xmlns:a16="http://schemas.microsoft.com/office/drawing/2014/main" id="{0332740A-A479-45E3-B632-E7C5A162A3E0}"/>
               </a:ext>
             </a:extLst>
           </p:cNvPr>
@@ -22806,7 +22863,7 @@
           <p:cNvPr id="14" name="">
             <a:extLst xmlns:a="http://schemas.openxmlformats.org/drawingml/2006/main">
               <a:ext uri="{FF2B5EF4-FFF2-40B4-BE49-F238E27FC236}">
-                <a16:creationId xmlns:a16="http://schemas.microsoft.com/office/drawing/2014/main" id="{369CDF04-183F-4545-90A5-DC27FD8C33BC}"/>
+                <a16:creationId xmlns:a16="http://schemas.microsoft.com/office/drawing/2014/main" id="{CCB8CEEE-75D0-47FF-8C55-AF5AEA878A1D}"/>
               </a:ext>
             </a:extLst>
           </p:cNvPr>
@@ -22863,7 +22920,7 @@
           <p:cNvPr id="15" name="">
             <a:extLst xmlns:a="http://schemas.openxmlformats.org/drawingml/2006/main">
               <a:ext uri="{FF2B5EF4-FFF2-40B4-BE49-F238E27FC236}">
-                <a16:creationId xmlns:a16="http://schemas.microsoft.com/office/drawing/2014/main" id="{E5DED342-8BC9-44F3-A7D1-7E4B79BD7A69}"/>
+                <a16:creationId xmlns:a16="http://schemas.microsoft.com/office/drawing/2014/main" id="{3B5DE31F-E0EC-46A2-A7FE-342AF868CC9C}"/>
               </a:ext>
             </a:extLst>
           </p:cNvPr>
@@ -22897,7 +22954,7 @@
           <p:cNvPr id="16" name="">
             <a:extLst xmlns:a="http://schemas.openxmlformats.org/drawingml/2006/main">
               <a:ext uri="{FF2B5EF4-FFF2-40B4-BE49-F238E27FC236}">
-                <a16:creationId xmlns:a16="http://schemas.microsoft.com/office/drawing/2014/main" id="{913766C8-8BFF-463A-A09E-34C61EEAB715}"/>
+                <a16:creationId xmlns:a16="http://schemas.microsoft.com/office/drawing/2014/main" id="{8C923536-45E7-4A85-931F-E9208E9FEE9A}"/>
               </a:ext>
             </a:extLst>
           </p:cNvPr>
@@ -22929,7 +22986,7 @@
           <p:cNvPr id="17" name="">
             <a:extLst xmlns:a="http://schemas.openxmlformats.org/drawingml/2006/main">
               <a:ext uri="{FF2B5EF4-FFF2-40B4-BE49-F238E27FC236}">
-                <a16:creationId xmlns:a16="http://schemas.microsoft.com/office/drawing/2014/main" id="{8525D018-963A-4EDF-92FB-0C35D0A1BF8C}"/>
+                <a16:creationId xmlns:a16="http://schemas.microsoft.com/office/drawing/2014/main" id="{C296FCAE-6E6F-47D2-9AF7-7EAA72091426}"/>
               </a:ext>
             </a:extLst>
           </p:cNvPr>
@@ -22986,7 +23043,7 @@
           <p:cNvPr id="18" name="">
             <a:extLst xmlns:a="http://schemas.openxmlformats.org/drawingml/2006/main">
               <a:ext uri="{FF2B5EF4-FFF2-40B4-BE49-F238E27FC236}">
-                <a16:creationId xmlns:a16="http://schemas.microsoft.com/office/drawing/2014/main" id="{EB8CA945-4699-47DB-9EB8-E0132FE76DA8}"/>
+                <a16:creationId xmlns:a16="http://schemas.microsoft.com/office/drawing/2014/main" id="{DBD321E5-22A5-4A10-A91B-7107C6FF957E}"/>
               </a:ext>
             </a:extLst>
           </p:cNvPr>
@@ -23066,7 +23123,7 @@
           <p:cNvPr id="19" name="">
             <a:extLst xmlns:a="http://schemas.openxmlformats.org/drawingml/2006/main">
               <a:ext uri="{FF2B5EF4-FFF2-40B4-BE49-F238E27FC236}">
-                <a16:creationId xmlns:a16="http://schemas.microsoft.com/office/drawing/2014/main" id="{4DABC403-0D22-475B-A773-F02ABD8EE337}"/>
+                <a16:creationId xmlns:a16="http://schemas.microsoft.com/office/drawing/2014/main" id="{61138675-F1B5-4CC1-B85A-DC2D5BA452C2}"/>
               </a:ext>
             </a:extLst>
           </p:cNvPr>
@@ -23146,7 +23203,7 @@
           <p:cNvPr id="20" name="">
             <a:extLst xmlns:a="http://schemas.openxmlformats.org/drawingml/2006/main">
               <a:ext uri="{FF2B5EF4-FFF2-40B4-BE49-F238E27FC236}">
-                <a16:creationId xmlns:a16="http://schemas.microsoft.com/office/drawing/2014/main" id="{79E2C17B-2C68-44DB-984E-6B279253646D}"/>
+                <a16:creationId xmlns:a16="http://schemas.microsoft.com/office/drawing/2014/main" id="{2F7A86F4-6BEB-4F94-8705-300EF15C9372}"/>
               </a:ext>
             </a:extLst>
           </p:cNvPr>
@@ -23180,7 +23237,7 @@
           <p:cNvPr id="21" name="">
             <a:extLst xmlns:a="http://schemas.openxmlformats.org/drawingml/2006/main">
               <a:ext uri="{FF2B5EF4-FFF2-40B4-BE49-F238E27FC236}">
-                <a16:creationId xmlns:a16="http://schemas.microsoft.com/office/drawing/2014/main" id="{BA692FAF-CFBF-4EC6-A15F-2CA52441D46E}"/>
+                <a16:creationId xmlns:a16="http://schemas.microsoft.com/office/drawing/2014/main" id="{AAA5631D-7D1F-4CB2-80E3-744968357E64}"/>
               </a:ext>
             </a:extLst>
           </p:cNvPr>
@@ -23212,7 +23269,7 @@
           <p:cNvPr id="22" name="">
             <a:extLst xmlns:a="http://schemas.openxmlformats.org/drawingml/2006/main">
               <a:ext uri="{FF2B5EF4-FFF2-40B4-BE49-F238E27FC236}">
-                <a16:creationId xmlns:a16="http://schemas.microsoft.com/office/drawing/2014/main" id="{40BB36D7-7CD5-44AE-87FE-21BC4DBE98FC}"/>
+                <a16:creationId xmlns:a16="http://schemas.microsoft.com/office/drawing/2014/main" id="{CAC00915-67BE-495A-BDB8-56825E7CDA49}"/>
               </a:ext>
             </a:extLst>
           </p:cNvPr>
@@ -23269,7 +23326,7 @@
           <p:cNvPr id="23" name="">
             <a:extLst xmlns:a="http://schemas.openxmlformats.org/drawingml/2006/main">
               <a:ext uri="{FF2B5EF4-FFF2-40B4-BE49-F238E27FC236}">
-                <a16:creationId xmlns:a16="http://schemas.microsoft.com/office/drawing/2014/main" id="{6853A022-D3C2-4663-9D8C-A21FD589491A}"/>
+                <a16:creationId xmlns:a16="http://schemas.microsoft.com/office/drawing/2014/main" id="{0CE109A0-BDE6-427C-9C58-F00438D22D67}"/>
               </a:ext>
             </a:extLst>
           </p:cNvPr>
@@ -23349,7 +23406,7 @@
           <p:cNvPr id="24" name="">
             <a:extLst xmlns:a="http://schemas.openxmlformats.org/drawingml/2006/main">
               <a:ext uri="{FF2B5EF4-FFF2-40B4-BE49-F238E27FC236}">
-                <a16:creationId xmlns:a16="http://schemas.microsoft.com/office/drawing/2014/main" id="{A39006C5-91F7-4892-A992-3FB74A11C129}"/>
+                <a16:creationId xmlns:a16="http://schemas.microsoft.com/office/drawing/2014/main" id="{E4A8EF82-771A-4738-9434-049C304312F8}"/>
               </a:ext>
             </a:extLst>
           </p:cNvPr>
@@ -23429,7 +23486,7 @@
           <p:cNvPr id="25" name="">
             <a:extLst xmlns:a="http://schemas.openxmlformats.org/drawingml/2006/main">
               <a:ext uri="{FF2B5EF4-FFF2-40B4-BE49-F238E27FC236}">
-                <a16:creationId xmlns:a16="http://schemas.microsoft.com/office/drawing/2014/main" id="{E40C2E33-4CAB-426E-B0B1-7EBD431637ED}"/>
+                <a16:creationId xmlns:a16="http://schemas.microsoft.com/office/drawing/2014/main" id="{558D5FDA-D887-4A0D-943C-01F8A71CB0B5}"/>
               </a:ext>
             </a:extLst>
           </p:cNvPr>
@@ -23486,23 +23543,23 @@
           <p:cNvPr id="26" name="">
             <a:extLst xmlns:a="http://schemas.openxmlformats.org/drawingml/2006/main">
               <a:ext uri="{FF2B5EF4-FFF2-40B4-BE49-F238E27FC236}">
-                <a16:creationId xmlns:a16="http://schemas.microsoft.com/office/drawing/2014/main" id="{93D3BAA3-7629-4ADC-B28D-B2E0A595ECBA}"/>
-              </a:ext>
-            </a:extLst>
-          </p:cNvPr>
-          <p:cNvSpPr>
-            <a:spLocks xmlns:a="http://schemas.openxmlformats.org/drawingml/2006/main" noGrp="1"/>
-          </p:cNvSpPr>
-          <p:nvPr/>
-        </p:nvSpPr>
-        <p:spPr>
-          <a:xfrm xmlns:a="http://schemas.openxmlformats.org/drawingml/2006/main">
-            <a:off x="1581150" y="5848350"/>
-            <a:ext cx="8648700" cy="419100"/>
+                <a16:creationId xmlns:a16="http://schemas.microsoft.com/office/drawing/2014/main" id="{66F4589D-5BF0-47CE-8A62-DCB430091E90}"/>
+              </a:ext>
+            </a:extLst>
+          </p:cNvPr>
+          <p:cNvSpPr>
+            <a:spLocks xmlns:a="http://schemas.openxmlformats.org/drawingml/2006/main" noGrp="1"/>
+          </p:cNvSpPr>
+          <p:nvPr/>
+        </p:nvSpPr>
+        <p:spPr>
+          <a:xfrm xmlns:a="http://schemas.openxmlformats.org/drawingml/2006/main">
+            <a:off x="1581150" y="5753100"/>
+            <a:ext cx="8648700" cy="571500"/>
           </a:xfrm>
           <a:prstGeom xmlns:a="http://schemas.openxmlformats.org/drawingml/2006/main" prst="roundRect">
             <a:avLst>
-              <a:gd name="adj" fmla="val 18182"/>
+              <a:gd name="adj" fmla="val 13333"/>
             </a:avLst>
           </a:prstGeom>
           <a:solidFill xmlns:a="http://schemas.openxmlformats.org/drawingml/2006/main">
@@ -23518,19 +23575,19 @@
           <p:cNvPr id="27" name="">
             <a:extLst xmlns:a="http://schemas.openxmlformats.org/drawingml/2006/main">
               <a:ext uri="{FF2B5EF4-FFF2-40B4-BE49-F238E27FC236}">
-                <a16:creationId xmlns:a16="http://schemas.microsoft.com/office/drawing/2014/main" id="{DDD1D4A2-08D2-4F95-9C2B-BCACF9B5AE5F}"/>
-              </a:ext>
-            </a:extLst>
-          </p:cNvPr>
-          <p:cNvSpPr>
-            <a:spLocks xmlns:a="http://schemas.openxmlformats.org/drawingml/2006/main" noGrp="1"/>
-          </p:cNvSpPr>
-          <p:nvPr/>
-        </p:nvSpPr>
-        <p:spPr>
-          <a:xfrm xmlns:a="http://schemas.openxmlformats.org/drawingml/2006/main">
-            <a:off x="1866900" y="5972175"/>
-            <a:ext cx="8077200" cy="171450"/>
+                <a16:creationId xmlns:a16="http://schemas.microsoft.com/office/drawing/2014/main" id="{7B1C3060-8B73-466E-AEFB-0F36226028F5}"/>
+              </a:ext>
+            </a:extLst>
+          </p:cNvPr>
+          <p:cNvSpPr>
+            <a:spLocks xmlns:a="http://schemas.openxmlformats.org/drawingml/2006/main" noGrp="1"/>
+          </p:cNvSpPr>
+          <p:nvPr/>
+        </p:nvSpPr>
+        <p:spPr>
+          <a:xfrm xmlns:a="http://schemas.openxmlformats.org/drawingml/2006/main">
+            <a:off x="1866900" y="5867400"/>
+            <a:ext cx="8077200" cy="361950"/>
           </a:xfrm>
           <a:prstGeom xmlns:a="http://schemas.openxmlformats.org/drawingml/2006/main" prst="rect">
             <a:avLst/>
@@ -23547,7 +23604,7 @@
           <a:lstStyle xmlns:a="http://schemas.openxmlformats.org/drawingml/2006/main"/>
           <a:p xmlns:a="http://schemas.openxmlformats.org/drawingml/2006/main">
             <a:pPr algn="ctr">
-              <a:defRPr sz="1050" b="1">
+              <a:defRPr sz="975" b="1">
                 <a:solidFill>
                   <a:srgbClr val="202A44"/>
                 </a:solidFill>
@@ -23557,7 +23614,7 @@
               </a:defRPr>
             </a:pPr>
             <a:r>
-              <a:rPr sz="1050" b="1">
+              <a:rPr sz="975" b="1">
                 <a:solidFill>
                   <a:srgbClr val="202A44"/>
                 </a:solidFill>
@@ -23565,7 +23622,30 @@
                 <a:ea typeface="Arial"/>
                 <a:cs typeface="Arial"/>
               </a:rPr>
-              <a:t>Future IVR is a non-AI telephony adapter: confirmed DTMF or speech codes go to the Java deterministic engine.</a:t>
+              <a:t>Future IVR: confirmed menu selections map to fixed codes.</a:t>
+            </a:r>
+          </a:p>
+          <a:p xmlns:a="http://schemas.openxmlformats.org/drawingml/2006/main">
+            <a:pPr algn="ctr">
+              <a:defRPr sz="975" b="1">
+                <a:solidFill>
+                  <a:srgbClr val="202A44"/>
+                </a:solidFill>
+                <a:latin typeface="Arial"/>
+                <a:ea typeface="Arial"/>
+                <a:cs typeface="Arial"/>
+              </a:defRPr>
+            </a:pPr>
+            <a:r>
+              <a:rPr sz="975" b="1">
+                <a:solidFill>
+                  <a:srgbClr val="202A44"/>
+                </a:solidFill>
+                <a:latin typeface="Arial"/>
+                <a:ea typeface="Arial"/>
+                <a:cs typeface="Arial"/>
+              </a:rPr>
+              <a:t>Future free text and medical documents: post-route context only. They cannot change the route.</a:t>
             </a:r>
           </a:p>
         </p:txBody>
@@ -23575,7 +23655,7 @@
           <p:cNvPr id="28" name="">
             <a:extLst xmlns:a="http://schemas.openxmlformats.org/drawingml/2006/main">
               <a:ext uri="{FF2B5EF4-FFF2-40B4-BE49-F238E27FC236}">
-                <a16:creationId xmlns:a16="http://schemas.microsoft.com/office/drawing/2014/main" id="{08425EE8-75E9-456A-8209-03E051E3C6F5}"/>
+                <a16:creationId xmlns:a16="http://schemas.microsoft.com/office/drawing/2014/main" id="{C0689F68-5175-4217-BAB0-19B887F43B7E}"/>
               </a:ext>
             </a:extLst>
           </p:cNvPr>
@@ -23630,7 +23710,7 @@
     </p:spTree>
     <p:extLst>
       <p:ext uri="{BB962C8B-B14F-4D97-AF65-F5344CB8AC3E}">
-        <p14:creationId xmlns:p14="http://schemas.microsoft.com/office/powerpoint/2010/main" val="444000715"/>
+        <p14:creationId xmlns:p14="http://schemas.microsoft.com/office/powerpoint/2010/main" val="112790876"/>
       </p:ext>
     </p:extLst>
   </p:cSld>
@@ -23654,7 +23734,7 @@
           <p:cNvPr id="44" name="">
             <a:extLst xmlns:a="http://schemas.openxmlformats.org/drawingml/2006/main">
               <a:ext uri="{FF2B5EF4-FFF2-40B4-BE49-F238E27FC236}">
-                <a16:creationId xmlns:a16="http://schemas.microsoft.com/office/drawing/2014/main" id="{7EE41111-1A01-457C-8BB9-372EF804B5BE}"/>
+                <a16:creationId xmlns:a16="http://schemas.microsoft.com/office/drawing/2014/main" id="{F2EBA14C-4775-42AD-ADF2-7DD7363957BF}"/>
               </a:ext>
             </a:extLst>
           </p:cNvPr>
@@ -23684,7 +23764,7 @@
           <p:cNvPr id="2" name="">
             <a:extLst xmlns:a="http://schemas.openxmlformats.org/drawingml/2006/main">
               <a:ext uri="{FF2B5EF4-FFF2-40B4-BE49-F238E27FC236}">
-                <a16:creationId xmlns:a16="http://schemas.microsoft.com/office/drawing/2014/main" id="{BC9C4CA0-E817-49F4-ADDE-98A2596252F1}"/>
+                <a16:creationId xmlns:a16="http://schemas.microsoft.com/office/drawing/2014/main" id="{9E57D1BE-2CCE-4ACC-B294-F0285CE2BC2F}"/>
               </a:ext>
             </a:extLst>
           </p:cNvPr>
@@ -23741,7 +23821,7 @@
           <p:cNvPr id="3" name="">
             <a:extLst xmlns:a="http://schemas.openxmlformats.org/drawingml/2006/main">
               <a:ext uri="{FF2B5EF4-FFF2-40B4-BE49-F238E27FC236}">
-                <a16:creationId xmlns:a16="http://schemas.microsoft.com/office/drawing/2014/main" id="{BF1E86B8-1AAD-499F-9147-4925CAD7DF45}"/>
+                <a16:creationId xmlns:a16="http://schemas.microsoft.com/office/drawing/2014/main" id="{12F4BACA-AA7E-4165-B53F-B6B8B0CAC740}"/>
               </a:ext>
             </a:extLst>
           </p:cNvPr>
@@ -23798,7 +23878,7 @@
           <p:cNvPr id="4" name="">
             <a:extLst xmlns:a="http://schemas.openxmlformats.org/drawingml/2006/main">
               <a:ext uri="{FF2B5EF4-FFF2-40B4-BE49-F238E27FC236}">
-                <a16:creationId xmlns:a16="http://schemas.microsoft.com/office/drawing/2014/main" id="{1CCF11C5-4164-4CB8-BBA0-96ED19EBD617}"/>
+                <a16:creationId xmlns:a16="http://schemas.microsoft.com/office/drawing/2014/main" id="{A96CEB0E-CA53-499C-A19E-A98772EDFB8B}"/>
               </a:ext>
             </a:extLst>
           </p:cNvPr>
@@ -23855,7 +23935,7 @@
           <p:cNvPr id="5" name="">
             <a:extLst xmlns:a="http://schemas.openxmlformats.org/drawingml/2006/main">
               <a:ext uri="{FF2B5EF4-FFF2-40B4-BE49-F238E27FC236}">
-                <a16:creationId xmlns:a16="http://schemas.microsoft.com/office/drawing/2014/main" id="{66C891B4-D11F-435E-89BE-204318330875}"/>
+                <a16:creationId xmlns:a16="http://schemas.microsoft.com/office/drawing/2014/main" id="{3A2AD247-2848-45C7-97F7-A99BD305B11F}"/>
               </a:ext>
             </a:extLst>
           </p:cNvPr>
@@ -23912,7 +23992,7 @@
           <p:cNvPr id="6" name="">
             <a:extLst xmlns:a="http://schemas.openxmlformats.org/drawingml/2006/main">
               <a:ext uri="{FF2B5EF4-FFF2-40B4-BE49-F238E27FC236}">
-                <a16:creationId xmlns:a16="http://schemas.microsoft.com/office/drawing/2014/main" id="{EFCAB98B-D850-4183-9C94-BC9D2C87BF4D}"/>
+                <a16:creationId xmlns:a16="http://schemas.microsoft.com/office/drawing/2014/main" id="{EFEA469E-3778-428F-A424-FD49C1DB23EC}"/>
               </a:ext>
             </a:extLst>
           </p:cNvPr>
@@ -23942,7 +24022,7 @@
           <p:cNvPr id="7" name="">
             <a:extLst xmlns:a="http://schemas.openxmlformats.org/drawingml/2006/main">
               <a:ext uri="{FF2B5EF4-FFF2-40B4-BE49-F238E27FC236}">
-                <a16:creationId xmlns:a16="http://schemas.microsoft.com/office/drawing/2014/main" id="{03D15E21-81CB-4D47-8BB5-81E98979501A}"/>
+                <a16:creationId xmlns:a16="http://schemas.microsoft.com/office/drawing/2014/main" id="{59A25B28-7951-45B2-A934-392FDAF434AC}"/>
               </a:ext>
             </a:extLst>
           </p:cNvPr>
@@ -23976,7 +24056,7 @@
           <p:cNvPr id="8" name="">
             <a:extLst xmlns:a="http://schemas.openxmlformats.org/drawingml/2006/main">
               <a:ext uri="{FF2B5EF4-FFF2-40B4-BE49-F238E27FC236}">
-                <a16:creationId xmlns:a16="http://schemas.microsoft.com/office/drawing/2014/main" id="{CB9E1EBD-15C4-48F8-96C3-7A7ACFD9EFA3}"/>
+                <a16:creationId xmlns:a16="http://schemas.microsoft.com/office/drawing/2014/main" id="{3BA7CCB4-E84A-4A3A-83E2-573D3A66694A}"/>
               </a:ext>
             </a:extLst>
           </p:cNvPr>
@@ -24033,7 +24113,7 @@
           <p:cNvPr id="9" name="">
             <a:extLst xmlns:a="http://schemas.openxmlformats.org/drawingml/2006/main">
               <a:ext uri="{FF2B5EF4-FFF2-40B4-BE49-F238E27FC236}">
-                <a16:creationId xmlns:a16="http://schemas.microsoft.com/office/drawing/2014/main" id="{1FCBA14E-3FAF-4D95-AE42-DBD85A0F55D7}"/>
+                <a16:creationId xmlns:a16="http://schemas.microsoft.com/office/drawing/2014/main" id="{005E1315-1497-44B2-8C74-B5365C8E19C4}"/>
               </a:ext>
             </a:extLst>
           </p:cNvPr>
@@ -24063,7 +24143,7 @@
           <p:cNvPr id="10" name="">
             <a:extLst xmlns:a="http://schemas.openxmlformats.org/drawingml/2006/main">
               <a:ext uri="{FF2B5EF4-FFF2-40B4-BE49-F238E27FC236}">
-                <a16:creationId xmlns:a16="http://schemas.microsoft.com/office/drawing/2014/main" id="{7F633CB1-E3DC-4406-BC15-2AB1F8DBEF71}"/>
+                <a16:creationId xmlns:a16="http://schemas.microsoft.com/office/drawing/2014/main" id="{A6ABE695-19DF-4487-A24B-26319A52F1BD}"/>
               </a:ext>
             </a:extLst>
           </p:cNvPr>
@@ -24120,7 +24200,7 @@
           <p:cNvPr id="11" name="">
             <a:extLst xmlns:a="http://schemas.openxmlformats.org/drawingml/2006/main">
               <a:ext uri="{FF2B5EF4-FFF2-40B4-BE49-F238E27FC236}">
-                <a16:creationId xmlns:a16="http://schemas.microsoft.com/office/drawing/2014/main" id="{7BA24D27-0247-4713-A807-1D139EA2D5ED}"/>
+                <a16:creationId xmlns:a16="http://schemas.microsoft.com/office/drawing/2014/main" id="{4BF03800-A35F-4B93-B599-F92449FD0700}"/>
               </a:ext>
             </a:extLst>
           </p:cNvPr>
@@ -24177,7 +24257,7 @@
           <p:cNvPr id="12" name="">
             <a:extLst xmlns:a="http://schemas.openxmlformats.org/drawingml/2006/main">
               <a:ext uri="{FF2B5EF4-FFF2-40B4-BE49-F238E27FC236}">
-                <a16:creationId xmlns:a16="http://schemas.microsoft.com/office/drawing/2014/main" id="{6D247565-2F56-406A-96D1-6673DDAD3B08}"/>
+                <a16:creationId xmlns:a16="http://schemas.microsoft.com/office/drawing/2014/main" id="{2DC3C296-8384-4F47-8046-52FDF72DA4C1}"/>
               </a:ext>
             </a:extLst>
           </p:cNvPr>
@@ -24207,7 +24287,7 @@
           <p:cNvPr id="13" name="">
             <a:extLst xmlns:a="http://schemas.openxmlformats.org/drawingml/2006/main">
               <a:ext uri="{FF2B5EF4-FFF2-40B4-BE49-F238E27FC236}">
-                <a16:creationId xmlns:a16="http://schemas.microsoft.com/office/drawing/2014/main" id="{46AC1B8F-E7AD-439D-A890-C2211A8BECDF}"/>
+                <a16:creationId xmlns:a16="http://schemas.microsoft.com/office/drawing/2014/main" id="{F9D96264-7ACC-4CC9-878C-5C802C75E648}"/>
               </a:ext>
             </a:extLst>
           </p:cNvPr>
@@ -24264,7 +24344,7 @@
           <p:cNvPr id="14" name="">
             <a:extLst xmlns:a="http://schemas.openxmlformats.org/drawingml/2006/main">
               <a:ext uri="{FF2B5EF4-FFF2-40B4-BE49-F238E27FC236}">
-                <a16:creationId xmlns:a16="http://schemas.microsoft.com/office/drawing/2014/main" id="{95519340-223A-4672-ACBF-DB1167C2A8F6}"/>
+                <a16:creationId xmlns:a16="http://schemas.microsoft.com/office/drawing/2014/main" id="{9FD5C5EC-3C1E-443C-B7E9-D8C84D3DA8B3}"/>
               </a:ext>
             </a:extLst>
           </p:cNvPr>
@@ -24321,7 +24401,7 @@
           <p:cNvPr id="15" name="">
             <a:extLst xmlns:a="http://schemas.openxmlformats.org/drawingml/2006/main">
               <a:ext uri="{FF2B5EF4-FFF2-40B4-BE49-F238E27FC236}">
-                <a16:creationId xmlns:a16="http://schemas.microsoft.com/office/drawing/2014/main" id="{8FDFCCAE-8884-4738-BFAF-328AE1822EB9}"/>
+                <a16:creationId xmlns:a16="http://schemas.microsoft.com/office/drawing/2014/main" id="{E1832C13-C93A-407C-9E1A-DA9F35A2391D}"/>
               </a:ext>
             </a:extLst>
           </p:cNvPr>
@@ -24351,7 +24431,7 @@
           <p:cNvPr id="16" name="">
             <a:extLst xmlns:a="http://schemas.openxmlformats.org/drawingml/2006/main">
               <a:ext uri="{FF2B5EF4-FFF2-40B4-BE49-F238E27FC236}">
-                <a16:creationId xmlns:a16="http://schemas.microsoft.com/office/drawing/2014/main" id="{9F2C45B3-DAE8-44F4-B73E-508C900E27C2}"/>
+                <a16:creationId xmlns:a16="http://schemas.microsoft.com/office/drawing/2014/main" id="{0CEB41A4-3470-422B-89CF-6CC80F6A40B6}"/>
               </a:ext>
             </a:extLst>
           </p:cNvPr>
@@ -24408,7 +24488,7 @@
           <p:cNvPr id="17" name="">
             <a:extLst xmlns:a="http://schemas.openxmlformats.org/drawingml/2006/main">
               <a:ext uri="{FF2B5EF4-FFF2-40B4-BE49-F238E27FC236}">
-                <a16:creationId xmlns:a16="http://schemas.microsoft.com/office/drawing/2014/main" id="{025C26B3-B242-4B00-B800-4469685178FF}"/>
+                <a16:creationId xmlns:a16="http://schemas.microsoft.com/office/drawing/2014/main" id="{81A03C21-4D1E-4839-802D-B6B8E5E5CA79}"/>
               </a:ext>
             </a:extLst>
           </p:cNvPr>
@@ -24465,7 +24545,7 @@
           <p:cNvPr id="18" name="">
             <a:extLst xmlns:a="http://schemas.openxmlformats.org/drawingml/2006/main">
               <a:ext uri="{FF2B5EF4-FFF2-40B4-BE49-F238E27FC236}">
-                <a16:creationId xmlns:a16="http://schemas.microsoft.com/office/drawing/2014/main" id="{777B5F32-F28A-4B7A-91FB-256B98B157F9}"/>
+                <a16:creationId xmlns:a16="http://schemas.microsoft.com/office/drawing/2014/main" id="{63A1A1D7-1C04-4598-888E-578B14386974}"/>
               </a:ext>
             </a:extLst>
           </p:cNvPr>
@@ -24495,7 +24575,7 @@
           <p:cNvPr id="19" name="">
             <a:extLst xmlns:a="http://schemas.openxmlformats.org/drawingml/2006/main">
               <a:ext uri="{FF2B5EF4-FFF2-40B4-BE49-F238E27FC236}">
-                <a16:creationId xmlns:a16="http://schemas.microsoft.com/office/drawing/2014/main" id="{862D9B42-65BF-4FEA-A997-478C87DFAB36}"/>
+                <a16:creationId xmlns:a16="http://schemas.microsoft.com/office/drawing/2014/main" id="{A80CF168-1B6E-4495-994F-1D9FBB17AF9E}"/>
               </a:ext>
             </a:extLst>
           </p:cNvPr>
@@ -24552,7 +24632,7 @@
           <p:cNvPr id="20" name="">
             <a:extLst xmlns:a="http://schemas.openxmlformats.org/drawingml/2006/main">
               <a:ext uri="{FF2B5EF4-FFF2-40B4-BE49-F238E27FC236}">
-                <a16:creationId xmlns:a16="http://schemas.microsoft.com/office/drawing/2014/main" id="{FBFA244D-539D-4339-8A9D-CB4182C79CBE}"/>
+                <a16:creationId xmlns:a16="http://schemas.microsoft.com/office/drawing/2014/main" id="{1D907B8E-ED8C-45E1-B3C9-DCCDC1B66DD8}"/>
               </a:ext>
             </a:extLst>
           </p:cNvPr>
@@ -24609,7 +24689,7 @@
           <p:cNvPr id="21" name="">
             <a:extLst xmlns:a="http://schemas.openxmlformats.org/drawingml/2006/main">
               <a:ext uri="{FF2B5EF4-FFF2-40B4-BE49-F238E27FC236}">
-                <a16:creationId xmlns:a16="http://schemas.microsoft.com/office/drawing/2014/main" id="{AB75E30D-ED88-4AC6-9177-49D450C762A7}"/>
+                <a16:creationId xmlns:a16="http://schemas.microsoft.com/office/drawing/2014/main" id="{68FE30A5-FE14-4F66-88A3-BC8A59D3EDE4}"/>
               </a:ext>
             </a:extLst>
           </p:cNvPr>
@@ -24639,7 +24719,7 @@
           <p:cNvPr id="22" name="">
             <a:extLst xmlns:a="http://schemas.openxmlformats.org/drawingml/2006/main">
               <a:ext uri="{FF2B5EF4-FFF2-40B4-BE49-F238E27FC236}">
-                <a16:creationId xmlns:a16="http://schemas.microsoft.com/office/drawing/2014/main" id="{3DC89255-C0F8-49B2-9923-D1436BEE9515}"/>
+                <a16:creationId xmlns:a16="http://schemas.microsoft.com/office/drawing/2014/main" id="{C1155BCE-ED82-4073-8455-161B2DF74ABB}"/>
               </a:ext>
             </a:extLst>
           </p:cNvPr>
@@ -24696,7 +24776,7 @@
           <p:cNvPr id="23" name="">
             <a:extLst xmlns:a="http://schemas.openxmlformats.org/drawingml/2006/main">
               <a:ext uri="{FF2B5EF4-FFF2-40B4-BE49-F238E27FC236}">
-                <a16:creationId xmlns:a16="http://schemas.microsoft.com/office/drawing/2014/main" id="{8494D2DC-16F7-4198-905D-60081447227A}"/>
+                <a16:creationId xmlns:a16="http://schemas.microsoft.com/office/drawing/2014/main" id="{2CBDBB3A-8D74-47C6-B723-A5A5E8CC31B0}"/>
               </a:ext>
             </a:extLst>
           </p:cNvPr>
@@ -24753,7 +24833,7 @@
           <p:cNvPr id="24" name="">
             <a:extLst xmlns:a="http://schemas.openxmlformats.org/drawingml/2006/main">
               <a:ext uri="{FF2B5EF4-FFF2-40B4-BE49-F238E27FC236}">
-                <a16:creationId xmlns:a16="http://schemas.microsoft.com/office/drawing/2014/main" id="{9B36D125-9F90-49EF-BC1E-E85620C817DE}"/>
+                <a16:creationId xmlns:a16="http://schemas.microsoft.com/office/drawing/2014/main" id="{A2139BE6-DC97-4CA7-A26D-E2680E40B10C}"/>
               </a:ext>
             </a:extLst>
           </p:cNvPr>
@@ -24787,7 +24867,7 @@
           <p:cNvPr id="25" name="">
             <a:extLst xmlns:a="http://schemas.openxmlformats.org/drawingml/2006/main">
               <a:ext uri="{FF2B5EF4-FFF2-40B4-BE49-F238E27FC236}">
-                <a16:creationId xmlns:a16="http://schemas.microsoft.com/office/drawing/2014/main" id="{FA2DCD7E-B3FD-4826-A99C-EF92EB26B046}"/>
+                <a16:creationId xmlns:a16="http://schemas.microsoft.com/office/drawing/2014/main" id="{BF73AC3B-7BD5-478F-9989-4188F0BFE731}"/>
               </a:ext>
             </a:extLst>
           </p:cNvPr>
@@ -24844,7 +24924,7 @@
           <p:cNvPr id="26" name="">
             <a:extLst xmlns:a="http://schemas.openxmlformats.org/drawingml/2006/main">
               <a:ext uri="{FF2B5EF4-FFF2-40B4-BE49-F238E27FC236}">
-                <a16:creationId xmlns:a16="http://schemas.microsoft.com/office/drawing/2014/main" id="{F510C50C-DB4B-414A-AC46-E71487936FA3}"/>
+                <a16:creationId xmlns:a16="http://schemas.microsoft.com/office/drawing/2014/main" id="{DC97FA03-ACAF-4E33-8480-D2AA535027DB}"/>
               </a:ext>
             </a:extLst>
           </p:cNvPr>
@@ -24874,7 +24954,7 @@
           <p:cNvPr id="27" name="">
             <a:extLst xmlns:a="http://schemas.openxmlformats.org/drawingml/2006/main">
               <a:ext uri="{FF2B5EF4-FFF2-40B4-BE49-F238E27FC236}">
-                <a16:creationId xmlns:a16="http://schemas.microsoft.com/office/drawing/2014/main" id="{D8EF0FA5-93C2-45AB-8399-7BE6D363C25B}"/>
+                <a16:creationId xmlns:a16="http://schemas.microsoft.com/office/drawing/2014/main" id="{15EC700E-9E46-4237-BCC2-EA880105984B}"/>
               </a:ext>
             </a:extLst>
           </p:cNvPr>
@@ -24931,7 +25011,7 @@
           <p:cNvPr id="28" name="">
             <a:extLst xmlns:a="http://schemas.openxmlformats.org/drawingml/2006/main">
               <a:ext uri="{FF2B5EF4-FFF2-40B4-BE49-F238E27FC236}">
-                <a16:creationId xmlns:a16="http://schemas.microsoft.com/office/drawing/2014/main" id="{19924067-0B2B-45FC-937B-91285D50B335}"/>
+                <a16:creationId xmlns:a16="http://schemas.microsoft.com/office/drawing/2014/main" id="{40500759-8C89-488A-8EC3-C84007463F6E}"/>
               </a:ext>
             </a:extLst>
           </p:cNvPr>
@@ -24988,7 +25068,7 @@
           <p:cNvPr id="29" name="">
             <a:extLst xmlns:a="http://schemas.openxmlformats.org/drawingml/2006/main">
               <a:ext uri="{FF2B5EF4-FFF2-40B4-BE49-F238E27FC236}">
-                <a16:creationId xmlns:a16="http://schemas.microsoft.com/office/drawing/2014/main" id="{60DAE377-237C-4730-B3C8-528EEAE548FE}"/>
+                <a16:creationId xmlns:a16="http://schemas.microsoft.com/office/drawing/2014/main" id="{379A0F84-FA5B-4060-9876-743F3DCEA183}"/>
               </a:ext>
             </a:extLst>
           </p:cNvPr>
@@ -25018,7 +25098,7 @@
           <p:cNvPr id="30" name="">
             <a:extLst xmlns:a="http://schemas.openxmlformats.org/drawingml/2006/main">
               <a:ext uri="{FF2B5EF4-FFF2-40B4-BE49-F238E27FC236}">
-                <a16:creationId xmlns:a16="http://schemas.microsoft.com/office/drawing/2014/main" id="{B3BF63A8-1090-4F5A-8E60-13F4B212B06A}"/>
+                <a16:creationId xmlns:a16="http://schemas.microsoft.com/office/drawing/2014/main" id="{1844EB3B-F9EA-4A95-A6E9-A259CC59992A}"/>
               </a:ext>
             </a:extLst>
           </p:cNvPr>
@@ -25075,7 +25155,7 @@
           <p:cNvPr id="31" name="">
             <a:extLst xmlns:a="http://schemas.openxmlformats.org/drawingml/2006/main">
               <a:ext uri="{FF2B5EF4-FFF2-40B4-BE49-F238E27FC236}">
-                <a16:creationId xmlns:a16="http://schemas.microsoft.com/office/drawing/2014/main" id="{91681D8E-593A-4A11-9192-06984D143510}"/>
+                <a16:creationId xmlns:a16="http://schemas.microsoft.com/office/drawing/2014/main" id="{FFB766C6-159C-4A1E-91CD-991FEB2E10AD}"/>
               </a:ext>
             </a:extLst>
           </p:cNvPr>
@@ -25132,7 +25212,7 @@
           <p:cNvPr id="32" name="">
             <a:extLst xmlns:a="http://schemas.openxmlformats.org/drawingml/2006/main">
               <a:ext uri="{FF2B5EF4-FFF2-40B4-BE49-F238E27FC236}">
-                <a16:creationId xmlns:a16="http://schemas.microsoft.com/office/drawing/2014/main" id="{39F65F0B-7C58-42E4-A939-9F28AB3B4E44}"/>
+                <a16:creationId xmlns:a16="http://schemas.microsoft.com/office/drawing/2014/main" id="{54DA3AFF-463E-4A33-92D7-5BBEAECE0D93}"/>
               </a:ext>
             </a:extLst>
           </p:cNvPr>
@@ -25162,7 +25242,7 @@
           <p:cNvPr id="33" name="">
             <a:extLst xmlns:a="http://schemas.openxmlformats.org/drawingml/2006/main">
               <a:ext uri="{FF2B5EF4-FFF2-40B4-BE49-F238E27FC236}">
-                <a16:creationId xmlns:a16="http://schemas.microsoft.com/office/drawing/2014/main" id="{A689CBA0-05F7-4B62-8C98-AB48F55284A3}"/>
+                <a16:creationId xmlns:a16="http://schemas.microsoft.com/office/drawing/2014/main" id="{177BE720-836B-4E3E-9A34-299471B94CB7}"/>
               </a:ext>
             </a:extLst>
           </p:cNvPr>
@@ -25219,7 +25299,7 @@
           <p:cNvPr id="34" name="">
             <a:extLst xmlns:a="http://schemas.openxmlformats.org/drawingml/2006/main">
               <a:ext uri="{FF2B5EF4-FFF2-40B4-BE49-F238E27FC236}">
-                <a16:creationId xmlns:a16="http://schemas.microsoft.com/office/drawing/2014/main" id="{B295720D-E1A5-48ED-B794-BDCE23220A7C}"/>
+                <a16:creationId xmlns:a16="http://schemas.microsoft.com/office/drawing/2014/main" id="{35A44CB7-D384-4AAB-9838-3FC15079F548}"/>
               </a:ext>
             </a:extLst>
           </p:cNvPr>
@@ -25276,7 +25356,7 @@
           <p:cNvPr id="35" name="">
             <a:extLst xmlns:a="http://schemas.openxmlformats.org/drawingml/2006/main">
               <a:ext uri="{FF2B5EF4-FFF2-40B4-BE49-F238E27FC236}">
-                <a16:creationId xmlns:a16="http://schemas.microsoft.com/office/drawing/2014/main" id="{928D3B5D-B42F-49FC-ACDF-1D89E75C7000}"/>
+                <a16:creationId xmlns:a16="http://schemas.microsoft.com/office/drawing/2014/main" id="{9542409A-37DE-41EC-BD87-F0E59102D6BF}"/>
               </a:ext>
             </a:extLst>
           </p:cNvPr>
@@ -25306,7 +25386,7 @@
           <p:cNvPr id="36" name="">
             <a:extLst xmlns:a="http://schemas.openxmlformats.org/drawingml/2006/main">
               <a:ext uri="{FF2B5EF4-FFF2-40B4-BE49-F238E27FC236}">
-                <a16:creationId xmlns:a16="http://schemas.microsoft.com/office/drawing/2014/main" id="{EA16F1DD-0ABD-4AAD-A0F9-0E33589F1B03}"/>
+                <a16:creationId xmlns:a16="http://schemas.microsoft.com/office/drawing/2014/main" id="{A00C6765-8EB9-4F1A-BAB8-D4AE0E4D5A7A}"/>
               </a:ext>
             </a:extLst>
           </p:cNvPr>
@@ -25363,7 +25443,7 @@
           <p:cNvPr id="37" name="">
             <a:extLst xmlns:a="http://schemas.openxmlformats.org/drawingml/2006/main">
               <a:ext uri="{FF2B5EF4-FFF2-40B4-BE49-F238E27FC236}">
-                <a16:creationId xmlns:a16="http://schemas.microsoft.com/office/drawing/2014/main" id="{A53A172C-C15A-464A-A8FD-A9241F83F234}"/>
+                <a16:creationId xmlns:a16="http://schemas.microsoft.com/office/drawing/2014/main" id="{94712A17-F294-44B8-B373-4727AB191DFC}"/>
               </a:ext>
             </a:extLst>
           </p:cNvPr>
@@ -25420,7 +25500,7 @@
           <p:cNvPr id="38" name="">
             <a:extLst xmlns:a="http://schemas.openxmlformats.org/drawingml/2006/main">
               <a:ext uri="{FF2B5EF4-FFF2-40B4-BE49-F238E27FC236}">
-                <a16:creationId xmlns:a16="http://schemas.microsoft.com/office/drawing/2014/main" id="{EAD36CA5-35BC-4621-BC15-029309A35A99}"/>
+                <a16:creationId xmlns:a16="http://schemas.microsoft.com/office/drawing/2014/main" id="{B9F1B437-CD5D-4581-BC89-749149809938}"/>
               </a:ext>
             </a:extLst>
           </p:cNvPr>
@@ -25450,7 +25530,7 @@
           <p:cNvPr id="39" name="">
             <a:extLst xmlns:a="http://schemas.openxmlformats.org/drawingml/2006/main">
               <a:ext uri="{FF2B5EF4-FFF2-40B4-BE49-F238E27FC236}">
-                <a16:creationId xmlns:a16="http://schemas.microsoft.com/office/drawing/2014/main" id="{BD849AC9-AC83-48C1-85C7-27A5773B5F86}"/>
+                <a16:creationId xmlns:a16="http://schemas.microsoft.com/office/drawing/2014/main" id="{A88AA5D6-E071-47B1-B00F-B95E49D006B1}"/>
               </a:ext>
             </a:extLst>
           </p:cNvPr>
@@ -25507,7 +25587,7 @@
           <p:cNvPr id="40" name="">
             <a:extLst xmlns:a="http://schemas.openxmlformats.org/drawingml/2006/main">
               <a:ext uri="{FF2B5EF4-FFF2-40B4-BE49-F238E27FC236}">
-                <a16:creationId xmlns:a16="http://schemas.microsoft.com/office/drawing/2014/main" id="{98F65563-767D-47B9-BCAF-780221EF1CAF}"/>
+                <a16:creationId xmlns:a16="http://schemas.microsoft.com/office/drawing/2014/main" id="{D28637A5-F5EF-49E9-8DB8-6A27F2FB303D}"/>
               </a:ext>
             </a:extLst>
           </p:cNvPr>
@@ -25564,7 +25644,7 @@
           <p:cNvPr id="41" name="">
             <a:extLst xmlns:a="http://schemas.openxmlformats.org/drawingml/2006/main">
               <a:ext uri="{FF2B5EF4-FFF2-40B4-BE49-F238E27FC236}">
-                <a16:creationId xmlns:a16="http://schemas.microsoft.com/office/drawing/2014/main" id="{3A132019-833E-48E3-99AF-BD0CC856FA51}"/>
+                <a16:creationId xmlns:a16="http://schemas.microsoft.com/office/drawing/2014/main" id="{E882141B-64A5-4B8A-9B78-BA9950F7E50D}"/>
               </a:ext>
             </a:extLst>
           </p:cNvPr>
@@ -25596,7 +25676,7 @@
           <p:cNvPr id="42" name="">
             <a:extLst xmlns:a="http://schemas.openxmlformats.org/drawingml/2006/main">
               <a:ext uri="{FF2B5EF4-FFF2-40B4-BE49-F238E27FC236}">
-                <a16:creationId xmlns:a16="http://schemas.microsoft.com/office/drawing/2014/main" id="{B6BE6284-7402-41D7-8948-064DCF5AC7FE}"/>
+                <a16:creationId xmlns:a16="http://schemas.microsoft.com/office/drawing/2014/main" id="{F22D0FC2-C6BC-47A6-9DEC-E997A4790A94}"/>
               </a:ext>
             </a:extLst>
           </p:cNvPr>
@@ -25653,7 +25733,7 @@
           <p:cNvPr id="43" name="">
             <a:extLst xmlns:a="http://schemas.openxmlformats.org/drawingml/2006/main">
               <a:ext uri="{FF2B5EF4-FFF2-40B4-BE49-F238E27FC236}">
-                <a16:creationId xmlns:a16="http://schemas.microsoft.com/office/drawing/2014/main" id="{16F71565-B604-42C8-BDDB-0DAFEF79DFD1}"/>
+                <a16:creationId xmlns:a16="http://schemas.microsoft.com/office/drawing/2014/main" id="{860D8C60-815C-4B90-A59E-EF3182899CF4}"/>
               </a:ext>
             </a:extLst>
           </p:cNvPr>
@@ -25708,7 +25788,7 @@
     </p:spTree>
     <p:extLst>
       <p:ext uri="{BB962C8B-B14F-4D97-AF65-F5344CB8AC3E}">
-        <p14:creationId xmlns:p14="http://schemas.microsoft.com/office/powerpoint/2010/main" val="1313688188"/>
+        <p14:creationId xmlns:p14="http://schemas.microsoft.com/office/powerpoint/2010/main" val="2089537136"/>
       </p:ext>
     </p:extLst>
   </p:cSld>
@@ -25732,7 +25812,7 @@
           <p:cNvPr id="32" name="">
             <a:extLst xmlns:a="http://schemas.openxmlformats.org/drawingml/2006/main">
               <a:ext uri="{FF2B5EF4-FFF2-40B4-BE49-F238E27FC236}">
-                <a16:creationId xmlns:a16="http://schemas.microsoft.com/office/drawing/2014/main" id="{55DDBA9E-910D-46DB-8E96-971B03EBE665}"/>
+                <a16:creationId xmlns:a16="http://schemas.microsoft.com/office/drawing/2014/main" id="{B8D1688F-7097-4171-90D1-323FA84B2D7A}"/>
               </a:ext>
             </a:extLst>
           </p:cNvPr>
@@ -25762,7 +25842,7 @@
           <p:cNvPr id="2" name="">
             <a:extLst xmlns:a="http://schemas.openxmlformats.org/drawingml/2006/main">
               <a:ext uri="{FF2B5EF4-FFF2-40B4-BE49-F238E27FC236}">
-                <a16:creationId xmlns:a16="http://schemas.microsoft.com/office/drawing/2014/main" id="{B102296C-1DC4-4CE2-9BED-AA2D89EA8EB0}"/>
+                <a16:creationId xmlns:a16="http://schemas.microsoft.com/office/drawing/2014/main" id="{7251B40D-A804-45ED-BDC0-7F640D8A45A6}"/>
               </a:ext>
             </a:extLst>
           </p:cNvPr>
@@ -25819,7 +25899,7 @@
           <p:cNvPr id="3" name="">
             <a:extLst xmlns:a="http://schemas.openxmlformats.org/drawingml/2006/main">
               <a:ext uri="{FF2B5EF4-FFF2-40B4-BE49-F238E27FC236}">
-                <a16:creationId xmlns:a16="http://schemas.microsoft.com/office/drawing/2014/main" id="{A81ED94E-F458-477C-A0ED-6DFD5FA1CF55}"/>
+                <a16:creationId xmlns:a16="http://schemas.microsoft.com/office/drawing/2014/main" id="{4D7A62B5-2B5B-423B-A7F6-69EF0B668B4E}"/>
               </a:ext>
             </a:extLst>
           </p:cNvPr>
@@ -25876,7 +25956,7 @@
           <p:cNvPr id="4" name="">
             <a:extLst xmlns:a="http://schemas.openxmlformats.org/drawingml/2006/main">
               <a:ext uri="{FF2B5EF4-FFF2-40B4-BE49-F238E27FC236}">
-                <a16:creationId xmlns:a16="http://schemas.microsoft.com/office/drawing/2014/main" id="{73907B26-2DC6-4E6E-903F-62D5074E2DBE}"/>
+                <a16:creationId xmlns:a16="http://schemas.microsoft.com/office/drawing/2014/main" id="{6C338EC8-A9F1-4739-AF68-48E5B8798146}"/>
               </a:ext>
             </a:extLst>
           </p:cNvPr>
@@ -25933,7 +26013,7 @@
           <p:cNvPr id="5" name="">
             <a:extLst xmlns:a="http://schemas.openxmlformats.org/drawingml/2006/main">
               <a:ext uri="{FF2B5EF4-FFF2-40B4-BE49-F238E27FC236}">
-                <a16:creationId xmlns:a16="http://schemas.microsoft.com/office/drawing/2014/main" id="{C16FAAA9-AB02-4A93-8A0A-1D65588FAEB1}"/>
+                <a16:creationId xmlns:a16="http://schemas.microsoft.com/office/drawing/2014/main" id="{CBD72ADF-B3FA-4D56-96BA-99F837FB33BA}"/>
               </a:ext>
             </a:extLst>
           </p:cNvPr>
@@ -25990,7 +26070,7 @@
           <p:cNvPr id="6" name="">
             <a:extLst xmlns:a="http://schemas.openxmlformats.org/drawingml/2006/main">
               <a:ext uri="{FF2B5EF4-FFF2-40B4-BE49-F238E27FC236}">
-                <a16:creationId xmlns:a16="http://schemas.microsoft.com/office/drawing/2014/main" id="{900D629A-11A3-4DF9-8AB5-440D2C6371FC}"/>
+                <a16:creationId xmlns:a16="http://schemas.microsoft.com/office/drawing/2014/main" id="{F9EC3BA8-702E-4F46-B375-F7B783D3C3E3}"/>
               </a:ext>
             </a:extLst>
           </p:cNvPr>
@@ -26020,7 +26100,7 @@
           <p:cNvPr id="7" name="">
             <a:extLst xmlns:a="http://schemas.openxmlformats.org/drawingml/2006/main">
               <a:ext uri="{FF2B5EF4-FFF2-40B4-BE49-F238E27FC236}">
-                <a16:creationId xmlns:a16="http://schemas.microsoft.com/office/drawing/2014/main" id="{8A498DA5-1195-480B-B8BD-CC463F1CB1B2}"/>
+                <a16:creationId xmlns:a16="http://schemas.microsoft.com/office/drawing/2014/main" id="{826F231E-5C9A-482B-854C-61EAF03A6FDE}"/>
               </a:ext>
             </a:extLst>
           </p:cNvPr>
@@ -26077,7 +26157,7 @@
           <p:cNvPr id="8" name="">
             <a:extLst xmlns:a="http://schemas.openxmlformats.org/drawingml/2006/main">
               <a:ext uri="{FF2B5EF4-FFF2-40B4-BE49-F238E27FC236}">
-                <a16:creationId xmlns:a16="http://schemas.microsoft.com/office/drawing/2014/main" id="{2F6B6794-6C08-4728-90D6-B94EC9CB845A}"/>
+                <a16:creationId xmlns:a16="http://schemas.microsoft.com/office/drawing/2014/main" id="{85246A44-A010-4235-A801-CAE5C435CEEB}"/>
               </a:ext>
             </a:extLst>
           </p:cNvPr>
@@ -26134,7 +26214,7 @@
           <p:cNvPr id="9" name="">
             <a:extLst xmlns:a="http://schemas.openxmlformats.org/drawingml/2006/main">
               <a:ext uri="{FF2B5EF4-FFF2-40B4-BE49-F238E27FC236}">
-                <a16:creationId xmlns:a16="http://schemas.microsoft.com/office/drawing/2014/main" id="{A674635C-8176-4CC9-B931-82DD2EE06FEF}"/>
+                <a16:creationId xmlns:a16="http://schemas.microsoft.com/office/drawing/2014/main" id="{21B4C31F-2F65-4811-92D2-5FC05B58FC4E}"/>
               </a:ext>
             </a:extLst>
           </p:cNvPr>
@@ -26191,7 +26271,7 @@
           <p:cNvPr id="10" name="">
             <a:extLst xmlns:a="http://schemas.openxmlformats.org/drawingml/2006/main">
               <a:ext uri="{FF2B5EF4-FFF2-40B4-BE49-F238E27FC236}">
-                <a16:creationId xmlns:a16="http://schemas.microsoft.com/office/drawing/2014/main" id="{4354514F-C7D9-4406-BC48-A6E0B2E898A1}"/>
+                <a16:creationId xmlns:a16="http://schemas.microsoft.com/office/drawing/2014/main" id="{69816E0E-E514-4AE4-B4E2-79D5016C8D72}"/>
               </a:ext>
             </a:extLst>
           </p:cNvPr>
@@ -26225,7 +26305,7 @@
           <p:cNvPr id="11" name="">
             <a:extLst xmlns:a="http://schemas.openxmlformats.org/drawingml/2006/main">
               <a:ext uri="{FF2B5EF4-FFF2-40B4-BE49-F238E27FC236}">
-                <a16:creationId xmlns:a16="http://schemas.microsoft.com/office/drawing/2014/main" id="{06B40CF4-7828-44E3-A9D6-775F83082889}"/>
+                <a16:creationId xmlns:a16="http://schemas.microsoft.com/office/drawing/2014/main" id="{070B03A6-93EF-4EA6-B0AB-F45486B95667}"/>
               </a:ext>
             </a:extLst>
           </p:cNvPr>
@@ -26282,7 +26362,7 @@
           <p:cNvPr id="12" name="">
             <a:extLst xmlns:a="http://schemas.openxmlformats.org/drawingml/2006/main">
               <a:ext uri="{FF2B5EF4-FFF2-40B4-BE49-F238E27FC236}">
-                <a16:creationId xmlns:a16="http://schemas.microsoft.com/office/drawing/2014/main" id="{21ABAF64-963C-42A8-B535-D80711987444}"/>
+                <a16:creationId xmlns:a16="http://schemas.microsoft.com/office/drawing/2014/main" id="{63D945F3-8FEF-4FA1-AD94-38000060586A}"/>
               </a:ext>
             </a:extLst>
           </p:cNvPr>
@@ -26362,7 +26442,7 @@
           <p:cNvPr id="13" name="">
             <a:extLst xmlns:a="http://schemas.openxmlformats.org/drawingml/2006/main">
               <a:ext uri="{FF2B5EF4-FFF2-40B4-BE49-F238E27FC236}">
-                <a16:creationId xmlns:a16="http://schemas.microsoft.com/office/drawing/2014/main" id="{8F9395AC-F887-4E63-BEAA-02C26564DFE6}"/>
+                <a16:creationId xmlns:a16="http://schemas.microsoft.com/office/drawing/2014/main" id="{947A668E-7968-4F80-85AB-2FCBCE183130}"/>
               </a:ext>
             </a:extLst>
           </p:cNvPr>
@@ -26419,7 +26499,7 @@
           <p:cNvPr id="14" name="">
             <a:extLst xmlns:a="http://schemas.openxmlformats.org/drawingml/2006/main">
               <a:ext uri="{FF2B5EF4-FFF2-40B4-BE49-F238E27FC236}">
-                <a16:creationId xmlns:a16="http://schemas.microsoft.com/office/drawing/2014/main" id="{7BC04F82-FEC8-468F-AAC1-A9EEBB27164D}"/>
+                <a16:creationId xmlns:a16="http://schemas.microsoft.com/office/drawing/2014/main" id="{52E65625-B7DB-4741-9BFF-62FCDD1F503D}"/>
               </a:ext>
             </a:extLst>
           </p:cNvPr>
@@ -26451,7 +26531,7 @@
           <p:cNvPr id="15" name="">
             <a:extLst xmlns:a="http://schemas.openxmlformats.org/drawingml/2006/main">
               <a:ext uri="{FF2B5EF4-FFF2-40B4-BE49-F238E27FC236}">
-                <a16:creationId xmlns:a16="http://schemas.microsoft.com/office/drawing/2014/main" id="{249247BA-1DEA-4919-9C7D-32DEB20876B1}"/>
+                <a16:creationId xmlns:a16="http://schemas.microsoft.com/office/drawing/2014/main" id="{09C06BCE-955B-4480-B62F-F5229FCEE4DA}"/>
               </a:ext>
             </a:extLst>
           </p:cNvPr>
@@ -26531,7 +26611,7 @@
           <p:cNvPr id="16" name="">
             <a:extLst xmlns:a="http://schemas.openxmlformats.org/drawingml/2006/main">
               <a:ext uri="{FF2B5EF4-FFF2-40B4-BE49-F238E27FC236}">
-                <a16:creationId xmlns:a16="http://schemas.microsoft.com/office/drawing/2014/main" id="{6D92495F-497F-4E7C-9034-B84DB4063F87}"/>
+                <a16:creationId xmlns:a16="http://schemas.microsoft.com/office/drawing/2014/main" id="{BF8E14C2-4853-4E3D-837E-9950364CB74D}"/>
               </a:ext>
             </a:extLst>
           </p:cNvPr>
@@ -26565,7 +26645,7 @@
           <p:cNvPr id="17" name="">
             <a:extLst xmlns:a="http://schemas.openxmlformats.org/drawingml/2006/main">
               <a:ext uri="{FF2B5EF4-FFF2-40B4-BE49-F238E27FC236}">
-                <a16:creationId xmlns:a16="http://schemas.microsoft.com/office/drawing/2014/main" id="{A51EF4B3-E03D-4268-B63F-1BF6E9E3A2FF}"/>
+                <a16:creationId xmlns:a16="http://schemas.microsoft.com/office/drawing/2014/main" id="{27E223D2-C06F-4CE4-8B36-9B45981833D7}"/>
               </a:ext>
             </a:extLst>
           </p:cNvPr>
@@ -26622,7 +26702,7 @@
           <p:cNvPr id="18" name="">
             <a:extLst xmlns:a="http://schemas.openxmlformats.org/drawingml/2006/main">
               <a:ext uri="{FF2B5EF4-FFF2-40B4-BE49-F238E27FC236}">
-                <a16:creationId xmlns:a16="http://schemas.microsoft.com/office/drawing/2014/main" id="{65135081-F042-4314-9629-5D1C67DECAE1}"/>
+                <a16:creationId xmlns:a16="http://schemas.microsoft.com/office/drawing/2014/main" id="{098B975B-653B-4803-B5DB-D90D7EA6A64C}"/>
               </a:ext>
             </a:extLst>
           </p:cNvPr>
@@ -26702,7 +26782,7 @@
           <p:cNvPr id="19" name="">
             <a:extLst xmlns:a="http://schemas.openxmlformats.org/drawingml/2006/main">
               <a:ext uri="{FF2B5EF4-FFF2-40B4-BE49-F238E27FC236}">
-                <a16:creationId xmlns:a16="http://schemas.microsoft.com/office/drawing/2014/main" id="{E9F2BDE6-737E-48AB-8D0D-FFBDDAF099E8}"/>
+                <a16:creationId xmlns:a16="http://schemas.microsoft.com/office/drawing/2014/main" id="{270552DF-2619-4C62-920F-A50FE30361DD}"/>
               </a:ext>
             </a:extLst>
           </p:cNvPr>
@@ -26759,7 +26839,7 @@
           <p:cNvPr id="20" name="">
             <a:extLst xmlns:a="http://schemas.openxmlformats.org/drawingml/2006/main">
               <a:ext uri="{FF2B5EF4-FFF2-40B4-BE49-F238E27FC236}">
-                <a16:creationId xmlns:a16="http://schemas.microsoft.com/office/drawing/2014/main" id="{A3855535-E3D4-4BC7-94BE-875B3F169AC5}"/>
+                <a16:creationId xmlns:a16="http://schemas.microsoft.com/office/drawing/2014/main" id="{8A2475EF-ADFA-41BC-8FD6-11F3CECBAD13}"/>
               </a:ext>
             </a:extLst>
           </p:cNvPr>
@@ -26793,7 +26873,7 @@
           <p:cNvPr id="21" name="">
             <a:extLst xmlns:a="http://schemas.openxmlformats.org/drawingml/2006/main">
               <a:ext uri="{FF2B5EF4-FFF2-40B4-BE49-F238E27FC236}">
-                <a16:creationId xmlns:a16="http://schemas.microsoft.com/office/drawing/2014/main" id="{D5086B73-459C-4FD8-9AE4-4F0C87AC1E8E}"/>
+                <a16:creationId xmlns:a16="http://schemas.microsoft.com/office/drawing/2014/main" id="{9AD7583D-F55E-42EE-B835-BEB24BF71401}"/>
               </a:ext>
             </a:extLst>
           </p:cNvPr>
@@ -26850,7 +26930,7 @@
           <p:cNvPr id="22" name="">
             <a:extLst xmlns:a="http://schemas.openxmlformats.org/drawingml/2006/main">
               <a:ext uri="{FF2B5EF4-FFF2-40B4-BE49-F238E27FC236}">
-                <a16:creationId xmlns:a16="http://schemas.microsoft.com/office/drawing/2014/main" id="{A33C7C45-BDBE-4439-AD4B-E356D8B6FB54}"/>
+                <a16:creationId xmlns:a16="http://schemas.microsoft.com/office/drawing/2014/main" id="{9FB365B6-2ACC-46CF-91A8-41F7B8096D45}"/>
               </a:ext>
             </a:extLst>
           </p:cNvPr>
@@ -26930,7 +27010,7 @@
           <p:cNvPr id="23" name="">
             <a:extLst xmlns:a="http://schemas.openxmlformats.org/drawingml/2006/main">
               <a:ext uri="{FF2B5EF4-FFF2-40B4-BE49-F238E27FC236}">
-                <a16:creationId xmlns:a16="http://schemas.microsoft.com/office/drawing/2014/main" id="{E0209A05-C6EC-418B-BFD8-7A6B382F2956}"/>
+                <a16:creationId xmlns:a16="http://schemas.microsoft.com/office/drawing/2014/main" id="{D2BD8BB3-2240-47C7-BCC7-DDC8B5F417EA}"/>
               </a:ext>
             </a:extLst>
           </p:cNvPr>
@@ -26987,7 +27067,7 @@
           <p:cNvPr id="24" name="">
             <a:extLst xmlns:a="http://schemas.openxmlformats.org/drawingml/2006/main">
               <a:ext uri="{FF2B5EF4-FFF2-40B4-BE49-F238E27FC236}">
-                <a16:creationId xmlns:a16="http://schemas.microsoft.com/office/drawing/2014/main" id="{30D99106-DF09-4C35-B92E-645837D1D823}"/>
+                <a16:creationId xmlns:a16="http://schemas.microsoft.com/office/drawing/2014/main" id="{AF5006AA-C4A2-4D52-B7BC-489377365CAE}"/>
               </a:ext>
             </a:extLst>
           </p:cNvPr>
@@ -27021,7 +27101,7 @@
           <p:cNvPr id="25" name="">
             <a:extLst xmlns:a="http://schemas.openxmlformats.org/drawingml/2006/main">
               <a:ext uri="{FF2B5EF4-FFF2-40B4-BE49-F238E27FC236}">
-                <a16:creationId xmlns:a16="http://schemas.microsoft.com/office/drawing/2014/main" id="{073ABCAD-3057-48B7-82CA-6D5484D77A6C}"/>
+                <a16:creationId xmlns:a16="http://schemas.microsoft.com/office/drawing/2014/main" id="{EE5285B9-A024-40E4-8C57-7C2E68A9AA76}"/>
               </a:ext>
             </a:extLst>
           </p:cNvPr>
@@ -27078,7 +27158,7 @@
           <p:cNvPr id="26" name="">
             <a:extLst xmlns:a="http://schemas.openxmlformats.org/drawingml/2006/main">
               <a:ext uri="{FF2B5EF4-FFF2-40B4-BE49-F238E27FC236}">
-                <a16:creationId xmlns:a16="http://schemas.microsoft.com/office/drawing/2014/main" id="{25F9C17C-08CE-45E7-BD73-954699020761}"/>
+                <a16:creationId xmlns:a16="http://schemas.microsoft.com/office/drawing/2014/main" id="{E7A3799C-B037-4C8A-98AB-A71843B0DC35}"/>
               </a:ext>
             </a:extLst>
           </p:cNvPr>
@@ -27158,7 +27238,7 @@
           <p:cNvPr id="27" name="">
             <a:extLst xmlns:a="http://schemas.openxmlformats.org/drawingml/2006/main">
               <a:ext uri="{FF2B5EF4-FFF2-40B4-BE49-F238E27FC236}">
-                <a16:creationId xmlns:a16="http://schemas.microsoft.com/office/drawing/2014/main" id="{F8C5F8D1-A331-4D93-BD42-0252AD207802}"/>
+                <a16:creationId xmlns:a16="http://schemas.microsoft.com/office/drawing/2014/main" id="{B744FA03-9BB3-444E-86B0-74D8918EC8FB}"/>
               </a:ext>
             </a:extLst>
           </p:cNvPr>
@@ -27215,7 +27295,7 @@
           <p:cNvPr id="28" name="">
             <a:extLst xmlns:a="http://schemas.openxmlformats.org/drawingml/2006/main">
               <a:ext uri="{FF2B5EF4-FFF2-40B4-BE49-F238E27FC236}">
-                <a16:creationId xmlns:a16="http://schemas.microsoft.com/office/drawing/2014/main" id="{BA6E891F-79E8-4F09-91F6-70DD9A5B5273}"/>
+                <a16:creationId xmlns:a16="http://schemas.microsoft.com/office/drawing/2014/main" id="{FF7626FE-CA4D-40CB-9C0D-C820488941B6}"/>
               </a:ext>
             </a:extLst>
           </p:cNvPr>
@@ -27247,7 +27327,7 @@
           <p:cNvPr id="29" name="">
             <a:extLst xmlns:a="http://schemas.openxmlformats.org/drawingml/2006/main">
               <a:ext uri="{FF2B5EF4-FFF2-40B4-BE49-F238E27FC236}">
-                <a16:creationId xmlns:a16="http://schemas.microsoft.com/office/drawing/2014/main" id="{49CCCC64-CDD1-44BF-A81E-447AF9BAE11F}"/>
+                <a16:creationId xmlns:a16="http://schemas.microsoft.com/office/drawing/2014/main" id="{0873250F-B678-4BFC-A1DC-46BF4D8332DC}"/>
               </a:ext>
             </a:extLst>
           </p:cNvPr>
@@ -27304,7 +27384,7 @@
           <p:cNvPr id="30" name="">
             <a:extLst xmlns:a="http://schemas.openxmlformats.org/drawingml/2006/main">
               <a:ext uri="{FF2B5EF4-FFF2-40B4-BE49-F238E27FC236}">
-                <a16:creationId xmlns:a16="http://schemas.microsoft.com/office/drawing/2014/main" id="{9715C5F5-681B-4D96-8F12-E7046670CF7A}"/>
+                <a16:creationId xmlns:a16="http://schemas.microsoft.com/office/drawing/2014/main" id="{708CB568-CA6E-4CD2-ABA1-008D65FB37D5}"/>
               </a:ext>
             </a:extLst>
           </p:cNvPr>
@@ -27361,7 +27441,7 @@
           <p:cNvPr id="31" name="">
             <a:extLst xmlns:a="http://schemas.openxmlformats.org/drawingml/2006/main">
               <a:ext uri="{FF2B5EF4-FFF2-40B4-BE49-F238E27FC236}">
-                <a16:creationId xmlns:a16="http://schemas.microsoft.com/office/drawing/2014/main" id="{E119FD2A-1500-4797-947C-517B369D2326}"/>
+                <a16:creationId xmlns:a16="http://schemas.microsoft.com/office/drawing/2014/main" id="{899F639A-04C8-423D-BE9C-E4614F8FD65E}"/>
               </a:ext>
             </a:extLst>
           </p:cNvPr>
@@ -27416,7 +27496,7 @@
     </p:spTree>
     <p:extLst>
       <p:ext uri="{BB962C8B-B14F-4D97-AF65-F5344CB8AC3E}">
-        <p14:creationId xmlns:p14="http://schemas.microsoft.com/office/powerpoint/2010/main" val="1521034268"/>
+        <p14:creationId xmlns:p14="http://schemas.microsoft.com/office/powerpoint/2010/main" val="1696823357"/>
       </p:ext>
     </p:extLst>
   </p:cSld>

</xml_diff>